<commit_message>
Minor updates to intro and overview
</commit_message>
<xml_diff>
--- a/intro.pptx
+++ b/intro.pptx
@@ -5,10 +5,10 @@
     <p:sldMasterId id="2147483935" r:id="rId4"/>
   </p:sldMasterIdLst>
   <p:notesMasterIdLst>
-    <p:notesMasterId r:id="rId16"/>
+    <p:notesMasterId r:id="rId15"/>
   </p:notesMasterIdLst>
   <p:handoutMasterIdLst>
-    <p:handoutMasterId r:id="rId17"/>
+    <p:handoutMasterId r:id="rId16"/>
   </p:handoutMasterIdLst>
   <p:sldIdLst>
     <p:sldId id="617" r:id="rId5"/>
@@ -16,12 +16,11 @@
     <p:sldId id="308" r:id="rId7"/>
     <p:sldId id="324" r:id="rId8"/>
     <p:sldId id="329" r:id="rId9"/>
-    <p:sldId id="619" r:id="rId10"/>
-    <p:sldId id="620" r:id="rId11"/>
-    <p:sldId id="622" r:id="rId12"/>
-    <p:sldId id="616" r:id="rId13"/>
-    <p:sldId id="624" r:id="rId14"/>
-    <p:sldId id="261" r:id="rId15"/>
+    <p:sldId id="620" r:id="rId10"/>
+    <p:sldId id="622" r:id="rId11"/>
+    <p:sldId id="616" r:id="rId12"/>
+    <p:sldId id="624" r:id="rId13"/>
+    <p:sldId id="261" r:id="rId14"/>
   </p:sldIdLst>
   <p:sldSz cx="12188825" cy="6858000"/>
   <p:notesSz cx="7010400" cy="9296400"/>
@@ -4344,669 +4343,6 @@
 </file>
 
 <file path=ppt/slides/slide10.xml><?xml version="1.0" encoding="utf-8"?>
-<p:sld xmlns:a="http://schemas.openxmlformats.org/drawingml/2006/main" xmlns:r="http://schemas.openxmlformats.org/officeDocument/2006/relationships" xmlns:p="http://schemas.openxmlformats.org/presentationml/2006/main" showMasterSp="0">
-  <p:cSld>
-    <p:spTree>
-      <p:nvGrpSpPr>
-        <p:cNvPr id="1" name=""/>
-        <p:cNvGrpSpPr/>
-        <p:nvPr/>
-      </p:nvGrpSpPr>
-      <p:grpSpPr>
-        <a:xfrm>
-          <a:off x="0" y="0"/>
-          <a:ext cx="0" cy="0"/>
-          <a:chOff x="0" y="0"/>
-          <a:chExt cx="0" cy="0"/>
-        </a:xfrm>
-      </p:grpSpPr>
-      <p:sp>
-        <p:nvSpPr>
-          <p:cNvPr id="2" name="Title 1">
-            <a:extLst>
-              <a:ext uri="{FF2B5EF4-FFF2-40B4-BE49-F238E27FC236}">
-                <a16:creationId xmlns:a16="http://schemas.microsoft.com/office/drawing/2014/main" id="{1D6756EE-C2D9-4E52-B0B6-3C831FD6A565}"/>
-              </a:ext>
-            </a:extLst>
-          </p:cNvPr>
-          <p:cNvSpPr>
-            <a:spLocks noGrp="1"/>
-          </p:cNvSpPr>
-          <p:nvPr>
-            <p:ph type="title"/>
-          </p:nvPr>
-        </p:nvSpPr>
-        <p:spPr>
-          <a:xfrm>
-            <a:off x="408175" y="160020"/>
-            <a:ext cx="11372473" cy="914400"/>
-          </a:xfrm>
-        </p:spPr>
-        <p:txBody>
-          <a:bodyPr/>
-          <a:lstStyle/>
-          <a:p>
-            <a:r>
-              <a:rPr lang="en-US" dirty="0"/>
-              <a:t>Agenda (1/2)</a:t>
-            </a:r>
-          </a:p>
-        </p:txBody>
-      </p:sp>
-      <p:graphicFrame>
-        <p:nvGraphicFramePr>
-          <p:cNvPr id="6" name="Table 6">
-            <a:extLst>
-              <a:ext uri="{FF2B5EF4-FFF2-40B4-BE49-F238E27FC236}">
-                <a16:creationId xmlns:a16="http://schemas.microsoft.com/office/drawing/2014/main" id="{99D13FB2-5BF8-4AC0-A13D-ECB8E230F5BC}"/>
-              </a:ext>
-            </a:extLst>
-          </p:cNvPr>
-          <p:cNvGraphicFramePr>
-            <a:graphicFrameLocks noGrp="1"/>
-          </p:cNvGraphicFramePr>
-          <p:nvPr>
-            <p:ph idx="1"/>
-            <p:extLst>
-              <p:ext uri="{D42A27DB-BD31-4B8C-83A1-F6EECF244321}">
-                <p14:modId xmlns:p14="http://schemas.microsoft.com/office/powerpoint/2010/main" val="3435222980"/>
-              </p:ext>
-            </p:extLst>
-          </p:nvPr>
-        </p:nvGraphicFramePr>
-        <p:xfrm>
-          <a:off x="1051560" y="1074420"/>
-          <a:ext cx="9692640" cy="4637532"/>
-        </p:xfrm>
-        <a:graphic>
-          <a:graphicData uri="http://schemas.openxmlformats.org/drawingml/2006/table">
-            <a:tbl>
-              <a:tblPr firstRow="1" bandRow="1">
-                <a:tableStyleId>{5C22544A-7EE6-4342-B048-85BDC9FD1C3A}</a:tableStyleId>
-              </a:tblPr>
-              <a:tblGrid>
-                <a:gridCol w="1328947">
-                  <a:extLst>
-                    <a:ext uri="{9D8B030D-6E8A-4147-A177-3AD203B41FA5}">
-                      <a16:colId xmlns:a16="http://schemas.microsoft.com/office/drawing/2014/main" val="41390910"/>
-                    </a:ext>
-                  </a:extLst>
-                </a:gridCol>
-                <a:gridCol w="5033753">
-                  <a:extLst>
-                    <a:ext uri="{9D8B030D-6E8A-4147-A177-3AD203B41FA5}">
-                      <a16:colId xmlns:a16="http://schemas.microsoft.com/office/drawing/2014/main" val="2092910534"/>
-                    </a:ext>
-                  </a:extLst>
-                </a:gridCol>
-                <a:gridCol w="3329940">
-                  <a:extLst>
-                    <a:ext uri="{9D8B030D-6E8A-4147-A177-3AD203B41FA5}">
-                      <a16:colId xmlns:a16="http://schemas.microsoft.com/office/drawing/2014/main" val="1261297711"/>
-                    </a:ext>
-                  </a:extLst>
-                </a:gridCol>
-              </a:tblGrid>
-              <a:tr h="526542">
-                <a:tc>
-                  <a:txBody>
-                    <a:bodyPr/>
-                    <a:lstStyle/>
-                    <a:p>
-                      <a:pPr algn="r"/>
-                      <a:r>
-                        <a:rPr lang="en-US" sz="1800" dirty="0">
-                          <a:effectLst/>
-                        </a:rPr>
-                        <a:t>Time (CDT)</a:t>
-                      </a:r>
-                    </a:p>
-                  </a:txBody>
-                  <a:tcPr marL="142875" marR="142875" marT="95250" marB="95250" anchor="ctr"/>
-                </a:tc>
-                <a:tc>
-                  <a:txBody>
-                    <a:bodyPr/>
-                    <a:lstStyle/>
-                    <a:p>
-                      <a:pPr algn="l"/>
-                      <a:r>
-                        <a:rPr lang="en-US" sz="1800" dirty="0">
-                          <a:effectLst/>
-                        </a:rPr>
-                        <a:t>Title</a:t>
-                      </a:r>
-                    </a:p>
-                  </a:txBody>
-                  <a:tcPr marL="142875" marR="142875" marT="95250" marB="95250" anchor="ctr"/>
-                </a:tc>
-                <a:tc>
-                  <a:txBody>
-                    <a:bodyPr/>
-                    <a:lstStyle/>
-                    <a:p>
-                      <a:r>
-                        <a:rPr lang="en-US" sz="1800" dirty="0">
-                          <a:effectLst/>
-                        </a:rPr>
-                        <a:t>Presenter</a:t>
-                      </a:r>
-                    </a:p>
-                  </a:txBody>
-                  <a:tcPr marL="142875" marR="142875" marT="95250" marB="95250" anchor="ctr"/>
-                </a:tc>
-                <a:extLst>
-                  <a:ext uri="{0D108BD9-81ED-4DB2-BD59-A6C34878D82A}">
-                    <a16:rowId xmlns:a16="http://schemas.microsoft.com/office/drawing/2014/main" val="2098024418"/>
-                  </a:ext>
-                </a:extLst>
-              </a:tr>
-              <a:tr h="526542">
-                <a:tc>
-                  <a:txBody>
-                    <a:bodyPr/>
-                    <a:lstStyle/>
-                    <a:p>
-                      <a:pPr algn="r"/>
-                      <a:r>
-                        <a:rPr lang="en-US">
-                          <a:effectLst/>
-                        </a:rPr>
-                        <a:t>8:30 AM</a:t>
-                      </a:r>
-                    </a:p>
-                  </a:txBody>
-                  <a:tcPr marL="142875" marR="142875" marT="95250" marB="95250" anchor="ctr"/>
-                </a:tc>
-                <a:tc>
-                  <a:txBody>
-                    <a:bodyPr/>
-                    <a:lstStyle/>
-                    <a:p>
-                      <a:r>
-                        <a:rPr lang="en-US">
-                          <a:effectLst/>
-                        </a:rPr>
-                        <a:t>Introduction</a:t>
-                      </a:r>
-                    </a:p>
-                  </a:txBody>
-                  <a:tcPr marL="142875" marR="142875" marT="95250" marB="95250" anchor="ctr"/>
-                </a:tc>
-                <a:tc>
-                  <a:txBody>
-                    <a:bodyPr/>
-                    <a:lstStyle/>
-                    <a:p>
-                      <a:r>
-                        <a:rPr lang="en-US">
-                          <a:effectLst/>
-                        </a:rPr>
-                        <a:t>David E. Bernholdt (ORNL)</a:t>
-                      </a:r>
-                    </a:p>
-                  </a:txBody>
-                  <a:tcPr marL="142875" marR="142875" marT="95250" marB="95250" anchor="ctr"/>
-                </a:tc>
-                <a:extLst>
-                  <a:ext uri="{0D108BD9-81ED-4DB2-BD59-A6C34878D82A}">
-                    <a16:rowId xmlns:a16="http://schemas.microsoft.com/office/drawing/2014/main" val="4011846257"/>
-                  </a:ext>
-                </a:extLst>
-              </a:tr>
-              <a:tr h="526542">
-                <a:tc>
-                  <a:txBody>
-                    <a:bodyPr/>
-                    <a:lstStyle/>
-                    <a:p>
-                      <a:pPr algn="r"/>
-                      <a:r>
-                        <a:rPr lang="en-US">
-                          <a:effectLst/>
-                        </a:rPr>
-                        <a:t>8:35 AM</a:t>
-                      </a:r>
-                    </a:p>
-                  </a:txBody>
-                  <a:tcPr marL="142875" marR="142875" marT="95250" marB="95250" anchor="ctr"/>
-                </a:tc>
-                <a:tc>
-                  <a:txBody>
-                    <a:bodyPr/>
-                    <a:lstStyle/>
-                    <a:p>
-                      <a:r>
-                        <a:rPr lang="en-US">
-                          <a:effectLst/>
-                        </a:rPr>
-                        <a:t>Motivation and Overview of Best Practices in HPC Software Development</a:t>
-                      </a:r>
-                    </a:p>
-                  </a:txBody>
-                  <a:tcPr marL="142875" marR="142875" marT="95250" marB="95250" anchor="ctr"/>
-                </a:tc>
-                <a:tc>
-                  <a:txBody>
-                    <a:bodyPr/>
-                    <a:lstStyle/>
-                    <a:p>
-                      <a:r>
-                        <a:rPr lang="en-US">
-                          <a:effectLst/>
-                        </a:rPr>
-                        <a:t>David E. Bernholdt (ORNL)</a:t>
-                      </a:r>
-                    </a:p>
-                  </a:txBody>
-                  <a:tcPr marL="142875" marR="142875" marT="95250" marB="95250" anchor="ctr"/>
-                </a:tc>
-                <a:extLst>
-                  <a:ext uri="{0D108BD9-81ED-4DB2-BD59-A6C34878D82A}">
-                    <a16:rowId xmlns:a16="http://schemas.microsoft.com/office/drawing/2014/main" val="541819896"/>
-                  </a:ext>
-                </a:extLst>
-              </a:tr>
-              <a:tr h="526542">
-                <a:tc>
-                  <a:txBody>
-                    <a:bodyPr/>
-                    <a:lstStyle/>
-                    <a:p>
-                      <a:pPr algn="r"/>
-                      <a:r>
-                        <a:rPr lang="en-US">
-                          <a:effectLst/>
-                        </a:rPr>
-                        <a:t>9:15 AM</a:t>
-                      </a:r>
-                    </a:p>
-                  </a:txBody>
-                  <a:tcPr marL="142875" marR="142875" marT="95250" marB="95250" anchor="ctr"/>
-                </a:tc>
-                <a:tc>
-                  <a:txBody>
-                    <a:bodyPr/>
-                    <a:lstStyle/>
-                    <a:p>
-                      <a:r>
-                        <a:rPr lang="en-US">
-                          <a:effectLst/>
-                        </a:rPr>
-                        <a:t>Scientific Software Design</a:t>
-                      </a:r>
-                    </a:p>
-                  </a:txBody>
-                  <a:tcPr marL="142875" marR="142875" marT="95250" marB="95250" anchor="ctr"/>
-                </a:tc>
-                <a:tc>
-                  <a:txBody>
-                    <a:bodyPr/>
-                    <a:lstStyle/>
-                    <a:p>
-                      <a:r>
-                        <a:rPr lang="en-US">
-                          <a:effectLst/>
-                        </a:rPr>
-                        <a:t>Anshu Dubey (ANL)</a:t>
-                      </a:r>
-                    </a:p>
-                  </a:txBody>
-                  <a:tcPr marL="142875" marR="142875" marT="95250" marB="95250" anchor="ctr"/>
-                </a:tc>
-                <a:extLst>
-                  <a:ext uri="{0D108BD9-81ED-4DB2-BD59-A6C34878D82A}">
-                    <a16:rowId xmlns:a16="http://schemas.microsoft.com/office/drawing/2014/main" val="3922137579"/>
-                  </a:ext>
-                </a:extLst>
-              </a:tr>
-              <a:tr h="526542">
-                <a:tc>
-                  <a:txBody>
-                    <a:bodyPr/>
-                    <a:lstStyle/>
-                    <a:p>
-                      <a:pPr algn="r"/>
-                      <a:r>
-                        <a:rPr lang="en-US">
-                          <a:effectLst/>
-                        </a:rPr>
-                        <a:t>10:00 AM</a:t>
-                      </a:r>
-                    </a:p>
-                  </a:txBody>
-                  <a:tcPr marL="142875" marR="142875" marT="95250" marB="95250" anchor="ctr"/>
-                </a:tc>
-                <a:tc>
-                  <a:txBody>
-                    <a:bodyPr/>
-                    <a:lstStyle/>
-                    <a:p>
-                      <a:r>
-                        <a:rPr lang="en-US" i="1">
-                          <a:effectLst/>
-                        </a:rPr>
-                        <a:t>Break</a:t>
-                      </a:r>
-                      <a:endParaRPr lang="en-US">
-                        <a:effectLst/>
-                      </a:endParaRPr>
-                    </a:p>
-                  </a:txBody>
-                  <a:tcPr marL="142875" marR="142875" marT="95250" marB="95250" anchor="ctr"/>
-                </a:tc>
-                <a:tc>
-                  <a:txBody>
-                    <a:bodyPr/>
-                    <a:lstStyle/>
-                    <a:p>
-                      <a:endParaRPr lang="en-US">
-                        <a:effectLst/>
-                      </a:endParaRPr>
-                    </a:p>
-                  </a:txBody>
-                  <a:tcPr marL="142875" marR="142875" marT="95250" marB="95250" anchor="ctr"/>
-                </a:tc>
-                <a:extLst>
-                  <a:ext uri="{0D108BD9-81ED-4DB2-BD59-A6C34878D82A}">
-                    <a16:rowId xmlns:a16="http://schemas.microsoft.com/office/drawing/2014/main" val="476507548"/>
-                  </a:ext>
-                </a:extLst>
-              </a:tr>
-              <a:tr h="526542">
-                <a:tc>
-                  <a:txBody>
-                    <a:bodyPr/>
-                    <a:lstStyle/>
-                    <a:p>
-                      <a:pPr algn="r"/>
-                      <a:r>
-                        <a:rPr lang="en-US">
-                          <a:effectLst/>
-                        </a:rPr>
-                        <a:t>10:30 AM</a:t>
-                      </a:r>
-                    </a:p>
-                  </a:txBody>
-                  <a:tcPr marL="142875" marR="142875" marT="95250" marB="95250" anchor="ctr"/>
-                </a:tc>
-                <a:tc>
-                  <a:txBody>
-                    <a:bodyPr/>
-                    <a:lstStyle/>
-                    <a:p>
-                      <a:r>
-                        <a:rPr lang="en-US">
-                          <a:effectLst/>
-                        </a:rPr>
-                        <a:t>Spack: Package Management for HPC</a:t>
-                      </a:r>
-                    </a:p>
-                  </a:txBody>
-                  <a:tcPr marL="142875" marR="142875" marT="95250" marB="95250" anchor="ctr"/>
-                </a:tc>
-                <a:tc>
-                  <a:txBody>
-                    <a:bodyPr/>
-                    <a:lstStyle/>
-                    <a:p>
-                      <a:r>
-                        <a:rPr lang="en-US">
-                          <a:effectLst/>
-                        </a:rPr>
-                        <a:t>Todd Gamblin (LLNL)</a:t>
-                      </a:r>
-                    </a:p>
-                  </a:txBody>
-                  <a:tcPr marL="142875" marR="142875" marT="95250" marB="95250" anchor="ctr"/>
-                </a:tc>
-                <a:extLst>
-                  <a:ext uri="{0D108BD9-81ED-4DB2-BD59-A6C34878D82A}">
-                    <a16:rowId xmlns:a16="http://schemas.microsoft.com/office/drawing/2014/main" val="3487810232"/>
-                  </a:ext>
-                </a:extLst>
-              </a:tr>
-              <a:tr h="526542">
-                <a:tc>
-                  <a:txBody>
-                    <a:bodyPr/>
-                    <a:lstStyle/>
-                    <a:p>
-                      <a:pPr algn="r"/>
-                      <a:r>
-                        <a:rPr lang="en-US">
-                          <a:effectLst/>
-                        </a:rPr>
-                        <a:t>11:30 AM</a:t>
-                      </a:r>
-                    </a:p>
-                  </a:txBody>
-                  <a:tcPr marL="142875" marR="142875" marT="95250" marB="95250" anchor="ctr"/>
-                </a:tc>
-                <a:tc>
-                  <a:txBody>
-                    <a:bodyPr/>
-                    <a:lstStyle/>
-                    <a:p>
-                      <a:r>
-                        <a:rPr lang="en-US">
-                          <a:effectLst/>
-                        </a:rPr>
-                        <a:t>Spack Hands-On</a:t>
-                      </a:r>
-                    </a:p>
-                  </a:txBody>
-                  <a:tcPr marL="142875" marR="142875" marT="95250" marB="95250" anchor="ctr"/>
-                </a:tc>
-                <a:tc>
-                  <a:txBody>
-                    <a:bodyPr/>
-                    <a:lstStyle/>
-                    <a:p>
-                      <a:r>
-                        <a:rPr lang="en-US">
-                          <a:effectLst/>
-                        </a:rPr>
-                        <a:t>Todd Gamblin (LLNL)</a:t>
-                      </a:r>
-                    </a:p>
-                  </a:txBody>
-                  <a:tcPr marL="142875" marR="142875" marT="95250" marB="95250" anchor="ctr"/>
-                </a:tc>
-                <a:extLst>
-                  <a:ext uri="{0D108BD9-81ED-4DB2-BD59-A6C34878D82A}">
-                    <a16:rowId xmlns:a16="http://schemas.microsoft.com/office/drawing/2014/main" val="2034051112"/>
-                  </a:ext>
-                </a:extLst>
-              </a:tr>
-              <a:tr h="526542">
-                <a:tc>
-                  <a:txBody>
-                    <a:bodyPr/>
-                    <a:lstStyle/>
-                    <a:p>
-                      <a:pPr algn="r"/>
-                      <a:r>
-                        <a:rPr lang="en-US">
-                          <a:effectLst/>
-                        </a:rPr>
-                        <a:t>12:30 PM</a:t>
-                      </a:r>
-                    </a:p>
-                  </a:txBody>
-                  <a:tcPr marL="142875" marR="142875" marT="95250" marB="95250" anchor="ctr"/>
-                </a:tc>
-                <a:tc>
-                  <a:txBody>
-                    <a:bodyPr/>
-                    <a:lstStyle/>
-                    <a:p>
-                      <a:r>
-                        <a:rPr lang="en-US" i="1">
-                          <a:effectLst/>
-                        </a:rPr>
-                        <a:t>Lunch</a:t>
-                      </a:r>
-                      <a:endParaRPr lang="en-US">
-                        <a:effectLst/>
-                      </a:endParaRPr>
-                    </a:p>
-                  </a:txBody>
-                  <a:tcPr marL="142875" marR="142875" marT="95250" marB="95250" anchor="ctr"/>
-                </a:tc>
-                <a:tc>
-                  <a:txBody>
-                    <a:bodyPr/>
-                    <a:lstStyle/>
-                    <a:p>
-                      <a:endParaRPr lang="en-US" dirty="0">
-                        <a:effectLst/>
-                      </a:endParaRPr>
-                    </a:p>
-                  </a:txBody>
-                  <a:tcPr marL="142875" marR="142875" marT="95250" marB="95250" anchor="ctr"/>
-                </a:tc>
-                <a:extLst>
-                  <a:ext uri="{0D108BD9-81ED-4DB2-BD59-A6C34878D82A}">
-                    <a16:rowId xmlns:a16="http://schemas.microsoft.com/office/drawing/2014/main" val="1459939263"/>
-                  </a:ext>
-                </a:extLst>
-              </a:tr>
-            </a:tbl>
-          </a:graphicData>
-        </a:graphic>
-      </p:graphicFrame>
-      <p:sp>
-        <p:nvSpPr>
-          <p:cNvPr id="9" name="TextBox 8">
-            <a:extLst>
-              <a:ext uri="{FF2B5EF4-FFF2-40B4-BE49-F238E27FC236}">
-                <a16:creationId xmlns:a16="http://schemas.microsoft.com/office/drawing/2014/main" id="{2C67F121-FA5A-4323-B777-FC3438185944}"/>
-              </a:ext>
-            </a:extLst>
-          </p:cNvPr>
-          <p:cNvSpPr txBox="1"/>
-          <p:nvPr/>
-        </p:nvSpPr>
-        <p:spPr>
-          <a:xfrm>
-            <a:off x="4537710" y="45720"/>
-            <a:ext cx="7651115" cy="646331"/>
-          </a:xfrm>
-          <a:prstGeom prst="rect">
-            <a:avLst/>
-          </a:prstGeom>
-          <a:noFill/>
-        </p:spPr>
-        <p:txBody>
-          <a:bodyPr wrap="square">
-            <a:spAutoFit/>
-          </a:bodyPr>
-          <a:lstStyle/>
-          <a:p>
-            <a:pPr marL="0" marR="0" lvl="0" indent="0" algn="l" defTabSz="914400" rtl="0" eaLnBrk="1" fontAlgn="base" latinLnBrk="0" hangingPunct="1">
-              <a:lnSpc>
-                <a:spcPct val="100000"/>
-              </a:lnSpc>
-              <a:spcBef>
-                <a:spcPct val="0"/>
-              </a:spcBef>
-              <a:spcAft>
-                <a:spcPct val="0"/>
-              </a:spcAft>
-              <a:buClrTx/>
-              <a:buSzTx/>
-              <a:buFontTx/>
-              <a:buNone/>
-              <a:tabLst/>
-              <a:defRPr/>
-            </a:pPr>
-            <a:r>
-              <a:rPr kumimoji="0" lang="en-US" sz="1800" b="0" i="0" u="none" strike="noStrike" kern="1200" cap="none" spc="0" normalizeH="0" baseline="0" noProof="0" dirty="0">
-                <a:ln>
-                  <a:noFill/>
-                </a:ln>
-                <a:solidFill>
-                  <a:prstClr val="black"/>
-                </a:solidFill>
-                <a:effectLst/>
-                <a:uLnTx/>
-                <a:uFillTx/>
-                <a:latin typeface="Arial" charset="0"/>
-                <a:ea typeface="+mn-ea"/>
-                <a:cs typeface="Arial" charset="0"/>
-              </a:rPr>
-              <a:t>The agenda is also available on the tutorial web page.  Visit </a:t>
-            </a:r>
-            <a:r>
-              <a:rPr kumimoji="0" lang="en-US" sz="1800" b="1" i="0" u="none" strike="noStrike" kern="1200" cap="none" spc="0" normalizeH="0" baseline="0" noProof="0" dirty="0">
-                <a:ln>
-                  <a:noFill/>
-                </a:ln>
-                <a:solidFill>
-                  <a:prstClr val="black"/>
-                </a:solidFill>
-                <a:effectLst/>
-                <a:uLnTx/>
-                <a:uFillTx/>
-                <a:latin typeface="Arial" charset="0"/>
-                <a:ea typeface="+mn-ea"/>
-                <a:cs typeface="Arial" charset="0"/>
-                <a:hlinkClick r:id="rId2"/>
-              </a:rPr>
-              <a:t>https://bssw-tutorial.github.io</a:t>
-            </a:r>
-            <a:r>
-              <a:rPr kumimoji="0" lang="en-US" sz="1800" b="1" i="0" u="none" strike="noStrike" kern="1200" cap="none" spc="0" normalizeH="0" baseline="0" noProof="0" dirty="0">
-                <a:ln>
-                  <a:noFill/>
-                </a:ln>
-                <a:solidFill>
-                  <a:prstClr val="black"/>
-                </a:solidFill>
-                <a:effectLst/>
-                <a:uLnTx/>
-                <a:uFillTx/>
-                <a:latin typeface="Arial" charset="0"/>
-                <a:ea typeface="+mn-ea"/>
-                <a:cs typeface="Arial" charset="0"/>
-              </a:rPr>
-              <a:t> </a:t>
-            </a:r>
-            <a:r>
-              <a:rPr kumimoji="0" lang="en-US" sz="1800" b="0" i="0" u="none" strike="noStrike" kern="1200" cap="none" spc="0" normalizeH="0" baseline="0" noProof="0" dirty="0">
-                <a:ln>
-                  <a:noFill/>
-                </a:ln>
-                <a:solidFill>
-                  <a:prstClr val="black"/>
-                </a:solidFill>
-                <a:effectLst/>
-                <a:uLnTx/>
-                <a:uFillTx/>
-                <a:latin typeface="Arial" charset="0"/>
-                <a:ea typeface="+mn-ea"/>
-                <a:cs typeface="Arial" charset="0"/>
-              </a:rPr>
-              <a:t>and click on the link for today’s tutorial</a:t>
-            </a:r>
-          </a:p>
-        </p:txBody>
-      </p:sp>
-    </p:spTree>
-    <p:extLst>
-      <p:ext uri="{BB962C8B-B14F-4D97-AF65-F5344CB8AC3E}">
-        <p14:creationId xmlns:p14="http://schemas.microsoft.com/office/powerpoint/2010/main" val="3643219827"/>
-      </p:ext>
-    </p:extLst>
-  </p:cSld>
-  <p:clrMapOvr>
-    <a:masterClrMapping/>
-  </p:clrMapOvr>
-</p:sld>
-</file>
-
-<file path=ppt/slides/slide11.xml><?xml version="1.0" encoding="utf-8"?>
 <p:sld xmlns:a="http://schemas.openxmlformats.org/drawingml/2006/main" xmlns:r="http://schemas.openxmlformats.org/officeDocument/2006/relationships" xmlns:p="http://schemas.openxmlformats.org/presentationml/2006/main" showMasterSp="0">
   <p:cSld>
     <p:spTree>
@@ -7394,166 +6730,6 @@
           <p:cNvPr id="2" name="Title 1">
             <a:extLst>
               <a:ext uri="{FF2B5EF4-FFF2-40B4-BE49-F238E27FC236}">
-                <a16:creationId xmlns:a16="http://schemas.microsoft.com/office/drawing/2014/main" id="{92FBE35E-77C5-46DD-9F5D-290B55BEC8BD}"/>
-              </a:ext>
-            </a:extLst>
-          </p:cNvPr>
-          <p:cNvSpPr>
-            <a:spLocks noGrp="1"/>
-          </p:cNvSpPr>
-          <p:nvPr>
-            <p:ph type="title"/>
-          </p:nvPr>
-        </p:nvSpPr>
-        <p:spPr/>
-        <p:txBody>
-          <a:bodyPr/>
-          <a:lstStyle/>
-          <a:p>
-            <a:r>
-              <a:rPr lang="en-US" dirty="0"/>
-              <a:t>The Importance of Naming</a:t>
-            </a:r>
-          </a:p>
-        </p:txBody>
-      </p:sp>
-      <p:sp>
-        <p:nvSpPr>
-          <p:cNvPr id="3" name="Content Placeholder 2">
-            <a:extLst>
-              <a:ext uri="{FF2B5EF4-FFF2-40B4-BE49-F238E27FC236}">
-                <a16:creationId xmlns:a16="http://schemas.microsoft.com/office/drawing/2014/main" id="{0570DD6F-C774-41C2-BFA4-30EE69373698}"/>
-              </a:ext>
-            </a:extLst>
-          </p:cNvPr>
-          <p:cNvSpPr>
-            <a:spLocks noGrp="1"/>
-          </p:cNvSpPr>
-          <p:nvPr>
-            <p:ph idx="1"/>
-          </p:nvPr>
-        </p:nvSpPr>
-        <p:spPr>
-          <a:xfrm>
-            <a:off x="365760" y="1231518"/>
-            <a:ext cx="11369809" cy="4047778"/>
-          </a:xfrm>
-        </p:spPr>
-        <p:txBody>
-          <a:bodyPr/>
-          <a:lstStyle/>
-          <a:p>
-            <a:r>
-              <a:rPr lang="en-US" dirty="0"/>
-              <a:t>Computing is rife with terminology that many consider harmful and exclusionary</a:t>
-            </a:r>
-          </a:p>
-          <a:p>
-            <a:pPr lvl="1"/>
-            <a:r>
-              <a:rPr lang="en-US" dirty="0"/>
-              <a:t>Examples include: whitelist/blacklist, master/slave, and master (standalone)</a:t>
-            </a:r>
-          </a:p>
-          <a:p>
-            <a:r>
-              <a:rPr lang="en-US" dirty="0"/>
-              <a:t>We support efforts to replace such language with more inclusive language</a:t>
-            </a:r>
-          </a:p>
-          <a:p>
-            <a:r>
-              <a:rPr lang="en-US" dirty="0"/>
-              <a:t>In this tutorial, we strive to use inclusive language</a:t>
-            </a:r>
-          </a:p>
-          <a:p>
-            <a:pPr lvl="1"/>
-            <a:r>
-              <a:rPr lang="en-US" dirty="0"/>
-              <a:t>Example: we use “main” for the default git branch, even where outside sources we reference may use “master”</a:t>
-            </a:r>
-          </a:p>
-          <a:p>
-            <a:r>
-              <a:rPr lang="en-US" dirty="0"/>
-              <a:t>We welcome suggestions for further improvements in our tutorial</a:t>
-            </a:r>
-          </a:p>
-          <a:p>
-            <a:r>
-              <a:rPr lang="en-US" dirty="0"/>
-              <a:t>Additional information:</a:t>
-            </a:r>
-          </a:p>
-          <a:p>
-            <a:pPr lvl="1"/>
-            <a:r>
-              <a:rPr lang="en-US" dirty="0"/>
-              <a:t>The </a:t>
-            </a:r>
-            <a:r>
-              <a:rPr lang="en-US" dirty="0">
-                <a:hlinkClick r:id="rId2"/>
-              </a:rPr>
-              <a:t>Inclusive Naming Initiative</a:t>
-            </a:r>
-            <a:endParaRPr lang="en-US" dirty="0"/>
-          </a:p>
-          <a:p>
-            <a:pPr lvl="1"/>
-            <a:r>
-              <a:rPr lang="en-US" dirty="0"/>
-              <a:t>The BSSw.io </a:t>
-            </a:r>
-            <a:r>
-              <a:rPr lang="en-US" dirty="0">
-                <a:hlinkClick r:id="rId3"/>
-              </a:rPr>
-              <a:t>resource on inclusive naming</a:t>
-            </a:r>
-            <a:r>
-              <a:rPr lang="en-US" dirty="0"/>
-              <a:t> provides some additional context and links</a:t>
-            </a:r>
-          </a:p>
-        </p:txBody>
-      </p:sp>
-    </p:spTree>
-    <p:extLst>
-      <p:ext uri="{BB962C8B-B14F-4D97-AF65-F5344CB8AC3E}">
-        <p14:creationId xmlns:p14="http://schemas.microsoft.com/office/powerpoint/2010/main" val="3064435251"/>
-      </p:ext>
-    </p:extLst>
-  </p:cSld>
-  <p:clrMapOvr>
-    <a:masterClrMapping/>
-  </p:clrMapOvr>
-</p:sld>
-</file>
-
-<file path=ppt/slides/slide7.xml><?xml version="1.0" encoding="utf-8"?>
-<p:sld xmlns:a="http://schemas.openxmlformats.org/drawingml/2006/main" xmlns:r="http://schemas.openxmlformats.org/officeDocument/2006/relationships" xmlns:p="http://schemas.openxmlformats.org/presentationml/2006/main">
-  <p:cSld>
-    <p:spTree>
-      <p:nvGrpSpPr>
-        <p:cNvPr id="1" name=""/>
-        <p:cNvGrpSpPr/>
-        <p:nvPr/>
-      </p:nvGrpSpPr>
-      <p:grpSpPr>
-        <a:xfrm>
-          <a:off x="0" y="0"/>
-          <a:ext cx="0" cy="0"/>
-          <a:chOff x="0" y="0"/>
-          <a:chExt cx="0" cy="0"/>
-        </a:xfrm>
-      </p:grpSpPr>
-      <p:sp>
-        <p:nvSpPr>
-          <p:cNvPr id="2" name="Title 1">
-            <a:extLst>
-              <a:ext uri="{FF2B5EF4-FFF2-40B4-BE49-F238E27FC236}">
                 <a16:creationId xmlns:a16="http://schemas.microsoft.com/office/drawing/2014/main" id="{290A2901-48B8-469D-BFD7-34B28CA8F61C}"/>
               </a:ext>
             </a:extLst>
@@ -7711,7 +6887,7 @@
 </p:sld>
 </file>
 
-<file path=ppt/slides/slide8.xml><?xml version="1.0" encoding="utf-8"?>
+<file path=ppt/slides/slide7.xml><?xml version="1.0" encoding="utf-8"?>
 <p:sld xmlns:a="http://schemas.openxmlformats.org/drawingml/2006/main" xmlns:r="http://schemas.openxmlformats.org/officeDocument/2006/relationships" xmlns:p="http://schemas.openxmlformats.org/presentationml/2006/main">
   <p:cSld>
     <p:spTree>
@@ -7854,7 +7030,7 @@
 </p:sld>
 </file>
 
-<file path=ppt/slides/slide9.xml><?xml version="1.0" encoding="utf-8"?>
+<file path=ppt/slides/slide8.xml><?xml version="1.0" encoding="utf-8"?>
 <p:sld xmlns:a="http://schemas.openxmlformats.org/drawingml/2006/main" xmlns:r="http://schemas.openxmlformats.org/officeDocument/2006/relationships" xmlns:p="http://schemas.openxmlformats.org/presentationml/2006/main">
   <p:cSld>
     <p:spTree>
@@ -8015,6 +7191,669 @@
     <p:extLst>
       <p:ext uri="{BB962C8B-B14F-4D97-AF65-F5344CB8AC3E}">
         <p14:creationId xmlns:p14="http://schemas.microsoft.com/office/powerpoint/2010/main" val="3695382487"/>
+      </p:ext>
+    </p:extLst>
+  </p:cSld>
+  <p:clrMapOvr>
+    <a:masterClrMapping/>
+  </p:clrMapOvr>
+</p:sld>
+</file>
+
+<file path=ppt/slides/slide9.xml><?xml version="1.0" encoding="utf-8"?>
+<p:sld xmlns:a="http://schemas.openxmlformats.org/drawingml/2006/main" xmlns:r="http://schemas.openxmlformats.org/officeDocument/2006/relationships" xmlns:p="http://schemas.openxmlformats.org/presentationml/2006/main" showMasterSp="0">
+  <p:cSld>
+    <p:spTree>
+      <p:nvGrpSpPr>
+        <p:cNvPr id="1" name=""/>
+        <p:cNvGrpSpPr/>
+        <p:nvPr/>
+      </p:nvGrpSpPr>
+      <p:grpSpPr>
+        <a:xfrm>
+          <a:off x="0" y="0"/>
+          <a:ext cx="0" cy="0"/>
+          <a:chOff x="0" y="0"/>
+          <a:chExt cx="0" cy="0"/>
+        </a:xfrm>
+      </p:grpSpPr>
+      <p:sp>
+        <p:nvSpPr>
+          <p:cNvPr id="2" name="Title 1">
+            <a:extLst>
+              <a:ext uri="{FF2B5EF4-FFF2-40B4-BE49-F238E27FC236}">
+                <a16:creationId xmlns:a16="http://schemas.microsoft.com/office/drawing/2014/main" id="{1D6756EE-C2D9-4E52-B0B6-3C831FD6A565}"/>
+              </a:ext>
+            </a:extLst>
+          </p:cNvPr>
+          <p:cNvSpPr>
+            <a:spLocks noGrp="1"/>
+          </p:cNvSpPr>
+          <p:nvPr>
+            <p:ph type="title"/>
+          </p:nvPr>
+        </p:nvSpPr>
+        <p:spPr>
+          <a:xfrm>
+            <a:off x="408175" y="160020"/>
+            <a:ext cx="11372473" cy="914400"/>
+          </a:xfrm>
+        </p:spPr>
+        <p:txBody>
+          <a:bodyPr/>
+          <a:lstStyle/>
+          <a:p>
+            <a:r>
+              <a:rPr lang="en-US" dirty="0"/>
+              <a:t>Agenda (1/2)</a:t>
+            </a:r>
+          </a:p>
+        </p:txBody>
+      </p:sp>
+      <p:graphicFrame>
+        <p:nvGraphicFramePr>
+          <p:cNvPr id="6" name="Table 6">
+            <a:extLst>
+              <a:ext uri="{FF2B5EF4-FFF2-40B4-BE49-F238E27FC236}">
+                <a16:creationId xmlns:a16="http://schemas.microsoft.com/office/drawing/2014/main" id="{99D13FB2-5BF8-4AC0-A13D-ECB8E230F5BC}"/>
+              </a:ext>
+            </a:extLst>
+          </p:cNvPr>
+          <p:cNvGraphicFramePr>
+            <a:graphicFrameLocks noGrp="1"/>
+          </p:cNvGraphicFramePr>
+          <p:nvPr>
+            <p:ph idx="1"/>
+            <p:extLst>
+              <p:ext uri="{D42A27DB-BD31-4B8C-83A1-F6EECF244321}">
+                <p14:modId xmlns:p14="http://schemas.microsoft.com/office/powerpoint/2010/main" val="3435222980"/>
+              </p:ext>
+            </p:extLst>
+          </p:nvPr>
+        </p:nvGraphicFramePr>
+        <p:xfrm>
+          <a:off x="1051560" y="1074420"/>
+          <a:ext cx="9692640" cy="4637532"/>
+        </p:xfrm>
+        <a:graphic>
+          <a:graphicData uri="http://schemas.openxmlformats.org/drawingml/2006/table">
+            <a:tbl>
+              <a:tblPr firstRow="1" bandRow="1">
+                <a:tableStyleId>{5C22544A-7EE6-4342-B048-85BDC9FD1C3A}</a:tableStyleId>
+              </a:tblPr>
+              <a:tblGrid>
+                <a:gridCol w="1328947">
+                  <a:extLst>
+                    <a:ext uri="{9D8B030D-6E8A-4147-A177-3AD203B41FA5}">
+                      <a16:colId xmlns:a16="http://schemas.microsoft.com/office/drawing/2014/main" val="41390910"/>
+                    </a:ext>
+                  </a:extLst>
+                </a:gridCol>
+                <a:gridCol w="5033753">
+                  <a:extLst>
+                    <a:ext uri="{9D8B030D-6E8A-4147-A177-3AD203B41FA5}">
+                      <a16:colId xmlns:a16="http://schemas.microsoft.com/office/drawing/2014/main" val="2092910534"/>
+                    </a:ext>
+                  </a:extLst>
+                </a:gridCol>
+                <a:gridCol w="3329940">
+                  <a:extLst>
+                    <a:ext uri="{9D8B030D-6E8A-4147-A177-3AD203B41FA5}">
+                      <a16:colId xmlns:a16="http://schemas.microsoft.com/office/drawing/2014/main" val="1261297711"/>
+                    </a:ext>
+                  </a:extLst>
+                </a:gridCol>
+              </a:tblGrid>
+              <a:tr h="526542">
+                <a:tc>
+                  <a:txBody>
+                    <a:bodyPr/>
+                    <a:lstStyle/>
+                    <a:p>
+                      <a:pPr algn="r"/>
+                      <a:r>
+                        <a:rPr lang="en-US" sz="1800" dirty="0">
+                          <a:effectLst/>
+                        </a:rPr>
+                        <a:t>Time (CDT)</a:t>
+                      </a:r>
+                    </a:p>
+                  </a:txBody>
+                  <a:tcPr marL="142875" marR="142875" marT="95250" marB="95250" anchor="ctr"/>
+                </a:tc>
+                <a:tc>
+                  <a:txBody>
+                    <a:bodyPr/>
+                    <a:lstStyle/>
+                    <a:p>
+                      <a:pPr algn="l"/>
+                      <a:r>
+                        <a:rPr lang="en-US" sz="1800" dirty="0">
+                          <a:effectLst/>
+                        </a:rPr>
+                        <a:t>Title</a:t>
+                      </a:r>
+                    </a:p>
+                  </a:txBody>
+                  <a:tcPr marL="142875" marR="142875" marT="95250" marB="95250" anchor="ctr"/>
+                </a:tc>
+                <a:tc>
+                  <a:txBody>
+                    <a:bodyPr/>
+                    <a:lstStyle/>
+                    <a:p>
+                      <a:r>
+                        <a:rPr lang="en-US" sz="1800" dirty="0">
+                          <a:effectLst/>
+                        </a:rPr>
+                        <a:t>Presenter</a:t>
+                      </a:r>
+                    </a:p>
+                  </a:txBody>
+                  <a:tcPr marL="142875" marR="142875" marT="95250" marB="95250" anchor="ctr"/>
+                </a:tc>
+                <a:extLst>
+                  <a:ext uri="{0D108BD9-81ED-4DB2-BD59-A6C34878D82A}">
+                    <a16:rowId xmlns:a16="http://schemas.microsoft.com/office/drawing/2014/main" val="2098024418"/>
+                  </a:ext>
+                </a:extLst>
+              </a:tr>
+              <a:tr h="526542">
+                <a:tc>
+                  <a:txBody>
+                    <a:bodyPr/>
+                    <a:lstStyle/>
+                    <a:p>
+                      <a:pPr algn="r"/>
+                      <a:r>
+                        <a:rPr lang="en-US">
+                          <a:effectLst/>
+                        </a:rPr>
+                        <a:t>8:30 AM</a:t>
+                      </a:r>
+                    </a:p>
+                  </a:txBody>
+                  <a:tcPr marL="142875" marR="142875" marT="95250" marB="95250" anchor="ctr"/>
+                </a:tc>
+                <a:tc>
+                  <a:txBody>
+                    <a:bodyPr/>
+                    <a:lstStyle/>
+                    <a:p>
+                      <a:r>
+                        <a:rPr lang="en-US">
+                          <a:effectLst/>
+                        </a:rPr>
+                        <a:t>Introduction</a:t>
+                      </a:r>
+                    </a:p>
+                  </a:txBody>
+                  <a:tcPr marL="142875" marR="142875" marT="95250" marB="95250" anchor="ctr"/>
+                </a:tc>
+                <a:tc>
+                  <a:txBody>
+                    <a:bodyPr/>
+                    <a:lstStyle/>
+                    <a:p>
+                      <a:r>
+                        <a:rPr lang="en-US">
+                          <a:effectLst/>
+                        </a:rPr>
+                        <a:t>David E. Bernholdt (ORNL)</a:t>
+                      </a:r>
+                    </a:p>
+                  </a:txBody>
+                  <a:tcPr marL="142875" marR="142875" marT="95250" marB="95250" anchor="ctr"/>
+                </a:tc>
+                <a:extLst>
+                  <a:ext uri="{0D108BD9-81ED-4DB2-BD59-A6C34878D82A}">
+                    <a16:rowId xmlns:a16="http://schemas.microsoft.com/office/drawing/2014/main" val="4011846257"/>
+                  </a:ext>
+                </a:extLst>
+              </a:tr>
+              <a:tr h="526542">
+                <a:tc>
+                  <a:txBody>
+                    <a:bodyPr/>
+                    <a:lstStyle/>
+                    <a:p>
+                      <a:pPr algn="r"/>
+                      <a:r>
+                        <a:rPr lang="en-US">
+                          <a:effectLst/>
+                        </a:rPr>
+                        <a:t>8:35 AM</a:t>
+                      </a:r>
+                    </a:p>
+                  </a:txBody>
+                  <a:tcPr marL="142875" marR="142875" marT="95250" marB="95250" anchor="ctr"/>
+                </a:tc>
+                <a:tc>
+                  <a:txBody>
+                    <a:bodyPr/>
+                    <a:lstStyle/>
+                    <a:p>
+                      <a:r>
+                        <a:rPr lang="en-US">
+                          <a:effectLst/>
+                        </a:rPr>
+                        <a:t>Motivation and Overview of Best Practices in HPC Software Development</a:t>
+                      </a:r>
+                    </a:p>
+                  </a:txBody>
+                  <a:tcPr marL="142875" marR="142875" marT="95250" marB="95250" anchor="ctr"/>
+                </a:tc>
+                <a:tc>
+                  <a:txBody>
+                    <a:bodyPr/>
+                    <a:lstStyle/>
+                    <a:p>
+                      <a:r>
+                        <a:rPr lang="en-US">
+                          <a:effectLst/>
+                        </a:rPr>
+                        <a:t>David E. Bernholdt (ORNL)</a:t>
+                      </a:r>
+                    </a:p>
+                  </a:txBody>
+                  <a:tcPr marL="142875" marR="142875" marT="95250" marB="95250" anchor="ctr"/>
+                </a:tc>
+                <a:extLst>
+                  <a:ext uri="{0D108BD9-81ED-4DB2-BD59-A6C34878D82A}">
+                    <a16:rowId xmlns:a16="http://schemas.microsoft.com/office/drawing/2014/main" val="541819896"/>
+                  </a:ext>
+                </a:extLst>
+              </a:tr>
+              <a:tr h="526542">
+                <a:tc>
+                  <a:txBody>
+                    <a:bodyPr/>
+                    <a:lstStyle/>
+                    <a:p>
+                      <a:pPr algn="r"/>
+                      <a:r>
+                        <a:rPr lang="en-US">
+                          <a:effectLst/>
+                        </a:rPr>
+                        <a:t>9:15 AM</a:t>
+                      </a:r>
+                    </a:p>
+                  </a:txBody>
+                  <a:tcPr marL="142875" marR="142875" marT="95250" marB="95250" anchor="ctr"/>
+                </a:tc>
+                <a:tc>
+                  <a:txBody>
+                    <a:bodyPr/>
+                    <a:lstStyle/>
+                    <a:p>
+                      <a:r>
+                        <a:rPr lang="en-US">
+                          <a:effectLst/>
+                        </a:rPr>
+                        <a:t>Scientific Software Design</a:t>
+                      </a:r>
+                    </a:p>
+                  </a:txBody>
+                  <a:tcPr marL="142875" marR="142875" marT="95250" marB="95250" anchor="ctr"/>
+                </a:tc>
+                <a:tc>
+                  <a:txBody>
+                    <a:bodyPr/>
+                    <a:lstStyle/>
+                    <a:p>
+                      <a:r>
+                        <a:rPr lang="en-US">
+                          <a:effectLst/>
+                        </a:rPr>
+                        <a:t>Anshu Dubey (ANL)</a:t>
+                      </a:r>
+                    </a:p>
+                  </a:txBody>
+                  <a:tcPr marL="142875" marR="142875" marT="95250" marB="95250" anchor="ctr"/>
+                </a:tc>
+                <a:extLst>
+                  <a:ext uri="{0D108BD9-81ED-4DB2-BD59-A6C34878D82A}">
+                    <a16:rowId xmlns:a16="http://schemas.microsoft.com/office/drawing/2014/main" val="3922137579"/>
+                  </a:ext>
+                </a:extLst>
+              </a:tr>
+              <a:tr h="526542">
+                <a:tc>
+                  <a:txBody>
+                    <a:bodyPr/>
+                    <a:lstStyle/>
+                    <a:p>
+                      <a:pPr algn="r"/>
+                      <a:r>
+                        <a:rPr lang="en-US">
+                          <a:effectLst/>
+                        </a:rPr>
+                        <a:t>10:00 AM</a:t>
+                      </a:r>
+                    </a:p>
+                  </a:txBody>
+                  <a:tcPr marL="142875" marR="142875" marT="95250" marB="95250" anchor="ctr"/>
+                </a:tc>
+                <a:tc>
+                  <a:txBody>
+                    <a:bodyPr/>
+                    <a:lstStyle/>
+                    <a:p>
+                      <a:r>
+                        <a:rPr lang="en-US" i="1">
+                          <a:effectLst/>
+                        </a:rPr>
+                        <a:t>Break</a:t>
+                      </a:r>
+                      <a:endParaRPr lang="en-US">
+                        <a:effectLst/>
+                      </a:endParaRPr>
+                    </a:p>
+                  </a:txBody>
+                  <a:tcPr marL="142875" marR="142875" marT="95250" marB="95250" anchor="ctr"/>
+                </a:tc>
+                <a:tc>
+                  <a:txBody>
+                    <a:bodyPr/>
+                    <a:lstStyle/>
+                    <a:p>
+                      <a:endParaRPr lang="en-US">
+                        <a:effectLst/>
+                      </a:endParaRPr>
+                    </a:p>
+                  </a:txBody>
+                  <a:tcPr marL="142875" marR="142875" marT="95250" marB="95250" anchor="ctr"/>
+                </a:tc>
+                <a:extLst>
+                  <a:ext uri="{0D108BD9-81ED-4DB2-BD59-A6C34878D82A}">
+                    <a16:rowId xmlns:a16="http://schemas.microsoft.com/office/drawing/2014/main" val="476507548"/>
+                  </a:ext>
+                </a:extLst>
+              </a:tr>
+              <a:tr h="526542">
+                <a:tc>
+                  <a:txBody>
+                    <a:bodyPr/>
+                    <a:lstStyle/>
+                    <a:p>
+                      <a:pPr algn="r"/>
+                      <a:r>
+                        <a:rPr lang="en-US">
+                          <a:effectLst/>
+                        </a:rPr>
+                        <a:t>10:30 AM</a:t>
+                      </a:r>
+                    </a:p>
+                  </a:txBody>
+                  <a:tcPr marL="142875" marR="142875" marT="95250" marB="95250" anchor="ctr"/>
+                </a:tc>
+                <a:tc>
+                  <a:txBody>
+                    <a:bodyPr/>
+                    <a:lstStyle/>
+                    <a:p>
+                      <a:r>
+                        <a:rPr lang="en-US">
+                          <a:effectLst/>
+                        </a:rPr>
+                        <a:t>Spack: Package Management for HPC</a:t>
+                      </a:r>
+                    </a:p>
+                  </a:txBody>
+                  <a:tcPr marL="142875" marR="142875" marT="95250" marB="95250" anchor="ctr"/>
+                </a:tc>
+                <a:tc>
+                  <a:txBody>
+                    <a:bodyPr/>
+                    <a:lstStyle/>
+                    <a:p>
+                      <a:r>
+                        <a:rPr lang="en-US">
+                          <a:effectLst/>
+                        </a:rPr>
+                        <a:t>Todd Gamblin (LLNL)</a:t>
+                      </a:r>
+                    </a:p>
+                  </a:txBody>
+                  <a:tcPr marL="142875" marR="142875" marT="95250" marB="95250" anchor="ctr"/>
+                </a:tc>
+                <a:extLst>
+                  <a:ext uri="{0D108BD9-81ED-4DB2-BD59-A6C34878D82A}">
+                    <a16:rowId xmlns:a16="http://schemas.microsoft.com/office/drawing/2014/main" val="3487810232"/>
+                  </a:ext>
+                </a:extLst>
+              </a:tr>
+              <a:tr h="526542">
+                <a:tc>
+                  <a:txBody>
+                    <a:bodyPr/>
+                    <a:lstStyle/>
+                    <a:p>
+                      <a:pPr algn="r"/>
+                      <a:r>
+                        <a:rPr lang="en-US">
+                          <a:effectLst/>
+                        </a:rPr>
+                        <a:t>11:30 AM</a:t>
+                      </a:r>
+                    </a:p>
+                  </a:txBody>
+                  <a:tcPr marL="142875" marR="142875" marT="95250" marB="95250" anchor="ctr"/>
+                </a:tc>
+                <a:tc>
+                  <a:txBody>
+                    <a:bodyPr/>
+                    <a:lstStyle/>
+                    <a:p>
+                      <a:r>
+                        <a:rPr lang="en-US">
+                          <a:effectLst/>
+                        </a:rPr>
+                        <a:t>Spack Hands-On</a:t>
+                      </a:r>
+                    </a:p>
+                  </a:txBody>
+                  <a:tcPr marL="142875" marR="142875" marT="95250" marB="95250" anchor="ctr"/>
+                </a:tc>
+                <a:tc>
+                  <a:txBody>
+                    <a:bodyPr/>
+                    <a:lstStyle/>
+                    <a:p>
+                      <a:r>
+                        <a:rPr lang="en-US">
+                          <a:effectLst/>
+                        </a:rPr>
+                        <a:t>Todd Gamblin (LLNL)</a:t>
+                      </a:r>
+                    </a:p>
+                  </a:txBody>
+                  <a:tcPr marL="142875" marR="142875" marT="95250" marB="95250" anchor="ctr"/>
+                </a:tc>
+                <a:extLst>
+                  <a:ext uri="{0D108BD9-81ED-4DB2-BD59-A6C34878D82A}">
+                    <a16:rowId xmlns:a16="http://schemas.microsoft.com/office/drawing/2014/main" val="2034051112"/>
+                  </a:ext>
+                </a:extLst>
+              </a:tr>
+              <a:tr h="526542">
+                <a:tc>
+                  <a:txBody>
+                    <a:bodyPr/>
+                    <a:lstStyle/>
+                    <a:p>
+                      <a:pPr algn="r"/>
+                      <a:r>
+                        <a:rPr lang="en-US">
+                          <a:effectLst/>
+                        </a:rPr>
+                        <a:t>12:30 PM</a:t>
+                      </a:r>
+                    </a:p>
+                  </a:txBody>
+                  <a:tcPr marL="142875" marR="142875" marT="95250" marB="95250" anchor="ctr"/>
+                </a:tc>
+                <a:tc>
+                  <a:txBody>
+                    <a:bodyPr/>
+                    <a:lstStyle/>
+                    <a:p>
+                      <a:r>
+                        <a:rPr lang="en-US" i="1">
+                          <a:effectLst/>
+                        </a:rPr>
+                        <a:t>Lunch</a:t>
+                      </a:r>
+                      <a:endParaRPr lang="en-US">
+                        <a:effectLst/>
+                      </a:endParaRPr>
+                    </a:p>
+                  </a:txBody>
+                  <a:tcPr marL="142875" marR="142875" marT="95250" marB="95250" anchor="ctr"/>
+                </a:tc>
+                <a:tc>
+                  <a:txBody>
+                    <a:bodyPr/>
+                    <a:lstStyle/>
+                    <a:p>
+                      <a:endParaRPr lang="en-US" dirty="0">
+                        <a:effectLst/>
+                      </a:endParaRPr>
+                    </a:p>
+                  </a:txBody>
+                  <a:tcPr marL="142875" marR="142875" marT="95250" marB="95250" anchor="ctr"/>
+                </a:tc>
+                <a:extLst>
+                  <a:ext uri="{0D108BD9-81ED-4DB2-BD59-A6C34878D82A}">
+                    <a16:rowId xmlns:a16="http://schemas.microsoft.com/office/drawing/2014/main" val="1459939263"/>
+                  </a:ext>
+                </a:extLst>
+              </a:tr>
+            </a:tbl>
+          </a:graphicData>
+        </a:graphic>
+      </p:graphicFrame>
+      <p:sp>
+        <p:nvSpPr>
+          <p:cNvPr id="9" name="TextBox 8">
+            <a:extLst>
+              <a:ext uri="{FF2B5EF4-FFF2-40B4-BE49-F238E27FC236}">
+                <a16:creationId xmlns:a16="http://schemas.microsoft.com/office/drawing/2014/main" id="{2C67F121-FA5A-4323-B777-FC3438185944}"/>
+              </a:ext>
+            </a:extLst>
+          </p:cNvPr>
+          <p:cNvSpPr txBox="1"/>
+          <p:nvPr/>
+        </p:nvSpPr>
+        <p:spPr>
+          <a:xfrm>
+            <a:off x="4537710" y="45720"/>
+            <a:ext cx="7651115" cy="646331"/>
+          </a:xfrm>
+          <a:prstGeom prst="rect">
+            <a:avLst/>
+          </a:prstGeom>
+          <a:noFill/>
+        </p:spPr>
+        <p:txBody>
+          <a:bodyPr wrap="square">
+            <a:spAutoFit/>
+          </a:bodyPr>
+          <a:lstStyle/>
+          <a:p>
+            <a:pPr marL="0" marR="0" lvl="0" indent="0" algn="l" defTabSz="914400" rtl="0" eaLnBrk="1" fontAlgn="base" latinLnBrk="0" hangingPunct="1">
+              <a:lnSpc>
+                <a:spcPct val="100000"/>
+              </a:lnSpc>
+              <a:spcBef>
+                <a:spcPct val="0"/>
+              </a:spcBef>
+              <a:spcAft>
+                <a:spcPct val="0"/>
+              </a:spcAft>
+              <a:buClrTx/>
+              <a:buSzTx/>
+              <a:buFontTx/>
+              <a:buNone/>
+              <a:tabLst/>
+              <a:defRPr/>
+            </a:pPr>
+            <a:r>
+              <a:rPr kumimoji="0" lang="en-US" sz="1800" b="0" i="0" u="none" strike="noStrike" kern="1200" cap="none" spc="0" normalizeH="0" baseline="0" noProof="0" dirty="0">
+                <a:ln>
+                  <a:noFill/>
+                </a:ln>
+                <a:solidFill>
+                  <a:prstClr val="black"/>
+                </a:solidFill>
+                <a:effectLst/>
+                <a:uLnTx/>
+                <a:uFillTx/>
+                <a:latin typeface="Arial" charset="0"/>
+                <a:ea typeface="+mn-ea"/>
+                <a:cs typeface="Arial" charset="0"/>
+              </a:rPr>
+              <a:t>The agenda is also available on the tutorial web page.  Visit </a:t>
+            </a:r>
+            <a:r>
+              <a:rPr kumimoji="0" lang="en-US" sz="1800" b="1" i="0" u="none" strike="noStrike" kern="1200" cap="none" spc="0" normalizeH="0" baseline="0" noProof="0" dirty="0">
+                <a:ln>
+                  <a:noFill/>
+                </a:ln>
+                <a:solidFill>
+                  <a:prstClr val="black"/>
+                </a:solidFill>
+                <a:effectLst/>
+                <a:uLnTx/>
+                <a:uFillTx/>
+                <a:latin typeface="Arial" charset="0"/>
+                <a:ea typeface="+mn-ea"/>
+                <a:cs typeface="Arial" charset="0"/>
+                <a:hlinkClick r:id="rId2"/>
+              </a:rPr>
+              <a:t>https://bssw-tutorial.github.io</a:t>
+            </a:r>
+            <a:r>
+              <a:rPr kumimoji="0" lang="en-US" sz="1800" b="1" i="0" u="none" strike="noStrike" kern="1200" cap="none" spc="0" normalizeH="0" baseline="0" noProof="0" dirty="0">
+                <a:ln>
+                  <a:noFill/>
+                </a:ln>
+                <a:solidFill>
+                  <a:prstClr val="black"/>
+                </a:solidFill>
+                <a:effectLst/>
+                <a:uLnTx/>
+                <a:uFillTx/>
+                <a:latin typeface="Arial" charset="0"/>
+                <a:ea typeface="+mn-ea"/>
+                <a:cs typeface="Arial" charset="0"/>
+              </a:rPr>
+              <a:t> </a:t>
+            </a:r>
+            <a:r>
+              <a:rPr kumimoji="0" lang="en-US" sz="1800" b="0" i="0" u="none" strike="noStrike" kern="1200" cap="none" spc="0" normalizeH="0" baseline="0" noProof="0" dirty="0">
+                <a:ln>
+                  <a:noFill/>
+                </a:ln>
+                <a:solidFill>
+                  <a:prstClr val="black"/>
+                </a:solidFill>
+                <a:effectLst/>
+                <a:uLnTx/>
+                <a:uFillTx/>
+                <a:latin typeface="Arial" charset="0"/>
+                <a:ea typeface="+mn-ea"/>
+                <a:cs typeface="Arial" charset="0"/>
+              </a:rPr>
+              <a:t>and click on the link for today’s tutorial</a:t>
+            </a:r>
+          </a:p>
+        </p:txBody>
+      </p:sp>
+    </p:spTree>
+    <p:extLst>
+      <p:ext uri="{BB962C8B-B14F-4D97-AF65-F5344CB8AC3E}">
+        <p14:creationId xmlns:p14="http://schemas.microsoft.com/office/powerpoint/2010/main" val="3643219827"/>
       </p:ext>
     </p:extLst>
   </p:cSld>
@@ -8937,6 +8776,21 @@
 </file>
 
 <file path=customXml/item1.xml><?xml version="1.0" encoding="utf-8"?>
+<p:properties xmlns:p="http://schemas.microsoft.com/office/2006/metadata/properties" xmlns:xsi="http://www.w3.org/2001/XMLSchema-instance" xmlns:pc="http://schemas.microsoft.com/office/infopath/2007/PartnerControls">
+  <documentManagement/>
+</p:properties>
+</file>
+
+<file path=customXml/item2.xml><?xml version="1.0" encoding="utf-8"?>
+<?mso-contentType ?>
+<FormTemplates xmlns="http://schemas.microsoft.com/sharepoint/v3/contenttype/forms">
+  <Display>DocumentLibraryForm</Display>
+  <Edit>DocumentLibraryForm</Edit>
+  <New>DocumentLibraryForm</New>
+</FormTemplates>
+</file>
+
+<file path=customXml/item3.xml><?xml version="1.0" encoding="utf-8"?>
 <ct:contentTypeSchema xmlns:ct="http://schemas.microsoft.com/office/2006/metadata/contentType" xmlns:ma="http://schemas.microsoft.com/office/2006/metadata/properties/metaAttributes" ct:_="" ma:_="" ma:contentTypeName="Document" ma:contentTypeID="0x010100565464437F680748A68B85EB6594EA7D" ma:contentTypeVersion="0" ma:contentTypeDescription="Create a new document." ma:contentTypeScope="" ma:versionID="fe3f4dd58d5914c51cfc6deaa8ad845c">
   <xsd:schema xmlns:xsd="http://www.w3.org/2001/XMLSchema" xmlns:p="http://schemas.microsoft.com/office/2006/metadata/properties" targetNamespace="http://schemas.microsoft.com/office/2006/metadata/properties" ma:root="true" ma:fieldsID="4aeb20c0e3442673af7ee10786458764">
     <xsd:element name="properties">
@@ -8985,32 +8839,17 @@
 </ct:contentTypeSchema>
 </file>
 
-<file path=customXml/item2.xml><?xml version="1.0" encoding="utf-8"?>
-<?mso-contentType ?>
-<FormTemplates xmlns="http://schemas.microsoft.com/sharepoint/v3/contenttype/forms">
-  <Display>DocumentLibraryForm</Display>
-  <Edit>DocumentLibraryForm</Edit>
-  <New>DocumentLibraryForm</New>
-</FormTemplates>
-</file>
-
-<file path=customXml/item3.xml><?xml version="1.0" encoding="utf-8"?>
-<p:properties xmlns:p="http://schemas.microsoft.com/office/2006/metadata/properties" xmlns:xsi="http://www.w3.org/2001/XMLSchema-instance" xmlns:pc="http://schemas.microsoft.com/office/infopath/2007/PartnerControls">
-  <documentManagement/>
-</p:properties>
-</file>
-
 <file path=customXml/itemProps1.xml><?xml version="1.0" encoding="utf-8"?>
-<ds:datastoreItem xmlns:ds="http://schemas.openxmlformats.org/officeDocument/2006/customXml" ds:itemID="{E8DB7DEB-074E-4EE8-9B6E-FD277323109C}">
+<ds:datastoreItem xmlns:ds="http://schemas.openxmlformats.org/officeDocument/2006/customXml" ds:itemID="{A50EC660-24D0-43A0-AE5E-E274115E726B}">
   <ds:schemaRefs>
-    <ds:schemaRef ds:uri="http://schemas.microsoft.com/office/2006/metadata/contentType"/>
-    <ds:schemaRef ds:uri="http://schemas.microsoft.com/office/2006/metadata/properties/metaAttributes"/>
-    <ds:schemaRef ds:uri="http://www.w3.org/2001/XMLSchema"/>
+    <ds:schemaRef ds:uri="http://purl.org/dc/elements/1.1/"/>
     <ds:schemaRef ds:uri="http://schemas.microsoft.com/office/2006/metadata/properties"/>
+    <ds:schemaRef ds:uri="http://purl.org/dc/terms/"/>
     <ds:schemaRef ds:uri="http://schemas.openxmlformats.org/package/2006/metadata/core-properties"/>
-    <ds:schemaRef ds:uri="http://purl.org/dc/elements/1.1/"/>
-    <ds:schemaRef ds:uri="http://purl.org/dc/terms/"/>
-    <ds:schemaRef ds:uri="http://schemas.microsoft.com/office/internal/2005/internalDocumentation"/>
+    <ds:schemaRef ds:uri="http://schemas.microsoft.com/office/2006/documentManagement/types"/>
+    <ds:schemaRef ds:uri="http://www.w3.org/XML/1998/namespace"/>
+    <ds:schemaRef ds:uri="http://purl.org/dc/dcmitype/"/>
+    <ds:schemaRef ds:uri="http://schemas.microsoft.com/office/infopath/2007/PartnerControls"/>
   </ds:schemaRefs>
 </ds:datastoreItem>
 </file>
@@ -9024,16 +8863,16 @@
 </file>
 
 <file path=customXml/itemProps3.xml><?xml version="1.0" encoding="utf-8"?>
-<ds:datastoreItem xmlns:ds="http://schemas.openxmlformats.org/officeDocument/2006/customXml" ds:itemID="{A50EC660-24D0-43A0-AE5E-E274115E726B}">
+<ds:datastoreItem xmlns:ds="http://schemas.openxmlformats.org/officeDocument/2006/customXml" ds:itemID="{E8DB7DEB-074E-4EE8-9B6E-FD277323109C}">
   <ds:schemaRefs>
+    <ds:schemaRef ds:uri="http://schemas.microsoft.com/office/2006/metadata/contentType"/>
+    <ds:schemaRef ds:uri="http://schemas.microsoft.com/office/2006/metadata/properties/metaAttributes"/>
+    <ds:schemaRef ds:uri="http://www.w3.org/2001/XMLSchema"/>
+    <ds:schemaRef ds:uri="http://schemas.microsoft.com/office/2006/metadata/properties"/>
+    <ds:schemaRef ds:uri="http://schemas.openxmlformats.org/package/2006/metadata/core-properties"/>
     <ds:schemaRef ds:uri="http://purl.org/dc/elements/1.1/"/>
-    <ds:schemaRef ds:uri="http://schemas.microsoft.com/office/2006/metadata/properties"/>
     <ds:schemaRef ds:uri="http://purl.org/dc/terms/"/>
-    <ds:schemaRef ds:uri="http://schemas.openxmlformats.org/package/2006/metadata/core-properties"/>
-    <ds:schemaRef ds:uri="http://schemas.microsoft.com/office/2006/documentManagement/types"/>
-    <ds:schemaRef ds:uri="http://www.w3.org/XML/1998/namespace"/>
-    <ds:schemaRef ds:uri="http://purl.org/dc/dcmitype/"/>
-    <ds:schemaRef ds:uri="http://schemas.microsoft.com/office/infopath/2007/PartnerControls"/>
+    <ds:schemaRef ds:uri="http://schemas.microsoft.com/office/internal/2005/internalDocumentation"/>
   </ds:schemaRefs>
 </ds:datastoreItem>
 </file>
</xml_diff>

<commit_message>
Initial updates for SC25
</commit_message>
<xml_diff>
--- a/intro.pptx
+++ b/intro.pptx
@@ -5,14 +5,14 @@
     <p:sldMasterId id="2147483935" r:id="rId4"/>
   </p:sldMasterIdLst>
   <p:notesMasterIdLst>
-    <p:notesMasterId r:id="rId15"/>
+    <p:notesMasterId r:id="rId14"/>
   </p:notesMasterIdLst>
   <p:handoutMasterIdLst>
-    <p:handoutMasterId r:id="rId16"/>
+    <p:handoutMasterId r:id="rId15"/>
   </p:handoutMasterIdLst>
   <p:sldIdLst>
     <p:sldId id="617" r:id="rId5"/>
-    <p:sldId id="636" r:id="rId6"/>
+    <p:sldId id="320" r:id="rId6"/>
     <p:sldId id="308" r:id="rId7"/>
     <p:sldId id="324" r:id="rId8"/>
     <p:sldId id="329" r:id="rId9"/>
@@ -20,7 +20,6 @@
     <p:sldId id="622" r:id="rId11"/>
     <p:sldId id="616" r:id="rId12"/>
     <p:sldId id="624" r:id="rId13"/>
-    <p:sldId id="261" r:id="rId14"/>
   </p:sldIdLst>
   <p:sldSz cx="12188825" cy="6858000"/>
   <p:notesSz cx="7010400" cy="9296400"/>
@@ -264,7 +263,7 @@
           <a:p>
             <a:fld id="{0B842F42-2CE9-4E35-95C1-410DC08A50B1}" type="datetimeFigureOut">
               <a:rPr lang="en-US" smtClean="0"/>
-              <a:t>8/5/2025</a:t>
+              <a:t>10/19/2025</a:t>
             </a:fld>
             <a:endParaRPr lang="en-US"/>
           </a:p>
@@ -429,7 +428,7 @@
           <a:p>
             <a:fld id="{6F282904-F315-4730-8D91-37D99E141A6F}" type="datetimeFigureOut">
               <a:rPr lang="en-US" smtClean="0"/>
-              <a:t>8/5/2025</a:t>
+              <a:t>10/18/2025</a:t>
             </a:fld>
             <a:endParaRPr lang="en-US"/>
           </a:p>
@@ -4311,7 +4310,7 @@
             </a:pPr>
             <a:r>
               <a:rPr lang="en-US" dirty="0"/>
-              <a:t>Software Sustainability </a:t>
+              <a:t>Better Software for Reproducible Science </a:t>
             </a:r>
           </a:p>
         </p:txBody>
@@ -4344,7 +4343,7 @@
           <a:p>
             <a:r>
               <a:rPr lang="en-US" dirty="0"/>
-              <a:t>David E. Bernholdt, Anshu Dubey, and Todd Gamblin</a:t>
+              <a:t>David E. Bernholdt, Anshu Dubey</a:t>
             </a:r>
           </a:p>
           <a:p>
@@ -4354,15 +4353,16 @@
               </a:spcBef>
             </a:pPr>
             <a:r>
-              <a:rPr lang="en-US" sz="2000" b="0" i="0" dirty="0">
-                <a:solidFill>
-                  <a:srgbClr val="111111"/>
-                </a:solidFill>
-                <a:effectLst/>
-                <a:latin typeface="+mn-lt"/>
-              </a:rPr>
-              <a:t>Argonne Training Program on Extreme-Scale Computing summer school (2025)</a:t>
-            </a:r>
+              <a:rPr lang="en-US" sz="2000" dirty="0"/>
+              <a:t>The International Conference for High-Performance Computing, Networking, Storage, and Analysis (SC25) conference</a:t>
+            </a:r>
+            <a:endParaRPr lang="en-US" sz="1600" b="0" i="0" dirty="0">
+              <a:solidFill>
+                <a:srgbClr val="111111"/>
+              </a:solidFill>
+              <a:effectLst/>
+              <a:latin typeface="+mn-lt"/>
+            </a:endParaRPr>
           </a:p>
         </p:txBody>
       </p:sp>
@@ -4429,720 +4429,6 @@
     <p:extLst>
       <p:ext uri="{BB962C8B-B14F-4D97-AF65-F5344CB8AC3E}">
         <p14:creationId xmlns:p14="http://schemas.microsoft.com/office/powerpoint/2010/main" val="2146778437"/>
-      </p:ext>
-    </p:extLst>
-  </p:cSld>
-  <p:clrMapOvr>
-    <a:masterClrMapping/>
-  </p:clrMapOvr>
-</p:sld>
-</file>
-
-<file path=ppt/slides/slide10.xml><?xml version="1.0" encoding="utf-8"?>
-<p:sld xmlns:a="http://schemas.openxmlformats.org/drawingml/2006/main" xmlns:r="http://schemas.openxmlformats.org/officeDocument/2006/relationships" xmlns:p="http://schemas.openxmlformats.org/presentationml/2006/main" showMasterSp="0">
-  <p:cSld>
-    <p:spTree>
-      <p:nvGrpSpPr>
-        <p:cNvPr id="1" name=""/>
-        <p:cNvGrpSpPr/>
-        <p:nvPr/>
-      </p:nvGrpSpPr>
-      <p:grpSpPr>
-        <a:xfrm>
-          <a:off x="0" y="0"/>
-          <a:ext cx="0" cy="0"/>
-          <a:chOff x="0" y="0"/>
-          <a:chExt cx="0" cy="0"/>
-        </a:xfrm>
-      </p:grpSpPr>
-      <p:sp>
-        <p:nvSpPr>
-          <p:cNvPr id="2" name="Title 1">
-            <a:extLst>
-              <a:ext uri="{FF2B5EF4-FFF2-40B4-BE49-F238E27FC236}">
-                <a16:creationId xmlns:a16="http://schemas.microsoft.com/office/drawing/2014/main" id="{1D6756EE-C2D9-4E52-B0B6-3C831FD6A565}"/>
-              </a:ext>
-            </a:extLst>
-          </p:cNvPr>
-          <p:cNvSpPr>
-            <a:spLocks noGrp="1"/>
-          </p:cNvSpPr>
-          <p:nvPr>
-            <p:ph type="title"/>
-          </p:nvPr>
-        </p:nvSpPr>
-        <p:spPr>
-          <a:xfrm>
-            <a:off x="408175" y="160020"/>
-            <a:ext cx="11372473" cy="914400"/>
-          </a:xfrm>
-        </p:spPr>
-        <p:txBody>
-          <a:bodyPr/>
-          <a:lstStyle/>
-          <a:p>
-            <a:r>
-              <a:rPr lang="en-US" dirty="0"/>
-              <a:t>Agenda (2/2)</a:t>
-            </a:r>
-          </a:p>
-        </p:txBody>
-      </p:sp>
-      <p:graphicFrame>
-        <p:nvGraphicFramePr>
-          <p:cNvPr id="6" name="Table 6">
-            <a:extLst>
-              <a:ext uri="{FF2B5EF4-FFF2-40B4-BE49-F238E27FC236}">
-                <a16:creationId xmlns:a16="http://schemas.microsoft.com/office/drawing/2014/main" id="{99D13FB2-5BF8-4AC0-A13D-ECB8E230F5BC}"/>
-              </a:ext>
-            </a:extLst>
-          </p:cNvPr>
-          <p:cNvGraphicFramePr>
-            <a:graphicFrameLocks noGrp="1"/>
-          </p:cNvGraphicFramePr>
-          <p:nvPr>
-            <p:ph idx="1"/>
-            <p:extLst>
-              <p:ext uri="{D42A27DB-BD31-4B8C-83A1-F6EECF244321}">
-                <p14:modId xmlns:p14="http://schemas.microsoft.com/office/powerpoint/2010/main" val="3725039992"/>
-              </p:ext>
-            </p:extLst>
-          </p:nvPr>
-        </p:nvGraphicFramePr>
-        <p:xfrm>
-          <a:off x="1051560" y="1074420"/>
-          <a:ext cx="9692640" cy="5164074"/>
-        </p:xfrm>
-        <a:graphic>
-          <a:graphicData uri="http://schemas.openxmlformats.org/drawingml/2006/table">
-            <a:tbl>
-              <a:tblPr firstRow="1" bandRow="1">
-                <a:tableStyleId>{5C22544A-7EE6-4342-B048-85BDC9FD1C3A}</a:tableStyleId>
-              </a:tblPr>
-              <a:tblGrid>
-                <a:gridCol w="1328947">
-                  <a:extLst>
-                    <a:ext uri="{9D8B030D-6E8A-4147-A177-3AD203B41FA5}">
-                      <a16:colId xmlns:a16="http://schemas.microsoft.com/office/drawing/2014/main" val="41390910"/>
-                    </a:ext>
-                  </a:extLst>
-                </a:gridCol>
-                <a:gridCol w="5033753">
-                  <a:extLst>
-                    <a:ext uri="{9D8B030D-6E8A-4147-A177-3AD203B41FA5}">
-                      <a16:colId xmlns:a16="http://schemas.microsoft.com/office/drawing/2014/main" val="2092910534"/>
-                    </a:ext>
-                  </a:extLst>
-                </a:gridCol>
-                <a:gridCol w="3329940">
-                  <a:extLst>
-                    <a:ext uri="{9D8B030D-6E8A-4147-A177-3AD203B41FA5}">
-                      <a16:colId xmlns:a16="http://schemas.microsoft.com/office/drawing/2014/main" val="1261297711"/>
-                    </a:ext>
-                  </a:extLst>
-                </a:gridCol>
-              </a:tblGrid>
-              <a:tr h="526542">
-                <a:tc>
-                  <a:txBody>
-                    <a:bodyPr/>
-                    <a:lstStyle/>
-                    <a:p>
-                      <a:pPr algn="r"/>
-                      <a:r>
-                        <a:rPr lang="en-US" sz="1800" dirty="0">
-                          <a:effectLst/>
-                        </a:rPr>
-                        <a:t>Time (CDT)</a:t>
-                      </a:r>
-                    </a:p>
-                  </a:txBody>
-                  <a:tcPr marL="142875" marR="142875" marT="95250" marB="95250" anchor="ctr"/>
-                </a:tc>
-                <a:tc>
-                  <a:txBody>
-                    <a:bodyPr/>
-                    <a:lstStyle/>
-                    <a:p>
-                      <a:pPr algn="l"/>
-                      <a:r>
-                        <a:rPr lang="en-US" sz="1800" dirty="0">
-                          <a:effectLst/>
-                        </a:rPr>
-                        <a:t>Title</a:t>
-                      </a:r>
-                    </a:p>
-                  </a:txBody>
-                  <a:tcPr marL="142875" marR="142875" marT="95250" marB="95250" anchor="ctr"/>
-                </a:tc>
-                <a:tc>
-                  <a:txBody>
-                    <a:bodyPr/>
-                    <a:lstStyle/>
-                    <a:p>
-                      <a:r>
-                        <a:rPr lang="en-US" sz="1800" dirty="0">
-                          <a:effectLst/>
-                        </a:rPr>
-                        <a:t>Presenter</a:t>
-                      </a:r>
-                    </a:p>
-                  </a:txBody>
-                  <a:tcPr marL="142875" marR="142875" marT="95250" marB="95250" anchor="ctr"/>
-                </a:tc>
-                <a:extLst>
-                  <a:ext uri="{0D108BD9-81ED-4DB2-BD59-A6C34878D82A}">
-                    <a16:rowId xmlns:a16="http://schemas.microsoft.com/office/drawing/2014/main" val="2098024418"/>
-                  </a:ext>
-                </a:extLst>
-              </a:tr>
-              <a:tr h="526542">
-                <a:tc>
-                  <a:txBody>
-                    <a:bodyPr/>
-                    <a:lstStyle/>
-                    <a:p>
-                      <a:pPr algn="r"/>
-                      <a:r>
-                        <a:rPr lang="en-US">
-                          <a:effectLst/>
-                        </a:rPr>
-                        <a:t>12:30 PM</a:t>
-                      </a:r>
-                    </a:p>
-                  </a:txBody>
-                  <a:tcPr marL="142875" marR="142875" marT="95250" marB="95250" anchor="ctr"/>
-                </a:tc>
-                <a:tc>
-                  <a:txBody>
-                    <a:bodyPr/>
-                    <a:lstStyle/>
-                    <a:p>
-                      <a:r>
-                        <a:rPr lang="en-US" i="1">
-                          <a:effectLst/>
-                        </a:rPr>
-                        <a:t>Lunch</a:t>
-                      </a:r>
-                      <a:endParaRPr lang="en-US">
-                        <a:effectLst/>
-                      </a:endParaRPr>
-                    </a:p>
-                  </a:txBody>
-                  <a:tcPr marL="142875" marR="142875" marT="95250" marB="95250" anchor="ctr"/>
-                </a:tc>
-                <a:tc>
-                  <a:txBody>
-                    <a:bodyPr/>
-                    <a:lstStyle/>
-                    <a:p>
-                      <a:endParaRPr lang="en-US" dirty="0">
-                        <a:effectLst/>
-                      </a:endParaRPr>
-                    </a:p>
-                  </a:txBody>
-                  <a:tcPr marL="142875" marR="142875" marT="95250" marB="95250" anchor="ctr"/>
-                </a:tc>
-                <a:extLst>
-                  <a:ext uri="{0D108BD9-81ED-4DB2-BD59-A6C34878D82A}">
-                    <a16:rowId xmlns:a16="http://schemas.microsoft.com/office/drawing/2014/main" val="1459939263"/>
-                  </a:ext>
-                </a:extLst>
-              </a:tr>
-              <a:tr h="526542">
-                <a:tc>
-                  <a:txBody>
-                    <a:bodyPr/>
-                    <a:lstStyle/>
-                    <a:p>
-                      <a:pPr algn="r"/>
-                      <a:r>
-                        <a:rPr lang="en-US">
-                          <a:effectLst/>
-                        </a:rPr>
-                        <a:t>1:30 PM</a:t>
-                      </a:r>
-                    </a:p>
-                  </a:txBody>
-                  <a:tcPr marL="142875" marR="142875" marT="95250" marB="95250" anchor="ctr"/>
-                </a:tc>
-                <a:tc>
-                  <a:txBody>
-                    <a:bodyPr/>
-                    <a:lstStyle/>
-                    <a:p>
-                      <a:r>
-                        <a:rPr lang="en-US">
-                          <a:effectLst/>
-                        </a:rPr>
-                        <a:t>Software Testing and Verification</a:t>
-                      </a:r>
-                    </a:p>
-                  </a:txBody>
-                  <a:tcPr marL="142875" marR="142875" marT="95250" marB="95250" anchor="ctr"/>
-                </a:tc>
-                <a:tc>
-                  <a:txBody>
-                    <a:bodyPr/>
-                    <a:lstStyle/>
-                    <a:p>
-                      <a:r>
-                        <a:rPr lang="en-US">
-                          <a:effectLst/>
-                        </a:rPr>
-                        <a:t>Anshu Dubey (ANL)</a:t>
-                      </a:r>
-                    </a:p>
-                  </a:txBody>
-                  <a:tcPr marL="142875" marR="142875" marT="95250" marB="95250" anchor="ctr"/>
-                </a:tc>
-                <a:extLst>
-                  <a:ext uri="{0D108BD9-81ED-4DB2-BD59-A6C34878D82A}">
-                    <a16:rowId xmlns:a16="http://schemas.microsoft.com/office/drawing/2014/main" val="568411987"/>
-                  </a:ext>
-                </a:extLst>
-              </a:tr>
-              <a:tr h="526542">
-                <a:tc>
-                  <a:txBody>
-                    <a:bodyPr/>
-                    <a:lstStyle/>
-                    <a:p>
-                      <a:pPr algn="r"/>
-                      <a:r>
-                        <a:rPr lang="en-US">
-                          <a:effectLst/>
-                        </a:rPr>
-                        <a:t>2:30 PM</a:t>
-                      </a:r>
-                    </a:p>
-                  </a:txBody>
-                  <a:tcPr marL="142875" marR="142875" marT="95250" marB="95250" anchor="ctr"/>
-                </a:tc>
-                <a:tc>
-                  <a:txBody>
-                    <a:bodyPr/>
-                    <a:lstStyle/>
-                    <a:p>
-                      <a:r>
-                        <a:rPr lang="en-US">
-                          <a:effectLst/>
-                        </a:rPr>
-                        <a:t>Refactoring Scientific Software</a:t>
-                      </a:r>
-                    </a:p>
-                  </a:txBody>
-                  <a:tcPr marL="142875" marR="142875" marT="95250" marB="95250" anchor="ctr"/>
-                </a:tc>
-                <a:tc>
-                  <a:txBody>
-                    <a:bodyPr/>
-                    <a:lstStyle/>
-                    <a:p>
-                      <a:r>
-                        <a:rPr lang="en-US">
-                          <a:effectLst/>
-                        </a:rPr>
-                        <a:t>Anshu Dubey (ANL)</a:t>
-                      </a:r>
-                    </a:p>
-                  </a:txBody>
-                  <a:tcPr marL="142875" marR="142875" marT="95250" marB="95250" anchor="ctr"/>
-                </a:tc>
-                <a:extLst>
-                  <a:ext uri="{0D108BD9-81ED-4DB2-BD59-A6C34878D82A}">
-                    <a16:rowId xmlns:a16="http://schemas.microsoft.com/office/drawing/2014/main" val="439333682"/>
-                  </a:ext>
-                </a:extLst>
-              </a:tr>
-              <a:tr h="526542">
-                <a:tc>
-                  <a:txBody>
-                    <a:bodyPr/>
-                    <a:lstStyle/>
-                    <a:p>
-                      <a:pPr algn="r"/>
-                      <a:r>
-                        <a:rPr lang="en-US">
-                          <a:effectLst/>
-                        </a:rPr>
-                        <a:t>3:00 PM</a:t>
-                      </a:r>
-                    </a:p>
-                  </a:txBody>
-                  <a:tcPr marL="142875" marR="142875" marT="95250" marB="95250" anchor="ctr"/>
-                </a:tc>
-                <a:tc>
-                  <a:txBody>
-                    <a:bodyPr/>
-                    <a:lstStyle/>
-                    <a:p>
-                      <a:r>
-                        <a:rPr lang="en-US" i="1">
-                          <a:effectLst/>
-                        </a:rPr>
-                        <a:t>Break</a:t>
-                      </a:r>
-                      <a:endParaRPr lang="en-US">
-                        <a:effectLst/>
-                      </a:endParaRPr>
-                    </a:p>
-                  </a:txBody>
-                  <a:tcPr marL="142875" marR="142875" marT="95250" marB="95250" anchor="ctr"/>
-                </a:tc>
-                <a:tc>
-                  <a:txBody>
-                    <a:bodyPr/>
-                    <a:lstStyle/>
-                    <a:p>
-                      <a:endParaRPr lang="en-US">
-                        <a:effectLst/>
-                      </a:endParaRPr>
-                    </a:p>
-                  </a:txBody>
-                  <a:tcPr marL="142875" marR="142875" marT="95250" marB="95250" anchor="ctr"/>
-                </a:tc>
-                <a:extLst>
-                  <a:ext uri="{0D108BD9-81ED-4DB2-BD59-A6C34878D82A}">
-                    <a16:rowId xmlns:a16="http://schemas.microsoft.com/office/drawing/2014/main" val="3500361090"/>
-                  </a:ext>
-                </a:extLst>
-              </a:tr>
-              <a:tr h="526542">
-                <a:tc>
-                  <a:txBody>
-                    <a:bodyPr/>
-                    <a:lstStyle/>
-                    <a:p>
-                      <a:pPr algn="r"/>
-                      <a:r>
-                        <a:rPr lang="en-US">
-                          <a:effectLst/>
-                        </a:rPr>
-                        <a:t>3:30 PM</a:t>
-                      </a:r>
-                    </a:p>
-                  </a:txBody>
-                  <a:tcPr marL="142875" marR="142875" marT="95250" marB="95250" anchor="ctr"/>
-                </a:tc>
-                <a:tc>
-                  <a:txBody>
-                    <a:bodyPr/>
-                    <a:lstStyle/>
-                    <a:p>
-                      <a:r>
-                        <a:rPr lang="en-US">
-                          <a:effectLst/>
-                        </a:rPr>
-                        <a:t>Software Licensing</a:t>
-                      </a:r>
-                    </a:p>
-                  </a:txBody>
-                  <a:tcPr marL="142875" marR="142875" marT="95250" marB="95250" anchor="ctr"/>
-                </a:tc>
-                <a:tc>
-                  <a:txBody>
-                    <a:bodyPr/>
-                    <a:lstStyle/>
-                    <a:p>
-                      <a:r>
-                        <a:rPr lang="en-US">
-                          <a:effectLst/>
-                        </a:rPr>
-                        <a:t>David E. Bernholdt (ORNL)</a:t>
-                      </a:r>
-                    </a:p>
-                  </a:txBody>
-                  <a:tcPr marL="142875" marR="142875" marT="95250" marB="95250" anchor="ctr"/>
-                </a:tc>
-                <a:extLst>
-                  <a:ext uri="{0D108BD9-81ED-4DB2-BD59-A6C34878D82A}">
-                    <a16:rowId xmlns:a16="http://schemas.microsoft.com/office/drawing/2014/main" val="1733344417"/>
-                  </a:ext>
-                </a:extLst>
-              </a:tr>
-              <a:tr h="526542">
-                <a:tc>
-                  <a:txBody>
-                    <a:bodyPr/>
-                    <a:lstStyle/>
-                    <a:p>
-                      <a:pPr algn="r"/>
-                      <a:r>
-                        <a:rPr lang="en-US">
-                          <a:effectLst/>
-                        </a:rPr>
-                        <a:t>4:15 PM</a:t>
-                      </a:r>
-                    </a:p>
-                  </a:txBody>
-                  <a:tcPr marL="142875" marR="142875" marT="95250" marB="95250" anchor="ctr"/>
-                </a:tc>
-                <a:tc>
-                  <a:txBody>
-                    <a:bodyPr/>
-                    <a:lstStyle/>
-                    <a:p>
-                      <a:r>
-                        <a:rPr lang="en-US">
-                          <a:effectLst/>
-                        </a:rPr>
-                        <a:t>Improving Reproducibility Through Better Software Practices</a:t>
-                      </a:r>
-                    </a:p>
-                  </a:txBody>
-                  <a:tcPr marL="142875" marR="142875" marT="95250" marB="95250" anchor="ctr"/>
-                </a:tc>
-                <a:tc>
-                  <a:txBody>
-                    <a:bodyPr/>
-                    <a:lstStyle/>
-                    <a:p>
-                      <a:r>
-                        <a:rPr lang="en-US">
-                          <a:effectLst/>
-                        </a:rPr>
-                        <a:t>David E. Bernholdt (ORNL)</a:t>
-                      </a:r>
-                    </a:p>
-                  </a:txBody>
-                  <a:tcPr marL="142875" marR="142875" marT="95250" marB="95250" anchor="ctr"/>
-                </a:tc>
-                <a:extLst>
-                  <a:ext uri="{0D108BD9-81ED-4DB2-BD59-A6C34878D82A}">
-                    <a16:rowId xmlns:a16="http://schemas.microsoft.com/office/drawing/2014/main" val="1855854553"/>
-                  </a:ext>
-                </a:extLst>
-              </a:tr>
-              <a:tr h="526542">
-                <a:tc>
-                  <a:txBody>
-                    <a:bodyPr/>
-                    <a:lstStyle/>
-                    <a:p>
-                      <a:pPr algn="r"/>
-                      <a:r>
-                        <a:rPr lang="en-US">
-                          <a:effectLst/>
-                        </a:rPr>
-                        <a:t>5:00 PM</a:t>
-                      </a:r>
-                    </a:p>
-                  </a:txBody>
-                  <a:tcPr marL="142875" marR="142875" marT="95250" marB="95250" anchor="ctr"/>
-                </a:tc>
-                <a:tc>
-                  <a:txBody>
-                    <a:bodyPr/>
-                    <a:lstStyle/>
-                    <a:p>
-                      <a:r>
-                        <a:rPr lang="en-US" i="1">
-                          <a:effectLst/>
-                        </a:rPr>
-                        <a:t>Final Exam</a:t>
-                      </a:r>
-                      <a:endParaRPr lang="en-US">
-                        <a:effectLst/>
-                      </a:endParaRPr>
-                    </a:p>
-                  </a:txBody>
-                  <a:tcPr marL="142875" marR="142875" marT="95250" marB="95250" anchor="ctr"/>
-                </a:tc>
-                <a:tc>
-                  <a:txBody>
-                    <a:bodyPr/>
-                    <a:lstStyle/>
-                    <a:p>
-                      <a:endParaRPr lang="en-US">
-                        <a:effectLst/>
-                      </a:endParaRPr>
-                    </a:p>
-                  </a:txBody>
-                  <a:tcPr marL="142875" marR="142875" marT="95250" marB="95250" anchor="ctr"/>
-                </a:tc>
-                <a:extLst>
-                  <a:ext uri="{0D108BD9-81ED-4DB2-BD59-A6C34878D82A}">
-                    <a16:rowId xmlns:a16="http://schemas.microsoft.com/office/drawing/2014/main" val="2122309219"/>
-                  </a:ext>
-                </a:extLst>
-              </a:tr>
-              <a:tr h="526542">
-                <a:tc>
-                  <a:txBody>
-                    <a:bodyPr/>
-                    <a:lstStyle/>
-                    <a:p>
-                      <a:pPr algn="r"/>
-                      <a:r>
-                        <a:rPr lang="en-US">
-                          <a:effectLst/>
-                        </a:rPr>
-                        <a:t>6:00 PM</a:t>
-                      </a:r>
-                    </a:p>
-                  </a:txBody>
-                  <a:tcPr marL="142875" marR="142875" marT="95250" marB="95250" anchor="ctr"/>
-                </a:tc>
-                <a:tc>
-                  <a:txBody>
-                    <a:bodyPr/>
-                    <a:lstStyle/>
-                    <a:p>
-                      <a:r>
-                        <a:rPr lang="en-US" i="1">
-                          <a:effectLst/>
-                        </a:rPr>
-                        <a:t>Adjourn</a:t>
-                      </a:r>
-                      <a:endParaRPr lang="en-US">
-                        <a:effectLst/>
-                      </a:endParaRPr>
-                    </a:p>
-                  </a:txBody>
-                  <a:tcPr marL="142875" marR="142875" marT="95250" marB="95250" anchor="ctr"/>
-                </a:tc>
-                <a:tc>
-                  <a:txBody>
-                    <a:bodyPr/>
-                    <a:lstStyle/>
-                    <a:p>
-                      <a:endParaRPr lang="en-US" dirty="0"/>
-                    </a:p>
-                  </a:txBody>
-                  <a:tcPr/>
-                </a:tc>
-                <a:extLst>
-                  <a:ext uri="{0D108BD9-81ED-4DB2-BD59-A6C34878D82A}">
-                    <a16:rowId xmlns:a16="http://schemas.microsoft.com/office/drawing/2014/main" val="3774671062"/>
-                  </a:ext>
-                </a:extLst>
-              </a:tr>
-            </a:tbl>
-          </a:graphicData>
-        </a:graphic>
-      </p:graphicFrame>
-      <p:sp>
-        <p:nvSpPr>
-          <p:cNvPr id="9" name="TextBox 8">
-            <a:extLst>
-              <a:ext uri="{FF2B5EF4-FFF2-40B4-BE49-F238E27FC236}">
-                <a16:creationId xmlns:a16="http://schemas.microsoft.com/office/drawing/2014/main" id="{2C67F121-FA5A-4323-B777-FC3438185944}"/>
-              </a:ext>
-            </a:extLst>
-          </p:cNvPr>
-          <p:cNvSpPr txBox="1"/>
-          <p:nvPr/>
-        </p:nvSpPr>
-        <p:spPr>
-          <a:xfrm>
-            <a:off x="4537710" y="45720"/>
-            <a:ext cx="7651115" cy="646331"/>
-          </a:xfrm>
-          <a:prstGeom prst="rect">
-            <a:avLst/>
-          </a:prstGeom>
-          <a:noFill/>
-        </p:spPr>
-        <p:txBody>
-          <a:bodyPr wrap="square">
-            <a:spAutoFit/>
-          </a:bodyPr>
-          <a:lstStyle/>
-          <a:p>
-            <a:pPr marL="0" marR="0" lvl="0" indent="0" algn="l" defTabSz="914400" rtl="0" eaLnBrk="1" fontAlgn="base" latinLnBrk="0" hangingPunct="1">
-              <a:lnSpc>
-                <a:spcPct val="100000"/>
-              </a:lnSpc>
-              <a:spcBef>
-                <a:spcPct val="0"/>
-              </a:spcBef>
-              <a:spcAft>
-                <a:spcPct val="0"/>
-              </a:spcAft>
-              <a:buClrTx/>
-              <a:buSzTx/>
-              <a:buFontTx/>
-              <a:buNone/>
-              <a:tabLst/>
-              <a:defRPr/>
-            </a:pPr>
-            <a:r>
-              <a:rPr kumimoji="0" lang="en-US" sz="1800" b="0" i="0" u="none" strike="noStrike" kern="1200" cap="none" spc="0" normalizeH="0" baseline="0" noProof="0" dirty="0">
-                <a:ln>
-                  <a:noFill/>
-                </a:ln>
-                <a:solidFill>
-                  <a:prstClr val="black"/>
-                </a:solidFill>
-                <a:effectLst/>
-                <a:uLnTx/>
-                <a:uFillTx/>
-                <a:latin typeface="Arial" charset="0"/>
-                <a:ea typeface="+mn-ea"/>
-                <a:cs typeface="Arial" charset="0"/>
-              </a:rPr>
-              <a:t>The agenda is also available on the tutorial web page.  Visit </a:t>
-            </a:r>
-            <a:r>
-              <a:rPr kumimoji="0" lang="en-US" sz="1800" b="1" i="0" u="none" strike="noStrike" kern="1200" cap="none" spc="0" normalizeH="0" baseline="0" noProof="0" dirty="0">
-                <a:ln>
-                  <a:noFill/>
-                </a:ln>
-                <a:solidFill>
-                  <a:prstClr val="black"/>
-                </a:solidFill>
-                <a:effectLst/>
-                <a:uLnTx/>
-                <a:uFillTx/>
-                <a:latin typeface="Arial" charset="0"/>
-                <a:ea typeface="+mn-ea"/>
-                <a:cs typeface="Arial" charset="0"/>
-                <a:hlinkClick r:id="rId2"/>
-              </a:rPr>
-              <a:t>https://bssw-tutorial.github.io</a:t>
-            </a:r>
-            <a:r>
-              <a:rPr kumimoji="0" lang="en-US" sz="1800" b="1" i="0" u="none" strike="noStrike" kern="1200" cap="none" spc="0" normalizeH="0" baseline="0" noProof="0" dirty="0">
-                <a:ln>
-                  <a:noFill/>
-                </a:ln>
-                <a:solidFill>
-                  <a:prstClr val="black"/>
-                </a:solidFill>
-                <a:effectLst/>
-                <a:uLnTx/>
-                <a:uFillTx/>
-                <a:latin typeface="Arial" charset="0"/>
-                <a:ea typeface="+mn-ea"/>
-                <a:cs typeface="Arial" charset="0"/>
-              </a:rPr>
-              <a:t> </a:t>
-            </a:r>
-            <a:r>
-              <a:rPr kumimoji="0" lang="en-US" sz="1800" b="0" i="0" u="none" strike="noStrike" kern="1200" cap="none" spc="0" normalizeH="0" baseline="0" noProof="0" dirty="0">
-                <a:ln>
-                  <a:noFill/>
-                </a:ln>
-                <a:solidFill>
-                  <a:prstClr val="black"/>
-                </a:solidFill>
-                <a:effectLst/>
-                <a:uLnTx/>
-                <a:uFillTx/>
-                <a:latin typeface="Arial" charset="0"/>
-                <a:ea typeface="+mn-ea"/>
-                <a:cs typeface="Arial" charset="0"/>
-              </a:rPr>
-              <a:t>and click on the link for today’s tutorial</a:t>
-            </a:r>
-          </a:p>
-        </p:txBody>
-      </p:sp>
-    </p:spTree>
-    <p:extLst>
-      <p:ext uri="{BB962C8B-B14F-4D97-AF65-F5344CB8AC3E}">
-        <p14:creationId xmlns:p14="http://schemas.microsoft.com/office/powerpoint/2010/main" val="19783333"/>
       </p:ext>
     </p:extLst>
   </p:cSld>
@@ -5187,7 +4473,7 @@
         </p:nvSpPr>
         <p:spPr>
           <a:xfrm>
-            <a:off x="363096" y="112911"/>
+            <a:off x="363096" y="417709"/>
             <a:ext cx="11372473" cy="914400"/>
           </a:xfrm>
         </p:spPr>
@@ -5220,7 +4506,7 @@
         </p:nvSpPr>
         <p:spPr>
           <a:xfrm>
-            <a:off x="409507" y="570111"/>
+            <a:off x="409507" y="874909"/>
             <a:ext cx="11369809" cy="4047778"/>
           </a:xfrm>
         </p:spPr>
@@ -5275,13 +4561,13 @@
             </a:r>
             <a:r>
               <a:rPr lang="en-US" sz="1600" dirty="0"/>
-              <a:t>Anshu Dubey, David E. Bernholdt, and Todd Gamblin, Software Sustainability track, in Argonne Training Program on Extreme-Scale Computing, St. Charles, Illinois, 2025. DOI: </a:t>
+              <a:t>David E. Bernholdt and Anshu Dubey, Better Software for Reproducible Science tutorial, in The International Conference for High-Performance Computing, Networking, Storage, and Analysis (SC25), St. Louis, Missouri, 2025. DOI: </a:t>
             </a:r>
             <a:r>
               <a:rPr lang="en-US" sz="1600" dirty="0">
                 <a:hlinkClick r:id="rId4"/>
               </a:rPr>
-              <a:t>10.6084/m9.figshare.29816981</a:t>
+              <a:t>10.6084/m9.figshare.30394186</a:t>
             </a:r>
             <a:r>
               <a:rPr lang="en-US" sz="1600" dirty="0"/>
@@ -5476,7 +4762,7 @@
     </p:spTree>
     <p:extLst>
       <p:ext uri="{BB962C8B-B14F-4D97-AF65-F5344CB8AC3E}">
-        <p14:creationId xmlns:p14="http://schemas.microsoft.com/office/powerpoint/2010/main" val="978726433"/>
+        <p14:creationId xmlns:p14="http://schemas.microsoft.com/office/powerpoint/2010/main" val="2979228385"/>
       </p:ext>
     </p:extLst>
   </p:cSld>
@@ -5550,17 +4836,6 @@
               <a:t>Anshu Dubey, ANL</a:t>
             </a:r>
           </a:p>
-          <a:p>
-            <a:pPr>
-              <a:spcBef>
-                <a:spcPts val="1000"/>
-              </a:spcBef>
-            </a:pPr>
-            <a:r>
-              <a:rPr lang="en-US" dirty="0"/>
-              <a:t>Todd Gamblin, LLNL</a:t>
-            </a:r>
-          </a:p>
         </p:txBody>
       </p:sp>
       <p:sp>
@@ -5606,7 +4881,7 @@
         <p:spPr>
           <a:xfrm>
             <a:off x="453256" y="3373816"/>
-            <a:ext cx="10123321" cy="3016210"/>
+            <a:ext cx="10123321" cy="2631490"/>
           </a:xfrm>
           <a:prstGeom prst="rect">
             <a:avLst/>
@@ -5681,29 +4956,6 @@
             </a:pPr>
             <a:r>
               <a:rPr lang="en-US" sz="2000" dirty="0"/>
-              <a:t>Lead for the Spack project: </a:t>
-            </a:r>
-            <a:r>
-              <a:rPr lang="en-US" sz="2000" dirty="0">
-                <a:hlinkClick r:id="rId5"/>
-              </a:rPr>
-              <a:t>https://spack.io/</a:t>
-            </a:r>
-            <a:r>
-              <a:rPr lang="en-US" sz="2000" dirty="0"/>
-              <a:t> (Todd)</a:t>
-            </a:r>
-          </a:p>
-          <a:p>
-            <a:pPr marL="227013" indent="-227013">
-              <a:spcBef>
-                <a:spcPts val="600"/>
-              </a:spcBef>
-              <a:buFont typeface="Arial" panose="020B0604020202020204" pitchFamily="34" charset="0"/>
-              <a:buChar char="•"/>
-            </a:pPr>
-            <a:r>
-              <a:rPr lang="en-US" sz="2000" dirty="0"/>
               <a:t>Past involvement in</a:t>
             </a:r>
           </a:p>
@@ -5734,7 +4986,7 @@
             </a:r>
             <a:r>
               <a:rPr lang="en-US" sz="2000" dirty="0">
-                <a:hlinkClick r:id="rId6"/>
+                <a:hlinkClick r:id="rId5"/>
               </a:rPr>
               <a:t>https://ideas-productivity.org/</a:t>
             </a:r>
@@ -5769,7 +5021,7 @@
         </p:nvGrpSpPr>
         <p:grpSpPr>
           <a:xfrm>
-            <a:off x="8009031" y="1325880"/>
+            <a:off x="9515196" y="1325880"/>
             <a:ext cx="954107" cy="1805497"/>
             <a:chOff x="6614147" y="1346049"/>
             <a:chExt cx="954107" cy="1805497"/>
@@ -5841,7 +5093,7 @@
             <p:nvPr/>
           </p:nvPicPr>
           <p:blipFill>
-            <a:blip r:embed="rId7" cstate="print">
+            <a:blip r:embed="rId6" cstate="print">
               <a:extLst>
                 <a:ext uri="{28A0092B-C50C-407E-A947-70E740481C1C}">
                   <a14:useLocalDpi xmlns:a14="http://schemas.microsoft.com/office/drawing/2010/main" val="0"/>
@@ -5877,7 +5129,7 @@
         </p:nvGrpSpPr>
         <p:grpSpPr>
           <a:xfrm>
-            <a:off x="6393437" y="1325880"/>
+            <a:off x="7899602" y="1325880"/>
             <a:ext cx="1038027" cy="1797939"/>
             <a:chOff x="4187619" y="4211394"/>
             <a:chExt cx="1038027" cy="1797939"/>
@@ -5898,7 +5150,7 @@
             <p:nvPr/>
           </p:nvPicPr>
           <p:blipFill rotWithShape="1">
-            <a:blip r:embed="rId8" cstate="print">
+            <a:blip r:embed="rId7" cstate="print">
               <a:extLst>
                 <a:ext uri="{28A0092B-C50C-407E-A947-70E740481C1C}">
                   <a14:useLocalDpi xmlns:a14="http://schemas.microsoft.com/office/drawing/2010/main" val="0"/>
@@ -5954,113 +5206,6 @@
               <a:r>
                 <a:rPr lang="en-US" dirty="0"/>
                 <a:t>David</a:t>
-              </a:r>
-            </a:p>
-            <a:p>
-              <a:pPr algn="ctr">
-                <a:lnSpc>
-                  <a:spcPct val="90000"/>
-                </a:lnSpc>
-              </a:pPr>
-              <a:r>
-                <a:rPr lang="en-US" i="1" dirty="0"/>
-                <a:t>he/him</a:t>
-              </a:r>
-            </a:p>
-          </p:txBody>
-        </p:sp>
-      </p:grpSp>
-      <p:grpSp>
-        <p:nvGrpSpPr>
-          <p:cNvPr id="17" name="Group 16">
-            <a:extLst>
-              <a:ext uri="{FF2B5EF4-FFF2-40B4-BE49-F238E27FC236}">
-                <a16:creationId xmlns:a16="http://schemas.microsoft.com/office/drawing/2014/main" id="{B5FBC002-EA63-3AA1-A9F0-19BC36D2DD4E}"/>
-              </a:ext>
-            </a:extLst>
-          </p:cNvPr>
-          <p:cNvGrpSpPr/>
-          <p:nvPr/>
-        </p:nvGrpSpPr>
-        <p:grpSpPr>
-          <a:xfrm>
-            <a:off x="9554696" y="1338556"/>
-            <a:ext cx="1021881" cy="1792821"/>
-            <a:chOff x="10957831" y="1197414"/>
-            <a:chExt cx="1021881" cy="1792821"/>
-          </a:xfrm>
-        </p:grpSpPr>
-        <p:pic>
-          <p:nvPicPr>
-            <p:cNvPr id="18" name="Picture 17" descr="A person smiling for the camera&#10;&#10;Description automatically generated with medium confidence">
-              <a:extLst>
-                <a:ext uri="{FF2B5EF4-FFF2-40B4-BE49-F238E27FC236}">
-                  <a16:creationId xmlns:a16="http://schemas.microsoft.com/office/drawing/2014/main" id="{C611DBA7-7F94-A867-D486-31027D33AC75}"/>
-                </a:ext>
-              </a:extLst>
-            </p:cNvPr>
-            <p:cNvPicPr>
-              <a:picLocks noChangeAspect="1"/>
-            </p:cNvPicPr>
-            <p:nvPr/>
-          </p:nvPicPr>
-          <p:blipFill rotWithShape="1">
-            <a:blip r:embed="rId9" cstate="print">
-              <a:extLst>
-                <a:ext uri="{28A0092B-C50C-407E-A947-70E740481C1C}">
-                  <a14:useLocalDpi xmlns:a14="http://schemas.microsoft.com/office/drawing/2010/main" val="0"/>
-                </a:ext>
-              </a:extLst>
-            </a:blip>
-            <a:srcRect l="6373" r="8964"/>
-            <a:stretch/>
-          </p:blipFill>
-          <p:spPr>
-            <a:xfrm>
-              <a:off x="10957831" y="1197414"/>
-              <a:ext cx="1021881" cy="1207008"/>
-            </a:xfrm>
-            <a:prstGeom prst="rect">
-              <a:avLst/>
-            </a:prstGeom>
-          </p:spPr>
-        </p:pic>
-        <p:sp>
-          <p:nvSpPr>
-            <p:cNvPr id="19" name="TextBox 18">
-              <a:extLst>
-                <a:ext uri="{FF2B5EF4-FFF2-40B4-BE49-F238E27FC236}">
-                  <a16:creationId xmlns:a16="http://schemas.microsoft.com/office/drawing/2014/main" id="{0EFE8AB9-C901-D587-26CA-192E0897B099}"/>
-                </a:ext>
-              </a:extLst>
-            </p:cNvPr>
-            <p:cNvSpPr txBox="1"/>
-            <p:nvPr/>
-          </p:nvSpPr>
-          <p:spPr>
-            <a:xfrm>
-              <a:off x="11030189" y="2399304"/>
-              <a:ext cx="877164" cy="590931"/>
-            </a:xfrm>
-            <a:prstGeom prst="rect">
-              <a:avLst/>
-            </a:prstGeom>
-            <a:noFill/>
-          </p:spPr>
-          <p:txBody>
-            <a:bodyPr wrap="none" rtlCol="0">
-              <a:spAutoFit/>
-            </a:bodyPr>
-            <a:lstStyle/>
-            <a:p>
-              <a:pPr algn="ctr">
-                <a:lnSpc>
-                  <a:spcPct val="90000"/>
-                </a:lnSpc>
-              </a:pPr>
-              <a:r>
-                <a:rPr lang="en-US" dirty="0"/>
-                <a:t>Todd</a:t>
               </a:r>
             </a:p>
             <a:p>
@@ -7283,6 +6428,72 @@
           </a:p>
         </p:txBody>
       </p:sp>
+      <p:sp>
+        <p:nvSpPr>
+          <p:cNvPr id="4" name="TextBox 3">
+            <a:extLst>
+              <a:ext uri="{FF2B5EF4-FFF2-40B4-BE49-F238E27FC236}">
+                <a16:creationId xmlns:a16="http://schemas.microsoft.com/office/drawing/2014/main" id="{6067EE83-B4F9-019B-E0E8-E80C48D26F36}"/>
+              </a:ext>
+            </a:extLst>
+          </p:cNvPr>
+          <p:cNvSpPr txBox="1"/>
+          <p:nvPr/>
+        </p:nvSpPr>
+        <p:spPr>
+          <a:xfrm>
+            <a:off x="3361713" y="4561262"/>
+            <a:ext cx="5465397" cy="1846659"/>
+          </a:xfrm>
+          <a:prstGeom prst="rect">
+            <a:avLst/>
+          </a:prstGeom>
+          <a:solidFill>
+            <a:srgbClr val="FFFF00"/>
+          </a:solidFill>
+          <a:ln>
+            <a:solidFill>
+              <a:schemeClr val="tx1"/>
+            </a:solidFill>
+          </a:ln>
+        </p:spPr>
+        <p:txBody>
+          <a:bodyPr wrap="square" lIns="118872" tIns="91440" rIns="118872" bIns="91440" rtlCol="0" anchor="ctr" anchorCtr="0">
+            <a:spAutoFit/>
+          </a:bodyPr>
+          <a:lstStyle/>
+          <a:p>
+            <a:pPr algn="ctr">
+              <a:lnSpc>
+                <a:spcPct val="90000"/>
+              </a:lnSpc>
+            </a:pPr>
+            <a:r>
+              <a:rPr lang="en-US" sz="2400" dirty="0"/>
+              <a:t>You may also be interested in these other software-related events at SC25: </a:t>
+            </a:r>
+            <a:r>
+              <a:rPr lang="en-US" sz="2400" dirty="0">
+                <a:hlinkClick r:id="rId4"/>
+              </a:rPr>
+              <a:t>https://bssw.io/events/sc25-software-related-events </a:t>
+            </a:r>
+            <a:endParaRPr lang="en-US" sz="2400" dirty="0"/>
+          </a:p>
+          <a:p>
+            <a:pPr algn="ctr">
+              <a:lnSpc>
+                <a:spcPct val="90000"/>
+              </a:lnSpc>
+            </a:pPr>
+            <a:r>
+              <a:rPr lang="en-US" dirty="0"/>
+              <a:t>(link is also on tutorial web page)</a:t>
+            </a:r>
+            <a:endParaRPr lang="en-US" sz="2400" dirty="0"/>
+          </a:p>
+        </p:txBody>
+      </p:sp>
     </p:spTree>
     <p:extLst>
       <p:ext uri="{BB962C8B-B14F-4D97-AF65-F5344CB8AC3E}">
@@ -7341,7 +6552,7 @@
           <a:p>
             <a:r>
               <a:rPr lang="en-US" dirty="0"/>
-              <a:t>Agenda (1/2)</a:t>
+              <a:t>Agenda</a:t>
             </a:r>
           </a:p>
         </p:txBody>
@@ -7362,14 +6573,14 @@
             <p:ph idx="1"/>
             <p:extLst>
               <p:ext uri="{D42A27DB-BD31-4B8C-83A1-F6EECF244321}">
-                <p14:modId xmlns:p14="http://schemas.microsoft.com/office/powerpoint/2010/main" val="3435222980"/>
+                <p14:modId xmlns:p14="http://schemas.microsoft.com/office/powerpoint/2010/main" val="3590364095"/>
               </p:ext>
             </p:extLst>
           </p:nvPr>
         </p:nvGraphicFramePr>
         <p:xfrm>
           <a:off x="1051560" y="1074420"/>
-          <a:ext cx="9692640" cy="4637532"/>
+          <a:ext cx="9692640" cy="4323588"/>
         </p:xfrm>
         <a:graphic>
           <a:graphicData uri="http://schemas.openxmlformats.org/drawingml/2006/table">
@@ -7460,7 +6671,9 @@
                     <a:bodyPr/>
                     <a:lstStyle/>
                     <a:p>
-                      <a:pPr algn="r"/>
+                      <a:pPr algn="r">
+                        <a:buNone/>
+                      </a:pPr>
                       <a:r>
                         <a:rPr lang="en-US">
                           <a:effectLst/>
@@ -7476,6 +6689,9 @@
                     <a:bodyPr/>
                     <a:lstStyle/>
                     <a:p>
+                      <a:pPr>
+                        <a:buNone/>
+                      </a:pPr>
                       <a:r>
                         <a:rPr lang="en-US">
                           <a:effectLst/>
@@ -7491,61 +6707,11 @@
                     <a:bodyPr/>
                     <a:lstStyle/>
                     <a:p>
+                      <a:pPr>
+                        <a:buNone/>
+                      </a:pPr>
                       <a:r>
-                        <a:rPr lang="en-US">
-                          <a:effectLst/>
-                        </a:rPr>
-                        <a:t>David E. Bernholdt (ORNL)</a:t>
-                      </a:r>
-                    </a:p>
-                  </a:txBody>
-                  <a:tcPr marL="142875" marR="142875" marT="95250" marB="95250" anchor="ctr"/>
-                </a:tc>
-                <a:extLst>
-                  <a:ext uri="{0D108BD9-81ED-4DB2-BD59-A6C34878D82A}">
-                    <a16:rowId xmlns:a16="http://schemas.microsoft.com/office/drawing/2014/main" val="4011846257"/>
-                  </a:ext>
-                </a:extLst>
-              </a:tr>
-              <a:tr h="526542">
-                <a:tc>
-                  <a:txBody>
-                    <a:bodyPr/>
-                    <a:lstStyle/>
-                    <a:p>
-                      <a:pPr algn="r"/>
-                      <a:r>
-                        <a:rPr lang="en-US">
-                          <a:effectLst/>
-                        </a:rPr>
-                        <a:t>8:35 AM</a:t>
-                      </a:r>
-                    </a:p>
-                  </a:txBody>
-                  <a:tcPr marL="142875" marR="142875" marT="95250" marB="95250" anchor="ctr"/>
-                </a:tc>
-                <a:tc>
-                  <a:txBody>
-                    <a:bodyPr/>
-                    <a:lstStyle/>
-                    <a:p>
-                      <a:r>
-                        <a:rPr lang="en-US">
-                          <a:effectLst/>
-                        </a:rPr>
-                        <a:t>Motivation and Overview of Best Practices in HPC Software Development</a:t>
-                      </a:r>
-                    </a:p>
-                  </a:txBody>
-                  <a:tcPr marL="142875" marR="142875" marT="95250" marB="95250" anchor="ctr"/>
-                </a:tc>
-                <a:tc>
-                  <a:txBody>
-                    <a:bodyPr/>
-                    <a:lstStyle/>
-                    <a:p>
-                      <a:r>
-                        <a:rPr lang="en-US">
+                        <a:rPr lang="en-US" dirty="0">
                           <a:effectLst/>
                         </a:rPr>
                         <a:t>David E. Bernholdt (ORNL)</a:t>
@@ -7566,12 +6732,14 @@
                     <a:bodyPr/>
                     <a:lstStyle/>
                     <a:p>
-                      <a:pPr algn="r"/>
+                      <a:pPr algn="r">
+                        <a:buNone/>
+                      </a:pPr>
                       <a:r>
                         <a:rPr lang="en-US">
                           <a:effectLst/>
                         </a:rPr>
-                        <a:t>9:15 AM</a:t>
+                        <a:t>8:45 AM</a:t>
                       </a:r>
                     </a:p>
                   </a:txBody>
@@ -7582,11 +6750,14 @@
                     <a:bodyPr/>
                     <a:lstStyle/>
                     <a:p>
+                      <a:pPr>
+                        <a:buNone/>
+                      </a:pPr>
                       <a:r>
                         <a:rPr lang="en-US">
                           <a:effectLst/>
                         </a:rPr>
-                        <a:t>Scientific Software Design</a:t>
+                        <a:t>Motivation and Overview of Best Practices in HPC Software Development</a:t>
                       </a:r>
                     </a:p>
                   </a:txBody>
@@ -7597,11 +6768,14 @@
                     <a:bodyPr/>
                     <a:lstStyle/>
                     <a:p>
+                      <a:pPr>
+                        <a:buNone/>
+                      </a:pPr>
                       <a:r>
                         <a:rPr lang="en-US">
                           <a:effectLst/>
                         </a:rPr>
-                        <a:t>Anshu Dubey (ANL)</a:t>
+                        <a:t>David E. Bernholdt (ORNL)</a:t>
                       </a:r>
                     </a:p>
                   </a:txBody>
@@ -7619,12 +6793,14 @@
                     <a:bodyPr/>
                     <a:lstStyle/>
                     <a:p>
-                      <a:pPr algn="r"/>
+                      <a:pPr algn="r">
+                        <a:buNone/>
+                      </a:pPr>
                       <a:r>
                         <a:rPr lang="en-US">
                           <a:effectLst/>
                         </a:rPr>
-                        <a:t>10:00 AM</a:t>
+                        <a:t>9:15 AM</a:t>
                       </a:r>
                     </a:p>
                   </a:txBody>
@@ -7635,15 +6811,15 @@
                     <a:bodyPr/>
                     <a:lstStyle/>
                     <a:p>
+                      <a:pPr>
+                        <a:buNone/>
+                      </a:pPr>
                       <a:r>
-                        <a:rPr lang="en-US" i="1">
+                        <a:rPr lang="en-US">
                           <a:effectLst/>
                         </a:rPr>
-                        <a:t>Break</a:t>
+                        <a:t>Improving Reproducibility Through Better Software Practices</a:t>
                       </a:r>
-                      <a:endParaRPr lang="en-US">
-                        <a:effectLst/>
-                      </a:endParaRPr>
                     </a:p>
                   </a:txBody>
                   <a:tcPr marL="142875" marR="142875" marT="95250" marB="95250" anchor="ctr"/>
@@ -7653,9 +6829,15 @@
                     <a:bodyPr/>
                     <a:lstStyle/>
                     <a:p>
-                      <a:endParaRPr lang="en-US">
-                        <a:effectLst/>
-                      </a:endParaRPr>
+                      <a:pPr>
+                        <a:buNone/>
+                      </a:pPr>
+                      <a:r>
+                        <a:rPr lang="en-US">
+                          <a:effectLst/>
+                        </a:rPr>
+                        <a:t>David E. Bernholdt (ORNL)</a:t>
+                      </a:r>
                     </a:p>
                   </a:txBody>
                   <a:tcPr marL="142875" marR="142875" marT="95250" marB="95250" anchor="ctr"/>
@@ -7672,12 +6854,14 @@
                     <a:bodyPr/>
                     <a:lstStyle/>
                     <a:p>
-                      <a:pPr algn="r"/>
+                      <a:pPr algn="r">
+                        <a:buNone/>
+                      </a:pPr>
                       <a:r>
                         <a:rPr lang="en-US">
                           <a:effectLst/>
                         </a:rPr>
-                        <a:t>10:30 AM</a:t>
+                        <a:t>10:00 AM</a:t>
                       </a:r>
                     </a:p>
                   </a:txBody>
@@ -7688,12 +6872,18 @@
                     <a:bodyPr/>
                     <a:lstStyle/>
                     <a:p>
+                      <a:pPr>
+                        <a:buNone/>
+                      </a:pPr>
                       <a:r>
-                        <a:rPr lang="en-US">
+                        <a:rPr lang="en-US" i="1">
                           <a:effectLst/>
                         </a:rPr>
-                        <a:t>Spack: Package Management for HPC</a:t>
+                        <a:t>Morning break</a:t>
                       </a:r>
+                      <a:endParaRPr lang="en-US">
+                        <a:effectLst/>
+                      </a:endParaRPr>
                     </a:p>
                   </a:txBody>
                   <a:tcPr marL="142875" marR="142875" marT="95250" marB="95250" anchor="ctr"/>
@@ -7703,12 +6893,12 @@
                     <a:bodyPr/>
                     <a:lstStyle/>
                     <a:p>
-                      <a:r>
-                        <a:rPr lang="en-US">
-                          <a:effectLst/>
-                        </a:rPr>
-                        <a:t>Todd Gamblin (LLNL)</a:t>
-                      </a:r>
+                      <a:pPr>
+                        <a:buNone/>
+                      </a:pPr>
+                      <a:endParaRPr lang="en-US">
+                        <a:effectLst/>
+                      </a:endParaRPr>
                     </a:p>
                   </a:txBody>
                   <a:tcPr marL="142875" marR="142875" marT="95250" marB="95250" anchor="ctr"/>
@@ -7725,12 +6915,14 @@
                     <a:bodyPr/>
                     <a:lstStyle/>
                     <a:p>
-                      <a:pPr algn="r"/>
+                      <a:pPr algn="r">
+                        <a:buNone/>
+                      </a:pPr>
                       <a:r>
                         <a:rPr lang="en-US">
                           <a:effectLst/>
                         </a:rPr>
-                        <a:t>11:30 AM</a:t>
+                        <a:t>10:30 AM</a:t>
                       </a:r>
                     </a:p>
                   </a:txBody>
@@ -7741,11 +6933,14 @@
                     <a:bodyPr/>
                     <a:lstStyle/>
                     <a:p>
+                      <a:pPr>
+                        <a:buNone/>
+                      </a:pPr>
                       <a:r>
                         <a:rPr lang="en-US">
                           <a:effectLst/>
                         </a:rPr>
-                        <a:t>Spack Hands-On</a:t>
+                        <a:t>Responsible Software Development with LLMs</a:t>
                       </a:r>
                     </a:p>
                   </a:txBody>
@@ -7756,11 +6951,14 @@
                     <a:bodyPr/>
                     <a:lstStyle/>
                     <a:p>
+                      <a:pPr>
+                        <a:buNone/>
+                      </a:pPr>
                       <a:r>
                         <a:rPr lang="en-US">
                           <a:effectLst/>
                         </a:rPr>
-                        <a:t>Todd Gamblin (LLNL)</a:t>
+                        <a:t>Anshu Dubey (ANL)</a:t>
                       </a:r>
                     </a:p>
                   </a:txBody>
@@ -7778,12 +6976,14 @@
                     <a:bodyPr/>
                     <a:lstStyle/>
                     <a:p>
-                      <a:pPr algn="r"/>
+                      <a:pPr algn="r">
+                        <a:buNone/>
+                      </a:pPr>
                       <a:r>
                         <a:rPr lang="en-US">
                           <a:effectLst/>
                         </a:rPr>
-                        <a:t>12:30 PM</a:t>
+                        <a:t>12:00 PM</a:t>
                       </a:r>
                     </a:p>
                   </a:txBody>
@@ -7794,11 +6994,14 @@
                     <a:bodyPr/>
                     <a:lstStyle/>
                     <a:p>
+                      <a:pPr>
+                        <a:buNone/>
+                      </a:pPr>
                       <a:r>
                         <a:rPr lang="en-US" i="1">
                           <a:effectLst/>
                         </a:rPr>
-                        <a:t>Lunch</a:t>
+                        <a:t>Adjourn</a:t>
                       </a:r>
                       <a:endParaRPr lang="en-US">
                         <a:effectLst/>
@@ -7812,6 +7015,9 @@
                     <a:bodyPr/>
                     <a:lstStyle/>
                     <a:p>
+                      <a:pPr>
+                        <a:buNone/>
+                      </a:pPr>
                       <a:endParaRPr lang="en-US" dirty="0">
                         <a:effectLst/>
                       </a:endParaRPr>
@@ -8872,18 +8078,18 @@
 </file>
 
 <file path=customXml/item1.xml><?xml version="1.0" encoding="utf-8"?>
+<p:properties xmlns:p="http://schemas.microsoft.com/office/2006/metadata/properties" xmlns:xsi="http://www.w3.org/2001/XMLSchema-instance" xmlns:pc="http://schemas.microsoft.com/office/infopath/2007/PartnerControls">
+  <documentManagement/>
+</p:properties>
+</file>
+
+<file path=customXml/item2.xml><?xml version="1.0" encoding="utf-8"?>
 <?mso-contentType ?>
 <FormTemplates xmlns="http://schemas.microsoft.com/sharepoint/v3/contenttype/forms">
   <Display>DocumentLibraryForm</Display>
   <Edit>DocumentLibraryForm</Edit>
   <New>DocumentLibraryForm</New>
 </FormTemplates>
-</file>
-
-<file path=customXml/item2.xml><?xml version="1.0" encoding="utf-8"?>
-<p:properties xmlns:p="http://schemas.microsoft.com/office/2006/metadata/properties" xmlns:xsi="http://www.w3.org/2001/XMLSchema-instance" xmlns:pc="http://schemas.microsoft.com/office/infopath/2007/PartnerControls">
-  <documentManagement/>
-</p:properties>
 </file>
 
 <file path=customXml/item3.xml><?xml version="1.0" encoding="utf-8"?>
@@ -8936,14 +8142,6 @@
 </file>
 
 <file path=customXml/itemProps1.xml><?xml version="1.0" encoding="utf-8"?>
-<ds:datastoreItem xmlns:ds="http://schemas.openxmlformats.org/officeDocument/2006/customXml" ds:itemID="{19E20559-B232-4371-8690-E3D8007EDB82}">
-  <ds:schemaRefs>
-    <ds:schemaRef ds:uri="http://schemas.microsoft.com/sharepoint/v3/contenttype/forms"/>
-  </ds:schemaRefs>
-</ds:datastoreItem>
-</file>
-
-<file path=customXml/itemProps2.xml><?xml version="1.0" encoding="utf-8"?>
 <ds:datastoreItem xmlns:ds="http://schemas.openxmlformats.org/officeDocument/2006/customXml" ds:itemID="{A50EC660-24D0-43A0-AE5E-E274115E726B}">
   <ds:schemaRefs>
     <ds:schemaRef ds:uri="http://purl.org/dc/elements/1.1/"/>
@@ -8954,6 +8152,14 @@
     <ds:schemaRef ds:uri="http://www.w3.org/XML/1998/namespace"/>
     <ds:schemaRef ds:uri="http://purl.org/dc/dcmitype/"/>
     <ds:schemaRef ds:uri="http://schemas.microsoft.com/office/infopath/2007/PartnerControls"/>
+  </ds:schemaRefs>
+</ds:datastoreItem>
+</file>
+
+<file path=customXml/itemProps2.xml><?xml version="1.0" encoding="utf-8"?>
+<ds:datastoreItem xmlns:ds="http://schemas.openxmlformats.org/officeDocument/2006/customXml" ds:itemID="{19E20559-B232-4371-8690-E3D8007EDB82}">
+  <ds:schemaRefs>
+    <ds:schemaRef ds:uri="http://schemas.microsoft.com/sharepoint/v3/contenttype/forms"/>
   </ds:schemaRefs>
 </ds:datastoreItem>
 </file>

</xml_diff>

<commit_message>
Initial cut at hands-on notes
Also updated license page
</commit_message>
<xml_diff>
--- a/intro.pptx
+++ b/intro.pptx
@@ -5,21 +5,22 @@
     <p:sldMasterId id="2147483935" r:id="rId4"/>
   </p:sldMasterIdLst>
   <p:notesMasterIdLst>
-    <p:notesMasterId r:id="rId14"/>
+    <p:notesMasterId r:id="rId15"/>
   </p:notesMasterIdLst>
   <p:handoutMasterIdLst>
-    <p:handoutMasterId r:id="rId15"/>
+    <p:handoutMasterId r:id="rId16"/>
   </p:handoutMasterIdLst>
   <p:sldIdLst>
     <p:sldId id="617" r:id="rId5"/>
-    <p:sldId id="320" r:id="rId6"/>
+    <p:sldId id="625" r:id="rId6"/>
     <p:sldId id="308" r:id="rId7"/>
     <p:sldId id="324" r:id="rId8"/>
     <p:sldId id="329" r:id="rId9"/>
     <p:sldId id="620" r:id="rId10"/>
     <p:sldId id="622" r:id="rId11"/>
     <p:sldId id="616" r:id="rId12"/>
-    <p:sldId id="624" r:id="rId13"/>
+    <p:sldId id="626" r:id="rId13"/>
+    <p:sldId id="624" r:id="rId14"/>
   </p:sldIdLst>
   <p:sldSz cx="12188825" cy="6858000"/>
   <p:notesSz cx="7010400" cy="9296400"/>
@@ -263,7 +264,7 @@
           <a:p>
             <a:fld id="{0B842F42-2CE9-4E35-95C1-410DC08A50B1}" type="datetimeFigureOut">
               <a:rPr lang="en-US" smtClean="0"/>
-              <a:t>10/19/2025</a:t>
+              <a:t>10/25/2025</a:t>
             </a:fld>
             <a:endParaRPr lang="en-US"/>
           </a:p>
@@ -428,7 +429,7 @@
           <a:p>
             <a:fld id="{6F282904-F315-4730-8D91-37D99E141A6F}" type="datetimeFigureOut">
               <a:rPr lang="en-US" smtClean="0"/>
-              <a:t>10/18/2025</a:t>
+              <a:t>10/25/2025</a:t>
             </a:fld>
             <a:endParaRPr lang="en-US"/>
           </a:p>
@@ -4438,2076 +4439,7 @@
 </p:sld>
 </file>
 
-<file path=ppt/slides/slide2.xml><?xml version="1.0" encoding="utf-8"?>
-<p:sld xmlns:a="http://schemas.openxmlformats.org/drawingml/2006/main" xmlns:r="http://schemas.openxmlformats.org/officeDocument/2006/relationships" xmlns:p="http://schemas.openxmlformats.org/presentationml/2006/main">
-  <p:cSld>
-    <p:spTree>
-      <p:nvGrpSpPr>
-        <p:cNvPr id="1" name=""/>
-        <p:cNvGrpSpPr/>
-        <p:nvPr/>
-      </p:nvGrpSpPr>
-      <p:grpSpPr>
-        <a:xfrm>
-          <a:off x="0" y="0"/>
-          <a:ext cx="0" cy="0"/>
-          <a:chOff x="0" y="0"/>
-          <a:chExt cx="0" cy="0"/>
-        </a:xfrm>
-      </p:grpSpPr>
-      <p:sp>
-        <p:nvSpPr>
-          <p:cNvPr id="2" name="Title 1">
-            <a:extLst>
-              <a:ext uri="{FF2B5EF4-FFF2-40B4-BE49-F238E27FC236}">
-                <a16:creationId xmlns:a16="http://schemas.microsoft.com/office/drawing/2014/main" id="{6442C24D-D970-4D40-8F14-D70C10A96304}"/>
-              </a:ext>
-            </a:extLst>
-          </p:cNvPr>
-          <p:cNvSpPr>
-            <a:spLocks noGrp="1"/>
-          </p:cNvSpPr>
-          <p:nvPr>
-            <p:ph type="title"/>
-          </p:nvPr>
-        </p:nvSpPr>
-        <p:spPr>
-          <a:xfrm>
-            <a:off x="363096" y="417709"/>
-            <a:ext cx="11372473" cy="914400"/>
-          </a:xfrm>
-        </p:spPr>
-        <p:txBody>
-          <a:bodyPr/>
-          <a:lstStyle/>
-          <a:p>
-            <a:r>
-              <a:rPr lang="en-US" dirty="0"/>
-              <a:t>License, Citation and Acknowledgements</a:t>
-            </a:r>
-          </a:p>
-        </p:txBody>
-      </p:sp>
-      <p:sp>
-        <p:nvSpPr>
-          <p:cNvPr id="3" name="Content Placeholder 2">
-            <a:extLst>
-              <a:ext uri="{FF2B5EF4-FFF2-40B4-BE49-F238E27FC236}">
-                <a16:creationId xmlns:a16="http://schemas.microsoft.com/office/drawing/2014/main" id="{0385A3AB-B258-4D59-B407-F7D57545A163}"/>
-              </a:ext>
-            </a:extLst>
-          </p:cNvPr>
-          <p:cNvSpPr>
-            <a:spLocks noGrp="1"/>
-          </p:cNvSpPr>
-          <p:nvPr>
-            <p:ph idx="1"/>
-          </p:nvPr>
-        </p:nvSpPr>
-        <p:spPr>
-          <a:xfrm>
-            <a:off x="409507" y="874909"/>
-            <a:ext cx="11369809" cy="4047778"/>
-          </a:xfrm>
-        </p:spPr>
-        <p:txBody>
-          <a:bodyPr/>
-          <a:lstStyle/>
-          <a:p>
-            <a:pPr marL="0" indent="0">
-              <a:buNone/>
-            </a:pPr>
-            <a:r>
-              <a:rPr lang="en-US" sz="2000" b="1" dirty="0"/>
-              <a:t>License and Citation</a:t>
-            </a:r>
-          </a:p>
-          <a:p>
-            <a:pPr>
-              <a:spcBef>
-                <a:spcPts val="400"/>
-              </a:spcBef>
-            </a:pPr>
-            <a:r>
-              <a:rPr lang="en-US" sz="1600" dirty="0"/>
-              <a:t>This work is licensed under a </a:t>
-            </a:r>
-            <a:r>
-              <a:rPr lang="en-US" sz="1600" dirty="0">
-                <a:hlinkClick r:id="rId2"/>
-              </a:rPr>
-              <a:t>Creative</a:t>
-            </a:r>
-            <a:r>
-              <a:rPr lang="en-US" sz="1600" dirty="0">
-                <a:hlinkClick r:id="rId3"/>
-              </a:rPr>
-              <a:t> Commons Attribution 4.0 International License</a:t>
-            </a:r>
-            <a:r>
-              <a:rPr lang="en-US" sz="1600" dirty="0"/>
-              <a:t> (CC BY 4.0).</a:t>
-            </a:r>
-          </a:p>
-          <a:p>
-            <a:pPr>
-              <a:spcBef>
-                <a:spcPts val="400"/>
-              </a:spcBef>
-            </a:pPr>
-            <a:r>
-              <a:rPr lang="en-US" sz="1600" b="1" dirty="0"/>
-              <a:t>The requested citation the overall tutorial is: </a:t>
-            </a:r>
-            <a:r>
-              <a:rPr lang="en-US" sz="1600" dirty="0"/>
-              <a:t>David E. Bernholdt and Anshu Dubey, Better Software for Reproducible Science tutorial, in The International Conference for High-Performance Computing, Networking, Storage, and Analysis (SC25), St. Louis, Missouri, 2025. DOI: </a:t>
-            </a:r>
-            <a:r>
-              <a:rPr lang="en-US" sz="1600" dirty="0">
-                <a:hlinkClick r:id="rId4"/>
-              </a:rPr>
-              <a:t>10.6084/m9.figshare.30394186</a:t>
-            </a:r>
-            <a:r>
-              <a:rPr lang="en-US" sz="1600" dirty="0"/>
-              <a:t>.</a:t>
-            </a:r>
-            <a:endParaRPr lang="en-US" sz="1600" b="0" i="0" dirty="0">
-              <a:solidFill>
-                <a:srgbClr val="111111"/>
-              </a:solidFill>
-              <a:effectLst/>
-              <a:latin typeface="+mn-lt"/>
-            </a:endParaRPr>
-          </a:p>
-          <a:p>
-            <a:pPr>
-              <a:spcBef>
-                <a:spcPts val="400"/>
-              </a:spcBef>
-            </a:pPr>
-            <a:r>
-              <a:rPr lang="en-US" sz="1600" dirty="0"/>
-              <a:t>Individual modules may be cited as </a:t>
-            </a:r>
-            <a:r>
-              <a:rPr lang="en-US" sz="1600" i="1" dirty="0"/>
-              <a:t>Speaker, Module Title</a:t>
-            </a:r>
-            <a:r>
-              <a:rPr lang="en-US" sz="1600" dirty="0"/>
-              <a:t>, in </a:t>
-            </a:r>
-            <a:r>
-              <a:rPr lang="en-US" sz="1600" b="0" i="1" dirty="0">
-                <a:solidFill>
-                  <a:srgbClr val="111111"/>
-                </a:solidFill>
-                <a:effectLst/>
-                <a:latin typeface="+mn-lt"/>
-              </a:rPr>
-              <a:t>Tutorial Title</a:t>
-            </a:r>
-            <a:r>
-              <a:rPr lang="en-US" sz="1600" dirty="0"/>
-              <a:t>, …</a:t>
-            </a:r>
-          </a:p>
-          <a:p>
-            <a:pPr marL="0" indent="0">
-              <a:spcBef>
-                <a:spcPts val="800"/>
-              </a:spcBef>
-              <a:buNone/>
-            </a:pPr>
-            <a:r>
-              <a:rPr lang="en-US" sz="2000" b="1" dirty="0"/>
-              <a:t>Acknowledgements</a:t>
-            </a:r>
-          </a:p>
-          <a:p>
-            <a:pPr>
-              <a:spcBef>
-                <a:spcPts val="400"/>
-              </a:spcBef>
-            </a:pPr>
-            <a:r>
-              <a:rPr lang="en-US" sz="1400" dirty="0"/>
-              <a:t>This work was supported by the U.S. Department of Energy Office of Science, Office of Advanced Scientific Computing Research (ASCR), and by the Exascale Computing Project (17-SC-20-SC), a collaborative effort of the U.S. Department of Energy Office of Science and the National Nuclear Security Administration</a:t>
-            </a:r>
-            <a:r>
-              <a:rPr lang="en-US" sz="1400" i="1" dirty="0"/>
-              <a:t>.</a:t>
-            </a:r>
-          </a:p>
-          <a:p>
-            <a:pPr>
-              <a:spcBef>
-                <a:spcPts val="400"/>
-              </a:spcBef>
-            </a:pPr>
-            <a:r>
-              <a:rPr lang="en-US" sz="1400" b="0" i="0" dirty="0">
-                <a:effectLst/>
-                <a:latin typeface="+mn-lt"/>
-              </a:rPr>
-              <a:t>This work was supported by the U.S. Department of Energy, Office of Science, Office of Advanced Scientific Computing Research, Next-Generation Scientific Software Technologies (NGSST) program.</a:t>
-            </a:r>
-          </a:p>
-          <a:p>
-            <a:pPr>
-              <a:spcBef>
-                <a:spcPts val="400"/>
-              </a:spcBef>
-            </a:pPr>
-            <a:r>
-              <a:rPr lang="en-US" sz="1400" dirty="0"/>
-              <a:t>This work was performed in part at the Argonne National Laboratory, which is managed by UChicago Argonne, LLC for the U.S. Department of Energy under Contract No. DE-AC02-06CH11357.</a:t>
-            </a:r>
-          </a:p>
-          <a:p>
-            <a:pPr>
-              <a:spcBef>
-                <a:spcPts val="400"/>
-              </a:spcBef>
-            </a:pPr>
-            <a:r>
-              <a:rPr lang="en-US" sz="1400" dirty="0"/>
-              <a:t>This work was performed in part at the Lawrence Livermore National Laboratory, which is managed by Lawrence Livermore National Security, LLC for the U.S. Department of Energy under Contract No. DE-AC52-07NA27344.</a:t>
-            </a:r>
-          </a:p>
-          <a:p>
-            <a:pPr>
-              <a:spcBef>
-                <a:spcPts val="400"/>
-              </a:spcBef>
-            </a:pPr>
-            <a:r>
-              <a:rPr lang="en-US" sz="1400" dirty="0"/>
-              <a:t>This work was performed in part at the Los Alamos National Laboratory, which is managed by Triad National Security, LLC for the U.S. Department of Energy under Contract No.89233218CNA000001</a:t>
-            </a:r>
-          </a:p>
-          <a:p>
-            <a:pPr>
-              <a:spcBef>
-                <a:spcPts val="400"/>
-              </a:spcBef>
-            </a:pPr>
-            <a:r>
-              <a:rPr lang="en-US" sz="1400" dirty="0"/>
-              <a:t>This work was performed in part at the Oak Ridge National Laboratory, which is managed by UT-Battelle, LLC for the U.S. Department of Energy under Contract No. DE-AC05-00OR22725.</a:t>
-            </a:r>
-          </a:p>
-          <a:p>
-            <a:pPr>
-              <a:spcBef>
-                <a:spcPts val="400"/>
-              </a:spcBef>
-            </a:pPr>
-            <a:r>
-              <a:rPr lang="en-US" sz="1400" dirty="0"/>
-              <a:t>This work was performed in part at Sandia National Laboratories. Sandia National Laboratories is a multi-mission laboratory managed and operated by National Technology and Engineering Solutions of Sandia, LLC., a wholly owned subsidiary of Honeywell International, Inc., for the U.S. Department of Energy’s National Nuclear Security Administration under contract DE-NA0003525.</a:t>
-            </a:r>
-          </a:p>
-        </p:txBody>
-      </p:sp>
-      <p:pic>
-        <p:nvPicPr>
-          <p:cNvPr id="4" name="Picture 2" descr="https://licensebuttons.net/l/by/4.0/88x31.png">
-            <a:extLst>
-              <a:ext uri="{FF2B5EF4-FFF2-40B4-BE49-F238E27FC236}">
-                <a16:creationId xmlns:a16="http://schemas.microsoft.com/office/drawing/2014/main" id="{61840015-22A0-4634-A2DE-AA05F998FD3A}"/>
-              </a:ext>
-            </a:extLst>
-          </p:cNvPr>
-          <p:cNvPicPr>
-            <a:picLocks noChangeAspect="1" noChangeArrowheads="1"/>
-          </p:cNvPicPr>
-          <p:nvPr/>
-        </p:nvPicPr>
-        <p:blipFill>
-          <a:blip r:embed="rId5">
-            <a:extLst>
-              <a:ext uri="{28A0092B-C50C-407E-A947-70E740481C1C}">
-                <a14:useLocalDpi xmlns:a14="http://schemas.microsoft.com/office/drawing/2010/main" val="0"/>
-              </a:ext>
-            </a:extLst>
-          </a:blip>
-          <a:srcRect/>
-          <a:stretch>
-            <a:fillRect/>
-          </a:stretch>
-        </p:blipFill>
-        <p:spPr bwMode="auto">
-          <a:xfrm>
-            <a:off x="10230336" y="879673"/>
-            <a:ext cx="838200" cy="295275"/>
-          </a:xfrm>
-          <a:prstGeom prst="rect">
-            <a:avLst/>
-          </a:prstGeom>
-          <a:noFill/>
-          <a:extLst>
-            <a:ext uri="{909E8E84-426E-40DD-AFC4-6F175D3DCCD1}">
-              <a14:hiddenFill xmlns:a14="http://schemas.microsoft.com/office/drawing/2010/main">
-                <a:solidFill>
-                  <a:srgbClr val="FFFFFF"/>
-                </a:solidFill>
-              </a14:hiddenFill>
-            </a:ext>
-          </a:extLst>
-        </p:spPr>
-      </p:pic>
-    </p:spTree>
-    <p:extLst>
-      <p:ext uri="{BB962C8B-B14F-4D97-AF65-F5344CB8AC3E}">
-        <p14:creationId xmlns:p14="http://schemas.microsoft.com/office/powerpoint/2010/main" val="2979228385"/>
-      </p:ext>
-    </p:extLst>
-  </p:cSld>
-  <p:clrMapOvr>
-    <a:masterClrMapping/>
-  </p:clrMapOvr>
-</p:sld>
-</file>
-
-<file path=ppt/slides/slide3.xml><?xml version="1.0" encoding="utf-8"?>
-<p:sld xmlns:a="http://schemas.openxmlformats.org/drawingml/2006/main" xmlns:r="http://schemas.openxmlformats.org/officeDocument/2006/relationships" xmlns:p="http://schemas.openxmlformats.org/presentationml/2006/main">
-  <p:cSld>
-    <p:spTree>
-      <p:nvGrpSpPr>
-        <p:cNvPr id="1" name=""/>
-        <p:cNvGrpSpPr/>
-        <p:nvPr/>
-      </p:nvGrpSpPr>
-      <p:grpSpPr>
-        <a:xfrm>
-          <a:off x="0" y="0"/>
-          <a:ext cx="0" cy="0"/>
-          <a:chOff x="0" y="0"/>
-          <a:chExt cx="0" cy="0"/>
-        </a:xfrm>
-      </p:grpSpPr>
-      <p:sp>
-        <p:nvSpPr>
-          <p:cNvPr id="3" name="Content Placeholder 2">
-            <a:extLst>
-              <a:ext uri="{FF2B5EF4-FFF2-40B4-BE49-F238E27FC236}">
-                <a16:creationId xmlns:a16="http://schemas.microsoft.com/office/drawing/2014/main" id="{3DF9CC39-F70C-4872-8BAF-FDB4FE40BE11}"/>
-              </a:ext>
-            </a:extLst>
-          </p:cNvPr>
-          <p:cNvSpPr>
-            <a:spLocks noGrp="1"/>
-          </p:cNvSpPr>
-          <p:nvPr>
-            <p:ph idx="1"/>
-          </p:nvPr>
-        </p:nvSpPr>
-        <p:spPr>
-          <a:xfrm>
-            <a:off x="365760" y="1280696"/>
-            <a:ext cx="11369809" cy="4047778"/>
-          </a:xfrm>
-        </p:spPr>
-        <p:txBody>
-          <a:bodyPr/>
-          <a:lstStyle/>
-          <a:p>
-            <a:pPr>
-              <a:spcBef>
-                <a:spcPts val="1000"/>
-              </a:spcBef>
-            </a:pPr>
-            <a:r>
-              <a:rPr lang="en-US" dirty="0"/>
-              <a:t>David E. Bernholdt, ORNL</a:t>
-            </a:r>
-          </a:p>
-          <a:p>
-            <a:pPr>
-              <a:spcBef>
-                <a:spcPts val="1000"/>
-              </a:spcBef>
-            </a:pPr>
-            <a:r>
-              <a:rPr lang="en-US" dirty="0"/>
-              <a:t>Anshu Dubey, ANL</a:t>
-            </a:r>
-          </a:p>
-        </p:txBody>
-      </p:sp>
-      <p:sp>
-        <p:nvSpPr>
-          <p:cNvPr id="2" name="Title 1">
-            <a:extLst>
-              <a:ext uri="{FF2B5EF4-FFF2-40B4-BE49-F238E27FC236}">
-                <a16:creationId xmlns:a16="http://schemas.microsoft.com/office/drawing/2014/main" id="{D7779183-6189-461C-B4D7-638E6AB5CA5F}"/>
-              </a:ext>
-            </a:extLst>
-          </p:cNvPr>
-          <p:cNvSpPr>
-            <a:spLocks noGrp="1"/>
-          </p:cNvSpPr>
-          <p:nvPr>
-            <p:ph type="title"/>
-          </p:nvPr>
-        </p:nvSpPr>
-        <p:spPr/>
-        <p:txBody>
-          <a:bodyPr/>
-          <a:lstStyle/>
-          <a:p>
-            <a:r>
-              <a:rPr lang="en-US" dirty="0"/>
-              <a:t>About Us</a:t>
-            </a:r>
-          </a:p>
-        </p:txBody>
-      </p:sp>
-      <p:sp>
-        <p:nvSpPr>
-          <p:cNvPr id="4" name="TextBox 3">
-            <a:extLst>
-              <a:ext uri="{FF2B5EF4-FFF2-40B4-BE49-F238E27FC236}">
-                <a16:creationId xmlns:a16="http://schemas.microsoft.com/office/drawing/2014/main" id="{75F24105-9372-1C03-4BB0-9287BF335D4A}"/>
-              </a:ext>
-            </a:extLst>
-          </p:cNvPr>
-          <p:cNvSpPr txBox="1"/>
-          <p:nvPr/>
-        </p:nvSpPr>
-        <p:spPr>
-          <a:xfrm>
-            <a:off x="453256" y="3373816"/>
-            <a:ext cx="10123321" cy="2631490"/>
-          </a:xfrm>
-          <a:prstGeom prst="rect">
-            <a:avLst/>
-          </a:prstGeom>
-          <a:noFill/>
-        </p:spPr>
-        <p:txBody>
-          <a:bodyPr wrap="square">
-            <a:spAutoFit/>
-          </a:bodyPr>
-          <a:lstStyle/>
-          <a:p>
-            <a:pPr marL="227013" indent="-227013">
-              <a:spcBef>
-                <a:spcPts val="600"/>
-              </a:spcBef>
-              <a:buFont typeface="Arial" panose="020B0604020202020204" pitchFamily="34" charset="0"/>
-              <a:buChar char="•"/>
-            </a:pPr>
-            <a:r>
-              <a:rPr lang="en-US" sz="2000" dirty="0"/>
-              <a:t>Participants in the Consortium for the Advancement of Scientific Software (CASS) and DOE/ASCR software stewardship projects: </a:t>
-            </a:r>
-            <a:r>
-              <a:rPr lang="en-US" sz="2000" dirty="0">
-                <a:hlinkClick r:id="rId2"/>
-              </a:rPr>
-              <a:t>https://cass.community/</a:t>
-            </a:r>
-            <a:endParaRPr lang="en-US" sz="2000" dirty="0"/>
-          </a:p>
-          <a:p>
-            <a:pPr marL="684213" lvl="1" indent="-227013">
-              <a:spcBef>
-                <a:spcPts val="600"/>
-              </a:spcBef>
-              <a:buFont typeface="Arial" panose="020B0604020202020204" pitchFamily="34" charset="0"/>
-              <a:buChar char="•"/>
-            </a:pPr>
-            <a:r>
-              <a:rPr lang="en-US" sz="2000" dirty="0"/>
-              <a:t>Members of the </a:t>
-            </a:r>
-            <a:r>
-              <a:rPr lang="en-US" sz="2000" dirty="0">
-                <a:hlinkClick r:id="rId3"/>
-              </a:rPr>
-              <a:t>PESO</a:t>
-            </a:r>
-            <a:r>
-              <a:rPr lang="en-US" sz="2000" dirty="0"/>
-              <a:t> and </a:t>
-            </a:r>
-            <a:r>
-              <a:rPr lang="en-US" sz="2000" dirty="0">
-                <a:hlinkClick r:id="rId4"/>
-              </a:rPr>
-              <a:t>RAPIDS</a:t>
-            </a:r>
-            <a:r>
-              <a:rPr lang="en-US" sz="2000" dirty="0"/>
-              <a:t> projects</a:t>
-            </a:r>
-          </a:p>
-          <a:p>
-            <a:pPr marL="227013" indent="-227013">
-              <a:spcBef>
-                <a:spcPts val="600"/>
-              </a:spcBef>
-              <a:buFont typeface="Arial" panose="020B0604020202020204" pitchFamily="34" charset="0"/>
-              <a:buChar char="•"/>
-            </a:pPr>
-            <a:r>
-              <a:rPr lang="en-US" sz="2000" dirty="0"/>
-              <a:t>Past involvement in</a:t>
-            </a:r>
-          </a:p>
-          <a:p>
-            <a:pPr marL="684213" lvl="1" indent="-227013">
-              <a:spcBef>
-                <a:spcPts val="600"/>
-              </a:spcBef>
-              <a:buFont typeface="Arial" panose="020B0604020202020204" pitchFamily="34" charset="0"/>
-              <a:buChar char="•"/>
-            </a:pPr>
-            <a:r>
-              <a:rPr lang="en-US" sz="2000" dirty="0"/>
-              <a:t>Exascale Computing Project</a:t>
-            </a:r>
-          </a:p>
-          <a:p>
-            <a:pPr marL="684213" lvl="1" indent="-227013">
-              <a:spcBef>
-                <a:spcPts val="600"/>
-              </a:spcBef>
-              <a:buFont typeface="Arial" panose="020B0604020202020204" pitchFamily="34" charset="0"/>
-              <a:buChar char="•"/>
-            </a:pPr>
-            <a:r>
-              <a:rPr lang="en-US" sz="2000" dirty="0"/>
-              <a:t>IDEAS Productivity family of projects: </a:t>
-            </a:r>
-            <a:r>
-              <a:rPr lang="en-US" sz="2000" dirty="0">
-                <a:hlinkClick r:id="rId5"/>
-              </a:rPr>
-              <a:t>https://ideas-productivity.org/</a:t>
-            </a:r>
-            <a:endParaRPr lang="en-US" sz="2000" dirty="0"/>
-          </a:p>
-          <a:p>
-            <a:pPr marL="684213" lvl="1" indent="-227013">
-              <a:spcBef>
-                <a:spcPts val="600"/>
-              </a:spcBef>
-              <a:buFont typeface="Arial" panose="020B0604020202020204" pitchFamily="34" charset="0"/>
-              <a:buChar char="•"/>
-            </a:pPr>
-            <a:r>
-              <a:rPr lang="en-US" sz="2000" dirty="0"/>
-              <a:t>And more!</a:t>
-            </a:r>
-          </a:p>
-        </p:txBody>
-      </p:sp>
-      <p:grpSp>
-        <p:nvGrpSpPr>
-          <p:cNvPr id="8" name="Group 7">
-            <a:extLst>
-              <a:ext uri="{FF2B5EF4-FFF2-40B4-BE49-F238E27FC236}">
-                <a16:creationId xmlns:a16="http://schemas.microsoft.com/office/drawing/2014/main" id="{C22DEB37-50E6-2254-1FB5-B0F6E81B4E4A}"/>
-              </a:ext>
-            </a:extLst>
-          </p:cNvPr>
-          <p:cNvGrpSpPr/>
-          <p:nvPr/>
-        </p:nvGrpSpPr>
-        <p:grpSpPr>
-          <a:xfrm>
-            <a:off x="9515196" y="1325880"/>
-            <a:ext cx="954107" cy="1805497"/>
-            <a:chOff x="6614147" y="1346049"/>
-            <a:chExt cx="954107" cy="1805497"/>
-          </a:xfrm>
-        </p:grpSpPr>
-        <p:sp>
-          <p:nvSpPr>
-            <p:cNvPr id="9" name="TextBox 8">
-              <a:extLst>
-                <a:ext uri="{FF2B5EF4-FFF2-40B4-BE49-F238E27FC236}">
-                  <a16:creationId xmlns:a16="http://schemas.microsoft.com/office/drawing/2014/main" id="{CEB57978-C3B6-32C4-C6C6-52ACB58C8A06}"/>
-                </a:ext>
-              </a:extLst>
-            </p:cNvPr>
-            <p:cNvSpPr txBox="1"/>
-            <p:nvPr/>
-          </p:nvSpPr>
-          <p:spPr>
-            <a:xfrm>
-              <a:off x="6614147" y="2560615"/>
-              <a:ext cx="954107" cy="590931"/>
-            </a:xfrm>
-            <a:prstGeom prst="rect">
-              <a:avLst/>
-            </a:prstGeom>
-            <a:noFill/>
-          </p:spPr>
-          <p:txBody>
-            <a:bodyPr wrap="none" rtlCol="0">
-              <a:spAutoFit/>
-            </a:bodyPr>
-            <a:lstStyle/>
-            <a:p>
-              <a:pPr algn="ctr">
-                <a:lnSpc>
-                  <a:spcPct val="90000"/>
-                </a:lnSpc>
-              </a:pPr>
-              <a:r>
-                <a:rPr lang="en-US" dirty="0"/>
-                <a:t>Anshu</a:t>
-              </a:r>
-            </a:p>
-            <a:p>
-              <a:pPr algn="ctr">
-                <a:lnSpc>
-                  <a:spcPct val="90000"/>
-                </a:lnSpc>
-              </a:pPr>
-              <a:r>
-                <a:rPr lang="en-US" i="1" dirty="0"/>
-                <a:t>she/her</a:t>
-              </a:r>
-            </a:p>
-          </p:txBody>
-        </p:sp>
-        <p:pic>
-          <p:nvPicPr>
-            <p:cNvPr id="10" name="Picture 9" descr="A person smiling for the camera&#10;&#10;Description automatically generated with low confidence">
-              <a:extLst>
-                <a:ext uri="{FF2B5EF4-FFF2-40B4-BE49-F238E27FC236}">
-                  <a16:creationId xmlns:a16="http://schemas.microsoft.com/office/drawing/2014/main" id="{4F1A04F2-5B52-D284-D8CF-CD12780422CE}"/>
-                </a:ext>
-              </a:extLst>
-            </p:cNvPr>
-            <p:cNvPicPr>
-              <a:picLocks noChangeAspect="1"/>
-            </p:cNvPicPr>
-            <p:nvPr/>
-          </p:nvPicPr>
-          <p:blipFill>
-            <a:blip r:embed="rId6" cstate="print">
-              <a:extLst>
-                <a:ext uri="{28A0092B-C50C-407E-A947-70E740481C1C}">
-                  <a14:useLocalDpi xmlns:a14="http://schemas.microsoft.com/office/drawing/2010/main" val="0"/>
-                </a:ext>
-              </a:extLst>
-            </a:blip>
-            <a:stretch>
-              <a:fillRect/>
-            </a:stretch>
-          </p:blipFill>
-          <p:spPr>
-            <a:xfrm>
-              <a:off x="6632063" y="1346049"/>
-              <a:ext cx="918273" cy="1207008"/>
-            </a:xfrm>
-            <a:prstGeom prst="rect">
-              <a:avLst/>
-            </a:prstGeom>
-          </p:spPr>
-        </p:pic>
-      </p:grpSp>
-      <p:grpSp>
-        <p:nvGrpSpPr>
-          <p:cNvPr id="11" name="Group 10">
-            <a:extLst>
-              <a:ext uri="{FF2B5EF4-FFF2-40B4-BE49-F238E27FC236}">
-                <a16:creationId xmlns:a16="http://schemas.microsoft.com/office/drawing/2014/main" id="{BF360452-D7C7-247A-386F-D3315474AFCB}"/>
-              </a:ext>
-            </a:extLst>
-          </p:cNvPr>
-          <p:cNvGrpSpPr/>
-          <p:nvPr/>
-        </p:nvGrpSpPr>
-        <p:grpSpPr>
-          <a:xfrm>
-            <a:off x="7899602" y="1325880"/>
-            <a:ext cx="1038027" cy="1797939"/>
-            <a:chOff x="4187619" y="4211394"/>
-            <a:chExt cx="1038027" cy="1797939"/>
-          </a:xfrm>
-        </p:grpSpPr>
-        <p:pic>
-          <p:nvPicPr>
-            <p:cNvPr id="12" name="Picture 11" descr="A person wearing glasses&#10;&#10;Description automatically generated with low confidence">
-              <a:extLst>
-                <a:ext uri="{FF2B5EF4-FFF2-40B4-BE49-F238E27FC236}">
-                  <a16:creationId xmlns:a16="http://schemas.microsoft.com/office/drawing/2014/main" id="{8B9A3899-C96B-3A08-5E0A-2906D305F982}"/>
-                </a:ext>
-              </a:extLst>
-            </p:cNvPr>
-            <p:cNvPicPr>
-              <a:picLocks noChangeAspect="1"/>
-            </p:cNvPicPr>
-            <p:nvPr/>
-          </p:nvPicPr>
-          <p:blipFill rotWithShape="1">
-            <a:blip r:embed="rId7" cstate="print">
-              <a:extLst>
-                <a:ext uri="{28A0092B-C50C-407E-A947-70E740481C1C}">
-                  <a14:useLocalDpi xmlns:a14="http://schemas.microsoft.com/office/drawing/2010/main" val="0"/>
-                </a:ext>
-              </a:extLst>
-            </a:blip>
-            <a:srcRect l="8053" t="854" r="5947" b="-854"/>
-            <a:stretch/>
-          </p:blipFill>
-          <p:spPr>
-            <a:xfrm>
-              <a:off x="4187619" y="4211394"/>
-              <a:ext cx="1038027" cy="1207008"/>
-            </a:xfrm>
-            <a:prstGeom prst="rect">
-              <a:avLst/>
-            </a:prstGeom>
-          </p:spPr>
-        </p:pic>
-        <p:sp>
-          <p:nvSpPr>
-            <p:cNvPr id="13" name="TextBox 12">
-              <a:extLst>
-                <a:ext uri="{FF2B5EF4-FFF2-40B4-BE49-F238E27FC236}">
-                  <a16:creationId xmlns:a16="http://schemas.microsoft.com/office/drawing/2014/main" id="{2B5EF80D-04B1-F98E-6FF3-532C3F5A9955}"/>
-                </a:ext>
-              </a:extLst>
-            </p:cNvPr>
-            <p:cNvSpPr txBox="1"/>
-            <p:nvPr/>
-          </p:nvSpPr>
-          <p:spPr>
-            <a:xfrm>
-              <a:off x="4268051" y="5418402"/>
-              <a:ext cx="877163" cy="590931"/>
-            </a:xfrm>
-            <a:prstGeom prst="rect">
-              <a:avLst/>
-            </a:prstGeom>
-            <a:noFill/>
-          </p:spPr>
-          <p:txBody>
-            <a:bodyPr wrap="none" rtlCol="0">
-              <a:spAutoFit/>
-            </a:bodyPr>
-            <a:lstStyle/>
-            <a:p>
-              <a:pPr algn="ctr">
-                <a:lnSpc>
-                  <a:spcPct val="90000"/>
-                </a:lnSpc>
-              </a:pPr>
-              <a:r>
-                <a:rPr lang="en-US" dirty="0"/>
-                <a:t>David</a:t>
-              </a:r>
-            </a:p>
-            <a:p>
-              <a:pPr algn="ctr">
-                <a:lnSpc>
-                  <a:spcPct val="90000"/>
-                </a:lnSpc>
-              </a:pPr>
-              <a:r>
-                <a:rPr lang="en-US" i="1" dirty="0"/>
-                <a:t>he/him</a:t>
-              </a:r>
-            </a:p>
-          </p:txBody>
-        </p:sp>
-      </p:grpSp>
-    </p:spTree>
-    <p:extLst>
-      <p:ext uri="{BB962C8B-B14F-4D97-AF65-F5344CB8AC3E}">
-        <p14:creationId xmlns:p14="http://schemas.microsoft.com/office/powerpoint/2010/main" val="397159740"/>
-      </p:ext>
-    </p:extLst>
-  </p:cSld>
-  <p:clrMapOvr>
-    <a:masterClrMapping/>
-  </p:clrMapOvr>
-</p:sld>
-</file>
-
-<file path=ppt/slides/slide4.xml><?xml version="1.0" encoding="utf-8"?>
-<p:sld xmlns:a="http://schemas.openxmlformats.org/drawingml/2006/main" xmlns:r="http://schemas.openxmlformats.org/officeDocument/2006/relationships" xmlns:p="http://schemas.openxmlformats.org/presentationml/2006/main">
-  <p:cSld>
-    <p:spTree>
-      <p:nvGrpSpPr>
-        <p:cNvPr id="1" name=""/>
-        <p:cNvGrpSpPr/>
-        <p:nvPr/>
-      </p:nvGrpSpPr>
-      <p:grpSpPr>
-        <a:xfrm>
-          <a:off x="0" y="0"/>
-          <a:ext cx="0" cy="0"/>
-          <a:chOff x="0" y="0"/>
-          <a:chExt cx="0" cy="0"/>
-        </a:xfrm>
-      </p:grpSpPr>
-      <p:sp>
-        <p:nvSpPr>
-          <p:cNvPr id="2" name="Title 1">
-            <a:extLst>
-              <a:ext uri="{FF2B5EF4-FFF2-40B4-BE49-F238E27FC236}">
-                <a16:creationId xmlns:a16="http://schemas.microsoft.com/office/drawing/2014/main" id="{8BCB2B88-3DDC-4986-8D89-A3EDC5187EA9}"/>
-              </a:ext>
-            </a:extLst>
-          </p:cNvPr>
-          <p:cNvSpPr>
-            <a:spLocks noGrp="1"/>
-          </p:cNvSpPr>
-          <p:nvPr>
-            <p:ph type="title"/>
-          </p:nvPr>
-        </p:nvSpPr>
-        <p:spPr/>
-        <p:txBody>
-          <a:bodyPr/>
-          <a:lstStyle/>
-          <a:p>
-            <a:r>
-              <a:rPr lang="en-US" dirty="0"/>
-              <a:t>Building an Online Community</a:t>
-            </a:r>
-          </a:p>
-        </p:txBody>
-      </p:sp>
-      <p:sp>
-        <p:nvSpPr>
-          <p:cNvPr id="3" name="Content Placeholder 2">
-            <a:extLst>
-              <a:ext uri="{FF2B5EF4-FFF2-40B4-BE49-F238E27FC236}">
-                <a16:creationId xmlns:a16="http://schemas.microsoft.com/office/drawing/2014/main" id="{EE3E28DE-DA44-4ED0-B0F8-EE01B9ACB982}"/>
-              </a:ext>
-            </a:extLst>
-          </p:cNvPr>
-          <p:cNvSpPr txBox="1">
-            <a:spLocks/>
-          </p:cNvSpPr>
-          <p:nvPr/>
-        </p:nvSpPr>
-        <p:spPr>
-          <a:xfrm>
-            <a:off x="365760" y="937454"/>
-            <a:ext cx="11658600" cy="4610100"/>
-          </a:xfrm>
-          <a:prstGeom prst="rect">
-            <a:avLst/>
-          </a:prstGeom>
-        </p:spPr>
-        <p:txBody>
-          <a:bodyPr/>
-          <a:lstStyle>
-            <a:lvl1pPr marL="230188" indent="-230188" algn="l" rtl="0" eaLnBrk="1" fontAlgn="base" hangingPunct="1">
-              <a:lnSpc>
-                <a:spcPct val="90000"/>
-              </a:lnSpc>
-              <a:spcBef>
-                <a:spcPts val="1400"/>
-              </a:spcBef>
-              <a:spcAft>
-                <a:spcPct val="0"/>
-              </a:spcAft>
-              <a:buClr>
-                <a:schemeClr val="tx1"/>
-              </a:buClr>
-              <a:buFont typeface="Arial" charset="0"/>
-              <a:buChar char="•"/>
-              <a:defRPr sz="2400" kern="1200">
-                <a:solidFill>
-                  <a:schemeClr val="tx1"/>
-                </a:solidFill>
-                <a:latin typeface="+mn-lt"/>
-                <a:ea typeface="+mn-ea"/>
-                <a:cs typeface="+mn-cs"/>
-              </a:defRPr>
-            </a:lvl1pPr>
-            <a:lvl2pPr marL="625475" indent="-279400" algn="l" rtl="0" eaLnBrk="1" fontAlgn="base" hangingPunct="1">
-              <a:lnSpc>
-                <a:spcPct val="90000"/>
-              </a:lnSpc>
-              <a:spcBef>
-                <a:spcPts val="800"/>
-              </a:spcBef>
-              <a:spcAft>
-                <a:spcPct val="0"/>
-              </a:spcAft>
-              <a:buClr>
-                <a:schemeClr val="tx1"/>
-              </a:buClr>
-              <a:buFont typeface="Arial" charset="0"/>
-              <a:buChar char="–"/>
-              <a:defRPr sz="2000" kern="1200">
-                <a:solidFill>
-                  <a:schemeClr val="tx1"/>
-                </a:solidFill>
-                <a:latin typeface="+mn-lt"/>
-                <a:ea typeface="+mn-ea"/>
-                <a:cs typeface="+mn-cs"/>
-              </a:defRPr>
-            </a:lvl2pPr>
-            <a:lvl3pPr marL="914400" indent="-230188" algn="l" rtl="0" eaLnBrk="1" fontAlgn="base" hangingPunct="1">
-              <a:lnSpc>
-                <a:spcPct val="90000"/>
-              </a:lnSpc>
-              <a:spcBef>
-                <a:spcPts val="800"/>
-              </a:spcBef>
-              <a:spcAft>
-                <a:spcPct val="0"/>
-              </a:spcAft>
-              <a:buClr>
-                <a:schemeClr val="tx1"/>
-              </a:buClr>
-              <a:buFont typeface="Arial" charset="0"/>
-              <a:buChar char="•"/>
-              <a:defRPr sz="1800" kern="1200">
-                <a:solidFill>
-                  <a:schemeClr val="tx1"/>
-                </a:solidFill>
-                <a:latin typeface="+mn-lt"/>
-                <a:ea typeface="+mn-ea"/>
-                <a:cs typeface="+mn-cs"/>
-              </a:defRPr>
-            </a:lvl3pPr>
-            <a:lvl4pPr marL="1144588" indent="-173038" algn="l" rtl="0" eaLnBrk="1" fontAlgn="base" hangingPunct="1">
-              <a:lnSpc>
-                <a:spcPct val="90000"/>
-              </a:lnSpc>
-              <a:spcBef>
-                <a:spcPts val="800"/>
-              </a:spcBef>
-              <a:spcAft>
-                <a:spcPct val="0"/>
-              </a:spcAft>
-              <a:buClr>
-                <a:schemeClr val="tx1"/>
-              </a:buClr>
-              <a:buFont typeface="Arial" charset="0"/>
-              <a:buChar char="–"/>
-              <a:defRPr sz="1600" kern="1200">
-                <a:solidFill>
-                  <a:schemeClr val="tx1"/>
-                </a:solidFill>
-                <a:latin typeface="+mn-lt"/>
-                <a:ea typeface="+mn-ea"/>
-                <a:cs typeface="+mn-cs"/>
-              </a:defRPr>
-            </a:lvl4pPr>
-            <a:lvl5pPr marL="1482725" indent="-222250" algn="l" rtl="0" eaLnBrk="1" fontAlgn="base" hangingPunct="1">
-              <a:lnSpc>
-                <a:spcPct val="90000"/>
-              </a:lnSpc>
-              <a:spcBef>
-                <a:spcPts val="600"/>
-              </a:spcBef>
-              <a:spcAft>
-                <a:spcPct val="0"/>
-              </a:spcAft>
-              <a:buClr>
-                <a:schemeClr val="tx1"/>
-              </a:buClr>
-              <a:buFont typeface="Arial" charset="0"/>
-              <a:buChar char="»"/>
-              <a:defRPr sz="1600" kern="1200">
-                <a:solidFill>
-                  <a:schemeClr val="tx1"/>
-                </a:solidFill>
-                <a:latin typeface="+mn-lt"/>
-                <a:ea typeface="+mn-ea"/>
-                <a:cs typeface="+mn-cs"/>
-              </a:defRPr>
-            </a:lvl5pPr>
-            <a:lvl6pPr marL="2514600" indent="-228600" algn="l" defTabSz="914400" rtl="0" eaLnBrk="1" latinLnBrk="0" hangingPunct="1">
-              <a:spcBef>
-                <a:spcPct val="20000"/>
-              </a:spcBef>
-              <a:buFont typeface="Arial" pitchFamily="34" charset="0"/>
-              <a:buChar char="•"/>
-              <a:defRPr sz="2000" kern="1200">
-                <a:solidFill>
-                  <a:schemeClr val="tx1"/>
-                </a:solidFill>
-                <a:latin typeface="+mn-lt"/>
-                <a:ea typeface="+mn-ea"/>
-                <a:cs typeface="+mn-cs"/>
-              </a:defRPr>
-            </a:lvl6pPr>
-            <a:lvl7pPr marL="2971800" indent="-228600" algn="l" defTabSz="914400" rtl="0" eaLnBrk="1" latinLnBrk="0" hangingPunct="1">
-              <a:spcBef>
-                <a:spcPct val="20000"/>
-              </a:spcBef>
-              <a:buFont typeface="Arial" pitchFamily="34" charset="0"/>
-              <a:buChar char="•"/>
-              <a:defRPr sz="2000" kern="1200">
-                <a:solidFill>
-                  <a:schemeClr val="tx1"/>
-                </a:solidFill>
-                <a:latin typeface="+mn-lt"/>
-                <a:ea typeface="+mn-ea"/>
-                <a:cs typeface="+mn-cs"/>
-              </a:defRPr>
-            </a:lvl7pPr>
-            <a:lvl8pPr marL="3429000" indent="-228600" algn="l" defTabSz="914400" rtl="0" eaLnBrk="1" latinLnBrk="0" hangingPunct="1">
-              <a:spcBef>
-                <a:spcPct val="20000"/>
-              </a:spcBef>
-              <a:buFont typeface="Arial" pitchFamily="34" charset="0"/>
-              <a:buChar char="•"/>
-              <a:defRPr sz="2000" kern="1200">
-                <a:solidFill>
-                  <a:schemeClr val="tx1"/>
-                </a:solidFill>
-                <a:latin typeface="+mn-lt"/>
-                <a:ea typeface="+mn-ea"/>
-                <a:cs typeface="+mn-cs"/>
-              </a:defRPr>
-            </a:lvl8pPr>
-            <a:lvl9pPr marL="3886200" indent="-228600" algn="l" defTabSz="914400" rtl="0" eaLnBrk="1" latinLnBrk="0" hangingPunct="1">
-              <a:spcBef>
-                <a:spcPct val="20000"/>
-              </a:spcBef>
-              <a:buFont typeface="Arial" pitchFamily="34" charset="0"/>
-              <a:buChar char="•"/>
-              <a:defRPr sz="2000" kern="1200">
-                <a:solidFill>
-                  <a:schemeClr val="tx1"/>
-                </a:solidFill>
-                <a:latin typeface="+mn-lt"/>
-                <a:ea typeface="+mn-ea"/>
-                <a:cs typeface="+mn-cs"/>
-              </a:defRPr>
-            </a:lvl9pPr>
-          </a:lstStyle>
-          <a:p>
-            <a:pPr marL="0" indent="0">
-              <a:spcBef>
-                <a:spcPts val="400"/>
-              </a:spcBef>
-              <a:buFont typeface="Arial" charset="0"/>
-              <a:buNone/>
-            </a:pPr>
-            <a:r>
-              <a:rPr lang="en-US" b="1" dirty="0">
-                <a:hlinkClick r:id="rId2"/>
-              </a:rPr>
-              <a:t>https://bssw.io </a:t>
-            </a:r>
-            <a:endParaRPr lang="en-US" b="1" dirty="0"/>
-          </a:p>
-          <a:p>
-            <a:pPr>
-              <a:spcBef>
-                <a:spcPts val="400"/>
-              </a:spcBef>
-            </a:pPr>
-            <a:r>
-              <a:rPr lang="en-US" sz="2000" b="1" dirty="0">
-                <a:solidFill>
-                  <a:schemeClr val="accent1"/>
-                </a:solidFill>
-              </a:rPr>
-              <a:t>New </a:t>
-            </a:r>
-            <a:r>
-              <a:rPr lang="en-US" sz="2000" b="1" u="sng" dirty="0">
-                <a:solidFill>
-                  <a:schemeClr val="accent1"/>
-                </a:solidFill>
-              </a:rPr>
-              <a:t>community-based resource</a:t>
-            </a:r>
-            <a:r>
-              <a:rPr lang="en-US" sz="2000" b="1" dirty="0">
-                <a:solidFill>
-                  <a:schemeClr val="accent1"/>
-                </a:solidFill>
-              </a:rPr>
-              <a:t> for scientific software </a:t>
-            </a:r>
-            <a:br>
-              <a:rPr lang="en-US" sz="2000" b="1" dirty="0">
-                <a:solidFill>
-                  <a:schemeClr val="accent1"/>
-                </a:solidFill>
-              </a:rPr>
-            </a:br>
-            <a:r>
-              <a:rPr lang="en-US" sz="2000" b="1" dirty="0">
-                <a:solidFill>
-                  <a:schemeClr val="accent1"/>
-                </a:solidFill>
-              </a:rPr>
-              <a:t>improvement</a:t>
-            </a:r>
-          </a:p>
-          <a:p>
-            <a:pPr>
-              <a:spcBef>
-                <a:spcPts val="400"/>
-              </a:spcBef>
-            </a:pPr>
-            <a:r>
-              <a:rPr lang="en-US" sz="2000" dirty="0"/>
-              <a:t>A central hub for sharing information on practices, techniques, experiences, and tools to improve developer productivity and software sustainability for computational science &amp; engineering (CSE)</a:t>
-            </a:r>
-            <a:endParaRPr lang="en-US" dirty="0"/>
-          </a:p>
-          <a:p>
-            <a:pPr marL="0" indent="0">
-              <a:buFont typeface="Arial" charset="0"/>
-              <a:buNone/>
-            </a:pPr>
-            <a:r>
-              <a:rPr lang="en-US" b="1" dirty="0"/>
-              <a:t>Goals</a:t>
-            </a:r>
-          </a:p>
-          <a:p>
-            <a:pPr>
-              <a:spcBef>
-                <a:spcPts val="400"/>
-              </a:spcBef>
-            </a:pPr>
-            <a:r>
-              <a:rPr lang="en-US" sz="2000" dirty="0"/>
-              <a:t>Raise awareness of the importance of </a:t>
-            </a:r>
-            <a:r>
-              <a:rPr lang="en-US" sz="2000" b="1" dirty="0"/>
-              <a:t>good software practices </a:t>
-            </a:r>
-            <a:r>
-              <a:rPr lang="en-US" sz="2000" dirty="0"/>
-              <a:t>to scientific productivity and to the quality and reliability of computationally-based scientific results</a:t>
-            </a:r>
-          </a:p>
-          <a:p>
-            <a:pPr>
-              <a:spcBef>
-                <a:spcPts val="400"/>
-              </a:spcBef>
-            </a:pPr>
-            <a:r>
-              <a:rPr lang="en-US" sz="2000" dirty="0"/>
-              <a:t>Raise awareness of the </a:t>
-            </a:r>
-            <a:r>
-              <a:rPr lang="en-US" sz="2000" b="1" dirty="0"/>
-              <a:t>increasing challenges </a:t>
-            </a:r>
-            <a:r>
-              <a:rPr lang="en-US" sz="2000" dirty="0"/>
-              <a:t>facing CSE software developers as high-end computing heads to extreme scales</a:t>
-            </a:r>
-          </a:p>
-          <a:p>
-            <a:pPr>
-              <a:spcBef>
-                <a:spcPts val="400"/>
-              </a:spcBef>
-            </a:pPr>
-            <a:r>
-              <a:rPr lang="en-US" sz="2000" dirty="0"/>
-              <a:t>Help CSE researchers </a:t>
-            </a:r>
-            <a:r>
-              <a:rPr lang="en-US" sz="2000" b="1" dirty="0"/>
-              <a:t>increase effectiveness </a:t>
-            </a:r>
-            <a:r>
-              <a:rPr lang="en-US" sz="2000" dirty="0"/>
-              <a:t>as well as leverage and impact</a:t>
-            </a:r>
-          </a:p>
-          <a:p>
-            <a:pPr>
-              <a:spcBef>
-                <a:spcPts val="400"/>
-              </a:spcBef>
-            </a:pPr>
-            <a:r>
-              <a:rPr lang="en-US" sz="2000" b="1" dirty="0"/>
-              <a:t>Facilitate CSE collaboration via software</a:t>
-            </a:r>
-            <a:r>
-              <a:rPr lang="en-US" sz="2000" dirty="0"/>
-              <a:t> in order to advance scientific discoveries</a:t>
-            </a:r>
-          </a:p>
-          <a:p>
-            <a:pPr marL="0" indent="0">
-              <a:buFont typeface="Arial" charset="0"/>
-              <a:buNone/>
-            </a:pPr>
-            <a:r>
-              <a:rPr lang="en-US" b="1" dirty="0"/>
-              <a:t>Site users can…</a:t>
-            </a:r>
-          </a:p>
-          <a:p>
-            <a:pPr>
-              <a:spcBef>
-                <a:spcPts val="400"/>
-              </a:spcBef>
-            </a:pPr>
-            <a:r>
-              <a:rPr lang="en-US" sz="2000" b="1" dirty="0"/>
-              <a:t>Find information </a:t>
-            </a:r>
-            <a:r>
-              <a:rPr lang="en-US" sz="2000" dirty="0"/>
-              <a:t>on scientific software topics</a:t>
-            </a:r>
-          </a:p>
-          <a:p>
-            <a:pPr>
-              <a:spcBef>
-                <a:spcPts val="400"/>
-              </a:spcBef>
-            </a:pPr>
-            <a:r>
-              <a:rPr lang="en-US" sz="2000" b="1" dirty="0"/>
-              <a:t>Contribute new resources </a:t>
-            </a:r>
-            <a:r>
-              <a:rPr lang="en-US" sz="2000" dirty="0"/>
-              <a:t>based on your experiences</a:t>
-            </a:r>
-          </a:p>
-          <a:p>
-            <a:pPr>
-              <a:spcBef>
-                <a:spcPts val="400"/>
-              </a:spcBef>
-            </a:pPr>
-            <a:r>
-              <a:rPr lang="en-US" sz="2000" dirty="0"/>
-              <a:t>Create content tailored to the unique needs and </a:t>
-            </a:r>
-            <a:br>
-              <a:rPr lang="en-US" sz="2000" dirty="0"/>
-            </a:br>
-            <a:r>
-              <a:rPr lang="en-US" sz="2000" dirty="0"/>
-              <a:t>perspectives of a focused scientific domain</a:t>
-            </a:r>
-          </a:p>
-        </p:txBody>
-      </p:sp>
-      <p:pic>
-        <p:nvPicPr>
-          <p:cNvPr id="4" name="Picture 3" descr="Screen Shot 2017-01-21 at 6.45.35 PM.png">
-            <a:extLst>
-              <a:ext uri="{FF2B5EF4-FFF2-40B4-BE49-F238E27FC236}">
-                <a16:creationId xmlns:a16="http://schemas.microsoft.com/office/drawing/2014/main" id="{4305FC7E-611D-4E7E-952D-9882E099EE96}"/>
-              </a:ext>
-            </a:extLst>
-          </p:cNvPr>
-          <p:cNvPicPr>
-            <a:picLocks noChangeAspect="1"/>
-          </p:cNvPicPr>
-          <p:nvPr/>
-        </p:nvPicPr>
-        <p:blipFill>
-          <a:blip r:embed="rId3" cstate="print">
-            <a:extLst>
-              <a:ext uri="{28A0092B-C50C-407E-A947-70E740481C1C}">
-                <a14:useLocalDpi xmlns:a14="http://schemas.microsoft.com/office/drawing/2010/main" val="0"/>
-              </a:ext>
-            </a:extLst>
-          </a:blip>
-          <a:stretch>
-            <a:fillRect/>
-          </a:stretch>
-        </p:blipFill>
-        <p:spPr>
-          <a:xfrm>
-            <a:off x="8483534" y="320039"/>
-            <a:ext cx="3357819" cy="1440667"/>
-          </a:xfrm>
-          <a:prstGeom prst="rect">
-            <a:avLst/>
-          </a:prstGeom>
-        </p:spPr>
-      </p:pic>
-    </p:spTree>
-    <p:extLst>
-      <p:ext uri="{BB962C8B-B14F-4D97-AF65-F5344CB8AC3E}">
-        <p14:creationId xmlns:p14="http://schemas.microsoft.com/office/powerpoint/2010/main" val="245510431"/>
-      </p:ext>
-    </p:extLst>
-  </p:cSld>
-  <p:clrMapOvr>
-    <a:masterClrMapping/>
-  </p:clrMapOvr>
-</p:sld>
-</file>
-
-<file path=ppt/slides/slide5.xml><?xml version="1.0" encoding="utf-8"?>
-<p:sld xmlns:a="http://schemas.openxmlformats.org/drawingml/2006/main" xmlns:r="http://schemas.openxmlformats.org/officeDocument/2006/relationships" xmlns:p="http://schemas.openxmlformats.org/presentationml/2006/main">
-  <p:cSld>
-    <p:spTree>
-      <p:nvGrpSpPr>
-        <p:cNvPr id="1" name=""/>
-        <p:cNvGrpSpPr/>
-        <p:nvPr/>
-      </p:nvGrpSpPr>
-      <p:grpSpPr>
-        <a:xfrm>
-          <a:off x="0" y="0"/>
-          <a:ext cx="0" cy="0"/>
-          <a:chOff x="0" y="0"/>
-          <a:chExt cx="0" cy="0"/>
-        </a:xfrm>
-      </p:grpSpPr>
-      <p:sp>
-        <p:nvSpPr>
-          <p:cNvPr id="3" name="Title 2">
-            <a:extLst>
-              <a:ext uri="{FF2B5EF4-FFF2-40B4-BE49-F238E27FC236}">
-                <a16:creationId xmlns:a16="http://schemas.microsoft.com/office/drawing/2014/main" id="{958CB878-0734-4463-835E-51258994794F}"/>
-              </a:ext>
-            </a:extLst>
-          </p:cNvPr>
-          <p:cNvSpPr>
-            <a:spLocks noGrp="1"/>
-          </p:cNvSpPr>
-          <p:nvPr>
-            <p:ph type="title"/>
-          </p:nvPr>
-        </p:nvSpPr>
-        <p:spPr/>
-        <p:txBody>
-          <a:bodyPr/>
-          <a:lstStyle/>
-          <a:p>
-            <a:r>
-              <a:rPr lang="en-US" dirty="0"/>
-              <a:t>Follow </a:t>
-            </a:r>
-            <a:r>
-              <a:rPr lang="en-US" dirty="0" err="1"/>
-              <a:t>BSSw</a:t>
-            </a:r>
-            <a:endParaRPr lang="en-US" dirty="0"/>
-          </a:p>
-        </p:txBody>
-      </p:sp>
-      <p:sp>
-        <p:nvSpPr>
-          <p:cNvPr id="4" name="Content Placeholder 3">
-            <a:extLst>
-              <a:ext uri="{FF2B5EF4-FFF2-40B4-BE49-F238E27FC236}">
-                <a16:creationId xmlns:a16="http://schemas.microsoft.com/office/drawing/2014/main" id="{AE2680D0-A841-4E56-972F-EBFB89AD4D33}"/>
-              </a:ext>
-            </a:extLst>
-          </p:cNvPr>
-          <p:cNvSpPr>
-            <a:spLocks noGrp="1"/>
-          </p:cNvSpPr>
-          <p:nvPr>
-            <p:ph idx="1"/>
-          </p:nvPr>
-        </p:nvSpPr>
-        <p:spPr/>
-        <p:txBody>
-          <a:bodyPr/>
-          <a:lstStyle/>
-          <a:p>
-            <a:pPr>
-              <a:spcBef>
-                <a:spcPts val="2400"/>
-              </a:spcBef>
-            </a:pPr>
-            <a:r>
-              <a:rPr lang="en-US" dirty="0" err="1"/>
-              <a:t>BSSw</a:t>
-            </a:r>
-            <a:r>
-              <a:rPr lang="en-US" dirty="0"/>
-              <a:t> Digest: </a:t>
-            </a:r>
-            <a:r>
-              <a:rPr lang="en-US" dirty="0">
-                <a:hlinkClick r:id="rId2"/>
-              </a:rPr>
-              <a:t>https://bssw.io/pages/receive-our-email-digest</a:t>
-            </a:r>
-            <a:endParaRPr lang="en-US" dirty="0"/>
-          </a:p>
-          <a:p>
-            <a:pPr lvl="1"/>
-            <a:r>
-              <a:rPr lang="en-US" dirty="0"/>
-              <a:t>Updates on </a:t>
-            </a:r>
-            <a:r>
-              <a:rPr lang="en-US" dirty="0" err="1"/>
-              <a:t>BSSw</a:t>
-            </a:r>
-            <a:r>
-              <a:rPr lang="en-US" dirty="0"/>
-              <a:t> content</a:t>
-            </a:r>
-          </a:p>
-          <a:p>
-            <a:pPr lvl="2"/>
-            <a:r>
-              <a:rPr lang="en-US" dirty="0"/>
-              <a:t>New blog posts, events, and resources</a:t>
-            </a:r>
-          </a:p>
-          <a:p>
-            <a:pPr lvl="2"/>
-            <a:r>
-              <a:rPr lang="en-US" dirty="0" err="1"/>
-              <a:t>BSSw</a:t>
-            </a:r>
-            <a:r>
-              <a:rPr lang="en-US" dirty="0"/>
-              <a:t> Fellowship</a:t>
-            </a:r>
-          </a:p>
-          <a:p>
-            <a:pPr lvl="1"/>
-            <a:r>
-              <a:rPr lang="en-US" dirty="0"/>
-              <a:t>Typically 1-2 messages per month</a:t>
-            </a:r>
-          </a:p>
-          <a:p>
-            <a:pPr lvl="1"/>
-            <a:r>
-              <a:rPr lang="en-US" dirty="0"/>
-              <a:t>Also: RSS feed: </a:t>
-            </a:r>
-            <a:r>
-              <a:rPr lang="en-US" dirty="0">
-                <a:hlinkClick r:id="rId3"/>
-              </a:rPr>
-              <a:t>https://bssw.io/items.rss</a:t>
-            </a:r>
-            <a:endParaRPr lang="en-US" dirty="0"/>
-          </a:p>
-        </p:txBody>
-      </p:sp>
-      <p:pic>
-        <p:nvPicPr>
-          <p:cNvPr id="5" name="Picture 4" descr="Screen Shot 2017-01-21 at 6.45.35 PM.png">
-            <a:extLst>
-              <a:ext uri="{FF2B5EF4-FFF2-40B4-BE49-F238E27FC236}">
-                <a16:creationId xmlns:a16="http://schemas.microsoft.com/office/drawing/2014/main" id="{DDAA8357-C3CA-4399-9F08-279982853473}"/>
-              </a:ext>
-            </a:extLst>
-          </p:cNvPr>
-          <p:cNvPicPr>
-            <a:picLocks noChangeAspect="1"/>
-          </p:cNvPicPr>
-          <p:nvPr/>
-        </p:nvPicPr>
-        <p:blipFill>
-          <a:blip r:embed="rId4" cstate="print">
-            <a:extLst>
-              <a:ext uri="{28A0092B-C50C-407E-A947-70E740481C1C}">
-                <a14:useLocalDpi xmlns:a14="http://schemas.microsoft.com/office/drawing/2010/main" val="0"/>
-              </a:ext>
-            </a:extLst>
-          </a:blip>
-          <a:stretch>
-            <a:fillRect/>
-          </a:stretch>
-        </p:blipFill>
-        <p:spPr>
-          <a:xfrm>
-            <a:off x="8558894" y="2643687"/>
-            <a:ext cx="2109916" cy="905256"/>
-          </a:xfrm>
-          <a:prstGeom prst="rect">
-            <a:avLst/>
-          </a:prstGeom>
-        </p:spPr>
-      </p:pic>
-    </p:spTree>
-    <p:extLst>
-      <p:ext uri="{BB962C8B-B14F-4D97-AF65-F5344CB8AC3E}">
-        <p14:creationId xmlns:p14="http://schemas.microsoft.com/office/powerpoint/2010/main" val="2696507976"/>
-      </p:ext>
-    </p:extLst>
-  </p:cSld>
-  <p:clrMapOvr>
-    <a:masterClrMapping/>
-  </p:clrMapOvr>
-</p:sld>
-</file>
-
-<file path=ppt/slides/slide6.xml><?xml version="1.0" encoding="utf-8"?>
-<p:sld xmlns:a="http://schemas.openxmlformats.org/drawingml/2006/main" xmlns:r="http://schemas.openxmlformats.org/officeDocument/2006/relationships" xmlns:p="http://schemas.openxmlformats.org/presentationml/2006/main">
-  <p:cSld>
-    <p:spTree>
-      <p:nvGrpSpPr>
-        <p:cNvPr id="1" name=""/>
-        <p:cNvGrpSpPr/>
-        <p:nvPr/>
-      </p:nvGrpSpPr>
-      <p:grpSpPr>
-        <a:xfrm>
-          <a:off x="0" y="0"/>
-          <a:ext cx="0" cy="0"/>
-          <a:chOff x="0" y="0"/>
-          <a:chExt cx="0" cy="0"/>
-        </a:xfrm>
-      </p:grpSpPr>
-      <p:sp>
-        <p:nvSpPr>
-          <p:cNvPr id="2" name="Title 1">
-            <a:extLst>
-              <a:ext uri="{FF2B5EF4-FFF2-40B4-BE49-F238E27FC236}">
-                <a16:creationId xmlns:a16="http://schemas.microsoft.com/office/drawing/2014/main" id="{290A2901-48B8-469D-BFD7-34B28CA8F61C}"/>
-              </a:ext>
-            </a:extLst>
-          </p:cNvPr>
-          <p:cNvSpPr>
-            <a:spLocks noGrp="1"/>
-          </p:cNvSpPr>
-          <p:nvPr>
-            <p:ph type="title"/>
-          </p:nvPr>
-        </p:nvSpPr>
-        <p:spPr/>
-        <p:txBody>
-          <a:bodyPr/>
-          <a:lstStyle/>
-          <a:p>
-            <a:r>
-              <a:rPr lang="en-US" dirty="0" err="1"/>
-              <a:t>BSSw</a:t>
-            </a:r>
-            <a:r>
-              <a:rPr lang="en-US" dirty="0"/>
-              <a:t> Tutorial Web Site</a:t>
-            </a:r>
-          </a:p>
-        </p:txBody>
-      </p:sp>
-      <p:sp>
-        <p:nvSpPr>
-          <p:cNvPr id="3" name="Content Placeholder 2">
-            <a:extLst>
-              <a:ext uri="{FF2B5EF4-FFF2-40B4-BE49-F238E27FC236}">
-                <a16:creationId xmlns:a16="http://schemas.microsoft.com/office/drawing/2014/main" id="{1C6E25F3-5A8B-478E-83F2-ED0BCAF1B015}"/>
-              </a:ext>
-            </a:extLst>
-          </p:cNvPr>
-          <p:cNvSpPr>
-            <a:spLocks noGrp="1"/>
-          </p:cNvSpPr>
-          <p:nvPr>
-            <p:ph idx="1"/>
-          </p:nvPr>
-        </p:nvSpPr>
-        <p:spPr>
-          <a:xfrm>
-            <a:off x="365760" y="1737360"/>
-            <a:ext cx="7453937" cy="4047778"/>
-          </a:xfrm>
-        </p:spPr>
-        <p:txBody>
-          <a:bodyPr/>
-          <a:lstStyle/>
-          <a:p>
-            <a:r>
-              <a:rPr lang="en-US" sz="2400" b="1" dirty="0">
-                <a:hlinkClick r:id="rId2"/>
-              </a:rPr>
-              <a:t>https://bssw-tutorial.github.io/</a:t>
-            </a:r>
-            <a:r>
-              <a:rPr lang="en-US" sz="2400" b="1" dirty="0"/>
-              <a:t> </a:t>
-            </a:r>
-            <a:r>
-              <a:rPr lang="en-US" sz="2400" dirty="0"/>
-              <a:t>is the one URL you need to find all the resources for this tutorial</a:t>
-            </a:r>
-          </a:p>
-          <a:p>
-            <a:r>
-              <a:rPr lang="en-US" dirty="0"/>
-              <a:t>Each tutorial event has its own page</a:t>
-            </a:r>
-          </a:p>
-          <a:p>
-            <a:r>
-              <a:rPr lang="en-US" dirty="0"/>
-              <a:t>Each tutorial page is considered archival</a:t>
-            </a:r>
-          </a:p>
-          <a:p>
-            <a:pPr lvl="1"/>
-            <a:r>
-              <a:rPr lang="en-US" dirty="0"/>
-              <a:t>All of the materials used in that tutorial (or links to them)</a:t>
-            </a:r>
-          </a:p>
-          <a:p>
-            <a:pPr lvl="1"/>
-            <a:r>
-              <a:rPr lang="en-US" dirty="0"/>
-              <a:t>Materials may be updated if we find mistakes</a:t>
-            </a:r>
-          </a:p>
-        </p:txBody>
-      </p:sp>
-      <p:pic>
-        <p:nvPicPr>
-          <p:cNvPr id="6" name="Picture 5" descr="Graphical user interface, text&#10;&#10;Description automatically generated">
-            <a:extLst>
-              <a:ext uri="{FF2B5EF4-FFF2-40B4-BE49-F238E27FC236}">
-                <a16:creationId xmlns:a16="http://schemas.microsoft.com/office/drawing/2014/main" id="{B36C999D-A67A-4A27-A8A2-05E0A7E3AD25}"/>
-              </a:ext>
-            </a:extLst>
-          </p:cNvPr>
-          <p:cNvPicPr>
-            <a:picLocks noChangeAspect="1"/>
-          </p:cNvPicPr>
-          <p:nvPr/>
-        </p:nvPicPr>
-        <p:blipFill>
-          <a:blip r:embed="rId3" cstate="print">
-            <a:extLst>
-              <a:ext uri="{28A0092B-C50C-407E-A947-70E740481C1C}">
-                <a14:useLocalDpi xmlns:a14="http://schemas.microsoft.com/office/drawing/2010/main" val="0"/>
-              </a:ext>
-            </a:extLst>
-          </a:blip>
-          <a:stretch>
-            <a:fillRect/>
-          </a:stretch>
-        </p:blipFill>
-        <p:spPr>
-          <a:xfrm>
-            <a:off x="7819697" y="455350"/>
-            <a:ext cx="4089597" cy="5345008"/>
-          </a:xfrm>
-          <a:prstGeom prst="rect">
-            <a:avLst/>
-          </a:prstGeom>
-          <a:ln>
-            <a:solidFill>
-              <a:schemeClr val="tx1"/>
-            </a:solidFill>
-          </a:ln>
-          <a:effectLst>
-            <a:outerShdw blurRad="50800" dist="38100" dir="2700000" algn="tl" rotWithShape="0">
-              <a:prstClr val="black">
-                <a:alpha val="40000"/>
-              </a:prstClr>
-            </a:outerShdw>
-          </a:effectLst>
-        </p:spPr>
-      </p:pic>
-    </p:spTree>
-    <p:extLst>
-      <p:ext uri="{BB962C8B-B14F-4D97-AF65-F5344CB8AC3E}">
-        <p14:creationId xmlns:p14="http://schemas.microsoft.com/office/powerpoint/2010/main" val="1366987390"/>
-      </p:ext>
-    </p:extLst>
-  </p:cSld>
-  <p:clrMapOvr>
-    <a:masterClrMapping/>
-  </p:clrMapOvr>
-</p:sld>
-</file>
-
-<file path=ppt/slides/slide7.xml><?xml version="1.0" encoding="utf-8"?>
-<p:sld xmlns:a="http://schemas.openxmlformats.org/drawingml/2006/main" xmlns:r="http://schemas.openxmlformats.org/officeDocument/2006/relationships" xmlns:p="http://schemas.openxmlformats.org/presentationml/2006/main">
-  <p:cSld>
-    <p:spTree>
-      <p:nvGrpSpPr>
-        <p:cNvPr id="1" name=""/>
-        <p:cNvGrpSpPr/>
-        <p:nvPr/>
-      </p:nvGrpSpPr>
-      <p:grpSpPr>
-        <a:xfrm>
-          <a:off x="0" y="0"/>
-          <a:ext cx="0" cy="0"/>
-          <a:chOff x="0" y="0"/>
-          <a:chExt cx="0" cy="0"/>
-        </a:xfrm>
-      </p:grpSpPr>
-      <p:sp>
-        <p:nvSpPr>
-          <p:cNvPr id="2" name="Title 1">
-            <a:extLst>
-              <a:ext uri="{FF2B5EF4-FFF2-40B4-BE49-F238E27FC236}">
-                <a16:creationId xmlns:a16="http://schemas.microsoft.com/office/drawing/2014/main" id="{7E57752C-4E2B-4E58-8726-8BAC8610FAC7}"/>
-              </a:ext>
-            </a:extLst>
-          </p:cNvPr>
-          <p:cNvSpPr>
-            <a:spLocks noGrp="1"/>
-          </p:cNvSpPr>
-          <p:nvPr>
-            <p:ph type="title"/>
-          </p:nvPr>
-        </p:nvSpPr>
-        <p:spPr/>
-        <p:txBody>
-          <a:bodyPr/>
-          <a:lstStyle/>
-          <a:p>
-            <a:r>
-              <a:rPr lang="en-US" dirty="0"/>
-              <a:t>Explaining Slide 2</a:t>
-            </a:r>
-          </a:p>
-        </p:txBody>
-      </p:sp>
-      <p:sp>
-        <p:nvSpPr>
-          <p:cNvPr id="3" name="Content Placeholder 2">
-            <a:extLst>
-              <a:ext uri="{FF2B5EF4-FFF2-40B4-BE49-F238E27FC236}">
-                <a16:creationId xmlns:a16="http://schemas.microsoft.com/office/drawing/2014/main" id="{9A010E9D-1983-429B-A89D-EBF4829E152F}"/>
-              </a:ext>
-            </a:extLst>
-          </p:cNvPr>
-          <p:cNvSpPr>
-            <a:spLocks noGrp="1"/>
-          </p:cNvSpPr>
-          <p:nvPr>
-            <p:ph idx="1"/>
-          </p:nvPr>
-        </p:nvSpPr>
-        <p:spPr>
-          <a:xfrm>
-            <a:off x="365760" y="1049985"/>
-            <a:ext cx="11369809" cy="4047778"/>
-          </a:xfrm>
-        </p:spPr>
-        <p:txBody>
-          <a:bodyPr/>
-          <a:lstStyle/>
-          <a:p>
-            <a:r>
-              <a:rPr lang="en-US" dirty="0"/>
-              <a:t>Slide 2 in all of our presentations contains the license, citation, and acknowledgements for the tutorial</a:t>
-            </a:r>
-          </a:p>
-          <a:p>
-            <a:r>
-              <a:rPr lang="en-US" dirty="0"/>
-              <a:t>(Software) best practice to make your license and preferred citation(s) </a:t>
-            </a:r>
-            <a:r>
-              <a:rPr lang="en-US"/>
-              <a:t>easily findable</a:t>
-            </a:r>
-            <a:endParaRPr lang="en-US" dirty="0"/>
-          </a:p>
-          <a:p>
-            <a:r>
-              <a:rPr lang="en-US" dirty="0"/>
-              <a:t>Sponsor acknowledgements rarely hurt!</a:t>
-            </a:r>
-          </a:p>
-        </p:txBody>
-      </p:sp>
-      <p:pic>
-        <p:nvPicPr>
-          <p:cNvPr id="10" name="Picture 9" descr="A document with text and images&#10;&#10;Description automatically generated">
-            <a:extLst>
-              <a:ext uri="{FF2B5EF4-FFF2-40B4-BE49-F238E27FC236}">
-                <a16:creationId xmlns:a16="http://schemas.microsoft.com/office/drawing/2014/main" id="{77E2D18D-1073-12C7-771C-B42CCA7E04E2}"/>
-              </a:ext>
-            </a:extLst>
-          </p:cNvPr>
-          <p:cNvPicPr>
-            <a:picLocks noChangeAspect="1"/>
-          </p:cNvPicPr>
-          <p:nvPr/>
-        </p:nvPicPr>
-        <p:blipFill rotWithShape="1">
-          <a:blip r:embed="rId2" cstate="print">
-            <a:extLst>
-              <a:ext uri="{28A0092B-C50C-407E-A947-70E740481C1C}">
-                <a14:useLocalDpi xmlns:a14="http://schemas.microsoft.com/office/drawing/2010/main" val="0"/>
-              </a:ext>
-            </a:extLst>
-          </a:blip>
-          <a:srcRect t="1" b="23157"/>
-          <a:stretch/>
-        </p:blipFill>
-        <p:spPr>
-          <a:xfrm>
-            <a:off x="1938615" y="3256754"/>
-            <a:ext cx="7772400" cy="3383280"/>
-          </a:xfrm>
-          <a:prstGeom prst="rect">
-            <a:avLst/>
-          </a:prstGeom>
-        </p:spPr>
-      </p:pic>
-    </p:spTree>
-    <p:extLst>
-      <p:ext uri="{BB962C8B-B14F-4D97-AF65-F5344CB8AC3E}">
-        <p14:creationId xmlns:p14="http://schemas.microsoft.com/office/powerpoint/2010/main" val="2504672246"/>
-      </p:ext>
-    </p:extLst>
-  </p:cSld>
-  <p:clrMapOvr>
-    <a:masterClrMapping/>
-  </p:clrMapOvr>
-</p:sld>
-</file>
-
-<file path=ppt/slides/slide8.xml><?xml version="1.0" encoding="utf-8"?>
-<p:sld xmlns:a="http://schemas.openxmlformats.org/drawingml/2006/main" xmlns:r="http://schemas.openxmlformats.org/officeDocument/2006/relationships" xmlns:p="http://schemas.openxmlformats.org/presentationml/2006/main">
-  <p:cSld>
-    <p:spTree>
-      <p:nvGrpSpPr>
-        <p:cNvPr id="1" name=""/>
-        <p:cNvGrpSpPr/>
-        <p:nvPr/>
-      </p:nvGrpSpPr>
-      <p:grpSpPr>
-        <a:xfrm>
-          <a:off x="0" y="0"/>
-          <a:ext cx="0" cy="0"/>
-          <a:chOff x="0" y="0"/>
-          <a:chExt cx="0" cy="0"/>
-        </a:xfrm>
-      </p:grpSpPr>
-      <p:sp>
-        <p:nvSpPr>
-          <p:cNvPr id="2" name="Title 1">
-            <a:extLst>
-              <a:ext uri="{FF2B5EF4-FFF2-40B4-BE49-F238E27FC236}">
-                <a16:creationId xmlns:a16="http://schemas.microsoft.com/office/drawing/2014/main" id="{88D7CFF0-36AC-4BF3-96D2-C6F302144850}"/>
-              </a:ext>
-            </a:extLst>
-          </p:cNvPr>
-          <p:cNvSpPr>
-            <a:spLocks noGrp="1"/>
-          </p:cNvSpPr>
-          <p:nvPr>
-            <p:ph type="title"/>
-          </p:nvPr>
-        </p:nvSpPr>
-        <p:spPr/>
-        <p:txBody>
-          <a:bodyPr/>
-          <a:lstStyle/>
-          <a:p>
-            <a:r>
-              <a:rPr lang="en-US" dirty="0"/>
-              <a:t>We Want to Interact with You!</a:t>
-            </a:r>
-          </a:p>
-        </p:txBody>
-      </p:sp>
-      <p:sp>
-        <p:nvSpPr>
-          <p:cNvPr id="3" name="Content Placeholder 2">
-            <a:extLst>
-              <a:ext uri="{FF2B5EF4-FFF2-40B4-BE49-F238E27FC236}">
-                <a16:creationId xmlns:a16="http://schemas.microsoft.com/office/drawing/2014/main" id="{AEFD04A9-5547-4AC6-89F3-E6EEC039A00D}"/>
-              </a:ext>
-            </a:extLst>
-          </p:cNvPr>
-          <p:cNvSpPr>
-            <a:spLocks noGrp="1"/>
-          </p:cNvSpPr>
-          <p:nvPr>
-            <p:ph idx="1"/>
-          </p:nvPr>
-        </p:nvSpPr>
-        <p:spPr>
-          <a:xfrm>
-            <a:off x="365760" y="919230"/>
-            <a:ext cx="11369809" cy="4047778"/>
-          </a:xfrm>
-        </p:spPr>
-        <p:txBody>
-          <a:bodyPr/>
-          <a:lstStyle/>
-          <a:p>
-            <a:pPr>
-              <a:spcBef>
-                <a:spcPts val="1800"/>
-              </a:spcBef>
-            </a:pPr>
-            <a:r>
-              <a:rPr lang="en-US" dirty="0"/>
-              <a:t>We find these tutorials most interesting and informative (for everyone) if you ask questions and share experiences!</a:t>
-            </a:r>
-          </a:p>
-          <a:p>
-            <a:pPr lvl="1">
-              <a:spcBef>
-                <a:spcPts val="400"/>
-              </a:spcBef>
-            </a:pPr>
-            <a:r>
-              <a:rPr lang="en-US" dirty="0"/>
-              <a:t>We learn too!</a:t>
-            </a:r>
-          </a:p>
-          <a:p>
-            <a:pPr>
-              <a:spcBef>
-                <a:spcPts val="400"/>
-              </a:spcBef>
-            </a:pPr>
-            <a:r>
-              <a:rPr lang="en-US" dirty="0"/>
-              <a:t>Please raise your hand at any time to ask a question</a:t>
-            </a:r>
-          </a:p>
-          <a:p>
-            <a:pPr>
-              <a:spcBef>
-                <a:spcPts val="1200"/>
-              </a:spcBef>
-            </a:pPr>
-            <a:r>
-              <a:rPr lang="en-US" dirty="0"/>
-              <a:t>After the tutorial email us at </a:t>
-            </a:r>
-            <a:r>
-              <a:rPr lang="en-US" dirty="0">
-                <a:hlinkClick r:id="rId2"/>
-              </a:rPr>
-              <a:t>bssw-tutorial@lists.mcs.anl.gov</a:t>
-            </a:r>
-            <a:endParaRPr lang="en-US" dirty="0"/>
-          </a:p>
-          <a:p>
-            <a:pPr lvl="1">
-              <a:spcBef>
-                <a:spcPts val="400"/>
-              </a:spcBef>
-            </a:pPr>
-            <a:r>
-              <a:rPr lang="en-US" dirty="0"/>
-              <a:t>With questions or feedback</a:t>
-            </a:r>
-          </a:p>
-          <a:p>
-            <a:pPr lvl="1"/>
-            <a:r>
-              <a:rPr lang="en-US" dirty="0"/>
-              <a:t>The list moderator will allow your messages to be posted</a:t>
-            </a:r>
-          </a:p>
-          <a:p>
-            <a:r>
-              <a:rPr lang="en-US" dirty="0"/>
-              <a:t>Refer to </a:t>
-            </a:r>
-            <a:r>
-              <a:rPr lang="en-US" dirty="0">
-                <a:hlinkClick r:id="rId3"/>
-              </a:rPr>
-              <a:t>bssw-tutorial.github.io</a:t>
-            </a:r>
-            <a:r>
-              <a:rPr lang="en-US" dirty="0"/>
-              <a:t> page for all tutorial materials</a:t>
-            </a:r>
-          </a:p>
-        </p:txBody>
-      </p:sp>
-      <p:sp>
-        <p:nvSpPr>
-          <p:cNvPr id="4" name="TextBox 3">
-            <a:extLst>
-              <a:ext uri="{FF2B5EF4-FFF2-40B4-BE49-F238E27FC236}">
-                <a16:creationId xmlns:a16="http://schemas.microsoft.com/office/drawing/2014/main" id="{6067EE83-B4F9-019B-E0E8-E80C48D26F36}"/>
-              </a:ext>
-            </a:extLst>
-          </p:cNvPr>
-          <p:cNvSpPr txBox="1"/>
-          <p:nvPr/>
-        </p:nvSpPr>
-        <p:spPr>
-          <a:xfrm>
-            <a:off x="3361713" y="4561262"/>
-            <a:ext cx="5465397" cy="1846659"/>
-          </a:xfrm>
-          <a:prstGeom prst="rect">
-            <a:avLst/>
-          </a:prstGeom>
-          <a:solidFill>
-            <a:srgbClr val="FFFF00"/>
-          </a:solidFill>
-          <a:ln>
-            <a:solidFill>
-              <a:schemeClr val="tx1"/>
-            </a:solidFill>
-          </a:ln>
-        </p:spPr>
-        <p:txBody>
-          <a:bodyPr wrap="square" lIns="118872" tIns="91440" rIns="118872" bIns="91440" rtlCol="0" anchor="ctr" anchorCtr="0">
-            <a:spAutoFit/>
-          </a:bodyPr>
-          <a:lstStyle/>
-          <a:p>
-            <a:pPr algn="ctr">
-              <a:lnSpc>
-                <a:spcPct val="90000"/>
-              </a:lnSpc>
-            </a:pPr>
-            <a:r>
-              <a:rPr lang="en-US" sz="2400" dirty="0"/>
-              <a:t>You may also be interested in these other software-related events at SC25: </a:t>
-            </a:r>
-            <a:r>
-              <a:rPr lang="en-US" sz="2400" dirty="0">
-                <a:hlinkClick r:id="rId4"/>
-              </a:rPr>
-              <a:t>https://bssw.io/events/sc25-software-related-events </a:t>
-            </a:r>
-            <a:endParaRPr lang="en-US" sz="2400" dirty="0"/>
-          </a:p>
-          <a:p>
-            <a:pPr algn="ctr">
-              <a:lnSpc>
-                <a:spcPct val="90000"/>
-              </a:lnSpc>
-            </a:pPr>
-            <a:r>
-              <a:rPr lang="en-US" dirty="0"/>
-              <a:t>(link is also on tutorial web page)</a:t>
-            </a:r>
-            <a:endParaRPr lang="en-US" sz="2400" dirty="0"/>
-          </a:p>
-        </p:txBody>
-      </p:sp>
-    </p:spTree>
-    <p:extLst>
-      <p:ext uri="{BB962C8B-B14F-4D97-AF65-F5344CB8AC3E}">
-        <p14:creationId xmlns:p14="http://schemas.microsoft.com/office/powerpoint/2010/main" val="3695382487"/>
-      </p:ext>
-    </p:extLst>
-  </p:cSld>
-  <p:clrMapOvr>
-    <a:masterClrMapping/>
-  </p:clrMapOvr>
-</p:sld>
-</file>
-
-<file path=ppt/slides/slide9.xml><?xml version="1.0" encoding="utf-8"?>
+<file path=ppt/slides/slide10.xml><?xml version="1.0" encoding="utf-8"?>
 <p:sld xmlns:a="http://schemas.openxmlformats.org/drawingml/2006/main" xmlns:r="http://schemas.openxmlformats.org/officeDocument/2006/relationships" xmlns:p="http://schemas.openxmlformats.org/presentationml/2006/main" showMasterSp="0">
   <p:cSld>
     <p:spTree>
@@ -6937,7 +4869,7 @@
                         <a:buNone/>
                       </a:pPr>
                       <a:r>
-                        <a:rPr lang="en-US">
+                        <a:rPr lang="en-US" dirty="0">
                           <a:effectLst/>
                         </a:rPr>
                         <a:t>Responsible Software Development with LLMs</a:t>
@@ -7156,6 +5088,2261 @@
     <p:extLst>
       <p:ext uri="{BB962C8B-B14F-4D97-AF65-F5344CB8AC3E}">
         <p14:creationId xmlns:p14="http://schemas.microsoft.com/office/powerpoint/2010/main" val="3643219827"/>
+      </p:ext>
+    </p:extLst>
+  </p:cSld>
+  <p:clrMapOvr>
+    <a:masterClrMapping/>
+  </p:clrMapOvr>
+</p:sld>
+</file>
+
+<file path=ppt/slides/slide2.xml><?xml version="1.0" encoding="utf-8"?>
+<p:sld xmlns:a="http://schemas.openxmlformats.org/drawingml/2006/main" xmlns:r="http://schemas.openxmlformats.org/officeDocument/2006/relationships" xmlns:p="http://schemas.openxmlformats.org/presentationml/2006/main">
+  <p:cSld>
+    <p:spTree>
+      <p:nvGrpSpPr>
+        <p:cNvPr id="1" name=""/>
+        <p:cNvGrpSpPr/>
+        <p:nvPr/>
+      </p:nvGrpSpPr>
+      <p:grpSpPr>
+        <a:xfrm>
+          <a:off x="0" y="0"/>
+          <a:ext cx="0" cy="0"/>
+          <a:chOff x="0" y="0"/>
+          <a:chExt cx="0" cy="0"/>
+        </a:xfrm>
+      </p:grpSpPr>
+      <p:sp>
+        <p:nvSpPr>
+          <p:cNvPr id="2" name="Title 1">
+            <a:extLst>
+              <a:ext uri="{FF2B5EF4-FFF2-40B4-BE49-F238E27FC236}">
+                <a16:creationId xmlns:a16="http://schemas.microsoft.com/office/drawing/2014/main" id="{6442C24D-D970-4D40-8F14-D70C10A96304}"/>
+              </a:ext>
+            </a:extLst>
+          </p:cNvPr>
+          <p:cNvSpPr>
+            <a:spLocks noGrp="1"/>
+          </p:cNvSpPr>
+          <p:nvPr>
+            <p:ph type="title"/>
+          </p:nvPr>
+        </p:nvSpPr>
+        <p:spPr>
+          <a:xfrm>
+            <a:off x="363096" y="411282"/>
+            <a:ext cx="11372473" cy="914400"/>
+          </a:xfrm>
+        </p:spPr>
+        <p:txBody>
+          <a:bodyPr/>
+          <a:lstStyle/>
+          <a:p>
+            <a:r>
+              <a:rPr lang="en-US" dirty="0"/>
+              <a:t>License, Citation and Acknowledgements</a:t>
+            </a:r>
+          </a:p>
+        </p:txBody>
+      </p:sp>
+      <p:sp>
+        <p:nvSpPr>
+          <p:cNvPr id="3" name="Content Placeholder 2">
+            <a:extLst>
+              <a:ext uri="{FF2B5EF4-FFF2-40B4-BE49-F238E27FC236}">
+                <a16:creationId xmlns:a16="http://schemas.microsoft.com/office/drawing/2014/main" id="{0385A3AB-B258-4D59-B407-F7D57545A163}"/>
+              </a:ext>
+            </a:extLst>
+          </p:cNvPr>
+          <p:cNvSpPr>
+            <a:spLocks noGrp="1"/>
+          </p:cNvSpPr>
+          <p:nvPr>
+            <p:ph idx="1"/>
+          </p:nvPr>
+        </p:nvSpPr>
+        <p:spPr>
+          <a:xfrm>
+            <a:off x="409507" y="868482"/>
+            <a:ext cx="11369809" cy="4047778"/>
+          </a:xfrm>
+        </p:spPr>
+        <p:txBody>
+          <a:bodyPr/>
+          <a:lstStyle/>
+          <a:p>
+            <a:pPr marL="0" indent="0">
+              <a:buNone/>
+            </a:pPr>
+            <a:r>
+              <a:rPr lang="en-US" sz="2000" b="1" dirty="0"/>
+              <a:t>License and Citation</a:t>
+            </a:r>
+          </a:p>
+          <a:p>
+            <a:pPr>
+              <a:spcBef>
+                <a:spcPts val="400"/>
+              </a:spcBef>
+            </a:pPr>
+            <a:r>
+              <a:rPr lang="en-US" sz="1600" dirty="0"/>
+              <a:t>This work is licensed under a </a:t>
+            </a:r>
+            <a:r>
+              <a:rPr lang="en-US" sz="1600" dirty="0">
+                <a:hlinkClick r:id="rId2"/>
+              </a:rPr>
+              <a:t>Creative</a:t>
+            </a:r>
+            <a:r>
+              <a:rPr lang="en-US" sz="1600" dirty="0">
+                <a:hlinkClick r:id="rId3"/>
+              </a:rPr>
+              <a:t> Commons Attribution 4.0 International License</a:t>
+            </a:r>
+            <a:r>
+              <a:rPr lang="en-US" sz="1600" dirty="0"/>
+              <a:t> (CC BY 4.0).</a:t>
+            </a:r>
+          </a:p>
+          <a:p>
+            <a:pPr>
+              <a:spcBef>
+                <a:spcPts val="400"/>
+              </a:spcBef>
+            </a:pPr>
+            <a:r>
+              <a:rPr lang="en-US" sz="1600" b="1" dirty="0"/>
+              <a:t>The requested citation the overall tutorial is: </a:t>
+            </a:r>
+            <a:r>
+              <a:rPr lang="en-US" sz="1600" dirty="0"/>
+              <a:t>David E. Bernholdt and Anshu Dubey, Better Software for Reproducible Science tutorial, in The International Conference for High-Performance Computing, Networking, Storage, and Analysis (SC25), St. Louis, Missouri, 2025. DOI: </a:t>
+            </a:r>
+            <a:r>
+              <a:rPr lang="en-US" sz="1600" dirty="0">
+                <a:hlinkClick r:id="rId4"/>
+              </a:rPr>
+              <a:t>10.6084/m9.figshare.30394186</a:t>
+            </a:r>
+            <a:r>
+              <a:rPr lang="en-US" sz="1600" dirty="0"/>
+              <a:t>.</a:t>
+            </a:r>
+            <a:endParaRPr lang="en-US" sz="1600" b="0" i="0" dirty="0">
+              <a:solidFill>
+                <a:srgbClr val="111111"/>
+              </a:solidFill>
+              <a:effectLst/>
+              <a:latin typeface="+mn-lt"/>
+            </a:endParaRPr>
+          </a:p>
+          <a:p>
+            <a:pPr>
+              <a:spcBef>
+                <a:spcPts val="400"/>
+              </a:spcBef>
+            </a:pPr>
+            <a:r>
+              <a:rPr lang="en-US" sz="1600" dirty="0"/>
+              <a:t>Individual modules may be cited as </a:t>
+            </a:r>
+            <a:r>
+              <a:rPr lang="en-US" sz="1600" i="1" dirty="0"/>
+              <a:t>Speaker, Module Title</a:t>
+            </a:r>
+            <a:r>
+              <a:rPr lang="en-US" sz="1600" dirty="0"/>
+              <a:t>, in </a:t>
+            </a:r>
+            <a:r>
+              <a:rPr lang="en-US" sz="1600" b="0" i="1" dirty="0">
+                <a:solidFill>
+                  <a:srgbClr val="111111"/>
+                </a:solidFill>
+                <a:effectLst/>
+                <a:latin typeface="+mn-lt"/>
+              </a:rPr>
+              <a:t>Tutorial Title</a:t>
+            </a:r>
+            <a:r>
+              <a:rPr lang="en-US" sz="1600" dirty="0"/>
+              <a:t>, …</a:t>
+            </a:r>
+          </a:p>
+          <a:p>
+            <a:pPr marL="0" indent="0">
+              <a:spcBef>
+                <a:spcPts val="800"/>
+              </a:spcBef>
+              <a:buNone/>
+            </a:pPr>
+            <a:r>
+              <a:rPr lang="en-US" sz="2000" b="1" dirty="0"/>
+              <a:t>Acknowledgements</a:t>
+            </a:r>
+          </a:p>
+          <a:p>
+            <a:pPr>
+              <a:spcBef>
+                <a:spcPts val="400"/>
+              </a:spcBef>
+            </a:pPr>
+            <a:r>
+              <a:rPr lang="en-US" sz="1400" dirty="0"/>
+              <a:t>This work was supported by the U.S. Department of Energy, Office of Science, Office of Advanced Scientific Computing Research, Next-Generation Scientific Software Technologies (NGSST) and Scientific Discovery through Advanced Computing (</a:t>
+            </a:r>
+            <a:r>
+              <a:rPr lang="en-US" sz="1400" dirty="0" err="1"/>
+              <a:t>SciDAC</a:t>
+            </a:r>
+            <a:r>
+              <a:rPr lang="en-US" sz="1400" dirty="0"/>
+              <a:t>) programs.</a:t>
+            </a:r>
+          </a:p>
+          <a:p>
+            <a:pPr>
+              <a:spcBef>
+                <a:spcPts val="400"/>
+              </a:spcBef>
+            </a:pPr>
+            <a:r>
+              <a:rPr lang="en-US" sz="1400" dirty="0"/>
+              <a:t>This work was supported by the U.S. Department of Energy Office of Science, Office of Advanced Scientific Computing Research (ASCR), and by the Exascale Computing Project (17-SC-20-SC), a collaborative effort of the U.S. Department of Energy Office of Science and the National Nuclear Security Administration</a:t>
+            </a:r>
+            <a:r>
+              <a:rPr lang="en-US" sz="1400" i="1" dirty="0"/>
+              <a:t>.</a:t>
+            </a:r>
+          </a:p>
+          <a:p>
+            <a:pPr>
+              <a:spcBef>
+                <a:spcPts val="400"/>
+              </a:spcBef>
+            </a:pPr>
+            <a:r>
+              <a:rPr lang="en-US" sz="1400" dirty="0"/>
+              <a:t>This work was performed in part at the Argonne National Laboratory, which is managed by UChicago Argonne, LLC for the U.S. Department of Energy under Contract No. DE-AC02-06CH11357.</a:t>
+            </a:r>
+          </a:p>
+          <a:p>
+            <a:pPr>
+              <a:spcBef>
+                <a:spcPts val="400"/>
+              </a:spcBef>
+            </a:pPr>
+            <a:r>
+              <a:rPr lang="en-US" sz="1400" dirty="0"/>
+              <a:t>This work was performed in part at the Lawrence Livermore National Laboratory, which is managed by Lawrence Livermore National Security, LLC for the U.S. Department of Energy under Contract No. DE-AC52-07NA27344.</a:t>
+            </a:r>
+          </a:p>
+          <a:p>
+            <a:pPr>
+              <a:spcBef>
+                <a:spcPts val="400"/>
+              </a:spcBef>
+            </a:pPr>
+            <a:r>
+              <a:rPr lang="en-US" sz="1400" dirty="0"/>
+              <a:t>This work was performed in part at the Los Alamos National Laboratory, which is managed by Triad National Security, LLC for the U.S. Department of Energy under Contract No.89233218CNA000001</a:t>
+            </a:r>
+          </a:p>
+          <a:p>
+            <a:pPr>
+              <a:spcBef>
+                <a:spcPts val="400"/>
+              </a:spcBef>
+            </a:pPr>
+            <a:r>
+              <a:rPr lang="en-US" sz="1400" dirty="0"/>
+              <a:t>This work was performed in part at the Oak Ridge National Laboratory, which is managed by UT-Battelle, LLC for the U.S. Department of Energy under Contract No. DE-AC05-00OR22725.</a:t>
+            </a:r>
+          </a:p>
+          <a:p>
+            <a:pPr>
+              <a:spcBef>
+                <a:spcPts val="400"/>
+              </a:spcBef>
+            </a:pPr>
+            <a:r>
+              <a:rPr lang="en-US" sz="1400" dirty="0"/>
+              <a:t>This work was performed in part at Sandia National Laboratories. Sandia National Laboratories is a multi-mission laboratory managed and operated by National Technology and Engineering Solutions of Sandia, LLC., a wholly owned subsidiary of Honeywell International, Inc., for the U.S. Department of Energy’s National Nuclear Security Administration under contract DE-NA0003525.</a:t>
+            </a:r>
+          </a:p>
+        </p:txBody>
+      </p:sp>
+      <p:pic>
+        <p:nvPicPr>
+          <p:cNvPr id="4" name="Picture 2" descr="https://licensebuttons.net/l/by/4.0/88x31.png">
+            <a:extLst>
+              <a:ext uri="{FF2B5EF4-FFF2-40B4-BE49-F238E27FC236}">
+                <a16:creationId xmlns:a16="http://schemas.microsoft.com/office/drawing/2014/main" id="{61840015-22A0-4634-A2DE-AA05F998FD3A}"/>
+              </a:ext>
+            </a:extLst>
+          </p:cNvPr>
+          <p:cNvPicPr>
+            <a:picLocks noChangeAspect="1" noChangeArrowheads="1"/>
+          </p:cNvPicPr>
+          <p:nvPr/>
+        </p:nvPicPr>
+        <p:blipFill>
+          <a:blip r:embed="rId5">
+            <a:extLst>
+              <a:ext uri="{28A0092B-C50C-407E-A947-70E740481C1C}">
+                <a14:useLocalDpi xmlns:a14="http://schemas.microsoft.com/office/drawing/2010/main" val="0"/>
+              </a:ext>
+            </a:extLst>
+          </a:blip>
+          <a:srcRect/>
+          <a:stretch>
+            <a:fillRect/>
+          </a:stretch>
+        </p:blipFill>
+        <p:spPr bwMode="auto">
+          <a:xfrm>
+            <a:off x="10230336" y="879673"/>
+            <a:ext cx="838200" cy="295275"/>
+          </a:xfrm>
+          <a:prstGeom prst="rect">
+            <a:avLst/>
+          </a:prstGeom>
+          <a:noFill/>
+          <a:extLst>
+            <a:ext uri="{909E8E84-426E-40DD-AFC4-6F175D3DCCD1}">
+              <a14:hiddenFill xmlns:a14="http://schemas.microsoft.com/office/drawing/2010/main">
+                <a:solidFill>
+                  <a:srgbClr val="FFFFFF"/>
+                </a:solidFill>
+              </a14:hiddenFill>
+            </a:ext>
+          </a:extLst>
+        </p:spPr>
+      </p:pic>
+    </p:spTree>
+    <p:extLst>
+      <p:ext uri="{BB962C8B-B14F-4D97-AF65-F5344CB8AC3E}">
+        <p14:creationId xmlns:p14="http://schemas.microsoft.com/office/powerpoint/2010/main" val="978726433"/>
+      </p:ext>
+    </p:extLst>
+  </p:cSld>
+  <p:clrMapOvr>
+    <a:masterClrMapping/>
+  </p:clrMapOvr>
+</p:sld>
+</file>
+
+<file path=ppt/slides/slide3.xml><?xml version="1.0" encoding="utf-8"?>
+<p:sld xmlns:a="http://schemas.openxmlformats.org/drawingml/2006/main" xmlns:r="http://schemas.openxmlformats.org/officeDocument/2006/relationships" xmlns:p="http://schemas.openxmlformats.org/presentationml/2006/main">
+  <p:cSld>
+    <p:spTree>
+      <p:nvGrpSpPr>
+        <p:cNvPr id="1" name=""/>
+        <p:cNvGrpSpPr/>
+        <p:nvPr/>
+      </p:nvGrpSpPr>
+      <p:grpSpPr>
+        <a:xfrm>
+          <a:off x="0" y="0"/>
+          <a:ext cx="0" cy="0"/>
+          <a:chOff x="0" y="0"/>
+          <a:chExt cx="0" cy="0"/>
+        </a:xfrm>
+      </p:grpSpPr>
+      <p:sp>
+        <p:nvSpPr>
+          <p:cNvPr id="3" name="Content Placeholder 2">
+            <a:extLst>
+              <a:ext uri="{FF2B5EF4-FFF2-40B4-BE49-F238E27FC236}">
+                <a16:creationId xmlns:a16="http://schemas.microsoft.com/office/drawing/2014/main" id="{3DF9CC39-F70C-4872-8BAF-FDB4FE40BE11}"/>
+              </a:ext>
+            </a:extLst>
+          </p:cNvPr>
+          <p:cNvSpPr>
+            <a:spLocks noGrp="1"/>
+          </p:cNvSpPr>
+          <p:nvPr>
+            <p:ph idx="1"/>
+          </p:nvPr>
+        </p:nvSpPr>
+        <p:spPr>
+          <a:xfrm>
+            <a:off x="365760" y="1280696"/>
+            <a:ext cx="11369809" cy="4047778"/>
+          </a:xfrm>
+        </p:spPr>
+        <p:txBody>
+          <a:bodyPr/>
+          <a:lstStyle/>
+          <a:p>
+            <a:pPr>
+              <a:spcBef>
+                <a:spcPts val="1000"/>
+              </a:spcBef>
+            </a:pPr>
+            <a:r>
+              <a:rPr lang="en-US" dirty="0"/>
+              <a:t>David E. Bernholdt, ORNL</a:t>
+            </a:r>
+          </a:p>
+          <a:p>
+            <a:pPr>
+              <a:spcBef>
+                <a:spcPts val="1000"/>
+              </a:spcBef>
+            </a:pPr>
+            <a:r>
+              <a:rPr lang="en-US" dirty="0"/>
+              <a:t>Anshu Dubey, ANL</a:t>
+            </a:r>
+          </a:p>
+        </p:txBody>
+      </p:sp>
+      <p:sp>
+        <p:nvSpPr>
+          <p:cNvPr id="2" name="Title 1">
+            <a:extLst>
+              <a:ext uri="{FF2B5EF4-FFF2-40B4-BE49-F238E27FC236}">
+                <a16:creationId xmlns:a16="http://schemas.microsoft.com/office/drawing/2014/main" id="{D7779183-6189-461C-B4D7-638E6AB5CA5F}"/>
+              </a:ext>
+            </a:extLst>
+          </p:cNvPr>
+          <p:cNvSpPr>
+            <a:spLocks noGrp="1"/>
+          </p:cNvSpPr>
+          <p:nvPr>
+            <p:ph type="title"/>
+          </p:nvPr>
+        </p:nvSpPr>
+        <p:spPr/>
+        <p:txBody>
+          <a:bodyPr/>
+          <a:lstStyle/>
+          <a:p>
+            <a:r>
+              <a:rPr lang="en-US" dirty="0"/>
+              <a:t>About Us</a:t>
+            </a:r>
+          </a:p>
+        </p:txBody>
+      </p:sp>
+      <p:sp>
+        <p:nvSpPr>
+          <p:cNvPr id="4" name="TextBox 3">
+            <a:extLst>
+              <a:ext uri="{FF2B5EF4-FFF2-40B4-BE49-F238E27FC236}">
+                <a16:creationId xmlns:a16="http://schemas.microsoft.com/office/drawing/2014/main" id="{75F24105-9372-1C03-4BB0-9287BF335D4A}"/>
+              </a:ext>
+            </a:extLst>
+          </p:cNvPr>
+          <p:cNvSpPr txBox="1"/>
+          <p:nvPr/>
+        </p:nvSpPr>
+        <p:spPr>
+          <a:xfrm>
+            <a:off x="453256" y="3373816"/>
+            <a:ext cx="10123321" cy="2631490"/>
+          </a:xfrm>
+          <a:prstGeom prst="rect">
+            <a:avLst/>
+          </a:prstGeom>
+          <a:noFill/>
+        </p:spPr>
+        <p:txBody>
+          <a:bodyPr wrap="square">
+            <a:spAutoFit/>
+          </a:bodyPr>
+          <a:lstStyle/>
+          <a:p>
+            <a:pPr marL="227013" indent="-227013">
+              <a:spcBef>
+                <a:spcPts val="600"/>
+              </a:spcBef>
+              <a:buFont typeface="Arial" panose="020B0604020202020204" pitchFamily="34" charset="0"/>
+              <a:buChar char="•"/>
+            </a:pPr>
+            <a:r>
+              <a:rPr lang="en-US" sz="2000" dirty="0"/>
+              <a:t>Participants in the Consortium for the Advancement of Scientific Software (CASS) and DOE/ASCR software stewardship projects: </a:t>
+            </a:r>
+            <a:r>
+              <a:rPr lang="en-US" sz="2000" dirty="0">
+                <a:hlinkClick r:id="rId2"/>
+              </a:rPr>
+              <a:t>https://cass.community/</a:t>
+            </a:r>
+            <a:endParaRPr lang="en-US" sz="2000" dirty="0"/>
+          </a:p>
+          <a:p>
+            <a:pPr marL="684213" lvl="1" indent="-227013">
+              <a:spcBef>
+                <a:spcPts val="600"/>
+              </a:spcBef>
+              <a:buFont typeface="Arial" panose="020B0604020202020204" pitchFamily="34" charset="0"/>
+              <a:buChar char="•"/>
+            </a:pPr>
+            <a:r>
+              <a:rPr lang="en-US" sz="2000" dirty="0"/>
+              <a:t>Members of the </a:t>
+            </a:r>
+            <a:r>
+              <a:rPr lang="en-US" sz="2000" dirty="0">
+                <a:hlinkClick r:id="rId3"/>
+              </a:rPr>
+              <a:t>PESO</a:t>
+            </a:r>
+            <a:r>
+              <a:rPr lang="en-US" sz="2000" dirty="0"/>
+              <a:t> and </a:t>
+            </a:r>
+            <a:r>
+              <a:rPr lang="en-US" sz="2000" dirty="0">
+                <a:hlinkClick r:id="rId4"/>
+              </a:rPr>
+              <a:t>RAPIDS</a:t>
+            </a:r>
+            <a:r>
+              <a:rPr lang="en-US" sz="2000" dirty="0"/>
+              <a:t> projects</a:t>
+            </a:r>
+          </a:p>
+          <a:p>
+            <a:pPr marL="227013" indent="-227013">
+              <a:spcBef>
+                <a:spcPts val="600"/>
+              </a:spcBef>
+              <a:buFont typeface="Arial" panose="020B0604020202020204" pitchFamily="34" charset="0"/>
+              <a:buChar char="•"/>
+            </a:pPr>
+            <a:r>
+              <a:rPr lang="en-US" sz="2000" dirty="0"/>
+              <a:t>Past involvement in</a:t>
+            </a:r>
+          </a:p>
+          <a:p>
+            <a:pPr marL="684213" lvl="1" indent="-227013">
+              <a:spcBef>
+                <a:spcPts val="600"/>
+              </a:spcBef>
+              <a:buFont typeface="Arial" panose="020B0604020202020204" pitchFamily="34" charset="0"/>
+              <a:buChar char="•"/>
+            </a:pPr>
+            <a:r>
+              <a:rPr lang="en-US" sz="2000" dirty="0"/>
+              <a:t>Exascale Computing Project</a:t>
+            </a:r>
+          </a:p>
+          <a:p>
+            <a:pPr marL="684213" lvl="1" indent="-227013">
+              <a:spcBef>
+                <a:spcPts val="600"/>
+              </a:spcBef>
+              <a:buFont typeface="Arial" panose="020B0604020202020204" pitchFamily="34" charset="0"/>
+              <a:buChar char="•"/>
+            </a:pPr>
+            <a:r>
+              <a:rPr lang="en-US" sz="2000" dirty="0"/>
+              <a:t>IDEAS Productivity family of projects: </a:t>
+            </a:r>
+            <a:r>
+              <a:rPr lang="en-US" sz="2000" dirty="0">
+                <a:hlinkClick r:id="rId5"/>
+              </a:rPr>
+              <a:t>https://ideas-productivity.org/</a:t>
+            </a:r>
+            <a:endParaRPr lang="en-US" sz="2000" dirty="0"/>
+          </a:p>
+          <a:p>
+            <a:pPr marL="684213" lvl="1" indent="-227013">
+              <a:spcBef>
+                <a:spcPts val="600"/>
+              </a:spcBef>
+              <a:buFont typeface="Arial" panose="020B0604020202020204" pitchFamily="34" charset="0"/>
+              <a:buChar char="•"/>
+            </a:pPr>
+            <a:r>
+              <a:rPr lang="en-US" sz="2000" dirty="0"/>
+              <a:t>And more!</a:t>
+            </a:r>
+          </a:p>
+        </p:txBody>
+      </p:sp>
+      <p:grpSp>
+        <p:nvGrpSpPr>
+          <p:cNvPr id="8" name="Group 7">
+            <a:extLst>
+              <a:ext uri="{FF2B5EF4-FFF2-40B4-BE49-F238E27FC236}">
+                <a16:creationId xmlns:a16="http://schemas.microsoft.com/office/drawing/2014/main" id="{C22DEB37-50E6-2254-1FB5-B0F6E81B4E4A}"/>
+              </a:ext>
+            </a:extLst>
+          </p:cNvPr>
+          <p:cNvGrpSpPr/>
+          <p:nvPr/>
+        </p:nvGrpSpPr>
+        <p:grpSpPr>
+          <a:xfrm>
+            <a:off x="9515196" y="1325880"/>
+            <a:ext cx="954107" cy="1805497"/>
+            <a:chOff x="6614147" y="1346049"/>
+            <a:chExt cx="954107" cy="1805497"/>
+          </a:xfrm>
+        </p:grpSpPr>
+        <p:sp>
+          <p:nvSpPr>
+            <p:cNvPr id="9" name="TextBox 8">
+              <a:extLst>
+                <a:ext uri="{FF2B5EF4-FFF2-40B4-BE49-F238E27FC236}">
+                  <a16:creationId xmlns:a16="http://schemas.microsoft.com/office/drawing/2014/main" id="{CEB57978-C3B6-32C4-C6C6-52ACB58C8A06}"/>
+                </a:ext>
+              </a:extLst>
+            </p:cNvPr>
+            <p:cNvSpPr txBox="1"/>
+            <p:nvPr/>
+          </p:nvSpPr>
+          <p:spPr>
+            <a:xfrm>
+              <a:off x="6614147" y="2560615"/>
+              <a:ext cx="954107" cy="590931"/>
+            </a:xfrm>
+            <a:prstGeom prst="rect">
+              <a:avLst/>
+            </a:prstGeom>
+            <a:noFill/>
+          </p:spPr>
+          <p:txBody>
+            <a:bodyPr wrap="none" rtlCol="0">
+              <a:spAutoFit/>
+            </a:bodyPr>
+            <a:lstStyle/>
+            <a:p>
+              <a:pPr algn="ctr">
+                <a:lnSpc>
+                  <a:spcPct val="90000"/>
+                </a:lnSpc>
+              </a:pPr>
+              <a:r>
+                <a:rPr lang="en-US" dirty="0"/>
+                <a:t>Anshu</a:t>
+              </a:r>
+            </a:p>
+            <a:p>
+              <a:pPr algn="ctr">
+                <a:lnSpc>
+                  <a:spcPct val="90000"/>
+                </a:lnSpc>
+              </a:pPr>
+              <a:r>
+                <a:rPr lang="en-US" i="1" dirty="0"/>
+                <a:t>she/her</a:t>
+              </a:r>
+            </a:p>
+          </p:txBody>
+        </p:sp>
+        <p:pic>
+          <p:nvPicPr>
+            <p:cNvPr id="10" name="Picture 9" descr="A person smiling for the camera&#10;&#10;Description automatically generated with low confidence">
+              <a:extLst>
+                <a:ext uri="{FF2B5EF4-FFF2-40B4-BE49-F238E27FC236}">
+                  <a16:creationId xmlns:a16="http://schemas.microsoft.com/office/drawing/2014/main" id="{4F1A04F2-5B52-D284-D8CF-CD12780422CE}"/>
+                </a:ext>
+              </a:extLst>
+            </p:cNvPr>
+            <p:cNvPicPr>
+              <a:picLocks noChangeAspect="1"/>
+            </p:cNvPicPr>
+            <p:nvPr/>
+          </p:nvPicPr>
+          <p:blipFill>
+            <a:blip r:embed="rId6" cstate="print">
+              <a:extLst>
+                <a:ext uri="{28A0092B-C50C-407E-A947-70E740481C1C}">
+                  <a14:useLocalDpi xmlns:a14="http://schemas.microsoft.com/office/drawing/2010/main" val="0"/>
+                </a:ext>
+              </a:extLst>
+            </a:blip>
+            <a:stretch>
+              <a:fillRect/>
+            </a:stretch>
+          </p:blipFill>
+          <p:spPr>
+            <a:xfrm>
+              <a:off x="6632063" y="1346049"/>
+              <a:ext cx="918273" cy="1207008"/>
+            </a:xfrm>
+            <a:prstGeom prst="rect">
+              <a:avLst/>
+            </a:prstGeom>
+          </p:spPr>
+        </p:pic>
+      </p:grpSp>
+      <p:grpSp>
+        <p:nvGrpSpPr>
+          <p:cNvPr id="11" name="Group 10">
+            <a:extLst>
+              <a:ext uri="{FF2B5EF4-FFF2-40B4-BE49-F238E27FC236}">
+                <a16:creationId xmlns:a16="http://schemas.microsoft.com/office/drawing/2014/main" id="{BF360452-D7C7-247A-386F-D3315474AFCB}"/>
+              </a:ext>
+            </a:extLst>
+          </p:cNvPr>
+          <p:cNvGrpSpPr/>
+          <p:nvPr/>
+        </p:nvGrpSpPr>
+        <p:grpSpPr>
+          <a:xfrm>
+            <a:off x="7899602" y="1325880"/>
+            <a:ext cx="1038027" cy="1797939"/>
+            <a:chOff x="4187619" y="4211394"/>
+            <a:chExt cx="1038027" cy="1797939"/>
+          </a:xfrm>
+        </p:grpSpPr>
+        <p:pic>
+          <p:nvPicPr>
+            <p:cNvPr id="12" name="Picture 11" descr="A person wearing glasses&#10;&#10;Description automatically generated with low confidence">
+              <a:extLst>
+                <a:ext uri="{FF2B5EF4-FFF2-40B4-BE49-F238E27FC236}">
+                  <a16:creationId xmlns:a16="http://schemas.microsoft.com/office/drawing/2014/main" id="{8B9A3899-C96B-3A08-5E0A-2906D305F982}"/>
+                </a:ext>
+              </a:extLst>
+            </p:cNvPr>
+            <p:cNvPicPr>
+              <a:picLocks noChangeAspect="1"/>
+            </p:cNvPicPr>
+            <p:nvPr/>
+          </p:nvPicPr>
+          <p:blipFill rotWithShape="1">
+            <a:blip r:embed="rId7" cstate="print">
+              <a:extLst>
+                <a:ext uri="{28A0092B-C50C-407E-A947-70E740481C1C}">
+                  <a14:useLocalDpi xmlns:a14="http://schemas.microsoft.com/office/drawing/2010/main" val="0"/>
+                </a:ext>
+              </a:extLst>
+            </a:blip>
+            <a:srcRect l="8053" t="854" r="5947" b="-854"/>
+            <a:stretch/>
+          </p:blipFill>
+          <p:spPr>
+            <a:xfrm>
+              <a:off x="4187619" y="4211394"/>
+              <a:ext cx="1038027" cy="1207008"/>
+            </a:xfrm>
+            <a:prstGeom prst="rect">
+              <a:avLst/>
+            </a:prstGeom>
+          </p:spPr>
+        </p:pic>
+        <p:sp>
+          <p:nvSpPr>
+            <p:cNvPr id="13" name="TextBox 12">
+              <a:extLst>
+                <a:ext uri="{FF2B5EF4-FFF2-40B4-BE49-F238E27FC236}">
+                  <a16:creationId xmlns:a16="http://schemas.microsoft.com/office/drawing/2014/main" id="{2B5EF80D-04B1-F98E-6FF3-532C3F5A9955}"/>
+                </a:ext>
+              </a:extLst>
+            </p:cNvPr>
+            <p:cNvSpPr txBox="1"/>
+            <p:nvPr/>
+          </p:nvSpPr>
+          <p:spPr>
+            <a:xfrm>
+              <a:off x="4268051" y="5418402"/>
+              <a:ext cx="877163" cy="590931"/>
+            </a:xfrm>
+            <a:prstGeom prst="rect">
+              <a:avLst/>
+            </a:prstGeom>
+            <a:noFill/>
+          </p:spPr>
+          <p:txBody>
+            <a:bodyPr wrap="none" rtlCol="0">
+              <a:spAutoFit/>
+            </a:bodyPr>
+            <a:lstStyle/>
+            <a:p>
+              <a:pPr algn="ctr">
+                <a:lnSpc>
+                  <a:spcPct val="90000"/>
+                </a:lnSpc>
+              </a:pPr>
+              <a:r>
+                <a:rPr lang="en-US" dirty="0"/>
+                <a:t>David</a:t>
+              </a:r>
+            </a:p>
+            <a:p>
+              <a:pPr algn="ctr">
+                <a:lnSpc>
+                  <a:spcPct val="90000"/>
+                </a:lnSpc>
+              </a:pPr>
+              <a:r>
+                <a:rPr lang="en-US" i="1" dirty="0"/>
+                <a:t>he/him</a:t>
+              </a:r>
+            </a:p>
+          </p:txBody>
+        </p:sp>
+      </p:grpSp>
+    </p:spTree>
+    <p:extLst>
+      <p:ext uri="{BB962C8B-B14F-4D97-AF65-F5344CB8AC3E}">
+        <p14:creationId xmlns:p14="http://schemas.microsoft.com/office/powerpoint/2010/main" val="397159740"/>
+      </p:ext>
+    </p:extLst>
+  </p:cSld>
+  <p:clrMapOvr>
+    <a:masterClrMapping/>
+  </p:clrMapOvr>
+</p:sld>
+</file>
+
+<file path=ppt/slides/slide4.xml><?xml version="1.0" encoding="utf-8"?>
+<p:sld xmlns:a="http://schemas.openxmlformats.org/drawingml/2006/main" xmlns:r="http://schemas.openxmlformats.org/officeDocument/2006/relationships" xmlns:p="http://schemas.openxmlformats.org/presentationml/2006/main">
+  <p:cSld>
+    <p:spTree>
+      <p:nvGrpSpPr>
+        <p:cNvPr id="1" name=""/>
+        <p:cNvGrpSpPr/>
+        <p:nvPr/>
+      </p:nvGrpSpPr>
+      <p:grpSpPr>
+        <a:xfrm>
+          <a:off x="0" y="0"/>
+          <a:ext cx="0" cy="0"/>
+          <a:chOff x="0" y="0"/>
+          <a:chExt cx="0" cy="0"/>
+        </a:xfrm>
+      </p:grpSpPr>
+      <p:sp>
+        <p:nvSpPr>
+          <p:cNvPr id="2" name="Title 1">
+            <a:extLst>
+              <a:ext uri="{FF2B5EF4-FFF2-40B4-BE49-F238E27FC236}">
+                <a16:creationId xmlns:a16="http://schemas.microsoft.com/office/drawing/2014/main" id="{8BCB2B88-3DDC-4986-8D89-A3EDC5187EA9}"/>
+              </a:ext>
+            </a:extLst>
+          </p:cNvPr>
+          <p:cNvSpPr>
+            <a:spLocks noGrp="1"/>
+          </p:cNvSpPr>
+          <p:nvPr>
+            <p:ph type="title"/>
+          </p:nvPr>
+        </p:nvSpPr>
+        <p:spPr/>
+        <p:txBody>
+          <a:bodyPr/>
+          <a:lstStyle/>
+          <a:p>
+            <a:r>
+              <a:rPr lang="en-US" dirty="0"/>
+              <a:t>Building an Online Community</a:t>
+            </a:r>
+          </a:p>
+        </p:txBody>
+      </p:sp>
+      <p:sp>
+        <p:nvSpPr>
+          <p:cNvPr id="3" name="Content Placeholder 2">
+            <a:extLst>
+              <a:ext uri="{FF2B5EF4-FFF2-40B4-BE49-F238E27FC236}">
+                <a16:creationId xmlns:a16="http://schemas.microsoft.com/office/drawing/2014/main" id="{EE3E28DE-DA44-4ED0-B0F8-EE01B9ACB982}"/>
+              </a:ext>
+            </a:extLst>
+          </p:cNvPr>
+          <p:cNvSpPr txBox="1">
+            <a:spLocks/>
+          </p:cNvSpPr>
+          <p:nvPr/>
+        </p:nvSpPr>
+        <p:spPr>
+          <a:xfrm>
+            <a:off x="365760" y="937454"/>
+            <a:ext cx="11658600" cy="4610100"/>
+          </a:xfrm>
+          <a:prstGeom prst="rect">
+            <a:avLst/>
+          </a:prstGeom>
+        </p:spPr>
+        <p:txBody>
+          <a:bodyPr/>
+          <a:lstStyle>
+            <a:lvl1pPr marL="230188" indent="-230188" algn="l" rtl="0" eaLnBrk="1" fontAlgn="base" hangingPunct="1">
+              <a:lnSpc>
+                <a:spcPct val="90000"/>
+              </a:lnSpc>
+              <a:spcBef>
+                <a:spcPts val="1400"/>
+              </a:spcBef>
+              <a:spcAft>
+                <a:spcPct val="0"/>
+              </a:spcAft>
+              <a:buClr>
+                <a:schemeClr val="tx1"/>
+              </a:buClr>
+              <a:buFont typeface="Arial" charset="0"/>
+              <a:buChar char="•"/>
+              <a:defRPr sz="2400" kern="1200">
+                <a:solidFill>
+                  <a:schemeClr val="tx1"/>
+                </a:solidFill>
+                <a:latin typeface="+mn-lt"/>
+                <a:ea typeface="+mn-ea"/>
+                <a:cs typeface="+mn-cs"/>
+              </a:defRPr>
+            </a:lvl1pPr>
+            <a:lvl2pPr marL="625475" indent="-279400" algn="l" rtl="0" eaLnBrk="1" fontAlgn="base" hangingPunct="1">
+              <a:lnSpc>
+                <a:spcPct val="90000"/>
+              </a:lnSpc>
+              <a:spcBef>
+                <a:spcPts val="800"/>
+              </a:spcBef>
+              <a:spcAft>
+                <a:spcPct val="0"/>
+              </a:spcAft>
+              <a:buClr>
+                <a:schemeClr val="tx1"/>
+              </a:buClr>
+              <a:buFont typeface="Arial" charset="0"/>
+              <a:buChar char="–"/>
+              <a:defRPr sz="2000" kern="1200">
+                <a:solidFill>
+                  <a:schemeClr val="tx1"/>
+                </a:solidFill>
+                <a:latin typeface="+mn-lt"/>
+                <a:ea typeface="+mn-ea"/>
+                <a:cs typeface="+mn-cs"/>
+              </a:defRPr>
+            </a:lvl2pPr>
+            <a:lvl3pPr marL="914400" indent="-230188" algn="l" rtl="0" eaLnBrk="1" fontAlgn="base" hangingPunct="1">
+              <a:lnSpc>
+                <a:spcPct val="90000"/>
+              </a:lnSpc>
+              <a:spcBef>
+                <a:spcPts val="800"/>
+              </a:spcBef>
+              <a:spcAft>
+                <a:spcPct val="0"/>
+              </a:spcAft>
+              <a:buClr>
+                <a:schemeClr val="tx1"/>
+              </a:buClr>
+              <a:buFont typeface="Arial" charset="0"/>
+              <a:buChar char="•"/>
+              <a:defRPr sz="1800" kern="1200">
+                <a:solidFill>
+                  <a:schemeClr val="tx1"/>
+                </a:solidFill>
+                <a:latin typeface="+mn-lt"/>
+                <a:ea typeface="+mn-ea"/>
+                <a:cs typeface="+mn-cs"/>
+              </a:defRPr>
+            </a:lvl3pPr>
+            <a:lvl4pPr marL="1144588" indent="-173038" algn="l" rtl="0" eaLnBrk="1" fontAlgn="base" hangingPunct="1">
+              <a:lnSpc>
+                <a:spcPct val="90000"/>
+              </a:lnSpc>
+              <a:spcBef>
+                <a:spcPts val="800"/>
+              </a:spcBef>
+              <a:spcAft>
+                <a:spcPct val="0"/>
+              </a:spcAft>
+              <a:buClr>
+                <a:schemeClr val="tx1"/>
+              </a:buClr>
+              <a:buFont typeface="Arial" charset="0"/>
+              <a:buChar char="–"/>
+              <a:defRPr sz="1600" kern="1200">
+                <a:solidFill>
+                  <a:schemeClr val="tx1"/>
+                </a:solidFill>
+                <a:latin typeface="+mn-lt"/>
+                <a:ea typeface="+mn-ea"/>
+                <a:cs typeface="+mn-cs"/>
+              </a:defRPr>
+            </a:lvl4pPr>
+            <a:lvl5pPr marL="1482725" indent="-222250" algn="l" rtl="0" eaLnBrk="1" fontAlgn="base" hangingPunct="1">
+              <a:lnSpc>
+                <a:spcPct val="90000"/>
+              </a:lnSpc>
+              <a:spcBef>
+                <a:spcPts val="600"/>
+              </a:spcBef>
+              <a:spcAft>
+                <a:spcPct val="0"/>
+              </a:spcAft>
+              <a:buClr>
+                <a:schemeClr val="tx1"/>
+              </a:buClr>
+              <a:buFont typeface="Arial" charset="0"/>
+              <a:buChar char="»"/>
+              <a:defRPr sz="1600" kern="1200">
+                <a:solidFill>
+                  <a:schemeClr val="tx1"/>
+                </a:solidFill>
+                <a:latin typeface="+mn-lt"/>
+                <a:ea typeface="+mn-ea"/>
+                <a:cs typeface="+mn-cs"/>
+              </a:defRPr>
+            </a:lvl5pPr>
+            <a:lvl6pPr marL="2514600" indent="-228600" algn="l" defTabSz="914400" rtl="0" eaLnBrk="1" latinLnBrk="0" hangingPunct="1">
+              <a:spcBef>
+                <a:spcPct val="20000"/>
+              </a:spcBef>
+              <a:buFont typeface="Arial" pitchFamily="34" charset="0"/>
+              <a:buChar char="•"/>
+              <a:defRPr sz="2000" kern="1200">
+                <a:solidFill>
+                  <a:schemeClr val="tx1"/>
+                </a:solidFill>
+                <a:latin typeface="+mn-lt"/>
+                <a:ea typeface="+mn-ea"/>
+                <a:cs typeface="+mn-cs"/>
+              </a:defRPr>
+            </a:lvl6pPr>
+            <a:lvl7pPr marL="2971800" indent="-228600" algn="l" defTabSz="914400" rtl="0" eaLnBrk="1" latinLnBrk="0" hangingPunct="1">
+              <a:spcBef>
+                <a:spcPct val="20000"/>
+              </a:spcBef>
+              <a:buFont typeface="Arial" pitchFamily="34" charset="0"/>
+              <a:buChar char="•"/>
+              <a:defRPr sz="2000" kern="1200">
+                <a:solidFill>
+                  <a:schemeClr val="tx1"/>
+                </a:solidFill>
+                <a:latin typeface="+mn-lt"/>
+                <a:ea typeface="+mn-ea"/>
+                <a:cs typeface="+mn-cs"/>
+              </a:defRPr>
+            </a:lvl7pPr>
+            <a:lvl8pPr marL="3429000" indent="-228600" algn="l" defTabSz="914400" rtl="0" eaLnBrk="1" latinLnBrk="0" hangingPunct="1">
+              <a:spcBef>
+                <a:spcPct val="20000"/>
+              </a:spcBef>
+              <a:buFont typeface="Arial" pitchFamily="34" charset="0"/>
+              <a:buChar char="•"/>
+              <a:defRPr sz="2000" kern="1200">
+                <a:solidFill>
+                  <a:schemeClr val="tx1"/>
+                </a:solidFill>
+                <a:latin typeface="+mn-lt"/>
+                <a:ea typeface="+mn-ea"/>
+                <a:cs typeface="+mn-cs"/>
+              </a:defRPr>
+            </a:lvl8pPr>
+            <a:lvl9pPr marL="3886200" indent="-228600" algn="l" defTabSz="914400" rtl="0" eaLnBrk="1" latinLnBrk="0" hangingPunct="1">
+              <a:spcBef>
+                <a:spcPct val="20000"/>
+              </a:spcBef>
+              <a:buFont typeface="Arial" pitchFamily="34" charset="0"/>
+              <a:buChar char="•"/>
+              <a:defRPr sz="2000" kern="1200">
+                <a:solidFill>
+                  <a:schemeClr val="tx1"/>
+                </a:solidFill>
+                <a:latin typeface="+mn-lt"/>
+                <a:ea typeface="+mn-ea"/>
+                <a:cs typeface="+mn-cs"/>
+              </a:defRPr>
+            </a:lvl9pPr>
+          </a:lstStyle>
+          <a:p>
+            <a:pPr marL="0" indent="0">
+              <a:spcBef>
+                <a:spcPts val="400"/>
+              </a:spcBef>
+              <a:buFont typeface="Arial" charset="0"/>
+              <a:buNone/>
+            </a:pPr>
+            <a:r>
+              <a:rPr lang="en-US" b="1" dirty="0">
+                <a:hlinkClick r:id="rId2"/>
+              </a:rPr>
+              <a:t>https://bssw.io </a:t>
+            </a:r>
+            <a:endParaRPr lang="en-US" b="1" dirty="0"/>
+          </a:p>
+          <a:p>
+            <a:pPr>
+              <a:spcBef>
+                <a:spcPts val="400"/>
+              </a:spcBef>
+            </a:pPr>
+            <a:r>
+              <a:rPr lang="en-US" sz="2000" b="1" dirty="0">
+                <a:solidFill>
+                  <a:schemeClr val="accent1"/>
+                </a:solidFill>
+              </a:rPr>
+              <a:t>New </a:t>
+            </a:r>
+            <a:r>
+              <a:rPr lang="en-US" sz="2000" b="1" u="sng" dirty="0">
+                <a:solidFill>
+                  <a:schemeClr val="accent1"/>
+                </a:solidFill>
+              </a:rPr>
+              <a:t>community-based resource</a:t>
+            </a:r>
+            <a:r>
+              <a:rPr lang="en-US" sz="2000" b="1" dirty="0">
+                <a:solidFill>
+                  <a:schemeClr val="accent1"/>
+                </a:solidFill>
+              </a:rPr>
+              <a:t> for scientific software </a:t>
+            </a:r>
+            <a:br>
+              <a:rPr lang="en-US" sz="2000" b="1" dirty="0">
+                <a:solidFill>
+                  <a:schemeClr val="accent1"/>
+                </a:solidFill>
+              </a:rPr>
+            </a:br>
+            <a:r>
+              <a:rPr lang="en-US" sz="2000" b="1" dirty="0">
+                <a:solidFill>
+                  <a:schemeClr val="accent1"/>
+                </a:solidFill>
+              </a:rPr>
+              <a:t>improvement</a:t>
+            </a:r>
+          </a:p>
+          <a:p>
+            <a:pPr>
+              <a:spcBef>
+                <a:spcPts val="400"/>
+              </a:spcBef>
+            </a:pPr>
+            <a:r>
+              <a:rPr lang="en-US" sz="2000" dirty="0"/>
+              <a:t>A central hub for sharing information on practices, techniques, experiences, and tools to improve developer productivity and software sustainability for computational science &amp; engineering (CSE)</a:t>
+            </a:r>
+            <a:endParaRPr lang="en-US" dirty="0"/>
+          </a:p>
+          <a:p>
+            <a:pPr marL="0" indent="0">
+              <a:buFont typeface="Arial" charset="0"/>
+              <a:buNone/>
+            </a:pPr>
+            <a:r>
+              <a:rPr lang="en-US" b="1" dirty="0"/>
+              <a:t>Goals</a:t>
+            </a:r>
+          </a:p>
+          <a:p>
+            <a:pPr>
+              <a:spcBef>
+                <a:spcPts val="400"/>
+              </a:spcBef>
+            </a:pPr>
+            <a:r>
+              <a:rPr lang="en-US" sz="2000" dirty="0"/>
+              <a:t>Raise awareness of the importance of </a:t>
+            </a:r>
+            <a:r>
+              <a:rPr lang="en-US" sz="2000" b="1" dirty="0"/>
+              <a:t>good software practices </a:t>
+            </a:r>
+            <a:r>
+              <a:rPr lang="en-US" sz="2000" dirty="0"/>
+              <a:t>to scientific productivity and to the quality and reliability of computationally-based scientific results</a:t>
+            </a:r>
+          </a:p>
+          <a:p>
+            <a:pPr>
+              <a:spcBef>
+                <a:spcPts val="400"/>
+              </a:spcBef>
+            </a:pPr>
+            <a:r>
+              <a:rPr lang="en-US" sz="2000" dirty="0"/>
+              <a:t>Raise awareness of the </a:t>
+            </a:r>
+            <a:r>
+              <a:rPr lang="en-US" sz="2000" b="1" dirty="0"/>
+              <a:t>increasing challenges </a:t>
+            </a:r>
+            <a:r>
+              <a:rPr lang="en-US" sz="2000" dirty="0"/>
+              <a:t>facing CSE software developers as high-end computing heads to extreme scales</a:t>
+            </a:r>
+          </a:p>
+          <a:p>
+            <a:pPr>
+              <a:spcBef>
+                <a:spcPts val="400"/>
+              </a:spcBef>
+            </a:pPr>
+            <a:r>
+              <a:rPr lang="en-US" sz="2000" dirty="0"/>
+              <a:t>Help CSE researchers </a:t>
+            </a:r>
+            <a:r>
+              <a:rPr lang="en-US" sz="2000" b="1" dirty="0"/>
+              <a:t>increase effectiveness </a:t>
+            </a:r>
+            <a:r>
+              <a:rPr lang="en-US" sz="2000" dirty="0"/>
+              <a:t>as well as leverage and impact</a:t>
+            </a:r>
+          </a:p>
+          <a:p>
+            <a:pPr>
+              <a:spcBef>
+                <a:spcPts val="400"/>
+              </a:spcBef>
+            </a:pPr>
+            <a:r>
+              <a:rPr lang="en-US" sz="2000" b="1" dirty="0"/>
+              <a:t>Facilitate CSE collaboration via software</a:t>
+            </a:r>
+            <a:r>
+              <a:rPr lang="en-US" sz="2000" dirty="0"/>
+              <a:t> in order to advance scientific discoveries</a:t>
+            </a:r>
+          </a:p>
+          <a:p>
+            <a:pPr marL="0" indent="0">
+              <a:buFont typeface="Arial" charset="0"/>
+              <a:buNone/>
+            </a:pPr>
+            <a:r>
+              <a:rPr lang="en-US" b="1" dirty="0"/>
+              <a:t>Site users can…</a:t>
+            </a:r>
+          </a:p>
+          <a:p>
+            <a:pPr>
+              <a:spcBef>
+                <a:spcPts val="400"/>
+              </a:spcBef>
+            </a:pPr>
+            <a:r>
+              <a:rPr lang="en-US" sz="2000" b="1" dirty="0"/>
+              <a:t>Find information </a:t>
+            </a:r>
+            <a:r>
+              <a:rPr lang="en-US" sz="2000" dirty="0"/>
+              <a:t>on scientific software topics</a:t>
+            </a:r>
+          </a:p>
+          <a:p>
+            <a:pPr>
+              <a:spcBef>
+                <a:spcPts val="400"/>
+              </a:spcBef>
+            </a:pPr>
+            <a:r>
+              <a:rPr lang="en-US" sz="2000" b="1" dirty="0"/>
+              <a:t>Contribute new resources </a:t>
+            </a:r>
+            <a:r>
+              <a:rPr lang="en-US" sz="2000" dirty="0"/>
+              <a:t>based on your experiences</a:t>
+            </a:r>
+          </a:p>
+          <a:p>
+            <a:pPr>
+              <a:spcBef>
+                <a:spcPts val="400"/>
+              </a:spcBef>
+            </a:pPr>
+            <a:r>
+              <a:rPr lang="en-US" sz="2000" dirty="0"/>
+              <a:t>Create content tailored to the unique needs and </a:t>
+            </a:r>
+            <a:br>
+              <a:rPr lang="en-US" sz="2000" dirty="0"/>
+            </a:br>
+            <a:r>
+              <a:rPr lang="en-US" sz="2000" dirty="0"/>
+              <a:t>perspectives of a focused scientific domain</a:t>
+            </a:r>
+          </a:p>
+        </p:txBody>
+      </p:sp>
+      <p:pic>
+        <p:nvPicPr>
+          <p:cNvPr id="4" name="Picture 3" descr="Screen Shot 2017-01-21 at 6.45.35 PM.png">
+            <a:extLst>
+              <a:ext uri="{FF2B5EF4-FFF2-40B4-BE49-F238E27FC236}">
+                <a16:creationId xmlns:a16="http://schemas.microsoft.com/office/drawing/2014/main" id="{4305FC7E-611D-4E7E-952D-9882E099EE96}"/>
+              </a:ext>
+            </a:extLst>
+          </p:cNvPr>
+          <p:cNvPicPr>
+            <a:picLocks noChangeAspect="1"/>
+          </p:cNvPicPr>
+          <p:nvPr/>
+        </p:nvPicPr>
+        <p:blipFill>
+          <a:blip r:embed="rId3" cstate="print">
+            <a:extLst>
+              <a:ext uri="{28A0092B-C50C-407E-A947-70E740481C1C}">
+                <a14:useLocalDpi xmlns:a14="http://schemas.microsoft.com/office/drawing/2010/main" val="0"/>
+              </a:ext>
+            </a:extLst>
+          </a:blip>
+          <a:stretch>
+            <a:fillRect/>
+          </a:stretch>
+        </p:blipFill>
+        <p:spPr>
+          <a:xfrm>
+            <a:off x="8483534" y="320039"/>
+            <a:ext cx="3357819" cy="1440667"/>
+          </a:xfrm>
+          <a:prstGeom prst="rect">
+            <a:avLst/>
+          </a:prstGeom>
+        </p:spPr>
+      </p:pic>
+    </p:spTree>
+    <p:extLst>
+      <p:ext uri="{BB962C8B-B14F-4D97-AF65-F5344CB8AC3E}">
+        <p14:creationId xmlns:p14="http://schemas.microsoft.com/office/powerpoint/2010/main" val="245510431"/>
+      </p:ext>
+    </p:extLst>
+  </p:cSld>
+  <p:clrMapOvr>
+    <a:masterClrMapping/>
+  </p:clrMapOvr>
+</p:sld>
+</file>
+
+<file path=ppt/slides/slide5.xml><?xml version="1.0" encoding="utf-8"?>
+<p:sld xmlns:a="http://schemas.openxmlformats.org/drawingml/2006/main" xmlns:r="http://schemas.openxmlformats.org/officeDocument/2006/relationships" xmlns:p="http://schemas.openxmlformats.org/presentationml/2006/main">
+  <p:cSld>
+    <p:spTree>
+      <p:nvGrpSpPr>
+        <p:cNvPr id="1" name=""/>
+        <p:cNvGrpSpPr/>
+        <p:nvPr/>
+      </p:nvGrpSpPr>
+      <p:grpSpPr>
+        <a:xfrm>
+          <a:off x="0" y="0"/>
+          <a:ext cx="0" cy="0"/>
+          <a:chOff x="0" y="0"/>
+          <a:chExt cx="0" cy="0"/>
+        </a:xfrm>
+      </p:grpSpPr>
+      <p:sp>
+        <p:nvSpPr>
+          <p:cNvPr id="3" name="Title 2">
+            <a:extLst>
+              <a:ext uri="{FF2B5EF4-FFF2-40B4-BE49-F238E27FC236}">
+                <a16:creationId xmlns:a16="http://schemas.microsoft.com/office/drawing/2014/main" id="{958CB878-0734-4463-835E-51258994794F}"/>
+              </a:ext>
+            </a:extLst>
+          </p:cNvPr>
+          <p:cNvSpPr>
+            <a:spLocks noGrp="1"/>
+          </p:cNvSpPr>
+          <p:nvPr>
+            <p:ph type="title"/>
+          </p:nvPr>
+        </p:nvSpPr>
+        <p:spPr/>
+        <p:txBody>
+          <a:bodyPr/>
+          <a:lstStyle/>
+          <a:p>
+            <a:r>
+              <a:rPr lang="en-US" dirty="0"/>
+              <a:t>Follow </a:t>
+            </a:r>
+            <a:r>
+              <a:rPr lang="en-US" dirty="0" err="1"/>
+              <a:t>BSSw</a:t>
+            </a:r>
+            <a:endParaRPr lang="en-US" dirty="0"/>
+          </a:p>
+        </p:txBody>
+      </p:sp>
+      <p:sp>
+        <p:nvSpPr>
+          <p:cNvPr id="4" name="Content Placeholder 3">
+            <a:extLst>
+              <a:ext uri="{FF2B5EF4-FFF2-40B4-BE49-F238E27FC236}">
+                <a16:creationId xmlns:a16="http://schemas.microsoft.com/office/drawing/2014/main" id="{AE2680D0-A841-4E56-972F-EBFB89AD4D33}"/>
+              </a:ext>
+            </a:extLst>
+          </p:cNvPr>
+          <p:cNvSpPr>
+            <a:spLocks noGrp="1"/>
+          </p:cNvSpPr>
+          <p:nvPr>
+            <p:ph idx="1"/>
+          </p:nvPr>
+        </p:nvSpPr>
+        <p:spPr/>
+        <p:txBody>
+          <a:bodyPr/>
+          <a:lstStyle/>
+          <a:p>
+            <a:pPr>
+              <a:spcBef>
+                <a:spcPts val="2400"/>
+              </a:spcBef>
+            </a:pPr>
+            <a:r>
+              <a:rPr lang="en-US" dirty="0" err="1"/>
+              <a:t>BSSw</a:t>
+            </a:r>
+            <a:r>
+              <a:rPr lang="en-US" dirty="0"/>
+              <a:t> Digest: </a:t>
+            </a:r>
+            <a:r>
+              <a:rPr lang="en-US" dirty="0">
+                <a:hlinkClick r:id="rId2"/>
+              </a:rPr>
+              <a:t>https://bssw.io/pages/receive-our-email-digest</a:t>
+            </a:r>
+            <a:endParaRPr lang="en-US" dirty="0"/>
+          </a:p>
+          <a:p>
+            <a:pPr lvl="1"/>
+            <a:r>
+              <a:rPr lang="en-US" dirty="0"/>
+              <a:t>Updates on </a:t>
+            </a:r>
+            <a:r>
+              <a:rPr lang="en-US" dirty="0" err="1"/>
+              <a:t>BSSw</a:t>
+            </a:r>
+            <a:r>
+              <a:rPr lang="en-US" dirty="0"/>
+              <a:t> content</a:t>
+            </a:r>
+          </a:p>
+          <a:p>
+            <a:pPr lvl="2"/>
+            <a:r>
+              <a:rPr lang="en-US" dirty="0"/>
+              <a:t>New blog posts, events, and resources</a:t>
+            </a:r>
+          </a:p>
+          <a:p>
+            <a:pPr lvl="2"/>
+            <a:r>
+              <a:rPr lang="en-US" dirty="0" err="1"/>
+              <a:t>BSSw</a:t>
+            </a:r>
+            <a:r>
+              <a:rPr lang="en-US" dirty="0"/>
+              <a:t> Fellowship</a:t>
+            </a:r>
+          </a:p>
+          <a:p>
+            <a:pPr lvl="1"/>
+            <a:r>
+              <a:rPr lang="en-US" dirty="0"/>
+              <a:t>Typically 1-2 messages per month</a:t>
+            </a:r>
+          </a:p>
+          <a:p>
+            <a:pPr lvl="1"/>
+            <a:r>
+              <a:rPr lang="en-US" dirty="0"/>
+              <a:t>Also: RSS feed: </a:t>
+            </a:r>
+            <a:r>
+              <a:rPr lang="en-US" dirty="0">
+                <a:hlinkClick r:id="rId3"/>
+              </a:rPr>
+              <a:t>https://bssw.io/items.rss</a:t>
+            </a:r>
+            <a:endParaRPr lang="en-US" dirty="0"/>
+          </a:p>
+        </p:txBody>
+      </p:sp>
+      <p:pic>
+        <p:nvPicPr>
+          <p:cNvPr id="5" name="Picture 4" descr="Screen Shot 2017-01-21 at 6.45.35 PM.png">
+            <a:extLst>
+              <a:ext uri="{FF2B5EF4-FFF2-40B4-BE49-F238E27FC236}">
+                <a16:creationId xmlns:a16="http://schemas.microsoft.com/office/drawing/2014/main" id="{DDAA8357-C3CA-4399-9F08-279982853473}"/>
+              </a:ext>
+            </a:extLst>
+          </p:cNvPr>
+          <p:cNvPicPr>
+            <a:picLocks noChangeAspect="1"/>
+          </p:cNvPicPr>
+          <p:nvPr/>
+        </p:nvPicPr>
+        <p:blipFill>
+          <a:blip r:embed="rId4" cstate="print">
+            <a:extLst>
+              <a:ext uri="{28A0092B-C50C-407E-A947-70E740481C1C}">
+                <a14:useLocalDpi xmlns:a14="http://schemas.microsoft.com/office/drawing/2010/main" val="0"/>
+              </a:ext>
+            </a:extLst>
+          </a:blip>
+          <a:stretch>
+            <a:fillRect/>
+          </a:stretch>
+        </p:blipFill>
+        <p:spPr>
+          <a:xfrm>
+            <a:off x="8558894" y="2643687"/>
+            <a:ext cx="2109916" cy="905256"/>
+          </a:xfrm>
+          <a:prstGeom prst="rect">
+            <a:avLst/>
+          </a:prstGeom>
+        </p:spPr>
+      </p:pic>
+    </p:spTree>
+    <p:extLst>
+      <p:ext uri="{BB962C8B-B14F-4D97-AF65-F5344CB8AC3E}">
+        <p14:creationId xmlns:p14="http://schemas.microsoft.com/office/powerpoint/2010/main" val="2696507976"/>
+      </p:ext>
+    </p:extLst>
+  </p:cSld>
+  <p:clrMapOvr>
+    <a:masterClrMapping/>
+  </p:clrMapOvr>
+</p:sld>
+</file>
+
+<file path=ppt/slides/slide6.xml><?xml version="1.0" encoding="utf-8"?>
+<p:sld xmlns:a="http://schemas.openxmlformats.org/drawingml/2006/main" xmlns:r="http://schemas.openxmlformats.org/officeDocument/2006/relationships" xmlns:p="http://schemas.openxmlformats.org/presentationml/2006/main">
+  <p:cSld>
+    <p:spTree>
+      <p:nvGrpSpPr>
+        <p:cNvPr id="1" name=""/>
+        <p:cNvGrpSpPr/>
+        <p:nvPr/>
+      </p:nvGrpSpPr>
+      <p:grpSpPr>
+        <a:xfrm>
+          <a:off x="0" y="0"/>
+          <a:ext cx="0" cy="0"/>
+          <a:chOff x="0" y="0"/>
+          <a:chExt cx="0" cy="0"/>
+        </a:xfrm>
+      </p:grpSpPr>
+      <p:sp>
+        <p:nvSpPr>
+          <p:cNvPr id="2" name="Title 1">
+            <a:extLst>
+              <a:ext uri="{FF2B5EF4-FFF2-40B4-BE49-F238E27FC236}">
+                <a16:creationId xmlns:a16="http://schemas.microsoft.com/office/drawing/2014/main" id="{290A2901-48B8-469D-BFD7-34B28CA8F61C}"/>
+              </a:ext>
+            </a:extLst>
+          </p:cNvPr>
+          <p:cNvSpPr>
+            <a:spLocks noGrp="1"/>
+          </p:cNvSpPr>
+          <p:nvPr>
+            <p:ph type="title"/>
+          </p:nvPr>
+        </p:nvSpPr>
+        <p:spPr/>
+        <p:txBody>
+          <a:bodyPr/>
+          <a:lstStyle/>
+          <a:p>
+            <a:r>
+              <a:rPr lang="en-US" dirty="0" err="1"/>
+              <a:t>BSSw</a:t>
+            </a:r>
+            <a:r>
+              <a:rPr lang="en-US" dirty="0"/>
+              <a:t> Tutorial Web Site</a:t>
+            </a:r>
+          </a:p>
+        </p:txBody>
+      </p:sp>
+      <p:sp>
+        <p:nvSpPr>
+          <p:cNvPr id="3" name="Content Placeholder 2">
+            <a:extLst>
+              <a:ext uri="{FF2B5EF4-FFF2-40B4-BE49-F238E27FC236}">
+                <a16:creationId xmlns:a16="http://schemas.microsoft.com/office/drawing/2014/main" id="{1C6E25F3-5A8B-478E-83F2-ED0BCAF1B015}"/>
+              </a:ext>
+            </a:extLst>
+          </p:cNvPr>
+          <p:cNvSpPr>
+            <a:spLocks noGrp="1"/>
+          </p:cNvSpPr>
+          <p:nvPr>
+            <p:ph idx="1"/>
+          </p:nvPr>
+        </p:nvSpPr>
+        <p:spPr>
+          <a:xfrm>
+            <a:off x="365760" y="1737360"/>
+            <a:ext cx="7453937" cy="4047778"/>
+          </a:xfrm>
+        </p:spPr>
+        <p:txBody>
+          <a:bodyPr/>
+          <a:lstStyle/>
+          <a:p>
+            <a:r>
+              <a:rPr lang="en-US" sz="2400" b="1" dirty="0">
+                <a:hlinkClick r:id="rId2"/>
+              </a:rPr>
+              <a:t>https://bssw-tutorial.github.io/</a:t>
+            </a:r>
+            <a:r>
+              <a:rPr lang="en-US" sz="2400" b="1" dirty="0"/>
+              <a:t> </a:t>
+            </a:r>
+            <a:r>
+              <a:rPr lang="en-US" sz="2400" dirty="0"/>
+              <a:t>is the one URL you need to find all the resources for this tutorial</a:t>
+            </a:r>
+          </a:p>
+          <a:p>
+            <a:r>
+              <a:rPr lang="en-US" dirty="0"/>
+              <a:t>Each tutorial event has its own page</a:t>
+            </a:r>
+          </a:p>
+          <a:p>
+            <a:r>
+              <a:rPr lang="en-US" dirty="0"/>
+              <a:t>Each tutorial page is considered archival</a:t>
+            </a:r>
+          </a:p>
+          <a:p>
+            <a:pPr lvl="1"/>
+            <a:r>
+              <a:rPr lang="en-US" dirty="0"/>
+              <a:t>All of the materials used in that tutorial (or links to them)</a:t>
+            </a:r>
+          </a:p>
+          <a:p>
+            <a:pPr lvl="1"/>
+            <a:r>
+              <a:rPr lang="en-US" dirty="0"/>
+              <a:t>Materials may be updated if we find mistakes</a:t>
+            </a:r>
+          </a:p>
+        </p:txBody>
+      </p:sp>
+      <p:pic>
+        <p:nvPicPr>
+          <p:cNvPr id="6" name="Picture 5" descr="Graphical user interface, text&#10;&#10;Description automatically generated">
+            <a:extLst>
+              <a:ext uri="{FF2B5EF4-FFF2-40B4-BE49-F238E27FC236}">
+                <a16:creationId xmlns:a16="http://schemas.microsoft.com/office/drawing/2014/main" id="{B36C999D-A67A-4A27-A8A2-05E0A7E3AD25}"/>
+              </a:ext>
+            </a:extLst>
+          </p:cNvPr>
+          <p:cNvPicPr>
+            <a:picLocks noChangeAspect="1"/>
+          </p:cNvPicPr>
+          <p:nvPr/>
+        </p:nvPicPr>
+        <p:blipFill>
+          <a:blip r:embed="rId3" cstate="print">
+            <a:extLst>
+              <a:ext uri="{28A0092B-C50C-407E-A947-70E740481C1C}">
+                <a14:useLocalDpi xmlns:a14="http://schemas.microsoft.com/office/drawing/2010/main" val="0"/>
+              </a:ext>
+            </a:extLst>
+          </a:blip>
+          <a:stretch>
+            <a:fillRect/>
+          </a:stretch>
+        </p:blipFill>
+        <p:spPr>
+          <a:xfrm>
+            <a:off x="7819697" y="455350"/>
+            <a:ext cx="4089597" cy="5345008"/>
+          </a:xfrm>
+          <a:prstGeom prst="rect">
+            <a:avLst/>
+          </a:prstGeom>
+          <a:ln>
+            <a:solidFill>
+              <a:schemeClr val="tx1"/>
+            </a:solidFill>
+          </a:ln>
+          <a:effectLst>
+            <a:outerShdw blurRad="50800" dist="38100" dir="2700000" algn="tl" rotWithShape="0">
+              <a:prstClr val="black">
+                <a:alpha val="40000"/>
+              </a:prstClr>
+            </a:outerShdw>
+          </a:effectLst>
+        </p:spPr>
+      </p:pic>
+    </p:spTree>
+    <p:extLst>
+      <p:ext uri="{BB962C8B-B14F-4D97-AF65-F5344CB8AC3E}">
+        <p14:creationId xmlns:p14="http://schemas.microsoft.com/office/powerpoint/2010/main" val="1366987390"/>
+      </p:ext>
+    </p:extLst>
+  </p:cSld>
+  <p:clrMapOvr>
+    <a:masterClrMapping/>
+  </p:clrMapOvr>
+</p:sld>
+</file>
+
+<file path=ppt/slides/slide7.xml><?xml version="1.0" encoding="utf-8"?>
+<p:sld xmlns:a="http://schemas.openxmlformats.org/drawingml/2006/main" xmlns:r="http://schemas.openxmlformats.org/officeDocument/2006/relationships" xmlns:p="http://schemas.openxmlformats.org/presentationml/2006/main">
+  <p:cSld>
+    <p:spTree>
+      <p:nvGrpSpPr>
+        <p:cNvPr id="1" name=""/>
+        <p:cNvGrpSpPr/>
+        <p:nvPr/>
+      </p:nvGrpSpPr>
+      <p:grpSpPr>
+        <a:xfrm>
+          <a:off x="0" y="0"/>
+          <a:ext cx="0" cy="0"/>
+          <a:chOff x="0" y="0"/>
+          <a:chExt cx="0" cy="0"/>
+        </a:xfrm>
+      </p:grpSpPr>
+      <p:sp>
+        <p:nvSpPr>
+          <p:cNvPr id="2" name="Title 1">
+            <a:extLst>
+              <a:ext uri="{FF2B5EF4-FFF2-40B4-BE49-F238E27FC236}">
+                <a16:creationId xmlns:a16="http://schemas.microsoft.com/office/drawing/2014/main" id="{7E57752C-4E2B-4E58-8726-8BAC8610FAC7}"/>
+              </a:ext>
+            </a:extLst>
+          </p:cNvPr>
+          <p:cNvSpPr>
+            <a:spLocks noGrp="1"/>
+          </p:cNvSpPr>
+          <p:nvPr>
+            <p:ph type="title"/>
+          </p:nvPr>
+        </p:nvSpPr>
+        <p:spPr/>
+        <p:txBody>
+          <a:bodyPr/>
+          <a:lstStyle/>
+          <a:p>
+            <a:r>
+              <a:rPr lang="en-US" dirty="0"/>
+              <a:t>Explaining Slide 2</a:t>
+            </a:r>
+          </a:p>
+        </p:txBody>
+      </p:sp>
+      <p:sp>
+        <p:nvSpPr>
+          <p:cNvPr id="3" name="Content Placeholder 2">
+            <a:extLst>
+              <a:ext uri="{FF2B5EF4-FFF2-40B4-BE49-F238E27FC236}">
+                <a16:creationId xmlns:a16="http://schemas.microsoft.com/office/drawing/2014/main" id="{9A010E9D-1983-429B-A89D-EBF4829E152F}"/>
+              </a:ext>
+            </a:extLst>
+          </p:cNvPr>
+          <p:cNvSpPr>
+            <a:spLocks noGrp="1"/>
+          </p:cNvSpPr>
+          <p:nvPr>
+            <p:ph idx="1"/>
+          </p:nvPr>
+        </p:nvSpPr>
+        <p:spPr>
+          <a:xfrm>
+            <a:off x="365760" y="1049985"/>
+            <a:ext cx="11369809" cy="4047778"/>
+          </a:xfrm>
+        </p:spPr>
+        <p:txBody>
+          <a:bodyPr/>
+          <a:lstStyle/>
+          <a:p>
+            <a:r>
+              <a:rPr lang="en-US" dirty="0"/>
+              <a:t>Slide 2 in all of our presentations contains the license, citation, and acknowledgements for the tutorial</a:t>
+            </a:r>
+          </a:p>
+          <a:p>
+            <a:r>
+              <a:rPr lang="en-US" dirty="0"/>
+              <a:t>(Software) best practice to make your license and preferred citation(s) </a:t>
+            </a:r>
+            <a:r>
+              <a:rPr lang="en-US"/>
+              <a:t>easily findable</a:t>
+            </a:r>
+            <a:endParaRPr lang="en-US" dirty="0"/>
+          </a:p>
+          <a:p>
+            <a:r>
+              <a:rPr lang="en-US" dirty="0"/>
+              <a:t>Sponsor acknowledgements rarely hurt!</a:t>
+            </a:r>
+          </a:p>
+        </p:txBody>
+      </p:sp>
+      <p:pic>
+        <p:nvPicPr>
+          <p:cNvPr id="10" name="Picture 9" descr="A document with text and images&#10;&#10;Description automatically generated">
+            <a:extLst>
+              <a:ext uri="{FF2B5EF4-FFF2-40B4-BE49-F238E27FC236}">
+                <a16:creationId xmlns:a16="http://schemas.microsoft.com/office/drawing/2014/main" id="{77E2D18D-1073-12C7-771C-B42CCA7E04E2}"/>
+              </a:ext>
+            </a:extLst>
+          </p:cNvPr>
+          <p:cNvPicPr>
+            <a:picLocks noChangeAspect="1"/>
+          </p:cNvPicPr>
+          <p:nvPr/>
+        </p:nvPicPr>
+        <p:blipFill rotWithShape="1">
+          <a:blip r:embed="rId2" cstate="print">
+            <a:extLst>
+              <a:ext uri="{28A0092B-C50C-407E-A947-70E740481C1C}">
+                <a14:useLocalDpi xmlns:a14="http://schemas.microsoft.com/office/drawing/2010/main" val="0"/>
+              </a:ext>
+            </a:extLst>
+          </a:blip>
+          <a:srcRect t="1" b="23157"/>
+          <a:stretch/>
+        </p:blipFill>
+        <p:spPr>
+          <a:xfrm>
+            <a:off x="1938615" y="3256754"/>
+            <a:ext cx="7772400" cy="3383280"/>
+          </a:xfrm>
+          <a:prstGeom prst="rect">
+            <a:avLst/>
+          </a:prstGeom>
+        </p:spPr>
+      </p:pic>
+    </p:spTree>
+    <p:extLst>
+      <p:ext uri="{BB962C8B-B14F-4D97-AF65-F5344CB8AC3E}">
+        <p14:creationId xmlns:p14="http://schemas.microsoft.com/office/powerpoint/2010/main" val="2504672246"/>
+      </p:ext>
+    </p:extLst>
+  </p:cSld>
+  <p:clrMapOvr>
+    <a:masterClrMapping/>
+  </p:clrMapOvr>
+</p:sld>
+</file>
+
+<file path=ppt/slides/slide8.xml><?xml version="1.0" encoding="utf-8"?>
+<p:sld xmlns:a="http://schemas.openxmlformats.org/drawingml/2006/main" xmlns:r="http://schemas.openxmlformats.org/officeDocument/2006/relationships" xmlns:p="http://schemas.openxmlformats.org/presentationml/2006/main">
+  <p:cSld>
+    <p:spTree>
+      <p:nvGrpSpPr>
+        <p:cNvPr id="1" name=""/>
+        <p:cNvGrpSpPr/>
+        <p:nvPr/>
+      </p:nvGrpSpPr>
+      <p:grpSpPr>
+        <a:xfrm>
+          <a:off x="0" y="0"/>
+          <a:ext cx="0" cy="0"/>
+          <a:chOff x="0" y="0"/>
+          <a:chExt cx="0" cy="0"/>
+        </a:xfrm>
+      </p:grpSpPr>
+      <p:sp>
+        <p:nvSpPr>
+          <p:cNvPr id="2" name="Title 1">
+            <a:extLst>
+              <a:ext uri="{FF2B5EF4-FFF2-40B4-BE49-F238E27FC236}">
+                <a16:creationId xmlns:a16="http://schemas.microsoft.com/office/drawing/2014/main" id="{88D7CFF0-36AC-4BF3-96D2-C6F302144850}"/>
+              </a:ext>
+            </a:extLst>
+          </p:cNvPr>
+          <p:cNvSpPr>
+            <a:spLocks noGrp="1"/>
+          </p:cNvSpPr>
+          <p:nvPr>
+            <p:ph type="title"/>
+          </p:nvPr>
+        </p:nvSpPr>
+        <p:spPr/>
+        <p:txBody>
+          <a:bodyPr/>
+          <a:lstStyle/>
+          <a:p>
+            <a:r>
+              <a:rPr lang="en-US" dirty="0"/>
+              <a:t>We Want to Interact with You!</a:t>
+            </a:r>
+          </a:p>
+        </p:txBody>
+      </p:sp>
+      <p:sp>
+        <p:nvSpPr>
+          <p:cNvPr id="3" name="Content Placeholder 2">
+            <a:extLst>
+              <a:ext uri="{FF2B5EF4-FFF2-40B4-BE49-F238E27FC236}">
+                <a16:creationId xmlns:a16="http://schemas.microsoft.com/office/drawing/2014/main" id="{AEFD04A9-5547-4AC6-89F3-E6EEC039A00D}"/>
+              </a:ext>
+            </a:extLst>
+          </p:cNvPr>
+          <p:cNvSpPr>
+            <a:spLocks noGrp="1"/>
+          </p:cNvSpPr>
+          <p:nvPr>
+            <p:ph idx="1"/>
+          </p:nvPr>
+        </p:nvSpPr>
+        <p:spPr>
+          <a:xfrm>
+            <a:off x="365760" y="919230"/>
+            <a:ext cx="11369809" cy="4047778"/>
+          </a:xfrm>
+        </p:spPr>
+        <p:txBody>
+          <a:bodyPr/>
+          <a:lstStyle/>
+          <a:p>
+            <a:pPr>
+              <a:spcBef>
+                <a:spcPts val="1800"/>
+              </a:spcBef>
+            </a:pPr>
+            <a:r>
+              <a:rPr lang="en-US" dirty="0"/>
+              <a:t>We find these tutorials most interesting and informative (for everyone) if you ask questions and share experiences!</a:t>
+            </a:r>
+          </a:p>
+          <a:p>
+            <a:pPr lvl="1">
+              <a:spcBef>
+                <a:spcPts val="400"/>
+              </a:spcBef>
+            </a:pPr>
+            <a:r>
+              <a:rPr lang="en-US" dirty="0"/>
+              <a:t>We learn too!</a:t>
+            </a:r>
+          </a:p>
+          <a:p>
+            <a:pPr>
+              <a:spcBef>
+                <a:spcPts val="400"/>
+              </a:spcBef>
+            </a:pPr>
+            <a:r>
+              <a:rPr lang="en-US" dirty="0"/>
+              <a:t>Please raise your hand at any time to ask a question</a:t>
+            </a:r>
+          </a:p>
+          <a:p>
+            <a:pPr>
+              <a:spcBef>
+                <a:spcPts val="1200"/>
+              </a:spcBef>
+            </a:pPr>
+            <a:r>
+              <a:rPr lang="en-US" dirty="0"/>
+              <a:t>After the tutorial email us at </a:t>
+            </a:r>
+            <a:r>
+              <a:rPr lang="en-US" dirty="0">
+                <a:hlinkClick r:id="rId2"/>
+              </a:rPr>
+              <a:t>bssw-tutorial@lists.mcs.anl.gov</a:t>
+            </a:r>
+            <a:endParaRPr lang="en-US" dirty="0"/>
+          </a:p>
+          <a:p>
+            <a:pPr lvl="1">
+              <a:spcBef>
+                <a:spcPts val="400"/>
+              </a:spcBef>
+            </a:pPr>
+            <a:r>
+              <a:rPr lang="en-US" dirty="0"/>
+              <a:t>With questions or feedback</a:t>
+            </a:r>
+          </a:p>
+          <a:p>
+            <a:pPr lvl="1"/>
+            <a:r>
+              <a:rPr lang="en-US" dirty="0"/>
+              <a:t>The list moderator will allow your messages to be posted</a:t>
+            </a:r>
+          </a:p>
+          <a:p>
+            <a:r>
+              <a:rPr lang="en-US" dirty="0"/>
+              <a:t>Refer to </a:t>
+            </a:r>
+            <a:r>
+              <a:rPr lang="en-US" dirty="0">
+                <a:hlinkClick r:id="rId3"/>
+              </a:rPr>
+              <a:t>bssw-tutorial.github.io</a:t>
+            </a:r>
+            <a:r>
+              <a:rPr lang="en-US" dirty="0"/>
+              <a:t> page for all tutorial materials</a:t>
+            </a:r>
+          </a:p>
+        </p:txBody>
+      </p:sp>
+      <p:sp>
+        <p:nvSpPr>
+          <p:cNvPr id="4" name="TextBox 3">
+            <a:extLst>
+              <a:ext uri="{FF2B5EF4-FFF2-40B4-BE49-F238E27FC236}">
+                <a16:creationId xmlns:a16="http://schemas.microsoft.com/office/drawing/2014/main" id="{6067EE83-B4F9-019B-E0E8-E80C48D26F36}"/>
+              </a:ext>
+            </a:extLst>
+          </p:cNvPr>
+          <p:cNvSpPr txBox="1"/>
+          <p:nvPr/>
+        </p:nvSpPr>
+        <p:spPr>
+          <a:xfrm>
+            <a:off x="3361713" y="4561262"/>
+            <a:ext cx="5465397" cy="1846659"/>
+          </a:xfrm>
+          <a:prstGeom prst="rect">
+            <a:avLst/>
+          </a:prstGeom>
+          <a:solidFill>
+            <a:srgbClr val="FFFF00"/>
+          </a:solidFill>
+          <a:ln>
+            <a:solidFill>
+              <a:schemeClr val="tx1"/>
+            </a:solidFill>
+          </a:ln>
+        </p:spPr>
+        <p:txBody>
+          <a:bodyPr wrap="square" lIns="118872" tIns="91440" rIns="118872" bIns="91440" rtlCol="0" anchor="ctr" anchorCtr="0">
+            <a:spAutoFit/>
+          </a:bodyPr>
+          <a:lstStyle/>
+          <a:p>
+            <a:pPr algn="ctr">
+              <a:lnSpc>
+                <a:spcPct val="90000"/>
+              </a:lnSpc>
+            </a:pPr>
+            <a:r>
+              <a:rPr lang="en-US" sz="2400" dirty="0"/>
+              <a:t>You may also be interested in these other software-related events at SC25: </a:t>
+            </a:r>
+            <a:r>
+              <a:rPr lang="en-US" sz="2400" dirty="0">
+                <a:hlinkClick r:id="rId4"/>
+              </a:rPr>
+              <a:t>https://bssw.io/events/sc25-software-related-events </a:t>
+            </a:r>
+            <a:endParaRPr lang="en-US" sz="2400" dirty="0"/>
+          </a:p>
+          <a:p>
+            <a:pPr algn="ctr">
+              <a:lnSpc>
+                <a:spcPct val="90000"/>
+              </a:lnSpc>
+            </a:pPr>
+            <a:r>
+              <a:rPr lang="en-US" dirty="0"/>
+              <a:t>(link is also on tutorial web page)</a:t>
+            </a:r>
+            <a:endParaRPr lang="en-US" sz="2400" dirty="0"/>
+          </a:p>
+        </p:txBody>
+      </p:sp>
+    </p:spTree>
+    <p:extLst>
+      <p:ext uri="{BB962C8B-B14F-4D97-AF65-F5344CB8AC3E}">
+        <p14:creationId xmlns:p14="http://schemas.microsoft.com/office/powerpoint/2010/main" val="3695382487"/>
+      </p:ext>
+    </p:extLst>
+  </p:cSld>
+  <p:clrMapOvr>
+    <a:masterClrMapping/>
+  </p:clrMapOvr>
+</p:sld>
+</file>
+
+<file path=ppt/slides/slide9.xml><?xml version="1.0" encoding="utf-8"?>
+<p:sld xmlns:a="http://schemas.openxmlformats.org/drawingml/2006/main" xmlns:r="http://schemas.openxmlformats.org/officeDocument/2006/relationships" xmlns:p="http://schemas.openxmlformats.org/presentationml/2006/main">
+  <p:cSld>
+    <p:spTree>
+      <p:nvGrpSpPr>
+        <p:cNvPr id="1" name=""/>
+        <p:cNvGrpSpPr/>
+        <p:nvPr/>
+      </p:nvGrpSpPr>
+      <p:grpSpPr>
+        <a:xfrm>
+          <a:off x="0" y="0"/>
+          <a:ext cx="0" cy="0"/>
+          <a:chOff x="0" y="0"/>
+          <a:chExt cx="0" cy="0"/>
+        </a:xfrm>
+      </p:grpSpPr>
+      <p:sp>
+        <p:nvSpPr>
+          <p:cNvPr id="2" name="Title 1">
+            <a:extLst>
+              <a:ext uri="{FF2B5EF4-FFF2-40B4-BE49-F238E27FC236}">
+                <a16:creationId xmlns:a16="http://schemas.microsoft.com/office/drawing/2014/main" id="{D922857B-C8AE-3636-C96D-01CD92D9CB12}"/>
+              </a:ext>
+            </a:extLst>
+          </p:cNvPr>
+          <p:cNvSpPr>
+            <a:spLocks noGrp="1"/>
+          </p:cNvSpPr>
+          <p:nvPr>
+            <p:ph type="title"/>
+          </p:nvPr>
+        </p:nvSpPr>
+        <p:spPr/>
+        <p:txBody>
+          <a:bodyPr/>
+          <a:lstStyle/>
+          <a:p>
+            <a:r>
+              <a:rPr lang="en-US" dirty="0"/>
+              <a:t>Hands-On Activities</a:t>
+            </a:r>
+          </a:p>
+        </p:txBody>
+      </p:sp>
+      <p:sp>
+        <p:nvSpPr>
+          <p:cNvPr id="3" name="Content Placeholder 2">
+            <a:extLst>
+              <a:ext uri="{FF2B5EF4-FFF2-40B4-BE49-F238E27FC236}">
+                <a16:creationId xmlns:a16="http://schemas.microsoft.com/office/drawing/2014/main" id="{097E720E-7D3E-58A1-FD58-328F8C1D8DC1}"/>
+              </a:ext>
+            </a:extLst>
+          </p:cNvPr>
+          <p:cNvSpPr>
+            <a:spLocks noGrp="1"/>
+          </p:cNvSpPr>
+          <p:nvPr>
+            <p:ph idx="1"/>
+          </p:nvPr>
+        </p:nvSpPr>
+        <p:spPr>
+          <a:xfrm>
+            <a:off x="365760" y="1100865"/>
+            <a:ext cx="11369809" cy="4047778"/>
+          </a:xfrm>
+        </p:spPr>
+        <p:txBody>
+          <a:bodyPr/>
+          <a:lstStyle/>
+          <a:p>
+            <a:r>
+              <a:rPr lang="en-US" dirty="0"/>
+              <a:t>The “Responsible Software Development with LLMs” module includes a hands-on component</a:t>
+            </a:r>
+          </a:p>
+          <a:p>
+            <a:pPr lvl="1">
+              <a:spcBef>
+                <a:spcPts val="200"/>
+              </a:spcBef>
+            </a:pPr>
+            <a:r>
+              <a:rPr lang="en-US" dirty="0"/>
+              <a:t>You will be using an LLM to generate code and tests</a:t>
+            </a:r>
+          </a:p>
+          <a:p>
+            <a:r>
+              <a:rPr lang="en-US" dirty="0"/>
+              <a:t>Participation in the hands-on is encouraged but not required</a:t>
+            </a:r>
+          </a:p>
+          <a:p>
+            <a:pPr lvl="1">
+              <a:spcBef>
+                <a:spcPts val="200"/>
+              </a:spcBef>
+            </a:pPr>
+            <a:r>
+              <a:rPr lang="en-US" dirty="0"/>
+              <a:t>The instructor’s prompts and generated code will be made available to participants after the exercise</a:t>
+            </a:r>
+          </a:p>
+          <a:p>
+            <a:r>
+              <a:rPr lang="en-US" dirty="0"/>
+              <a:t>To participate in the hands-on, you will need access to a web-based LLM chat tool</a:t>
+            </a:r>
+          </a:p>
+          <a:p>
+            <a:pPr lvl="1">
+              <a:spcBef>
+                <a:spcPts val="200"/>
+              </a:spcBef>
+            </a:pPr>
+            <a:r>
+              <a:rPr lang="en-US" dirty="0"/>
+              <a:t>The instructor will be using ChatGPT, but any similar tool will work</a:t>
+            </a:r>
+          </a:p>
+          <a:p>
+            <a:r>
+              <a:rPr lang="en-US" dirty="0"/>
+              <a:t>Access to a C compiler will be needed to compile and run the generated code</a:t>
+            </a:r>
+          </a:p>
+          <a:p>
+            <a:pPr lvl="1">
+              <a:spcBef>
+                <a:spcPts val="200"/>
+              </a:spcBef>
+            </a:pPr>
+            <a:r>
+              <a:rPr lang="en-US" dirty="0"/>
+              <a:t>Local or remote doesn’t matter</a:t>
+            </a:r>
+          </a:p>
+          <a:p>
+            <a:pPr lvl="1">
+              <a:spcBef>
+                <a:spcPts val="200"/>
+              </a:spcBef>
+            </a:pPr>
+            <a:r>
+              <a:rPr lang="en-US" dirty="0"/>
+              <a:t>Alternatively, you can inspect the code – not as rigorous, but fine for this tutorial</a:t>
+            </a:r>
+          </a:p>
+          <a:p>
+            <a:r>
+              <a:rPr lang="en-US" dirty="0"/>
+              <a:t>For complete details, see the tutorial web page</a:t>
+            </a:r>
+            <a:r>
+              <a:rPr lang="en-US"/>
+              <a:t>: </a:t>
+            </a:r>
+            <a:r>
+              <a:rPr lang="en-US">
+                <a:hlinkClick r:id="rId2"/>
+              </a:rPr>
+              <a:t>https://bssw-tutorial.github.io/2025-11-16-sc/</a:t>
+            </a:r>
+            <a:endParaRPr lang="en-US"/>
+          </a:p>
+        </p:txBody>
+      </p:sp>
+    </p:spTree>
+    <p:extLst>
+      <p:ext uri="{BB962C8B-B14F-4D97-AF65-F5344CB8AC3E}">
+        <p14:creationId xmlns:p14="http://schemas.microsoft.com/office/powerpoint/2010/main" val="2959188582"/>
       </p:ext>
     </p:extLst>
   </p:cSld>
@@ -8078,21 +8265,6 @@
 </file>
 
 <file path=customXml/item1.xml><?xml version="1.0" encoding="utf-8"?>
-<p:properties xmlns:p="http://schemas.microsoft.com/office/2006/metadata/properties" xmlns:xsi="http://www.w3.org/2001/XMLSchema-instance" xmlns:pc="http://schemas.microsoft.com/office/infopath/2007/PartnerControls">
-  <documentManagement/>
-</p:properties>
-</file>
-
-<file path=customXml/item2.xml><?xml version="1.0" encoding="utf-8"?>
-<?mso-contentType ?>
-<FormTemplates xmlns="http://schemas.microsoft.com/sharepoint/v3/contenttype/forms">
-  <Display>DocumentLibraryForm</Display>
-  <Edit>DocumentLibraryForm</Edit>
-  <New>DocumentLibraryForm</New>
-</FormTemplates>
-</file>
-
-<file path=customXml/item3.xml><?xml version="1.0" encoding="utf-8"?>
 <ct:contentTypeSchema xmlns:ct="http://schemas.microsoft.com/office/2006/metadata/contentType" xmlns:ma="http://schemas.microsoft.com/office/2006/metadata/properties/metaAttributes" ct:_="" ma:_="" ma:contentTypeName="Document" ma:contentTypeID="0x010100565464437F680748A68B85EB6594EA7D" ma:contentTypeVersion="0" ma:contentTypeDescription="Create a new document." ma:contentTypeScope="" ma:versionID="fe3f4dd58d5914c51cfc6deaa8ad845c">
   <xsd:schema xmlns:xsd="http://www.w3.org/2001/XMLSchema" xmlns:p="http://schemas.microsoft.com/office/2006/metadata/properties" targetNamespace="http://schemas.microsoft.com/office/2006/metadata/properties" ma:root="true" ma:fieldsID="4aeb20c0e3442673af7ee10786458764">
     <xsd:element name="properties">
@@ -8141,17 +8313,32 @@
 </ct:contentTypeSchema>
 </file>
 
+<file path=customXml/item2.xml><?xml version="1.0" encoding="utf-8"?>
+<?mso-contentType ?>
+<FormTemplates xmlns="http://schemas.microsoft.com/sharepoint/v3/contenttype/forms">
+  <Display>DocumentLibraryForm</Display>
+  <Edit>DocumentLibraryForm</Edit>
+  <New>DocumentLibraryForm</New>
+</FormTemplates>
+</file>
+
+<file path=customXml/item3.xml><?xml version="1.0" encoding="utf-8"?>
+<p:properties xmlns:p="http://schemas.microsoft.com/office/2006/metadata/properties" xmlns:xsi="http://www.w3.org/2001/XMLSchema-instance" xmlns:pc="http://schemas.microsoft.com/office/infopath/2007/PartnerControls">
+  <documentManagement/>
+</p:properties>
+</file>
+
 <file path=customXml/itemProps1.xml><?xml version="1.0" encoding="utf-8"?>
-<ds:datastoreItem xmlns:ds="http://schemas.openxmlformats.org/officeDocument/2006/customXml" ds:itemID="{A50EC660-24D0-43A0-AE5E-E274115E726B}">
+<ds:datastoreItem xmlns:ds="http://schemas.openxmlformats.org/officeDocument/2006/customXml" ds:itemID="{E8DB7DEB-074E-4EE8-9B6E-FD277323109C}">
   <ds:schemaRefs>
+    <ds:schemaRef ds:uri="http://schemas.microsoft.com/office/2006/metadata/contentType"/>
+    <ds:schemaRef ds:uri="http://schemas.microsoft.com/office/2006/metadata/properties/metaAttributes"/>
+    <ds:schemaRef ds:uri="http://www.w3.org/2001/XMLSchema"/>
+    <ds:schemaRef ds:uri="http://schemas.microsoft.com/office/2006/metadata/properties"/>
+    <ds:schemaRef ds:uri="http://schemas.openxmlformats.org/package/2006/metadata/core-properties"/>
     <ds:schemaRef ds:uri="http://purl.org/dc/elements/1.1/"/>
-    <ds:schemaRef ds:uri="http://schemas.microsoft.com/office/2006/metadata/properties"/>
     <ds:schemaRef ds:uri="http://purl.org/dc/terms/"/>
-    <ds:schemaRef ds:uri="http://schemas.openxmlformats.org/package/2006/metadata/core-properties"/>
-    <ds:schemaRef ds:uri="http://schemas.microsoft.com/office/2006/documentManagement/types"/>
-    <ds:schemaRef ds:uri="http://www.w3.org/XML/1998/namespace"/>
-    <ds:schemaRef ds:uri="http://purl.org/dc/dcmitype/"/>
-    <ds:schemaRef ds:uri="http://schemas.microsoft.com/office/infopath/2007/PartnerControls"/>
+    <ds:schemaRef ds:uri="http://schemas.microsoft.com/office/internal/2005/internalDocumentation"/>
   </ds:schemaRefs>
 </ds:datastoreItem>
 </file>
@@ -8165,16 +8352,16 @@
 </file>
 
 <file path=customXml/itemProps3.xml><?xml version="1.0" encoding="utf-8"?>
-<ds:datastoreItem xmlns:ds="http://schemas.openxmlformats.org/officeDocument/2006/customXml" ds:itemID="{E8DB7DEB-074E-4EE8-9B6E-FD277323109C}">
+<ds:datastoreItem xmlns:ds="http://schemas.openxmlformats.org/officeDocument/2006/customXml" ds:itemID="{A50EC660-24D0-43A0-AE5E-E274115E726B}">
   <ds:schemaRefs>
-    <ds:schemaRef ds:uri="http://schemas.microsoft.com/office/2006/metadata/contentType"/>
-    <ds:schemaRef ds:uri="http://schemas.microsoft.com/office/2006/metadata/properties/metaAttributes"/>
-    <ds:schemaRef ds:uri="http://www.w3.org/2001/XMLSchema"/>
+    <ds:schemaRef ds:uri="http://purl.org/dc/elements/1.1/"/>
     <ds:schemaRef ds:uri="http://schemas.microsoft.com/office/2006/metadata/properties"/>
+    <ds:schemaRef ds:uri="http://purl.org/dc/terms/"/>
     <ds:schemaRef ds:uri="http://schemas.openxmlformats.org/package/2006/metadata/core-properties"/>
-    <ds:schemaRef ds:uri="http://purl.org/dc/elements/1.1/"/>
-    <ds:schemaRef ds:uri="http://purl.org/dc/terms/"/>
-    <ds:schemaRef ds:uri="http://schemas.microsoft.com/office/internal/2005/internalDocumentation"/>
+    <ds:schemaRef ds:uri="http://schemas.microsoft.com/office/2006/documentManagement/types"/>
+    <ds:schemaRef ds:uri="http://www.w3.org/XML/1998/namespace"/>
+    <ds:schemaRef ds:uri="http://purl.org/dc/dcmitype/"/>
+    <ds:schemaRef ds:uri="http://schemas.microsoft.com/office/infopath/2007/PartnerControls"/>
   </ds:schemaRefs>
 </ds:datastoreItem>
 </file>
</xml_diff>

<commit_message>
Final (?) revision of hands-on instruction slide
</commit_message>
<xml_diff>
--- a/intro.pptx
+++ b/intro.pptx
@@ -264,7 +264,7 @@
           <a:p>
             <a:fld id="{0B842F42-2CE9-4E35-95C1-410DC08A50B1}" type="datetimeFigureOut">
               <a:rPr lang="en-US" smtClean="0"/>
-              <a:t>10/25/2025</a:t>
+              <a:t>10/26/2025</a:t>
             </a:fld>
             <a:endParaRPr lang="en-US"/>
           </a:p>
@@ -429,7 +429,7 @@
           <a:p>
             <a:fld id="{6F282904-F315-4730-8D91-37D99E141A6F}" type="datetimeFigureOut">
               <a:rPr lang="en-US" smtClean="0"/>
-              <a:t>10/25/2025</a:t>
+              <a:t>10/26/2025</a:t>
             </a:fld>
             <a:endParaRPr lang="en-US"/>
           </a:p>
@@ -4505,7 +4505,7 @@
             <p:ph idx="1"/>
             <p:extLst>
               <p:ext uri="{D42A27DB-BD31-4B8C-83A1-F6EECF244321}">
-                <p14:modId xmlns:p14="http://schemas.microsoft.com/office/powerpoint/2010/main" val="3590364095"/>
+                <p14:modId xmlns:p14="http://schemas.microsoft.com/office/powerpoint/2010/main" val="119092645"/>
               </p:ext>
             </p:extLst>
           </p:nvPr>
@@ -4554,7 +4554,7 @@
                         <a:rPr lang="en-US" sz="1800" dirty="0">
                           <a:effectLst/>
                         </a:rPr>
-                        <a:t>Time (CDT)</a:t>
+                        <a:t>Time (CST)</a:t>
                       </a:r>
                     </a:p>
                   </a:txBody>
@@ -7204,7 +7204,12 @@
             <p:ph type="title"/>
           </p:nvPr>
         </p:nvSpPr>
-        <p:spPr/>
+        <p:spPr>
+          <a:xfrm>
+            <a:off x="365760" y="411480"/>
+            <a:ext cx="11372473" cy="914400"/>
+          </a:xfrm>
+        </p:spPr>
         <p:txBody>
           <a:bodyPr/>
           <a:lstStyle/>
@@ -7234,7 +7239,7 @@
         </p:nvSpPr>
         <p:spPr>
           <a:xfrm>
-            <a:off x="365760" y="1100865"/>
+            <a:off x="365760" y="1737360"/>
             <a:ext cx="11369809" cy="4047778"/>
           </a:xfrm>
         </p:spPr>
@@ -7243,16 +7248,25 @@
           <a:lstStyle/>
           <a:p>
             <a:r>
+              <a:rPr lang="en-US" b="1" dirty="0"/>
+              <a:t>For detailed information, see the tutorial web page: </a:t>
+            </a:r>
+            <a:r>
+              <a:rPr lang="en-US" b="1" dirty="0">
+                <a:hlinkClick r:id="rId2"/>
+              </a:rPr>
+              <a:t>https://bssw-tutorial.github.io/2025-11-16-sc/#hands-on-activities</a:t>
+            </a:r>
+            <a:endParaRPr lang="en-US" b="1" dirty="0"/>
+          </a:p>
+          <a:p>
+            <a:r>
               <a:rPr lang="en-US" dirty="0"/>
               <a:t>The “Responsible Software Development with LLMs” module includes a hands-on component</a:t>
             </a:r>
           </a:p>
           <a:p>
-            <a:pPr lvl="1">
-              <a:spcBef>
-                <a:spcPts val="200"/>
-              </a:spcBef>
-            </a:pPr>
+            <a:pPr lvl="1"/>
             <a:r>
               <a:rPr lang="en-US" dirty="0"/>
               <a:t>You will be using an LLM to generate code and tests</a:t>
@@ -7265,11 +7279,7 @@
             </a:r>
           </a:p>
           <a:p>
-            <a:pPr lvl="1">
-              <a:spcBef>
-                <a:spcPts val="200"/>
-              </a:spcBef>
-            </a:pPr>
+            <a:pPr lvl="1"/>
             <a:r>
               <a:rPr lang="en-US" dirty="0"/>
               <a:t>The instructor’s prompts and generated code will be made available to participants after the exercise</a:t>
@@ -7277,65 +7287,31 @@
           </a:p>
           <a:p>
             <a:r>
-              <a:rPr lang="en-US" dirty="0"/>
+              <a:rPr lang="en-US" b="1" dirty="0"/>
               <a:t>To participate in the hands-on, you will need access to a web-based LLM chat tool</a:t>
             </a:r>
           </a:p>
           <a:p>
-            <a:pPr lvl="1">
-              <a:spcBef>
-                <a:spcPts val="200"/>
-              </a:spcBef>
-            </a:pPr>
+            <a:pPr lvl="1"/>
             <a:r>
               <a:rPr lang="en-US" dirty="0"/>
               <a:t>The instructor will be using ChatGPT, but any similar tool will work</a:t>
             </a:r>
           </a:p>
           <a:p>
+            <a:pPr lvl="1"/>
             <a:r>
               <a:rPr lang="en-US" dirty="0"/>
-              <a:t>Access to a C compiler will be needed to compile and run the generated code</a:t>
-            </a:r>
-          </a:p>
-          <a:p>
-            <a:pPr lvl="1">
-              <a:spcBef>
-                <a:spcPts val="200"/>
-              </a:spcBef>
-            </a:pPr>
+              <a:t>This is the “</a:t>
+            </a:r>
+            <a:r>
+              <a:rPr lang="en-US" b="1" dirty="0"/>
+              <a:t>web interface</a:t>
+            </a:r>
             <a:r>
               <a:rPr lang="en-US" dirty="0"/>
-              <a:t>Local or remote doesn’t matter</a:t>
-            </a:r>
-          </a:p>
-          <a:p>
-            <a:pPr lvl="1">
-              <a:spcBef>
-                <a:spcPts val="200"/>
-              </a:spcBef>
-            </a:pPr>
-            <a:r>
-              <a:rPr lang="en-US" dirty="0"/>
-              <a:t>Alternatively, you can inspect the code – not as rigorous, but fine for this tutorial</a:t>
-            </a:r>
-          </a:p>
-          <a:p>
-            <a:r>
-              <a:rPr lang="en-US" dirty="0"/>
-              <a:t>For complete details, see the tutorial web page</a:t>
-            </a:r>
-            <a:r>
-              <a:rPr lang="en-US"/>
-              <a:t>: </a:t>
-            </a:r>
-            <a:r>
-              <a:rPr lang="en-US">
-                <a:hlinkClick r:id="rId2"/>
-              </a:rPr>
-              <a:t>https://bssw-tutorial.github.io/2025-11-16-sc/</a:t>
-            </a:r>
-            <a:endParaRPr lang="en-US"/>
+              <a:t>” path in the instructions on the website</a:t>
+            </a:r>
           </a:p>
         </p:txBody>
       </p:sp>
@@ -8265,6 +8241,15 @@
 </file>
 
 <file path=customXml/item1.xml><?xml version="1.0" encoding="utf-8"?>
+<?mso-contentType ?>
+<FormTemplates xmlns="http://schemas.microsoft.com/sharepoint/v3/contenttype/forms">
+  <Display>DocumentLibraryForm</Display>
+  <Edit>DocumentLibraryForm</Edit>
+  <New>DocumentLibraryForm</New>
+</FormTemplates>
+</file>
+
+<file path=customXml/item2.xml><?xml version="1.0" encoding="utf-8"?>
 <ct:contentTypeSchema xmlns:ct="http://schemas.microsoft.com/office/2006/metadata/contentType" xmlns:ma="http://schemas.microsoft.com/office/2006/metadata/properties/metaAttributes" ct:_="" ma:_="" ma:contentTypeName="Document" ma:contentTypeID="0x010100565464437F680748A68B85EB6594EA7D" ma:contentTypeVersion="0" ma:contentTypeDescription="Create a new document." ma:contentTypeScope="" ma:versionID="fe3f4dd58d5914c51cfc6deaa8ad845c">
   <xsd:schema xmlns:xsd="http://www.w3.org/2001/XMLSchema" xmlns:p="http://schemas.microsoft.com/office/2006/metadata/properties" targetNamespace="http://schemas.microsoft.com/office/2006/metadata/properties" ma:root="true" ma:fieldsID="4aeb20c0e3442673af7ee10786458764">
     <xsd:element name="properties">
@@ -8313,15 +8298,6 @@
 </ct:contentTypeSchema>
 </file>
 
-<file path=customXml/item2.xml><?xml version="1.0" encoding="utf-8"?>
-<?mso-contentType ?>
-<FormTemplates xmlns="http://schemas.microsoft.com/sharepoint/v3/contenttype/forms">
-  <Display>DocumentLibraryForm</Display>
-  <Edit>DocumentLibraryForm</Edit>
-  <New>DocumentLibraryForm</New>
-</FormTemplates>
-</file>
-
 <file path=customXml/item3.xml><?xml version="1.0" encoding="utf-8"?>
 <p:properties xmlns:p="http://schemas.microsoft.com/office/2006/metadata/properties" xmlns:xsi="http://www.w3.org/2001/XMLSchema-instance" xmlns:pc="http://schemas.microsoft.com/office/infopath/2007/PartnerControls">
   <documentManagement/>
@@ -8329,6 +8305,14 @@
 </file>
 
 <file path=customXml/itemProps1.xml><?xml version="1.0" encoding="utf-8"?>
+<ds:datastoreItem xmlns:ds="http://schemas.openxmlformats.org/officeDocument/2006/customXml" ds:itemID="{19E20559-B232-4371-8690-E3D8007EDB82}">
+  <ds:schemaRefs>
+    <ds:schemaRef ds:uri="http://schemas.microsoft.com/sharepoint/v3/contenttype/forms"/>
+  </ds:schemaRefs>
+</ds:datastoreItem>
+</file>
+
+<file path=customXml/itemProps2.xml><?xml version="1.0" encoding="utf-8"?>
 <ds:datastoreItem xmlns:ds="http://schemas.openxmlformats.org/officeDocument/2006/customXml" ds:itemID="{E8DB7DEB-074E-4EE8-9B6E-FD277323109C}">
   <ds:schemaRefs>
     <ds:schemaRef ds:uri="http://schemas.microsoft.com/office/2006/metadata/contentType"/>
@@ -8339,14 +8323,6 @@
     <ds:schemaRef ds:uri="http://purl.org/dc/elements/1.1/"/>
     <ds:schemaRef ds:uri="http://purl.org/dc/terms/"/>
     <ds:schemaRef ds:uri="http://schemas.microsoft.com/office/internal/2005/internalDocumentation"/>
-  </ds:schemaRefs>
-</ds:datastoreItem>
-</file>
-
-<file path=customXml/itemProps2.xml><?xml version="1.0" encoding="utf-8"?>
-<ds:datastoreItem xmlns:ds="http://schemas.openxmlformats.org/officeDocument/2006/customXml" ds:itemID="{19E20559-B232-4371-8690-E3D8007EDB82}">
-  <ds:schemaRefs>
-    <ds:schemaRef ds:uri="http://schemas.microsoft.com/sharepoint/v3/contenttype/forms"/>
   </ds:schemaRefs>
 </ds:datastoreItem>
 </file>

</xml_diff>

<commit_message>
Fix slide number on agenda slide
</commit_message>
<xml_diff>
--- a/intro.pptx
+++ b/intro.pptx
@@ -4440,7 +4440,7 @@
 </file>
 
 <file path=ppt/slides/slide10.xml><?xml version="1.0" encoding="utf-8"?>
-<p:sld xmlns:a="http://schemas.openxmlformats.org/drawingml/2006/main" xmlns:r="http://schemas.openxmlformats.org/officeDocument/2006/relationships" xmlns:p="http://schemas.openxmlformats.org/presentationml/2006/main" showMasterSp="0">
+<p:sld xmlns:a="http://schemas.openxmlformats.org/drawingml/2006/main" xmlns:r="http://schemas.openxmlformats.org/officeDocument/2006/relationships" xmlns:p="http://schemas.openxmlformats.org/presentationml/2006/main">
   <p:cSld>
     <p:spTree>
       <p:nvGrpSpPr>
@@ -8241,12 +8241,9 @@
 </file>
 
 <file path=customXml/item1.xml><?xml version="1.0" encoding="utf-8"?>
-<?mso-contentType ?>
-<FormTemplates xmlns="http://schemas.microsoft.com/sharepoint/v3/contenttype/forms">
-  <Display>DocumentLibraryForm</Display>
-  <Edit>DocumentLibraryForm</Edit>
-  <New>DocumentLibraryForm</New>
-</FormTemplates>
+<p:properties xmlns:p="http://schemas.microsoft.com/office/2006/metadata/properties" xmlns:xsi="http://www.w3.org/2001/XMLSchema-instance" xmlns:pc="http://schemas.microsoft.com/office/infopath/2007/PartnerControls">
+  <documentManagement/>
+</p:properties>
 </file>
 
 <file path=customXml/item2.xml><?xml version="1.0" encoding="utf-8"?>
@@ -8299,15 +8296,25 @@
 </file>
 
 <file path=customXml/item3.xml><?xml version="1.0" encoding="utf-8"?>
-<p:properties xmlns:p="http://schemas.microsoft.com/office/2006/metadata/properties" xmlns:xsi="http://www.w3.org/2001/XMLSchema-instance" xmlns:pc="http://schemas.microsoft.com/office/infopath/2007/PartnerControls">
-  <documentManagement/>
-</p:properties>
+<?mso-contentType ?>
+<FormTemplates xmlns="http://schemas.microsoft.com/sharepoint/v3/contenttype/forms">
+  <Display>DocumentLibraryForm</Display>
+  <Edit>DocumentLibraryForm</Edit>
+  <New>DocumentLibraryForm</New>
+</FormTemplates>
 </file>
 
 <file path=customXml/itemProps1.xml><?xml version="1.0" encoding="utf-8"?>
-<ds:datastoreItem xmlns:ds="http://schemas.openxmlformats.org/officeDocument/2006/customXml" ds:itemID="{19E20559-B232-4371-8690-E3D8007EDB82}">
+<ds:datastoreItem xmlns:ds="http://schemas.openxmlformats.org/officeDocument/2006/customXml" ds:itemID="{A50EC660-24D0-43A0-AE5E-E274115E726B}">
   <ds:schemaRefs>
-    <ds:schemaRef ds:uri="http://schemas.microsoft.com/sharepoint/v3/contenttype/forms"/>
+    <ds:schemaRef ds:uri="http://purl.org/dc/elements/1.1/"/>
+    <ds:schemaRef ds:uri="http://schemas.microsoft.com/office/2006/metadata/properties"/>
+    <ds:schemaRef ds:uri="http://purl.org/dc/terms/"/>
+    <ds:schemaRef ds:uri="http://schemas.openxmlformats.org/package/2006/metadata/core-properties"/>
+    <ds:schemaRef ds:uri="http://schemas.microsoft.com/office/2006/documentManagement/types"/>
+    <ds:schemaRef ds:uri="http://www.w3.org/XML/1998/namespace"/>
+    <ds:schemaRef ds:uri="http://purl.org/dc/dcmitype/"/>
+    <ds:schemaRef ds:uri="http://schemas.microsoft.com/office/infopath/2007/PartnerControls"/>
   </ds:schemaRefs>
 </ds:datastoreItem>
 </file>
@@ -8328,16 +8335,9 @@
 </file>
 
 <file path=customXml/itemProps3.xml><?xml version="1.0" encoding="utf-8"?>
-<ds:datastoreItem xmlns:ds="http://schemas.openxmlformats.org/officeDocument/2006/customXml" ds:itemID="{A50EC660-24D0-43A0-AE5E-E274115E726B}">
+<ds:datastoreItem xmlns:ds="http://schemas.openxmlformats.org/officeDocument/2006/customXml" ds:itemID="{19E20559-B232-4371-8690-E3D8007EDB82}">
   <ds:schemaRefs>
-    <ds:schemaRef ds:uri="http://purl.org/dc/elements/1.1/"/>
-    <ds:schemaRef ds:uri="http://schemas.microsoft.com/office/2006/metadata/properties"/>
-    <ds:schemaRef ds:uri="http://purl.org/dc/terms/"/>
-    <ds:schemaRef ds:uri="http://schemas.openxmlformats.org/package/2006/metadata/core-properties"/>
-    <ds:schemaRef ds:uri="http://schemas.microsoft.com/office/2006/documentManagement/types"/>
-    <ds:schemaRef ds:uri="http://www.w3.org/XML/1998/namespace"/>
-    <ds:schemaRef ds:uri="http://purl.org/dc/dcmitype/"/>
-    <ds:schemaRef ds:uri="http://schemas.microsoft.com/office/infopath/2007/PartnerControls"/>
+    <ds:schemaRef ds:uri="http://schemas.microsoft.com/sharepoint/v3/contenttype/forms"/>
   </ds:schemaRefs>
 </ds:datastoreItem>
 </file>
</xml_diff>

<commit_message>
Update intro for ATPESC 2026
</commit_message>
<xml_diff>
--- a/intro.pptx
+++ b/intro.pptx
@@ -5,22 +5,21 @@
     <p:sldMasterId id="2147483935" r:id="rId4"/>
   </p:sldMasterIdLst>
   <p:notesMasterIdLst>
-    <p:notesMasterId r:id="rId15"/>
+    <p:notesMasterId r:id="rId14"/>
   </p:notesMasterIdLst>
   <p:handoutMasterIdLst>
-    <p:handoutMasterId r:id="rId16"/>
+    <p:handoutMasterId r:id="rId15"/>
   </p:handoutMasterIdLst>
   <p:sldIdLst>
     <p:sldId id="617" r:id="rId5"/>
-    <p:sldId id="320" r:id="rId6"/>
+    <p:sldId id="627" r:id="rId6"/>
     <p:sldId id="308" r:id="rId7"/>
     <p:sldId id="324" r:id="rId8"/>
     <p:sldId id="329" r:id="rId9"/>
     <p:sldId id="620" r:id="rId10"/>
     <p:sldId id="622" r:id="rId11"/>
     <p:sldId id="616" r:id="rId12"/>
-    <p:sldId id="626" r:id="rId13"/>
-    <p:sldId id="624" r:id="rId14"/>
+    <p:sldId id="624" r:id="rId13"/>
   </p:sldIdLst>
   <p:sldSz cx="12188825" cy="6858000"/>
   <p:notesSz cx="7010400" cy="9296400"/>
@@ -264,7 +263,7 @@
           <a:p>
             <a:fld id="{0B842F42-2CE9-4E35-95C1-410DC08A50B1}" type="datetimeFigureOut">
               <a:rPr lang="en-US" smtClean="0"/>
-              <a:t>1/22/2026</a:t>
+              <a:t>8/2/2026</a:t>
             </a:fld>
             <a:endParaRPr lang="en-US"/>
           </a:p>
@@ -429,7 +428,7 @@
           <a:p>
             <a:fld id="{6F282904-F315-4730-8D91-37D99E141A6F}" type="datetimeFigureOut">
               <a:rPr lang="en-US" smtClean="0"/>
-              <a:t>1/22/2026</a:t>
+              <a:t>8/2/2026</a:t>
             </a:fld>
             <a:endParaRPr lang="en-US"/>
           </a:p>
@@ -1534,7 +1533,7 @@
         </p:blipFill>
         <p:spPr>
           <a:xfrm>
-            <a:off x="418659" y="158509"/>
+            <a:off x="296061" y="158509"/>
             <a:ext cx="2109916" cy="905256"/>
           </a:xfrm>
           <a:prstGeom prst="rect">
@@ -1556,7 +1555,7 @@
         </p:nvSpPr>
         <p:spPr>
           <a:xfrm>
-            <a:off x="901538" y="1454246"/>
+            <a:off x="778940" y="1454246"/>
             <a:ext cx="1144159" cy="350865"/>
           </a:xfrm>
           <a:prstGeom prst="rect">
@@ -1596,8 +1595,8 @@
         </p:nvSpPr>
         <p:spPr>
           <a:xfrm>
-            <a:off x="948025" y="2646131"/>
-            <a:ext cx="1051185" cy="350865"/>
+            <a:off x="863899" y="2646131"/>
+            <a:ext cx="974241" cy="350865"/>
           </a:xfrm>
           <a:prstGeom prst="rect">
             <a:avLst/>
@@ -1617,7 +1616,7 @@
             </a:pPr>
             <a:r>
               <a:rPr lang="en-US" sz="1200" i="1" dirty="0"/>
-              <a:t>Members of</a:t>
+              <a:t>Member of</a:t>
             </a:r>
           </a:p>
         </p:txBody>
@@ -1636,7 +1635,7 @@
         </p:nvSpPr>
         <p:spPr>
           <a:xfrm>
-            <a:off x="572120" y="4624321"/>
+            <a:off x="449522" y="4624321"/>
             <a:ext cx="1802994" cy="350865"/>
           </a:xfrm>
           <a:prstGeom prst="rect">
@@ -1676,7 +1675,7 @@
         </p:nvGrpSpPr>
         <p:grpSpPr>
           <a:xfrm>
-            <a:off x="355043" y="5027111"/>
+            <a:off x="232445" y="5027111"/>
             <a:ext cx="2237149" cy="457200"/>
             <a:chOff x="343050" y="5128711"/>
             <a:chExt cx="2237149" cy="457200"/>
@@ -1755,207 +1754,96 @@
           </p:spPr>
         </p:pic>
       </p:grpSp>
-      <p:grpSp>
-        <p:nvGrpSpPr>
-          <p:cNvPr id="29" name="Group 28">
+      <p:pic>
+        <p:nvPicPr>
+          <p:cNvPr id="1026" name="Picture 2" descr="A picture containing graphics, logo, font, symbol&#10;&#10;Description automatically generated">
             <a:extLst>
               <a:ext uri="{FF2B5EF4-FFF2-40B4-BE49-F238E27FC236}">
-                <a16:creationId xmlns:a16="http://schemas.microsoft.com/office/drawing/2014/main" id="{AB0D32FE-ACDB-0573-B6AB-58AEF4858851}"/>
+                <a16:creationId xmlns:a16="http://schemas.microsoft.com/office/drawing/2014/main" id="{679CE625-4F36-E8C6-21FE-5F9C17202854}"/>
               </a:ext>
             </a:extLst>
           </p:cNvPr>
-          <p:cNvGrpSpPr/>
+          <p:cNvPicPr>
+            <a:picLocks noChangeAspect="1" noChangeArrowheads="1"/>
+          </p:cNvPicPr>
           <p:nvPr userDrawn="1"/>
-        </p:nvGrpSpPr>
-        <p:grpSpPr>
-          <a:xfrm>
-            <a:off x="-69503" y="1892144"/>
-            <a:ext cx="2985270" cy="790169"/>
-            <a:chOff x="-69503" y="2214872"/>
-            <a:chExt cx="2985270" cy="790169"/>
-          </a:xfrm>
-        </p:grpSpPr>
-        <p:pic>
-          <p:nvPicPr>
-            <p:cNvPr id="7" name="Picture 4">
-              <a:extLst>
-                <a:ext uri="{FF2B5EF4-FFF2-40B4-BE49-F238E27FC236}">
-                  <a16:creationId xmlns:a16="http://schemas.microsoft.com/office/drawing/2014/main" id="{05CDAB3D-B8D6-9AC9-8507-6F95230AEE45}"/>
-                </a:ext>
-              </a:extLst>
-            </p:cNvPr>
-            <p:cNvPicPr>
-              <a:picLocks noChangeAspect="1" noChangeArrowheads="1"/>
-            </p:cNvPicPr>
-            <p:nvPr userDrawn="1"/>
-          </p:nvPicPr>
-          <p:blipFill>
-            <a:blip r:embed="rId8" cstate="print">
-              <a:extLst>
-                <a:ext uri="{28A0092B-C50C-407E-A947-70E740481C1C}">
-                  <a14:useLocalDpi xmlns:a14="http://schemas.microsoft.com/office/drawing/2010/main" val="0"/>
-                </a:ext>
-              </a:extLst>
-            </a:blip>
-            <a:srcRect/>
-            <a:stretch>
-              <a:fillRect/>
-            </a:stretch>
-          </p:blipFill>
-          <p:spPr bwMode="auto">
-            <a:xfrm>
-              <a:off x="1484438" y="2317122"/>
-              <a:ext cx="1371600" cy="318873"/>
-            </a:xfrm>
-            <a:prstGeom prst="rect">
-              <a:avLst/>
-            </a:prstGeom>
-            <a:noFill/>
+        </p:nvPicPr>
+        <p:blipFill>
+          <a:blip r:embed="rId8" cstate="print">
             <a:extLst>
-              <a:ext uri="{909E8E84-426E-40DD-AFC4-6F175D3DCCD1}">
-                <a14:hiddenFill xmlns:a14="http://schemas.microsoft.com/office/drawing/2010/main">
-                  <a:solidFill>
-                    <a:srgbClr val="FFFFFF"/>
-                  </a:solidFill>
-                </a14:hiddenFill>
+              <a:ext uri="{28A0092B-C50C-407E-A947-70E740481C1C}">
+                <a14:useLocalDpi xmlns:a14="http://schemas.microsoft.com/office/drawing/2010/main" val="0"/>
               </a:ext>
             </a:extLst>
-          </p:spPr>
-        </p:pic>
-        <p:pic>
-          <p:nvPicPr>
-            <p:cNvPr id="1026" name="Picture 2" descr="A picture containing graphics, logo, font, symbol&#10;&#10;Description automatically generated">
-              <a:extLst>
-                <a:ext uri="{FF2B5EF4-FFF2-40B4-BE49-F238E27FC236}">
-                  <a16:creationId xmlns:a16="http://schemas.microsoft.com/office/drawing/2014/main" id="{679CE625-4F36-E8C6-21FE-5F9C17202854}"/>
-                </a:ext>
-              </a:extLst>
-            </p:cNvPr>
-            <p:cNvPicPr>
-              <a:picLocks noChangeAspect="1" noChangeArrowheads="1"/>
-            </p:cNvPicPr>
-            <p:nvPr userDrawn="1"/>
-          </p:nvPicPr>
-          <p:blipFill>
-            <a:blip r:embed="rId9" cstate="print">
-              <a:extLst>
-                <a:ext uri="{28A0092B-C50C-407E-A947-70E740481C1C}">
-                  <a14:useLocalDpi xmlns:a14="http://schemas.microsoft.com/office/drawing/2010/main" val="0"/>
-                </a:ext>
-              </a:extLst>
-            </a:blip>
-            <a:srcRect/>
-            <a:stretch>
-              <a:fillRect/>
-            </a:stretch>
-          </p:blipFill>
-          <p:spPr bwMode="auto">
-            <a:xfrm>
-              <a:off x="321595" y="2214872"/>
-              <a:ext cx="841248" cy="523372"/>
-            </a:xfrm>
-            <a:prstGeom prst="rect">
-              <a:avLst/>
-            </a:prstGeom>
-            <a:noFill/>
+          </a:blip>
+          <a:srcRect/>
+          <a:stretch>
+            <a:fillRect/>
+          </a:stretch>
+        </p:blipFill>
+        <p:spPr bwMode="auto">
+          <a:xfrm>
+            <a:off x="930395" y="1892144"/>
+            <a:ext cx="841248" cy="523372"/>
+          </a:xfrm>
+          <a:prstGeom prst="rect">
+            <a:avLst/>
+          </a:prstGeom>
+          <a:noFill/>
+          <a:extLst>
+            <a:ext uri="{909E8E84-426E-40DD-AFC4-6F175D3DCCD1}">
+              <a14:hiddenFill xmlns:a14="http://schemas.microsoft.com/office/drawing/2010/main">
+                <a:solidFill>
+                  <a:srgbClr val="FFFFFF"/>
+                </a:solidFill>
+              </a14:hiddenFill>
+            </a:ext>
+          </a:extLst>
+        </p:spPr>
+      </p:pic>
+      <p:sp>
+        <p:nvSpPr>
+          <p:cNvPr id="23" name="TextBox 22">
             <a:extLst>
-              <a:ext uri="{909E8E84-426E-40DD-AFC4-6F175D3DCCD1}">
-                <a14:hiddenFill xmlns:a14="http://schemas.microsoft.com/office/drawing/2010/main">
-                  <a:solidFill>
-                    <a:srgbClr val="FFFFFF"/>
-                  </a:solidFill>
-                </a14:hiddenFill>
+              <a:ext uri="{FF2B5EF4-FFF2-40B4-BE49-F238E27FC236}">
+                <a16:creationId xmlns:a16="http://schemas.microsoft.com/office/drawing/2014/main" id="{67C09547-A2FE-082D-8E64-9FFD35B9EF97}"/>
               </a:ext>
             </a:extLst>
-          </p:spPr>
-        </p:pic>
-        <p:sp>
-          <p:nvSpPr>
-            <p:cNvPr id="23" name="TextBox 22">
-              <a:extLst>
-                <a:ext uri="{FF2B5EF4-FFF2-40B4-BE49-F238E27FC236}">
-                  <a16:creationId xmlns:a16="http://schemas.microsoft.com/office/drawing/2014/main" id="{67C09547-A2FE-082D-8E64-9FFD35B9EF97}"/>
-                </a:ext>
-              </a:extLst>
-            </p:cNvPr>
-            <p:cNvSpPr txBox="1"/>
-            <p:nvPr userDrawn="1"/>
-          </p:nvSpPr>
-          <p:spPr>
-            <a:xfrm>
-              <a:off x="-69503" y="2668026"/>
-              <a:ext cx="1631472" cy="337015"/>
-            </a:xfrm>
-            <a:prstGeom prst="rect">
-              <a:avLst/>
-            </a:prstGeom>
-            <a:noFill/>
-          </p:spPr>
-          <p:txBody>
-            <a:bodyPr wrap="none" lIns="118872" tIns="91440" rIns="118872" bIns="91440" rtlCol="0" anchor="ctr" anchorCtr="0">
-              <a:spAutoFit/>
-            </a:bodyPr>
-            <a:lstStyle/>
-            <a:p>
-              <a:pPr algn="l">
-                <a:lnSpc>
-                  <a:spcPct val="90000"/>
-                </a:lnSpc>
-              </a:pPr>
-              <a:r>
-                <a:rPr lang="en-US" sz="1050" i="1" dirty="0">
-                  <a:hlinkClick r:id="rId10"/>
-                </a:rPr>
-                <a:t>https://pesoproject.org</a:t>
-              </a:r>
-              <a:endParaRPr lang="en-US" sz="1050" i="1" dirty="0"/>
-            </a:p>
-          </p:txBody>
-        </p:sp>
-        <p:sp>
-          <p:nvSpPr>
-            <p:cNvPr id="24" name="TextBox 23">
-              <a:extLst>
-                <a:ext uri="{FF2B5EF4-FFF2-40B4-BE49-F238E27FC236}">
-                  <a16:creationId xmlns:a16="http://schemas.microsoft.com/office/drawing/2014/main" id="{F26C03A6-6B94-ABCF-9A4D-F1700CC7A8C8}"/>
-                </a:ext>
-              </a:extLst>
-            </p:cNvPr>
-            <p:cNvSpPr txBox="1"/>
-            <p:nvPr userDrawn="1"/>
-          </p:nvSpPr>
-          <p:spPr>
-            <a:xfrm>
-              <a:off x="1423755" y="2668026"/>
-              <a:ext cx="1492012" cy="337015"/>
-            </a:xfrm>
-            <a:prstGeom prst="rect">
-              <a:avLst/>
-            </a:prstGeom>
-            <a:noFill/>
-          </p:spPr>
-          <p:txBody>
-            <a:bodyPr wrap="none" lIns="118872" tIns="91440" rIns="118872" bIns="91440" rtlCol="0" anchor="ctr" anchorCtr="0">
-              <a:spAutoFit/>
-            </a:bodyPr>
-            <a:lstStyle/>
-            <a:p>
-              <a:pPr algn="l">
-                <a:lnSpc>
-                  <a:spcPct val="90000"/>
-                </a:lnSpc>
-              </a:pPr>
-              <a:r>
-                <a:rPr lang="en-US" sz="1050" i="1" dirty="0">
-                  <a:hlinkClick r:id="rId11"/>
-                </a:rPr>
-                <a:t>https://rapids.lbl.gov</a:t>
-              </a:r>
-              <a:endParaRPr lang="en-US" sz="1050" i="1" dirty="0"/>
-            </a:p>
-          </p:txBody>
-        </p:sp>
-      </p:grpSp>
+          </p:cNvPr>
+          <p:cNvSpPr txBox="1"/>
+          <p:nvPr userDrawn="1"/>
+        </p:nvSpPr>
+        <p:spPr>
+          <a:xfrm>
+            <a:off x="535283" y="2345298"/>
+            <a:ext cx="1631472" cy="337015"/>
+          </a:xfrm>
+          <a:prstGeom prst="rect">
+            <a:avLst/>
+          </a:prstGeom>
+          <a:noFill/>
+        </p:spPr>
+        <p:txBody>
+          <a:bodyPr wrap="none" lIns="118872" tIns="91440" rIns="118872" bIns="91440" rtlCol="0" anchor="ctr" anchorCtr="0">
+            <a:spAutoFit/>
+          </a:bodyPr>
+          <a:lstStyle/>
+          <a:p>
+            <a:pPr algn="l">
+              <a:lnSpc>
+                <a:spcPct val="90000"/>
+              </a:lnSpc>
+            </a:pPr>
+            <a:r>
+              <a:rPr lang="en-US" sz="1050" i="1" dirty="0">
+                <a:hlinkClick r:id="rId9"/>
+              </a:rPr>
+              <a:t>https://pesoproject.org</a:t>
+            </a:r>
+            <a:endParaRPr lang="en-US" sz="1050" i="1" dirty="0"/>
+          </a:p>
+        </p:txBody>
+      </p:sp>
       <p:sp>
         <p:nvSpPr>
           <p:cNvPr id="30" name="TextBox 29">
@@ -1970,7 +1858,7 @@
         </p:nvSpPr>
         <p:spPr>
           <a:xfrm>
-            <a:off x="166031" y="4011401"/>
+            <a:off x="48264" y="4011401"/>
             <a:ext cx="2605511" cy="655564"/>
           </a:xfrm>
           <a:prstGeom prst="rect">
@@ -1998,7 +1886,7 @@
             </a:br>
             <a:r>
               <a:rPr lang="en-US" sz="1000" i="1" dirty="0">
-                <a:hlinkClick r:id="rId12"/>
+                <a:hlinkClick r:id="rId10"/>
               </a:rPr>
               <a:t>https://cass.community</a:t>
             </a:r>
@@ -2021,7 +1909,7 @@
           <p:nvPr userDrawn="1"/>
         </p:nvPicPr>
         <p:blipFill>
-          <a:blip r:embed="rId13" cstate="print">
+          <a:blip r:embed="rId11" cstate="print">
             <a:extLst>
               <a:ext uri="{28A0092B-C50C-407E-A947-70E740481C1C}">
                 <a14:useLocalDpi xmlns:a14="http://schemas.microsoft.com/office/drawing/2010/main" val="0"/>
@@ -2034,7 +1922,7 @@
         </p:blipFill>
         <p:spPr>
           <a:xfrm>
-            <a:off x="849769" y="2974535"/>
+            <a:off x="732002" y="2974535"/>
             <a:ext cx="1238034" cy="1128739"/>
           </a:xfrm>
           <a:prstGeom prst="rect">
@@ -4310,9 +4198,10 @@
               </a:spcBef>
             </a:pPr>
             <a:r>
-              <a:rPr lang="en-US" dirty="0"/>
-              <a:t>Better Software for Science with High-Performance Computing</a:t>
-            </a:r>
+              <a:rPr lang="en-US" b="0" dirty="0"/>
+              <a:t>Software Sustainability</a:t>
+            </a:r>
+            <a:endParaRPr lang="en-US" dirty="0"/>
           </a:p>
         </p:txBody>
       </p:sp>
@@ -4344,7 +4233,7 @@
           <a:p>
             <a:r>
               <a:rPr lang="en-US" dirty="0"/>
-              <a:t>Anshu Dubey and Akash Dhruv</a:t>
+              <a:t>David E. Bernholdt</a:t>
             </a:r>
           </a:p>
           <a:p>
@@ -4354,20 +4243,8 @@
               </a:spcBef>
             </a:pPr>
             <a:r>
-              <a:rPr lang="en-US" sz="2000" dirty="0" err="1"/>
-              <a:t>SupercomputingAsia</a:t>
-            </a:r>
-            <a:r>
               <a:rPr lang="en-US" sz="2000" dirty="0"/>
-              <a:t> 2026 (SCA 2026)/The International Conference on High Performance Computing in Asia-Pacific Region 2026 (</a:t>
-            </a:r>
-            <a:r>
-              <a:rPr lang="en-US" sz="2000" dirty="0" err="1"/>
-              <a:t>HPCAsia</a:t>
-            </a:r>
-            <a:r>
-              <a:rPr lang="en-US" sz="2000" dirty="0"/>
-              <a:t> 2026) conference</a:t>
+              <a:t>Argonne Training Program on Extreme-Scale Computing summer school (2026)</a:t>
             </a:r>
             <a:endParaRPr lang="en-US" sz="1400" b="0" i="0" dirty="0">
               <a:solidFill>
@@ -4442,1030 +4319,6 @@
     <p:extLst>
       <p:ext uri="{BB962C8B-B14F-4D97-AF65-F5344CB8AC3E}">
         <p14:creationId xmlns:p14="http://schemas.microsoft.com/office/powerpoint/2010/main" val="2146778437"/>
-      </p:ext>
-    </p:extLst>
-  </p:cSld>
-  <p:clrMapOvr>
-    <a:masterClrMapping/>
-  </p:clrMapOvr>
-</p:sld>
-</file>
-
-<file path=ppt/slides/slide10.xml><?xml version="1.0" encoding="utf-8"?>
-<p:sld xmlns:a="http://schemas.openxmlformats.org/drawingml/2006/main" xmlns:r="http://schemas.openxmlformats.org/officeDocument/2006/relationships" xmlns:p="http://schemas.openxmlformats.org/presentationml/2006/main">
-  <p:cSld>
-    <p:spTree>
-      <p:nvGrpSpPr>
-        <p:cNvPr id="1" name=""/>
-        <p:cNvGrpSpPr/>
-        <p:nvPr/>
-      </p:nvGrpSpPr>
-      <p:grpSpPr>
-        <a:xfrm>
-          <a:off x="0" y="0"/>
-          <a:ext cx="0" cy="0"/>
-          <a:chOff x="0" y="0"/>
-          <a:chExt cx="0" cy="0"/>
-        </a:xfrm>
-      </p:grpSpPr>
-      <p:sp>
-        <p:nvSpPr>
-          <p:cNvPr id="2" name="Title 1">
-            <a:extLst>
-              <a:ext uri="{FF2B5EF4-FFF2-40B4-BE49-F238E27FC236}">
-                <a16:creationId xmlns:a16="http://schemas.microsoft.com/office/drawing/2014/main" id="{1D6756EE-C2D9-4E52-B0B6-3C831FD6A565}"/>
-              </a:ext>
-            </a:extLst>
-          </p:cNvPr>
-          <p:cNvSpPr>
-            <a:spLocks noGrp="1"/>
-          </p:cNvSpPr>
-          <p:nvPr>
-            <p:ph type="title"/>
-          </p:nvPr>
-        </p:nvSpPr>
-        <p:spPr>
-          <a:xfrm>
-            <a:off x="408175" y="160020"/>
-            <a:ext cx="11372473" cy="914400"/>
-          </a:xfrm>
-        </p:spPr>
-        <p:txBody>
-          <a:bodyPr/>
-          <a:lstStyle/>
-          <a:p>
-            <a:r>
-              <a:rPr lang="en-US" dirty="0"/>
-              <a:t>Agenda</a:t>
-            </a:r>
-          </a:p>
-        </p:txBody>
-      </p:sp>
-      <p:graphicFrame>
-        <p:nvGraphicFramePr>
-          <p:cNvPr id="6" name="Table 6">
-            <a:extLst>
-              <a:ext uri="{FF2B5EF4-FFF2-40B4-BE49-F238E27FC236}">
-                <a16:creationId xmlns:a16="http://schemas.microsoft.com/office/drawing/2014/main" id="{99D13FB2-5BF8-4AC0-A13D-ECB8E230F5BC}"/>
-              </a:ext>
-            </a:extLst>
-          </p:cNvPr>
-          <p:cNvGraphicFramePr>
-            <a:graphicFrameLocks noGrp="1"/>
-          </p:cNvGraphicFramePr>
-          <p:nvPr>
-            <p:ph idx="1"/>
-            <p:extLst>
-              <p:ext uri="{D42A27DB-BD31-4B8C-83A1-F6EECF244321}">
-                <p14:modId xmlns:p14="http://schemas.microsoft.com/office/powerpoint/2010/main" val="291420920"/>
-              </p:ext>
-            </p:extLst>
-          </p:nvPr>
-        </p:nvGraphicFramePr>
-        <p:xfrm>
-          <a:off x="626110" y="722531"/>
-          <a:ext cx="10905491" cy="6045406"/>
-        </p:xfrm>
-        <a:graphic>
-          <a:graphicData uri="http://schemas.openxmlformats.org/drawingml/2006/table">
-            <a:tbl>
-              <a:tblPr firstRow="1" bandRow="1">
-                <a:tableStyleId>{5C22544A-7EE6-4342-B048-85BDC9FD1C3A}</a:tableStyleId>
-              </a:tblPr>
-              <a:tblGrid>
-                <a:gridCol w="1411194">
-                  <a:extLst>
-                    <a:ext uri="{9D8B030D-6E8A-4147-A177-3AD203B41FA5}">
-                      <a16:colId xmlns:a16="http://schemas.microsoft.com/office/drawing/2014/main" val="41390910"/>
-                    </a:ext>
-                  </a:extLst>
-                </a:gridCol>
-                <a:gridCol w="6977156">
-                  <a:extLst>
-                    <a:ext uri="{9D8B030D-6E8A-4147-A177-3AD203B41FA5}">
-                      <a16:colId xmlns:a16="http://schemas.microsoft.com/office/drawing/2014/main" val="2092910534"/>
-                    </a:ext>
-                  </a:extLst>
-                </a:gridCol>
-                <a:gridCol w="2517141">
-                  <a:extLst>
-                    <a:ext uri="{9D8B030D-6E8A-4147-A177-3AD203B41FA5}">
-                      <a16:colId xmlns:a16="http://schemas.microsoft.com/office/drawing/2014/main" val="1261297711"/>
-                    </a:ext>
-                  </a:extLst>
-                </a:gridCol>
-              </a:tblGrid>
-              <a:tr h="439813">
-                <a:tc>
-                  <a:txBody>
-                    <a:bodyPr/>
-                    <a:lstStyle/>
-                    <a:p>
-                      <a:pPr algn="r"/>
-                      <a:r>
-                        <a:rPr lang="en-US" sz="1600" dirty="0">
-                          <a:effectLst/>
-                        </a:rPr>
-                        <a:t>Time</a:t>
-                      </a:r>
-                    </a:p>
-                  </a:txBody>
-                  <a:tcPr marL="142875" marR="142875" marT="95250" marB="95250" anchor="ctr"/>
-                </a:tc>
-                <a:tc>
-                  <a:txBody>
-                    <a:bodyPr/>
-                    <a:lstStyle/>
-                    <a:p>
-                      <a:pPr algn="l"/>
-                      <a:r>
-                        <a:rPr lang="en-US" sz="1600" dirty="0">
-                          <a:effectLst/>
-                        </a:rPr>
-                        <a:t>Title</a:t>
-                      </a:r>
-                    </a:p>
-                  </a:txBody>
-                  <a:tcPr marL="142875" marR="142875" marT="95250" marB="95250" anchor="ctr"/>
-                </a:tc>
-                <a:tc>
-                  <a:txBody>
-                    <a:bodyPr/>
-                    <a:lstStyle/>
-                    <a:p>
-                      <a:r>
-                        <a:rPr lang="en-US" sz="1600" dirty="0">
-                          <a:effectLst/>
-                        </a:rPr>
-                        <a:t>Presenter</a:t>
-                      </a:r>
-                    </a:p>
-                  </a:txBody>
-                  <a:tcPr marL="142875" marR="142875" marT="95250" marB="95250" anchor="ctr"/>
-                </a:tc>
-                <a:extLst>
-                  <a:ext uri="{0D108BD9-81ED-4DB2-BD59-A6C34878D82A}">
-                    <a16:rowId xmlns:a16="http://schemas.microsoft.com/office/drawing/2014/main" val="2098024418"/>
-                  </a:ext>
-                </a:extLst>
-              </a:tr>
-              <a:tr h="382132">
-                <a:tc>
-                  <a:txBody>
-                    <a:bodyPr/>
-                    <a:lstStyle/>
-                    <a:p>
-                      <a:pPr algn="r">
-                        <a:buNone/>
-                      </a:pPr>
-                      <a:r>
-                        <a:rPr lang="en-US" sz="1600" dirty="0">
-                          <a:effectLst/>
-                        </a:rPr>
-                        <a:t>9:30 AM</a:t>
-                      </a:r>
-                    </a:p>
-                  </a:txBody>
-                  <a:tcPr marL="142875" marR="142875" marT="95250" marB="95250" anchor="ctr"/>
-                </a:tc>
-                <a:tc>
-                  <a:txBody>
-                    <a:bodyPr/>
-                    <a:lstStyle/>
-                    <a:p>
-                      <a:pPr>
-                        <a:buNone/>
-                      </a:pPr>
-                      <a:r>
-                        <a:rPr lang="en-US" sz="1600">
-                          <a:effectLst/>
-                        </a:rPr>
-                        <a:t>Introduction</a:t>
-                      </a:r>
-                    </a:p>
-                  </a:txBody>
-                  <a:tcPr marL="142875" marR="142875" marT="95250" marB="95250" anchor="ctr"/>
-                </a:tc>
-                <a:tc>
-                  <a:txBody>
-                    <a:bodyPr/>
-                    <a:lstStyle/>
-                    <a:p>
-                      <a:pPr>
-                        <a:buNone/>
-                      </a:pPr>
-                      <a:r>
-                        <a:rPr lang="en-US" sz="1600">
-                          <a:effectLst/>
-                        </a:rPr>
-                        <a:t>Anshu Dubey (ANL)</a:t>
-                      </a:r>
-                    </a:p>
-                  </a:txBody>
-                  <a:tcPr marL="142875" marR="142875" marT="95250" marB="95250" anchor="ctr"/>
-                </a:tc>
-                <a:extLst>
-                  <a:ext uri="{0D108BD9-81ED-4DB2-BD59-A6C34878D82A}">
-                    <a16:rowId xmlns:a16="http://schemas.microsoft.com/office/drawing/2014/main" val="541819896"/>
-                  </a:ext>
-                </a:extLst>
-              </a:tr>
-              <a:tr h="584013">
-                <a:tc>
-                  <a:txBody>
-                    <a:bodyPr/>
-                    <a:lstStyle/>
-                    <a:p>
-                      <a:pPr algn="r">
-                        <a:buNone/>
-                      </a:pPr>
-                      <a:r>
-                        <a:rPr lang="en-US" sz="1600">
-                          <a:effectLst/>
-                        </a:rPr>
-                        <a:t>9:45 AM</a:t>
-                      </a:r>
-                    </a:p>
-                  </a:txBody>
-                  <a:tcPr marL="142875" marR="142875" marT="95250" marB="95250" anchor="ctr"/>
-                </a:tc>
-                <a:tc>
-                  <a:txBody>
-                    <a:bodyPr/>
-                    <a:lstStyle/>
-                    <a:p>
-                      <a:pPr>
-                        <a:buNone/>
-                      </a:pPr>
-                      <a:r>
-                        <a:rPr lang="en-US" sz="1600">
-                          <a:effectLst/>
-                        </a:rPr>
-                        <a:t>Motivation and Overview of Best Practices in HPC Software Development</a:t>
-                      </a:r>
-                    </a:p>
-                  </a:txBody>
-                  <a:tcPr marL="142875" marR="142875" marT="95250" marB="95250" anchor="ctr"/>
-                </a:tc>
-                <a:tc>
-                  <a:txBody>
-                    <a:bodyPr/>
-                    <a:lstStyle/>
-                    <a:p>
-                      <a:pPr>
-                        <a:buNone/>
-                      </a:pPr>
-                      <a:r>
-                        <a:rPr lang="en-US" sz="1600">
-                          <a:effectLst/>
-                        </a:rPr>
-                        <a:t>Anshu Dubey (ANL)</a:t>
-                      </a:r>
-                    </a:p>
-                  </a:txBody>
-                  <a:tcPr marL="142875" marR="142875" marT="95250" marB="95250" anchor="ctr"/>
-                </a:tc>
-                <a:extLst>
-                  <a:ext uri="{0D108BD9-81ED-4DB2-BD59-A6C34878D82A}">
-                    <a16:rowId xmlns:a16="http://schemas.microsoft.com/office/drawing/2014/main" val="3922137579"/>
-                  </a:ext>
-                </a:extLst>
-              </a:tr>
-              <a:tr h="382132">
-                <a:tc>
-                  <a:txBody>
-                    <a:bodyPr/>
-                    <a:lstStyle/>
-                    <a:p>
-                      <a:pPr algn="r">
-                        <a:buNone/>
-                      </a:pPr>
-                      <a:r>
-                        <a:rPr lang="en-US" sz="1600">
-                          <a:effectLst/>
-                        </a:rPr>
-                        <a:t>10:15 AM</a:t>
-                      </a:r>
-                    </a:p>
-                  </a:txBody>
-                  <a:tcPr marL="142875" marR="142875" marT="95250" marB="95250" anchor="ctr"/>
-                </a:tc>
-                <a:tc>
-                  <a:txBody>
-                    <a:bodyPr/>
-                    <a:lstStyle/>
-                    <a:p>
-                      <a:pPr>
-                        <a:buNone/>
-                      </a:pPr>
-                      <a:r>
-                        <a:rPr lang="en-US" sz="1600">
-                          <a:effectLst/>
-                        </a:rPr>
-                        <a:t>Code Translation from Fortran to C++ using CodeScribe</a:t>
-                      </a:r>
-                    </a:p>
-                  </a:txBody>
-                  <a:tcPr marL="142875" marR="142875" marT="95250" marB="95250" anchor="ctr"/>
-                </a:tc>
-                <a:tc>
-                  <a:txBody>
-                    <a:bodyPr/>
-                    <a:lstStyle/>
-                    <a:p>
-                      <a:pPr>
-                        <a:buNone/>
-                      </a:pPr>
-                      <a:r>
-                        <a:rPr lang="en-US" sz="1600">
-                          <a:effectLst/>
-                        </a:rPr>
-                        <a:t>Akash Dhruv (ANL)</a:t>
-                      </a:r>
-                    </a:p>
-                  </a:txBody>
-                  <a:tcPr marL="142875" marR="142875" marT="95250" marB="95250" anchor="ctr"/>
-                </a:tc>
-                <a:extLst>
-                  <a:ext uri="{0D108BD9-81ED-4DB2-BD59-A6C34878D82A}">
-                    <a16:rowId xmlns:a16="http://schemas.microsoft.com/office/drawing/2014/main" val="476507548"/>
-                  </a:ext>
-                </a:extLst>
-              </a:tr>
-              <a:tr h="382132">
-                <a:tc>
-                  <a:txBody>
-                    <a:bodyPr/>
-                    <a:lstStyle/>
-                    <a:p>
-                      <a:pPr algn="r">
-                        <a:buNone/>
-                      </a:pPr>
-                      <a:r>
-                        <a:rPr lang="en-US" sz="1600">
-                          <a:effectLst/>
-                        </a:rPr>
-                        <a:t>10:45 AM</a:t>
-                      </a:r>
-                    </a:p>
-                  </a:txBody>
-                  <a:tcPr marL="142875" marR="142875" marT="95250" marB="95250" anchor="ctr"/>
-                </a:tc>
-                <a:tc>
-                  <a:txBody>
-                    <a:bodyPr/>
-                    <a:lstStyle/>
-                    <a:p>
-                      <a:pPr>
-                        <a:buNone/>
-                      </a:pPr>
-                      <a:r>
-                        <a:rPr lang="en-US" sz="1600" i="1">
-                          <a:effectLst/>
-                        </a:rPr>
-                        <a:t>Morning break</a:t>
-                      </a:r>
-                      <a:endParaRPr lang="en-US" sz="1600">
-                        <a:effectLst/>
-                      </a:endParaRPr>
-                    </a:p>
-                  </a:txBody>
-                  <a:tcPr marL="142875" marR="142875" marT="95250" marB="95250" anchor="ctr"/>
-                </a:tc>
-                <a:tc>
-                  <a:txBody>
-                    <a:bodyPr/>
-                    <a:lstStyle/>
-                    <a:p>
-                      <a:pPr>
-                        <a:buNone/>
-                      </a:pPr>
-                      <a:endParaRPr lang="en-US" sz="1600">
-                        <a:effectLst/>
-                      </a:endParaRPr>
-                    </a:p>
-                  </a:txBody>
-                  <a:tcPr marL="142875" marR="142875" marT="95250" marB="95250" anchor="ctr"/>
-                </a:tc>
-                <a:extLst>
-                  <a:ext uri="{0D108BD9-81ED-4DB2-BD59-A6C34878D82A}">
-                    <a16:rowId xmlns:a16="http://schemas.microsoft.com/office/drawing/2014/main" val="3487810232"/>
-                  </a:ext>
-                </a:extLst>
-              </a:tr>
-              <a:tr h="382132">
-                <a:tc>
-                  <a:txBody>
-                    <a:bodyPr/>
-                    <a:lstStyle/>
-                    <a:p>
-                      <a:pPr algn="r">
-                        <a:buNone/>
-                      </a:pPr>
-                      <a:r>
-                        <a:rPr lang="en-US" sz="1600">
-                          <a:effectLst/>
-                        </a:rPr>
-                        <a:t>11:15 AM</a:t>
-                      </a:r>
-                    </a:p>
-                  </a:txBody>
-                  <a:tcPr marL="142875" marR="142875" marT="95250" marB="95250" anchor="ctr"/>
-                </a:tc>
-                <a:tc>
-                  <a:txBody>
-                    <a:bodyPr/>
-                    <a:lstStyle/>
-                    <a:p>
-                      <a:pPr>
-                        <a:buNone/>
-                      </a:pPr>
-                      <a:r>
-                        <a:rPr lang="en-US" sz="1600">
-                          <a:effectLst/>
-                        </a:rPr>
-                        <a:t>Scientific Software Design</a:t>
-                      </a:r>
-                    </a:p>
-                  </a:txBody>
-                  <a:tcPr marL="142875" marR="142875" marT="95250" marB="95250" anchor="ctr"/>
-                </a:tc>
-                <a:tc>
-                  <a:txBody>
-                    <a:bodyPr/>
-                    <a:lstStyle/>
-                    <a:p>
-                      <a:pPr>
-                        <a:buNone/>
-                      </a:pPr>
-                      <a:r>
-                        <a:rPr lang="en-US" sz="1600">
-                          <a:effectLst/>
-                        </a:rPr>
-                        <a:t>Anshu Dubey (ANL)</a:t>
-                      </a:r>
-                    </a:p>
-                  </a:txBody>
-                  <a:tcPr marL="142875" marR="142875" marT="95250" marB="95250" anchor="ctr"/>
-                </a:tc>
-                <a:extLst>
-                  <a:ext uri="{0D108BD9-81ED-4DB2-BD59-A6C34878D82A}">
-                    <a16:rowId xmlns:a16="http://schemas.microsoft.com/office/drawing/2014/main" val="2034051112"/>
-                  </a:ext>
-                </a:extLst>
-              </a:tr>
-              <a:tr h="382132">
-                <a:tc>
-                  <a:txBody>
-                    <a:bodyPr/>
-                    <a:lstStyle/>
-                    <a:p>
-                      <a:pPr algn="r">
-                        <a:buNone/>
-                      </a:pPr>
-                      <a:r>
-                        <a:rPr lang="en-US" sz="1600">
-                          <a:effectLst/>
-                        </a:rPr>
-                        <a:t>11:50 AM</a:t>
-                      </a:r>
-                    </a:p>
-                  </a:txBody>
-                  <a:tcPr marL="142875" marR="142875" marT="95250" marB="95250" anchor="ctr"/>
-                </a:tc>
-                <a:tc>
-                  <a:txBody>
-                    <a:bodyPr/>
-                    <a:lstStyle/>
-                    <a:p>
-                      <a:pPr>
-                        <a:buNone/>
-                      </a:pPr>
-                      <a:r>
-                        <a:rPr lang="en-US" sz="1600">
-                          <a:effectLst/>
-                        </a:rPr>
-                        <a:t>Software Testing and Verification</a:t>
-                      </a:r>
-                    </a:p>
-                  </a:txBody>
-                  <a:tcPr marL="142875" marR="142875" marT="95250" marB="95250" anchor="ctr"/>
-                </a:tc>
-                <a:tc>
-                  <a:txBody>
-                    <a:bodyPr/>
-                    <a:lstStyle/>
-                    <a:p>
-                      <a:pPr>
-                        <a:buNone/>
-                      </a:pPr>
-                      <a:r>
-                        <a:rPr lang="en-US" sz="1600">
-                          <a:effectLst/>
-                        </a:rPr>
-                        <a:t>Anshu Dubey (ANL)</a:t>
-                      </a:r>
-                    </a:p>
-                  </a:txBody>
-                  <a:tcPr marL="142875" marR="142875" marT="95250" marB="95250" anchor="ctr"/>
-                </a:tc>
-                <a:extLst>
-                  <a:ext uri="{0D108BD9-81ED-4DB2-BD59-A6C34878D82A}">
-                    <a16:rowId xmlns:a16="http://schemas.microsoft.com/office/drawing/2014/main" val="1459939263"/>
-                  </a:ext>
-                </a:extLst>
-              </a:tr>
-              <a:tr h="382132">
-                <a:tc>
-                  <a:txBody>
-                    <a:bodyPr/>
-                    <a:lstStyle/>
-                    <a:p>
-                      <a:pPr algn="r">
-                        <a:buNone/>
-                      </a:pPr>
-                      <a:r>
-                        <a:rPr lang="en-US" sz="1600">
-                          <a:effectLst/>
-                        </a:rPr>
-                        <a:t>12:30 PM</a:t>
-                      </a:r>
-                    </a:p>
-                  </a:txBody>
-                  <a:tcPr marL="142875" marR="142875" marT="95250" marB="95250" anchor="ctr"/>
-                </a:tc>
-                <a:tc>
-                  <a:txBody>
-                    <a:bodyPr/>
-                    <a:lstStyle/>
-                    <a:p>
-                      <a:pPr>
-                        <a:buNone/>
-                      </a:pPr>
-                      <a:r>
-                        <a:rPr lang="en-US" sz="1600" i="1">
-                          <a:effectLst/>
-                        </a:rPr>
-                        <a:t>Lunch break</a:t>
-                      </a:r>
-                      <a:endParaRPr lang="en-US" sz="1600">
-                        <a:effectLst/>
-                      </a:endParaRPr>
-                    </a:p>
-                  </a:txBody>
-                  <a:tcPr marL="142875" marR="142875" marT="95250" marB="95250" anchor="ctr"/>
-                </a:tc>
-                <a:tc>
-                  <a:txBody>
-                    <a:bodyPr/>
-                    <a:lstStyle/>
-                    <a:p>
-                      <a:pPr>
-                        <a:buNone/>
-                      </a:pPr>
-                      <a:endParaRPr lang="en-US" sz="1600">
-                        <a:effectLst/>
-                      </a:endParaRPr>
-                    </a:p>
-                  </a:txBody>
-                  <a:tcPr marL="142875" marR="142875" marT="95250" marB="95250" anchor="ctr"/>
-                </a:tc>
-                <a:extLst>
-                  <a:ext uri="{0D108BD9-81ED-4DB2-BD59-A6C34878D82A}">
-                    <a16:rowId xmlns:a16="http://schemas.microsoft.com/office/drawing/2014/main" val="4251053983"/>
-                  </a:ext>
-                </a:extLst>
-              </a:tr>
-              <a:tr h="382132">
-                <a:tc>
-                  <a:txBody>
-                    <a:bodyPr/>
-                    <a:lstStyle/>
-                    <a:p>
-                      <a:pPr algn="r">
-                        <a:buNone/>
-                      </a:pPr>
-                      <a:r>
-                        <a:rPr lang="en-US" sz="1600">
-                          <a:effectLst/>
-                        </a:rPr>
-                        <a:t>1:30 PM</a:t>
-                      </a:r>
-                    </a:p>
-                  </a:txBody>
-                  <a:tcPr marL="142875" marR="142875" marT="95250" marB="95250" anchor="ctr"/>
-                </a:tc>
-                <a:tc>
-                  <a:txBody>
-                    <a:bodyPr/>
-                    <a:lstStyle/>
-                    <a:p>
-                      <a:pPr>
-                        <a:buNone/>
-                      </a:pPr>
-                      <a:r>
-                        <a:rPr lang="en-US" sz="1600">
-                          <a:effectLst/>
-                        </a:rPr>
-                        <a:t>Refactoring</a:t>
-                      </a:r>
-                    </a:p>
-                  </a:txBody>
-                  <a:tcPr marL="142875" marR="142875" marT="95250" marB="95250" anchor="ctr"/>
-                </a:tc>
-                <a:tc>
-                  <a:txBody>
-                    <a:bodyPr/>
-                    <a:lstStyle/>
-                    <a:p>
-                      <a:pPr>
-                        <a:buNone/>
-                      </a:pPr>
-                      <a:r>
-                        <a:rPr lang="en-US" sz="1600">
-                          <a:effectLst/>
-                        </a:rPr>
-                        <a:t>Anshu Dubey (ANL)</a:t>
-                      </a:r>
-                    </a:p>
-                  </a:txBody>
-                  <a:tcPr marL="142875" marR="142875" marT="95250" marB="95250" anchor="ctr"/>
-                </a:tc>
-                <a:extLst>
-                  <a:ext uri="{0D108BD9-81ED-4DB2-BD59-A6C34878D82A}">
-                    <a16:rowId xmlns:a16="http://schemas.microsoft.com/office/drawing/2014/main" val="3676510234"/>
-                  </a:ext>
-                </a:extLst>
-              </a:tr>
-              <a:tr h="382132">
-                <a:tc>
-                  <a:txBody>
-                    <a:bodyPr/>
-                    <a:lstStyle/>
-                    <a:p>
-                      <a:pPr algn="r">
-                        <a:buNone/>
-                      </a:pPr>
-                      <a:r>
-                        <a:rPr lang="en-US" sz="1600">
-                          <a:effectLst/>
-                        </a:rPr>
-                        <a:t>2:00 PM</a:t>
-                      </a:r>
-                    </a:p>
-                  </a:txBody>
-                  <a:tcPr marL="142875" marR="142875" marT="95250" marB="95250" anchor="ctr"/>
-                </a:tc>
-                <a:tc>
-                  <a:txBody>
-                    <a:bodyPr/>
-                    <a:lstStyle/>
-                    <a:p>
-                      <a:pPr>
-                        <a:buNone/>
-                      </a:pPr>
-                      <a:r>
-                        <a:rPr lang="en-US" sz="1600">
-                          <a:effectLst/>
-                        </a:rPr>
-                        <a:t>Improving Reproducibility Through Better Software Practices</a:t>
-                      </a:r>
-                    </a:p>
-                  </a:txBody>
-                  <a:tcPr marL="142875" marR="142875" marT="95250" marB="95250" anchor="ctr"/>
-                </a:tc>
-                <a:tc>
-                  <a:txBody>
-                    <a:bodyPr/>
-                    <a:lstStyle/>
-                    <a:p>
-                      <a:pPr>
-                        <a:buNone/>
-                      </a:pPr>
-                      <a:r>
-                        <a:rPr lang="en-US" sz="1600" dirty="0">
-                          <a:effectLst/>
-                        </a:rPr>
-                        <a:t>Akash Dhruv (ANL)</a:t>
-                      </a:r>
-                    </a:p>
-                  </a:txBody>
-                  <a:tcPr marL="142875" marR="142875" marT="95250" marB="95250" anchor="ctr"/>
-                </a:tc>
-                <a:extLst>
-                  <a:ext uri="{0D108BD9-81ED-4DB2-BD59-A6C34878D82A}">
-                    <a16:rowId xmlns:a16="http://schemas.microsoft.com/office/drawing/2014/main" val="12906980"/>
-                  </a:ext>
-                </a:extLst>
-              </a:tr>
-              <a:tr h="382132">
-                <a:tc>
-                  <a:txBody>
-                    <a:bodyPr/>
-                    <a:lstStyle/>
-                    <a:p>
-                      <a:pPr algn="r">
-                        <a:buNone/>
-                      </a:pPr>
-                      <a:r>
-                        <a:rPr lang="en-US" sz="1600">
-                          <a:effectLst/>
-                        </a:rPr>
-                        <a:t>2:45 PM</a:t>
-                      </a:r>
-                    </a:p>
-                  </a:txBody>
-                  <a:tcPr marL="142875" marR="142875" marT="95250" marB="95250" anchor="ctr"/>
-                </a:tc>
-                <a:tc>
-                  <a:txBody>
-                    <a:bodyPr/>
-                    <a:lstStyle/>
-                    <a:p>
-                      <a:pPr>
-                        <a:buNone/>
-                      </a:pPr>
-                      <a:r>
-                        <a:rPr lang="en-US" sz="1600" i="1">
-                          <a:effectLst/>
-                        </a:rPr>
-                        <a:t>Afternoon break</a:t>
-                      </a:r>
-                      <a:endParaRPr lang="en-US" sz="1600">
-                        <a:effectLst/>
-                      </a:endParaRPr>
-                    </a:p>
-                  </a:txBody>
-                  <a:tcPr marL="142875" marR="142875" marT="95250" marB="95250" anchor="ctr"/>
-                </a:tc>
-                <a:tc>
-                  <a:txBody>
-                    <a:bodyPr/>
-                    <a:lstStyle/>
-                    <a:p>
-                      <a:pPr>
-                        <a:buNone/>
-                      </a:pPr>
-                      <a:endParaRPr lang="en-US" sz="1600">
-                        <a:effectLst/>
-                      </a:endParaRPr>
-                    </a:p>
-                  </a:txBody>
-                  <a:tcPr marL="142875" marR="142875" marT="95250" marB="95250" anchor="ctr"/>
-                </a:tc>
-                <a:extLst>
-                  <a:ext uri="{0D108BD9-81ED-4DB2-BD59-A6C34878D82A}">
-                    <a16:rowId xmlns:a16="http://schemas.microsoft.com/office/drawing/2014/main" val="2644344774"/>
-                  </a:ext>
-                </a:extLst>
-              </a:tr>
-              <a:tr h="382132">
-                <a:tc>
-                  <a:txBody>
-                    <a:bodyPr/>
-                    <a:lstStyle/>
-                    <a:p>
-                      <a:pPr algn="r">
-                        <a:buNone/>
-                      </a:pPr>
-                      <a:r>
-                        <a:rPr lang="en-US" sz="1600">
-                          <a:effectLst/>
-                        </a:rPr>
-                        <a:t>3:15 PM</a:t>
-                      </a:r>
-                    </a:p>
-                  </a:txBody>
-                  <a:tcPr marL="142875" marR="142875" marT="95250" marB="95250" anchor="ctr"/>
-                </a:tc>
-                <a:tc>
-                  <a:txBody>
-                    <a:bodyPr/>
-                    <a:lstStyle/>
-                    <a:p>
-                      <a:pPr>
-                        <a:buNone/>
-                      </a:pPr>
-                      <a:r>
-                        <a:rPr lang="en-US" sz="1600">
-                          <a:effectLst/>
-                        </a:rPr>
-                        <a:t>Hands on coding tasks with LLMs</a:t>
-                      </a:r>
-                    </a:p>
-                  </a:txBody>
-                  <a:tcPr marL="142875" marR="142875" marT="95250" marB="95250" anchor="ctr"/>
-                </a:tc>
-                <a:tc>
-                  <a:txBody>
-                    <a:bodyPr/>
-                    <a:lstStyle/>
-                    <a:p>
-                      <a:pPr>
-                        <a:buNone/>
-                      </a:pPr>
-                      <a:r>
-                        <a:rPr lang="en-US" sz="1600">
-                          <a:effectLst/>
-                        </a:rPr>
-                        <a:t>Akash Dhruv (ANL) and Anshu Dubey (ANL)</a:t>
-                      </a:r>
-                    </a:p>
-                  </a:txBody>
-                  <a:tcPr marL="142875" marR="142875" marT="95250" marB="95250" anchor="ctr"/>
-                </a:tc>
-                <a:extLst>
-                  <a:ext uri="{0D108BD9-81ED-4DB2-BD59-A6C34878D82A}">
-                    <a16:rowId xmlns:a16="http://schemas.microsoft.com/office/drawing/2014/main" val="3792300201"/>
-                  </a:ext>
-                </a:extLst>
-              </a:tr>
-              <a:tr h="382132">
-                <a:tc>
-                  <a:txBody>
-                    <a:bodyPr/>
-                    <a:lstStyle/>
-                    <a:p>
-                      <a:pPr algn="r">
-                        <a:buNone/>
-                      </a:pPr>
-                      <a:r>
-                        <a:rPr lang="en-US" sz="1600">
-                          <a:effectLst/>
-                        </a:rPr>
-                        <a:t>4:30 PM</a:t>
-                      </a:r>
-                    </a:p>
-                  </a:txBody>
-                  <a:tcPr marL="142875" marR="142875" marT="95250" marB="95250" anchor="ctr"/>
-                </a:tc>
-                <a:tc>
-                  <a:txBody>
-                    <a:bodyPr/>
-                    <a:lstStyle/>
-                    <a:p>
-                      <a:pPr>
-                        <a:buNone/>
-                      </a:pPr>
-                      <a:r>
-                        <a:rPr lang="en-US" sz="1600" i="1">
-                          <a:effectLst/>
-                        </a:rPr>
-                        <a:t>Adjourn</a:t>
-                      </a:r>
-                      <a:endParaRPr lang="en-US" sz="1600">
-                        <a:effectLst/>
-                      </a:endParaRPr>
-                    </a:p>
-                  </a:txBody>
-                  <a:tcPr marL="142875" marR="142875" marT="95250" marB="95250" anchor="ctr"/>
-                </a:tc>
-                <a:tc>
-                  <a:txBody>
-                    <a:bodyPr/>
-                    <a:lstStyle/>
-                    <a:p>
-                      <a:pPr>
-                        <a:buNone/>
-                      </a:pPr>
-                      <a:endParaRPr lang="en-US" sz="1600" dirty="0">
-                        <a:effectLst/>
-                      </a:endParaRPr>
-                    </a:p>
-                  </a:txBody>
-                  <a:tcPr marL="142875" marR="142875" marT="95250" marB="95250" anchor="ctr"/>
-                </a:tc>
-                <a:extLst>
-                  <a:ext uri="{0D108BD9-81ED-4DB2-BD59-A6C34878D82A}">
-                    <a16:rowId xmlns:a16="http://schemas.microsoft.com/office/drawing/2014/main" val="178223575"/>
-                  </a:ext>
-                </a:extLst>
-              </a:tr>
-            </a:tbl>
-          </a:graphicData>
-        </a:graphic>
-      </p:graphicFrame>
-      <p:sp>
-        <p:nvSpPr>
-          <p:cNvPr id="9" name="TextBox 8">
-            <a:extLst>
-              <a:ext uri="{FF2B5EF4-FFF2-40B4-BE49-F238E27FC236}">
-                <a16:creationId xmlns:a16="http://schemas.microsoft.com/office/drawing/2014/main" id="{2C67F121-FA5A-4323-B777-FC3438185944}"/>
-              </a:ext>
-            </a:extLst>
-          </p:cNvPr>
-          <p:cNvSpPr txBox="1"/>
-          <p:nvPr/>
-        </p:nvSpPr>
-        <p:spPr>
-          <a:xfrm>
-            <a:off x="4537710" y="45720"/>
-            <a:ext cx="7651115" cy="646331"/>
-          </a:xfrm>
-          <a:prstGeom prst="rect">
-            <a:avLst/>
-          </a:prstGeom>
-          <a:noFill/>
-        </p:spPr>
-        <p:txBody>
-          <a:bodyPr wrap="square">
-            <a:spAutoFit/>
-          </a:bodyPr>
-          <a:lstStyle/>
-          <a:p>
-            <a:pPr marL="0" marR="0" lvl="0" indent="0" algn="l" defTabSz="914400" rtl="0" eaLnBrk="1" fontAlgn="base" latinLnBrk="0" hangingPunct="1">
-              <a:lnSpc>
-                <a:spcPct val="100000"/>
-              </a:lnSpc>
-              <a:spcBef>
-                <a:spcPct val="0"/>
-              </a:spcBef>
-              <a:spcAft>
-                <a:spcPct val="0"/>
-              </a:spcAft>
-              <a:buClrTx/>
-              <a:buSzTx/>
-              <a:buFontTx/>
-              <a:buNone/>
-              <a:tabLst/>
-              <a:defRPr/>
-            </a:pPr>
-            <a:r>
-              <a:rPr kumimoji="0" lang="en-US" sz="1800" b="0" i="0" u="none" strike="noStrike" kern="1200" cap="none" spc="0" normalizeH="0" baseline="0" noProof="0" dirty="0">
-                <a:ln>
-                  <a:noFill/>
-                </a:ln>
-                <a:solidFill>
-                  <a:prstClr val="black"/>
-                </a:solidFill>
-                <a:effectLst/>
-                <a:uLnTx/>
-                <a:uFillTx/>
-                <a:latin typeface="Arial" charset="0"/>
-                <a:ea typeface="+mn-ea"/>
-                <a:cs typeface="Arial" charset="0"/>
-              </a:rPr>
-              <a:t>The agenda is also available on the tutorial web page.  Visit </a:t>
-            </a:r>
-            <a:r>
-              <a:rPr kumimoji="0" lang="en-US" sz="1800" b="1" i="0" u="none" strike="noStrike" kern="1200" cap="none" spc="0" normalizeH="0" baseline="0" noProof="0" dirty="0">
-                <a:ln>
-                  <a:noFill/>
-                </a:ln>
-                <a:solidFill>
-                  <a:prstClr val="black"/>
-                </a:solidFill>
-                <a:effectLst/>
-                <a:uLnTx/>
-                <a:uFillTx/>
-                <a:latin typeface="Arial" charset="0"/>
-                <a:ea typeface="+mn-ea"/>
-                <a:cs typeface="Arial" charset="0"/>
-                <a:hlinkClick r:id="rId2"/>
-              </a:rPr>
-              <a:t>https://bssw-tutorial.github.io</a:t>
-            </a:r>
-            <a:r>
-              <a:rPr kumimoji="0" lang="en-US" sz="1800" b="1" i="0" u="none" strike="noStrike" kern="1200" cap="none" spc="0" normalizeH="0" baseline="0" noProof="0" dirty="0">
-                <a:ln>
-                  <a:noFill/>
-                </a:ln>
-                <a:solidFill>
-                  <a:prstClr val="black"/>
-                </a:solidFill>
-                <a:effectLst/>
-                <a:uLnTx/>
-                <a:uFillTx/>
-                <a:latin typeface="Arial" charset="0"/>
-                <a:ea typeface="+mn-ea"/>
-                <a:cs typeface="Arial" charset="0"/>
-              </a:rPr>
-              <a:t> </a:t>
-            </a:r>
-            <a:r>
-              <a:rPr kumimoji="0" lang="en-US" sz="1800" b="0" i="0" u="none" strike="noStrike" kern="1200" cap="none" spc="0" normalizeH="0" baseline="0" noProof="0" dirty="0">
-                <a:ln>
-                  <a:noFill/>
-                </a:ln>
-                <a:solidFill>
-                  <a:prstClr val="black"/>
-                </a:solidFill>
-                <a:effectLst/>
-                <a:uLnTx/>
-                <a:uFillTx/>
-                <a:latin typeface="Arial" charset="0"/>
-                <a:ea typeface="+mn-ea"/>
-                <a:cs typeface="Arial" charset="0"/>
-              </a:rPr>
-              <a:t>and click on the link for today’s tutorial</a:t>
-            </a:r>
-          </a:p>
-        </p:txBody>
-      </p:sp>
-    </p:spTree>
-    <p:extLst>
-      <p:ext uri="{BB962C8B-B14F-4D97-AF65-F5344CB8AC3E}">
-        <p14:creationId xmlns:p14="http://schemas.microsoft.com/office/powerpoint/2010/main" val="3643219827"/>
       </p:ext>
     </p:extLst>
   </p:cSld>
@@ -5598,29 +4451,13 @@
             </a:r>
             <a:r>
               <a:rPr lang="en-US" sz="1600" dirty="0"/>
-              <a:t>Anshu Dubey and Akash Dhruv, Better Software for Science with High-Performance Computing tutorial, in </a:t>
-            </a:r>
-            <a:r>
-              <a:rPr lang="en-US" sz="1600" dirty="0" err="1"/>
-              <a:t>SupercomputingAsia</a:t>
-            </a:r>
-            <a:r>
-              <a:rPr lang="en-US" sz="1600" dirty="0"/>
-              <a:t> 2026 (SCA 2026)/The International Conference on High Performance Computing in Asia-Pacific Region 2026 (</a:t>
-            </a:r>
-            <a:r>
-              <a:rPr lang="en-US" sz="1600" dirty="0" err="1"/>
-              <a:t>HPCAsia</a:t>
-            </a:r>
-            <a:r>
-              <a:rPr lang="en-US" sz="1600" dirty="0"/>
-              <a:t> 2026), Osaka, Japan, 2026. DOI: </a:t>
+              <a:t>David E. Bernholdt, Software Sustainability track, in Argonne Training Program on Extreme-Scale Computing, St. Charles, Illinois, 2026. DOI: </a:t>
             </a:r>
             <a:r>
               <a:rPr lang="en-US" sz="1600" dirty="0">
                 <a:hlinkClick r:id="rId4"/>
               </a:rPr>
-              <a:t>10.6084/m9.figshare.31130062</a:t>
+              <a:t>10.6084/m9.figshare.33139910</a:t>
             </a:r>
             <a:r>
               <a:rPr lang="en-US" sz="1600" dirty="0"/>
@@ -5820,7 +4657,7 @@
     </p:spTree>
     <p:extLst>
       <p:ext uri="{BB962C8B-B14F-4D97-AF65-F5344CB8AC3E}">
-        <p14:creationId xmlns:p14="http://schemas.microsoft.com/office/powerpoint/2010/main" val="328470658"/>
+        <p14:creationId xmlns:p14="http://schemas.microsoft.com/office/powerpoint/2010/main" val="978726433"/>
       </p:ext>
     </p:extLst>
   </p:cSld>
@@ -5880,18 +4717,7 @@
             </a:pPr>
             <a:r>
               <a:rPr lang="en-US" dirty="0"/>
-              <a:t>Anshu Dubey, ANL</a:t>
-            </a:r>
-          </a:p>
-          <a:p>
-            <a:pPr>
-              <a:spcBef>
-                <a:spcPts val="1000"/>
-              </a:spcBef>
-            </a:pPr>
-            <a:r>
-              <a:rPr lang="en-US" dirty="0"/>
-              <a:t>Akash Dhruv, ANL</a:t>
+              <a:t>David E. Bernholdt, ORNL</a:t>
             </a:r>
           </a:p>
         </p:txBody>
@@ -5961,7 +4787,7 @@
             </a:pPr>
             <a:r>
               <a:rPr lang="en-US" sz="2000" dirty="0"/>
-              <a:t>Participants in the Consortium for the Advancement of Scientific Software (CASS) and DOE/ASCR software stewardship projects: </a:t>
+              <a:t>Participant in the Consortium for the Advancement of Scientific Software (CASS) and DOE/ASCR software stewardship projects: </a:t>
             </a:r>
             <a:r>
               <a:rPr lang="en-US" sz="2000" dirty="0">
@@ -5987,7 +4813,7 @@
               <a:rPr lang="en-US" sz="2000" dirty="0">
                 <a:hlinkClick r:id="rId3"/>
               </a:rPr>
-              <a:t>RAPIDS</a:t>
+              <a:t>PESO</a:t>
             </a:r>
             <a:r>
               <a:rPr lang="en-US" sz="2000" dirty="0"/>
@@ -6057,10 +4883,10 @@
       </p:sp>
       <p:grpSp>
         <p:nvGrpSpPr>
-          <p:cNvPr id="8" name="Group 7">
+          <p:cNvPr id="12" name="Group 11">
             <a:extLst>
               <a:ext uri="{FF2B5EF4-FFF2-40B4-BE49-F238E27FC236}">
-                <a16:creationId xmlns:a16="http://schemas.microsoft.com/office/drawing/2014/main" id="{C22DEB37-50E6-2254-1FB5-B0F6E81B4E4A}"/>
+                <a16:creationId xmlns:a16="http://schemas.microsoft.com/office/drawing/2014/main" id="{C1CB8376-FC49-BC56-A4AC-5F5C8E6F61B2}"/>
               </a:ext>
             </a:extLst>
           </p:cNvPr>
@@ -6069,18 +4895,18 @@
         </p:nvGrpSpPr>
         <p:grpSpPr>
           <a:xfrm>
-            <a:off x="7930236" y="1325880"/>
-            <a:ext cx="954107" cy="1805497"/>
-            <a:chOff x="5029187" y="1346049"/>
-            <a:chExt cx="954107" cy="1805497"/>
+            <a:off x="9553668" y="1280696"/>
+            <a:ext cx="914400" cy="1517469"/>
+            <a:chOff x="9553668" y="1280696"/>
+            <a:chExt cx="914400" cy="1517469"/>
           </a:xfrm>
         </p:grpSpPr>
         <p:sp>
           <p:nvSpPr>
-            <p:cNvPr id="9" name="TextBox 8">
+            <p:cNvPr id="7" name="TextBox 6">
               <a:extLst>
                 <a:ext uri="{FF2B5EF4-FFF2-40B4-BE49-F238E27FC236}">
-                  <a16:creationId xmlns:a16="http://schemas.microsoft.com/office/drawing/2014/main" id="{CEB57978-C3B6-32C4-C6C6-52ACB58C8A06}"/>
+                  <a16:creationId xmlns:a16="http://schemas.microsoft.com/office/drawing/2014/main" id="{A721C738-DF8D-3EA9-2614-5824FE3BD0E9}"/>
                 </a:ext>
               </a:extLst>
             </p:cNvPr>
@@ -6089,8 +4915,8 @@
           </p:nvSpPr>
           <p:spPr>
             <a:xfrm>
-              <a:off x="5029187" y="2560615"/>
-              <a:ext cx="954107" cy="590931"/>
+              <a:off x="9553668" y="2207234"/>
+              <a:ext cx="877164" cy="590931"/>
             </a:xfrm>
             <a:prstGeom prst="rect">
               <a:avLst/>
@@ -6110,7 +4936,7 @@
               </a:pPr>
               <a:r>
                 <a:rPr lang="en-US" dirty="0"/>
-                <a:t>Anshu</a:t>
+                <a:t>David</a:t>
               </a:r>
             </a:p>
             <a:p>
@@ -6121,17 +4947,17 @@
               </a:pPr>
               <a:r>
                 <a:rPr lang="en-US" i="1" dirty="0"/>
-                <a:t>she/her</a:t>
+                <a:t>he/him</a:t>
               </a:r>
             </a:p>
           </p:txBody>
         </p:sp>
         <p:pic>
           <p:nvPicPr>
-            <p:cNvPr id="10" name="Picture 9" descr="A person smiling for the camera&#10;&#10;Description automatically generated with low confidence">
+            <p:cNvPr id="11" name="Picture 10">
               <a:extLst>
                 <a:ext uri="{FF2B5EF4-FFF2-40B4-BE49-F238E27FC236}">
-                  <a16:creationId xmlns:a16="http://schemas.microsoft.com/office/drawing/2014/main" id="{4F1A04F2-5B52-D284-D8CF-CD12780422CE}"/>
+                  <a16:creationId xmlns:a16="http://schemas.microsoft.com/office/drawing/2014/main" id="{CB83ECAB-4195-38FC-D057-70946F05D1DF}"/>
                 </a:ext>
               </a:extLst>
             </p:cNvPr>
@@ -6154,115 +4980,8 @@
           </p:blipFill>
           <p:spPr>
             <a:xfrm>
-              <a:off x="5047103" y="1346049"/>
-              <a:ext cx="918273" cy="1207008"/>
-            </a:xfrm>
-            <a:prstGeom prst="rect">
-              <a:avLst/>
-            </a:prstGeom>
-          </p:spPr>
-        </p:pic>
-      </p:grpSp>
-      <p:grpSp>
-        <p:nvGrpSpPr>
-          <p:cNvPr id="6" name="Group 5">
-            <a:extLst>
-              <a:ext uri="{FF2B5EF4-FFF2-40B4-BE49-F238E27FC236}">
-                <a16:creationId xmlns:a16="http://schemas.microsoft.com/office/drawing/2014/main" id="{910C8777-DB67-3320-C206-FEC35BE5F23B}"/>
-              </a:ext>
-            </a:extLst>
-          </p:cNvPr>
-          <p:cNvGrpSpPr/>
-          <p:nvPr/>
-        </p:nvGrpSpPr>
-        <p:grpSpPr>
-          <a:xfrm>
-            <a:off x="9539620" y="1325880"/>
-            <a:ext cx="905256" cy="1805497"/>
-            <a:chOff x="6638571" y="1346049"/>
-            <a:chExt cx="905256" cy="1805497"/>
-          </a:xfrm>
-        </p:grpSpPr>
-        <p:sp>
-          <p:nvSpPr>
-            <p:cNvPr id="7" name="TextBox 6">
-              <a:extLst>
-                <a:ext uri="{FF2B5EF4-FFF2-40B4-BE49-F238E27FC236}">
-                  <a16:creationId xmlns:a16="http://schemas.microsoft.com/office/drawing/2014/main" id="{A721C738-DF8D-3EA9-2614-5824FE3BD0E9}"/>
-                </a:ext>
-              </a:extLst>
-            </p:cNvPr>
-            <p:cNvSpPr txBox="1"/>
-            <p:nvPr/>
-          </p:nvSpPr>
-          <p:spPr>
-            <a:xfrm>
-              <a:off x="6652619" y="2560615"/>
-              <a:ext cx="877164" cy="590931"/>
-            </a:xfrm>
-            <a:prstGeom prst="rect">
-              <a:avLst/>
-            </a:prstGeom>
-            <a:noFill/>
-          </p:spPr>
-          <p:txBody>
-            <a:bodyPr wrap="none" rtlCol="0">
-              <a:spAutoFit/>
-            </a:bodyPr>
-            <a:lstStyle/>
-            <a:p>
-              <a:pPr algn="ctr">
-                <a:lnSpc>
-                  <a:spcPct val="90000"/>
-                </a:lnSpc>
-              </a:pPr>
-              <a:r>
-                <a:rPr lang="en-US" dirty="0"/>
-                <a:t>Akash</a:t>
-              </a:r>
-            </a:p>
-            <a:p>
-              <a:pPr algn="ctr">
-                <a:lnSpc>
-                  <a:spcPct val="90000"/>
-                </a:lnSpc>
-              </a:pPr>
-              <a:r>
-                <a:rPr lang="en-US" i="1" dirty="0"/>
-                <a:t>he/him</a:t>
-              </a:r>
-            </a:p>
-          </p:txBody>
-        </p:sp>
-        <p:pic>
-          <p:nvPicPr>
-            <p:cNvPr id="14" name="Picture 13">
-              <a:extLst>
-                <a:ext uri="{FF2B5EF4-FFF2-40B4-BE49-F238E27FC236}">
-                  <a16:creationId xmlns:a16="http://schemas.microsoft.com/office/drawing/2014/main" id="{EDF74DA1-F88E-0E20-42A8-366D2E842DE6}"/>
-                </a:ext>
-              </a:extLst>
-            </p:cNvPr>
-            <p:cNvPicPr>
-              <a:picLocks noChangeAspect="1"/>
-            </p:cNvPicPr>
-            <p:nvPr/>
-          </p:nvPicPr>
-          <p:blipFill>
-            <a:blip r:embed="rId6" cstate="print">
-              <a:extLst>
-                <a:ext uri="{28A0092B-C50C-407E-A947-70E740481C1C}">
-                  <a14:useLocalDpi xmlns:a14="http://schemas.microsoft.com/office/drawing/2010/main" val="0"/>
-                </a:ext>
-              </a:extLst>
-            </a:blip>
-            <a:srcRect/>
-            <a:stretch/>
-          </p:blipFill>
-          <p:spPr>
-            <a:xfrm>
-              <a:off x="6638571" y="1346049"/>
-              <a:ext cx="905256" cy="1207008"/>
+              <a:off x="9553668" y="1280696"/>
+              <a:ext cx="914400" cy="914400"/>
             </a:xfrm>
             <a:prstGeom prst="rect">
               <a:avLst/>
@@ -7511,7 +6230,7 @@
           <p:cNvPr id="2" name="Title 1">
             <a:extLst>
               <a:ext uri="{FF2B5EF4-FFF2-40B4-BE49-F238E27FC236}">
-                <a16:creationId xmlns:a16="http://schemas.microsoft.com/office/drawing/2014/main" id="{D922857B-C8AE-3636-C96D-01CD92D9CB12}"/>
+                <a16:creationId xmlns:a16="http://schemas.microsoft.com/office/drawing/2014/main" id="{1D6756EE-C2D9-4E52-B0B6-3C831FD6A565}"/>
               </a:ext>
             </a:extLst>
           </p:cNvPr>
@@ -7524,7 +6243,7 @@
         </p:nvSpPr>
         <p:spPr>
           <a:xfrm>
-            <a:off x="365760" y="411480"/>
+            <a:off x="408175" y="160020"/>
             <a:ext cx="11372473" cy="914400"/>
           </a:xfrm>
         </p:spPr>
@@ -7534,79 +6253,982 @@
           <a:p>
             <a:r>
               <a:rPr lang="en-US" dirty="0"/>
-              <a:t>Hands-On Activities</a:t>
+              <a:t>Agenda</a:t>
             </a:r>
           </a:p>
         </p:txBody>
       </p:sp>
-      <p:sp>
-        <p:nvSpPr>
-          <p:cNvPr id="3" name="Content Placeholder 2">
+      <p:graphicFrame>
+        <p:nvGraphicFramePr>
+          <p:cNvPr id="6" name="Table 6">
             <a:extLst>
               <a:ext uri="{FF2B5EF4-FFF2-40B4-BE49-F238E27FC236}">
-                <a16:creationId xmlns:a16="http://schemas.microsoft.com/office/drawing/2014/main" id="{097E720E-7D3E-58A1-FD58-328F8C1D8DC1}"/>
+                <a16:creationId xmlns:a16="http://schemas.microsoft.com/office/drawing/2014/main" id="{99D13FB2-5BF8-4AC0-A13D-ECB8E230F5BC}"/>
               </a:ext>
             </a:extLst>
           </p:cNvPr>
-          <p:cNvSpPr>
-            <a:spLocks noGrp="1"/>
-          </p:cNvSpPr>
+          <p:cNvGraphicFramePr>
+            <a:graphicFrameLocks noGrp="1"/>
+          </p:cNvGraphicFramePr>
           <p:nvPr>
             <p:ph idx="1"/>
+            <p:extLst>
+              <p:ext uri="{D42A27DB-BD31-4B8C-83A1-F6EECF244321}">
+                <p14:modId xmlns:p14="http://schemas.microsoft.com/office/powerpoint/2010/main" val="2307727803"/>
+              </p:ext>
+            </p:extLst>
           </p:nvPr>
+        </p:nvGraphicFramePr>
+        <p:xfrm>
+          <a:off x="626110" y="722531"/>
+          <a:ext cx="10905491" cy="4922520"/>
+        </p:xfrm>
+        <a:graphic>
+          <a:graphicData uri="http://schemas.openxmlformats.org/drawingml/2006/table">
+            <a:tbl>
+              <a:tblPr firstRow="1" bandRow="1">
+                <a:tableStyleId>{5C22544A-7EE6-4342-B048-85BDC9FD1C3A}</a:tableStyleId>
+              </a:tblPr>
+              <a:tblGrid>
+                <a:gridCol w="1210439">
+                  <a:extLst>
+                    <a:ext uri="{9D8B030D-6E8A-4147-A177-3AD203B41FA5}">
+                      <a16:colId xmlns:a16="http://schemas.microsoft.com/office/drawing/2014/main" val="41390910"/>
+                    </a:ext>
+                  </a:extLst>
+                </a:gridCol>
+                <a:gridCol w="6524787">
+                  <a:extLst>
+                    <a:ext uri="{9D8B030D-6E8A-4147-A177-3AD203B41FA5}">
+                      <a16:colId xmlns:a16="http://schemas.microsoft.com/office/drawing/2014/main" val="2092910534"/>
+                    </a:ext>
+                  </a:extLst>
+                </a:gridCol>
+                <a:gridCol w="3170265">
+                  <a:extLst>
+                    <a:ext uri="{9D8B030D-6E8A-4147-A177-3AD203B41FA5}">
+                      <a16:colId xmlns:a16="http://schemas.microsoft.com/office/drawing/2014/main" val="1261297711"/>
+                    </a:ext>
+                  </a:extLst>
+                </a:gridCol>
+              </a:tblGrid>
+              <a:tr h="439813">
+                <a:tc>
+                  <a:txBody>
+                    <a:bodyPr/>
+                    <a:lstStyle/>
+                    <a:p>
+                      <a:pPr algn="r"/>
+                      <a:r>
+                        <a:rPr lang="en-US" sz="1800" dirty="0">
+                          <a:effectLst/>
+                        </a:rPr>
+                        <a:t>Time</a:t>
+                      </a:r>
+                    </a:p>
+                  </a:txBody>
+                  <a:tcPr marL="142875" marR="142875" marT="95250" marB="95250" anchor="ctr"/>
+                </a:tc>
+                <a:tc>
+                  <a:txBody>
+                    <a:bodyPr/>
+                    <a:lstStyle/>
+                    <a:p>
+                      <a:pPr algn="l"/>
+                      <a:r>
+                        <a:rPr lang="en-US" sz="1800" dirty="0">
+                          <a:effectLst/>
+                        </a:rPr>
+                        <a:t>Title</a:t>
+                      </a:r>
+                    </a:p>
+                  </a:txBody>
+                  <a:tcPr marL="142875" marR="142875" marT="95250" marB="95250" anchor="ctr"/>
+                </a:tc>
+                <a:tc>
+                  <a:txBody>
+                    <a:bodyPr/>
+                    <a:lstStyle/>
+                    <a:p>
+                      <a:r>
+                        <a:rPr lang="en-US" sz="1800" dirty="0">
+                          <a:effectLst/>
+                        </a:rPr>
+                        <a:t>Presenter</a:t>
+                      </a:r>
+                    </a:p>
+                  </a:txBody>
+                  <a:tcPr marL="142875" marR="142875" marT="95250" marB="95250" anchor="ctr"/>
+                </a:tc>
+                <a:extLst>
+                  <a:ext uri="{0D108BD9-81ED-4DB2-BD59-A6C34878D82A}">
+                    <a16:rowId xmlns:a16="http://schemas.microsoft.com/office/drawing/2014/main" val="2098024418"/>
+                  </a:ext>
+                </a:extLst>
+              </a:tr>
+              <a:tr h="382132">
+                <a:tc>
+                  <a:txBody>
+                    <a:bodyPr/>
+                    <a:lstStyle/>
+                    <a:p>
+                      <a:pPr algn="r">
+                        <a:spcAft>
+                          <a:spcPts val="2250"/>
+                        </a:spcAft>
+                        <a:buNone/>
+                      </a:pPr>
+                      <a:r>
+                        <a:rPr lang="en-US" sz="1800" b="0" i="0" dirty="0">
+                          <a:solidFill>
+                            <a:srgbClr val="3F3F3F"/>
+                          </a:solidFill>
+                          <a:effectLst/>
+                          <a:latin typeface="+mn-lt"/>
+                        </a:rPr>
+                        <a:t>3:00 PM</a:t>
+                      </a:r>
+                    </a:p>
+                  </a:txBody>
+                  <a:tcPr marL="142875" marR="142875" marT="95250" marB="95250" anchor="ctr"/>
+                </a:tc>
+                <a:tc>
+                  <a:txBody>
+                    <a:bodyPr/>
+                    <a:lstStyle/>
+                    <a:p>
+                      <a:pPr algn="l">
+                        <a:spcAft>
+                          <a:spcPts val="2250"/>
+                        </a:spcAft>
+                        <a:buNone/>
+                      </a:pPr>
+                      <a:r>
+                        <a:rPr lang="en-US" sz="1800" b="0" i="0" dirty="0">
+                          <a:solidFill>
+                            <a:srgbClr val="3F3F3F"/>
+                          </a:solidFill>
+                          <a:effectLst/>
+                          <a:latin typeface="+mn-lt"/>
+                        </a:rPr>
+                        <a:t>Introduction</a:t>
+                      </a:r>
+                    </a:p>
+                  </a:txBody>
+                  <a:tcPr marL="142875" marR="142875" marT="95250" marB="95250" anchor="ctr"/>
+                </a:tc>
+                <a:tc>
+                  <a:txBody>
+                    <a:bodyPr/>
+                    <a:lstStyle/>
+                    <a:p>
+                      <a:pPr algn="l">
+                        <a:spcAft>
+                          <a:spcPts val="2250"/>
+                        </a:spcAft>
+                        <a:buNone/>
+                      </a:pPr>
+                      <a:r>
+                        <a:rPr lang="en-US" sz="1800" b="0" i="0">
+                          <a:solidFill>
+                            <a:srgbClr val="3F3F3F"/>
+                          </a:solidFill>
+                          <a:effectLst/>
+                          <a:latin typeface="+mn-lt"/>
+                        </a:rPr>
+                        <a:t>David E. Bernholdt (ORNL)</a:t>
+                      </a:r>
+                    </a:p>
+                  </a:txBody>
+                  <a:tcPr marL="142875" marR="142875" marT="95250" marB="95250" anchor="ctr"/>
+                </a:tc>
+                <a:extLst>
+                  <a:ext uri="{0D108BD9-81ED-4DB2-BD59-A6C34878D82A}">
+                    <a16:rowId xmlns:a16="http://schemas.microsoft.com/office/drawing/2014/main" val="178223575"/>
+                  </a:ext>
+                </a:extLst>
+              </a:tr>
+              <a:tr h="382132">
+                <a:tc>
+                  <a:txBody>
+                    <a:bodyPr/>
+                    <a:lstStyle/>
+                    <a:p>
+                      <a:pPr algn="r">
+                        <a:spcAft>
+                          <a:spcPts val="2250"/>
+                        </a:spcAft>
+                        <a:buNone/>
+                      </a:pPr>
+                      <a:r>
+                        <a:rPr lang="en-US" sz="1800" b="0" i="0" dirty="0">
+                          <a:solidFill>
+                            <a:srgbClr val="3F3F3F"/>
+                          </a:solidFill>
+                          <a:effectLst/>
+                          <a:latin typeface="+mn-lt"/>
+                        </a:rPr>
+                        <a:t>3:05 PM</a:t>
+                      </a:r>
+                    </a:p>
+                  </a:txBody>
+                  <a:tcPr marL="142875" marR="142875" marT="95250" marB="95250" anchor="ctr"/>
+                </a:tc>
+                <a:tc>
+                  <a:txBody>
+                    <a:bodyPr/>
+                    <a:lstStyle/>
+                    <a:p>
+                      <a:pPr algn="l">
+                        <a:spcAft>
+                          <a:spcPts val="2250"/>
+                        </a:spcAft>
+                        <a:buNone/>
+                      </a:pPr>
+                      <a:r>
+                        <a:rPr lang="en-US" sz="1800" b="0" i="0">
+                          <a:solidFill>
+                            <a:srgbClr val="3F3F3F"/>
+                          </a:solidFill>
+                          <a:effectLst/>
+                          <a:latin typeface="+mn-lt"/>
+                        </a:rPr>
+                        <a:t>Motivation and Overview of Best Practices in HPC Software Development</a:t>
+                      </a:r>
+                    </a:p>
+                  </a:txBody>
+                  <a:tcPr marL="142875" marR="142875" marT="95250" marB="95250" anchor="ctr"/>
+                </a:tc>
+                <a:tc>
+                  <a:txBody>
+                    <a:bodyPr/>
+                    <a:lstStyle/>
+                    <a:p>
+                      <a:pPr algn="l">
+                        <a:spcAft>
+                          <a:spcPts val="2250"/>
+                        </a:spcAft>
+                        <a:buNone/>
+                      </a:pPr>
+                      <a:r>
+                        <a:rPr lang="en-US" sz="1800" b="0" i="0">
+                          <a:solidFill>
+                            <a:srgbClr val="3F3F3F"/>
+                          </a:solidFill>
+                          <a:effectLst/>
+                          <a:latin typeface="+mn-lt"/>
+                        </a:rPr>
+                        <a:t>David E. Bernholdt (ORNL)</a:t>
+                      </a:r>
+                    </a:p>
+                  </a:txBody>
+                  <a:tcPr marL="142875" marR="142875" marT="95250" marB="95250" anchor="ctr"/>
+                </a:tc>
+                <a:extLst>
+                  <a:ext uri="{0D108BD9-81ED-4DB2-BD59-A6C34878D82A}">
+                    <a16:rowId xmlns:a16="http://schemas.microsoft.com/office/drawing/2014/main" val="3434665218"/>
+                  </a:ext>
+                </a:extLst>
+              </a:tr>
+              <a:tr h="382132">
+                <a:tc>
+                  <a:txBody>
+                    <a:bodyPr/>
+                    <a:lstStyle/>
+                    <a:p>
+                      <a:pPr algn="r">
+                        <a:spcAft>
+                          <a:spcPts val="2250"/>
+                        </a:spcAft>
+                        <a:buNone/>
+                      </a:pPr>
+                      <a:r>
+                        <a:rPr lang="en-US" sz="1800" b="0" i="0">
+                          <a:solidFill>
+                            <a:srgbClr val="3F3F3F"/>
+                          </a:solidFill>
+                          <a:effectLst/>
+                          <a:latin typeface="+mn-lt"/>
+                        </a:rPr>
+                        <a:t>3:30 PM</a:t>
+                      </a:r>
+                    </a:p>
+                  </a:txBody>
+                  <a:tcPr marL="142875" marR="142875" marT="95250" marB="95250" anchor="ctr"/>
+                </a:tc>
+                <a:tc>
+                  <a:txBody>
+                    <a:bodyPr/>
+                    <a:lstStyle/>
+                    <a:p>
+                      <a:pPr algn="l">
+                        <a:spcAft>
+                          <a:spcPts val="2250"/>
+                        </a:spcAft>
+                        <a:buNone/>
+                      </a:pPr>
+                      <a:r>
+                        <a:rPr lang="en-US" sz="1800" b="0" i="0" dirty="0">
+                          <a:solidFill>
+                            <a:srgbClr val="3F3F3F"/>
+                          </a:solidFill>
+                          <a:effectLst/>
+                          <a:latin typeface="+mn-lt"/>
+                        </a:rPr>
+                        <a:t>Scientific Software Design</a:t>
+                      </a:r>
+                    </a:p>
+                  </a:txBody>
+                  <a:tcPr marL="142875" marR="142875" marT="95250" marB="95250" anchor="ctr"/>
+                </a:tc>
+                <a:tc>
+                  <a:txBody>
+                    <a:bodyPr/>
+                    <a:lstStyle/>
+                    <a:p>
+                      <a:pPr algn="l">
+                        <a:spcAft>
+                          <a:spcPts val="2250"/>
+                        </a:spcAft>
+                        <a:buNone/>
+                      </a:pPr>
+                      <a:r>
+                        <a:rPr lang="en-US" sz="1800" b="0" i="0">
+                          <a:solidFill>
+                            <a:srgbClr val="3F3F3F"/>
+                          </a:solidFill>
+                          <a:effectLst/>
+                          <a:latin typeface="+mn-lt"/>
+                        </a:rPr>
+                        <a:t>David E. Bernholdt (ORNL)</a:t>
+                      </a:r>
+                    </a:p>
+                  </a:txBody>
+                  <a:tcPr marL="142875" marR="142875" marT="95250" marB="95250" anchor="ctr"/>
+                </a:tc>
+                <a:extLst>
+                  <a:ext uri="{0D108BD9-81ED-4DB2-BD59-A6C34878D82A}">
+                    <a16:rowId xmlns:a16="http://schemas.microsoft.com/office/drawing/2014/main" val="4182577452"/>
+                  </a:ext>
+                </a:extLst>
+              </a:tr>
+              <a:tr h="382132">
+                <a:tc>
+                  <a:txBody>
+                    <a:bodyPr/>
+                    <a:lstStyle/>
+                    <a:p>
+                      <a:pPr algn="r">
+                        <a:spcAft>
+                          <a:spcPts val="2250"/>
+                        </a:spcAft>
+                        <a:buNone/>
+                      </a:pPr>
+                      <a:r>
+                        <a:rPr lang="en-US" sz="1800" b="0" i="0">
+                          <a:solidFill>
+                            <a:srgbClr val="3F3F3F"/>
+                          </a:solidFill>
+                          <a:effectLst/>
+                          <a:latin typeface="+mn-lt"/>
+                        </a:rPr>
+                        <a:t>4:00 PM</a:t>
+                      </a:r>
+                    </a:p>
+                  </a:txBody>
+                  <a:tcPr marL="142875" marR="142875" marT="95250" marB="95250" anchor="ctr"/>
+                </a:tc>
+                <a:tc>
+                  <a:txBody>
+                    <a:bodyPr/>
+                    <a:lstStyle/>
+                    <a:p>
+                      <a:pPr algn="l">
+                        <a:spcAft>
+                          <a:spcPts val="2250"/>
+                        </a:spcAft>
+                        <a:buNone/>
+                      </a:pPr>
+                      <a:r>
+                        <a:rPr lang="en-US" sz="1800" b="0" i="1" dirty="0">
+                          <a:solidFill>
+                            <a:srgbClr val="3F3F3F"/>
+                          </a:solidFill>
+                          <a:effectLst/>
+                          <a:latin typeface="+mn-lt"/>
+                        </a:rPr>
+                        <a:t>Break</a:t>
+                      </a:r>
+                      <a:endParaRPr lang="en-US" sz="1800" b="0" i="0" dirty="0">
+                        <a:solidFill>
+                          <a:srgbClr val="3F3F3F"/>
+                        </a:solidFill>
+                        <a:effectLst/>
+                        <a:latin typeface="+mn-lt"/>
+                      </a:endParaRPr>
+                    </a:p>
+                  </a:txBody>
+                  <a:tcPr marL="142875" marR="142875" marT="95250" marB="95250" anchor="ctr"/>
+                </a:tc>
+                <a:tc>
+                  <a:txBody>
+                    <a:bodyPr/>
+                    <a:lstStyle/>
+                    <a:p>
+                      <a:pPr algn="l">
+                        <a:spcAft>
+                          <a:spcPts val="2250"/>
+                        </a:spcAft>
+                        <a:buNone/>
+                      </a:pPr>
+                      <a:endParaRPr lang="en-US" sz="1800" b="0" i="0">
+                        <a:solidFill>
+                          <a:srgbClr val="3F3F3F"/>
+                        </a:solidFill>
+                        <a:effectLst/>
+                        <a:latin typeface="+mn-lt"/>
+                      </a:endParaRPr>
+                    </a:p>
+                  </a:txBody>
+                  <a:tcPr marL="142875" marR="142875" marT="95250" marB="95250" anchor="ctr"/>
+                </a:tc>
+                <a:extLst>
+                  <a:ext uri="{0D108BD9-81ED-4DB2-BD59-A6C34878D82A}">
+                    <a16:rowId xmlns:a16="http://schemas.microsoft.com/office/drawing/2014/main" val="4021121108"/>
+                  </a:ext>
+                </a:extLst>
+              </a:tr>
+              <a:tr h="382132">
+                <a:tc>
+                  <a:txBody>
+                    <a:bodyPr/>
+                    <a:lstStyle/>
+                    <a:p>
+                      <a:pPr algn="r">
+                        <a:spcAft>
+                          <a:spcPts val="2250"/>
+                        </a:spcAft>
+                        <a:buNone/>
+                      </a:pPr>
+                      <a:r>
+                        <a:rPr lang="en-US" sz="1800" b="0" i="0">
+                          <a:solidFill>
+                            <a:srgbClr val="3F3F3F"/>
+                          </a:solidFill>
+                          <a:effectLst/>
+                          <a:latin typeface="+mn-lt"/>
+                        </a:rPr>
+                        <a:t>4:30 PM</a:t>
+                      </a:r>
+                    </a:p>
+                  </a:txBody>
+                  <a:tcPr marL="142875" marR="142875" marT="95250" marB="95250" anchor="ctr"/>
+                </a:tc>
+                <a:tc>
+                  <a:txBody>
+                    <a:bodyPr/>
+                    <a:lstStyle/>
+                    <a:p>
+                      <a:pPr algn="l">
+                        <a:spcAft>
+                          <a:spcPts val="2250"/>
+                        </a:spcAft>
+                        <a:buNone/>
+                      </a:pPr>
+                      <a:r>
+                        <a:rPr lang="en-US" sz="1800" b="0" i="0" dirty="0">
+                          <a:solidFill>
+                            <a:srgbClr val="3F3F3F"/>
+                          </a:solidFill>
+                          <a:effectLst/>
+                          <a:latin typeface="+mn-lt"/>
+                        </a:rPr>
+                        <a:t>Software Testing and Verification</a:t>
+                      </a:r>
+                    </a:p>
+                  </a:txBody>
+                  <a:tcPr marL="142875" marR="142875" marT="95250" marB="95250" anchor="ctr"/>
+                </a:tc>
+                <a:tc>
+                  <a:txBody>
+                    <a:bodyPr/>
+                    <a:lstStyle/>
+                    <a:p>
+                      <a:pPr algn="l">
+                        <a:spcAft>
+                          <a:spcPts val="2250"/>
+                        </a:spcAft>
+                        <a:buNone/>
+                      </a:pPr>
+                      <a:r>
+                        <a:rPr lang="en-US" sz="1800" b="0" i="0">
+                          <a:solidFill>
+                            <a:srgbClr val="3F3F3F"/>
+                          </a:solidFill>
+                          <a:effectLst/>
+                          <a:latin typeface="+mn-lt"/>
+                        </a:rPr>
+                        <a:t>David E. Bernholdt (ORNL)</a:t>
+                      </a:r>
+                    </a:p>
+                  </a:txBody>
+                  <a:tcPr marL="142875" marR="142875" marT="95250" marB="95250" anchor="ctr"/>
+                </a:tc>
+                <a:extLst>
+                  <a:ext uri="{0D108BD9-81ED-4DB2-BD59-A6C34878D82A}">
+                    <a16:rowId xmlns:a16="http://schemas.microsoft.com/office/drawing/2014/main" val="2552146737"/>
+                  </a:ext>
+                </a:extLst>
+              </a:tr>
+              <a:tr h="382132">
+                <a:tc>
+                  <a:txBody>
+                    <a:bodyPr/>
+                    <a:lstStyle/>
+                    <a:p>
+                      <a:pPr algn="r">
+                        <a:spcAft>
+                          <a:spcPts val="2250"/>
+                        </a:spcAft>
+                        <a:buNone/>
+                      </a:pPr>
+                      <a:r>
+                        <a:rPr lang="en-US" sz="1800" b="0" i="0">
+                          <a:solidFill>
+                            <a:srgbClr val="3F3F3F"/>
+                          </a:solidFill>
+                          <a:effectLst/>
+                          <a:latin typeface="+mn-lt"/>
+                        </a:rPr>
+                        <a:t>5:00 PM</a:t>
+                      </a:r>
+                    </a:p>
+                  </a:txBody>
+                  <a:tcPr marL="142875" marR="142875" marT="95250" marB="95250" anchor="ctr"/>
+                </a:tc>
+                <a:tc>
+                  <a:txBody>
+                    <a:bodyPr/>
+                    <a:lstStyle/>
+                    <a:p>
+                      <a:pPr algn="l">
+                        <a:spcAft>
+                          <a:spcPts val="2250"/>
+                        </a:spcAft>
+                        <a:buNone/>
+                      </a:pPr>
+                      <a:r>
+                        <a:rPr lang="en-US" sz="1800" b="0" i="0" dirty="0">
+                          <a:solidFill>
+                            <a:srgbClr val="3F3F3F"/>
+                          </a:solidFill>
+                          <a:effectLst/>
+                          <a:latin typeface="+mn-lt"/>
+                        </a:rPr>
+                        <a:t>Refactoring Scientific Software</a:t>
+                      </a:r>
+                    </a:p>
+                  </a:txBody>
+                  <a:tcPr marL="142875" marR="142875" marT="95250" marB="95250" anchor="ctr"/>
+                </a:tc>
+                <a:tc>
+                  <a:txBody>
+                    <a:bodyPr/>
+                    <a:lstStyle/>
+                    <a:p>
+                      <a:pPr algn="l">
+                        <a:spcAft>
+                          <a:spcPts val="2250"/>
+                        </a:spcAft>
+                        <a:buNone/>
+                      </a:pPr>
+                      <a:r>
+                        <a:rPr lang="en-US" sz="1800" b="0" i="0">
+                          <a:solidFill>
+                            <a:srgbClr val="3F3F3F"/>
+                          </a:solidFill>
+                          <a:effectLst/>
+                          <a:latin typeface="+mn-lt"/>
+                        </a:rPr>
+                        <a:t>David E. Bernholdt (ORNL)</a:t>
+                      </a:r>
+                    </a:p>
+                  </a:txBody>
+                  <a:tcPr marL="142875" marR="142875" marT="95250" marB="95250" anchor="ctr"/>
+                </a:tc>
+                <a:extLst>
+                  <a:ext uri="{0D108BD9-81ED-4DB2-BD59-A6C34878D82A}">
+                    <a16:rowId xmlns:a16="http://schemas.microsoft.com/office/drawing/2014/main" val="694601206"/>
+                  </a:ext>
+                </a:extLst>
+              </a:tr>
+              <a:tr h="382132">
+                <a:tc>
+                  <a:txBody>
+                    <a:bodyPr/>
+                    <a:lstStyle/>
+                    <a:p>
+                      <a:pPr algn="r">
+                        <a:spcAft>
+                          <a:spcPts val="2250"/>
+                        </a:spcAft>
+                        <a:buNone/>
+                      </a:pPr>
+                      <a:r>
+                        <a:rPr lang="en-US" sz="1800" b="0" i="0">
+                          <a:solidFill>
+                            <a:srgbClr val="3F3F3F"/>
+                          </a:solidFill>
+                          <a:effectLst/>
+                          <a:latin typeface="+mn-lt"/>
+                        </a:rPr>
+                        <a:t>5:30 PM</a:t>
+                      </a:r>
+                    </a:p>
+                  </a:txBody>
+                  <a:tcPr marL="142875" marR="142875" marT="95250" marB="95250" anchor="ctr"/>
+                </a:tc>
+                <a:tc>
+                  <a:txBody>
+                    <a:bodyPr/>
+                    <a:lstStyle/>
+                    <a:p>
+                      <a:pPr algn="l">
+                        <a:spcAft>
+                          <a:spcPts val="2250"/>
+                        </a:spcAft>
+                        <a:buNone/>
+                      </a:pPr>
+                      <a:r>
+                        <a:rPr lang="en-US" sz="1800" b="0" i="0" dirty="0">
+                          <a:solidFill>
+                            <a:srgbClr val="3F3F3F"/>
+                          </a:solidFill>
+                          <a:effectLst/>
+                          <a:latin typeface="+mn-lt"/>
+                        </a:rPr>
+                        <a:t>Improving Reproducibility Through Better Software Practices</a:t>
+                      </a:r>
+                    </a:p>
+                  </a:txBody>
+                  <a:tcPr marL="142875" marR="142875" marT="95250" marB="95250" anchor="ctr"/>
+                </a:tc>
+                <a:tc>
+                  <a:txBody>
+                    <a:bodyPr/>
+                    <a:lstStyle/>
+                    <a:p>
+                      <a:pPr algn="l">
+                        <a:spcAft>
+                          <a:spcPts val="2250"/>
+                        </a:spcAft>
+                        <a:buNone/>
+                      </a:pPr>
+                      <a:r>
+                        <a:rPr lang="en-US" sz="1800" b="0" i="0">
+                          <a:solidFill>
+                            <a:srgbClr val="3F3F3F"/>
+                          </a:solidFill>
+                          <a:effectLst/>
+                          <a:latin typeface="+mn-lt"/>
+                        </a:rPr>
+                        <a:t>David E. Bernholdt (ORNL)</a:t>
+                      </a:r>
+                    </a:p>
+                  </a:txBody>
+                  <a:tcPr marL="142875" marR="142875" marT="95250" marB="95250" anchor="ctr"/>
+                </a:tc>
+                <a:extLst>
+                  <a:ext uri="{0D108BD9-81ED-4DB2-BD59-A6C34878D82A}">
+                    <a16:rowId xmlns:a16="http://schemas.microsoft.com/office/drawing/2014/main" val="3870447031"/>
+                  </a:ext>
+                </a:extLst>
+              </a:tr>
+              <a:tr h="382132">
+                <a:tc>
+                  <a:txBody>
+                    <a:bodyPr/>
+                    <a:lstStyle/>
+                    <a:p>
+                      <a:pPr algn="r">
+                        <a:spcAft>
+                          <a:spcPts val="2250"/>
+                        </a:spcAft>
+                        <a:buNone/>
+                      </a:pPr>
+                      <a:r>
+                        <a:rPr lang="en-US" sz="1800" b="0" i="0">
+                          <a:solidFill>
+                            <a:srgbClr val="3F3F3F"/>
+                          </a:solidFill>
+                          <a:effectLst/>
+                          <a:latin typeface="+mn-lt"/>
+                        </a:rPr>
+                        <a:t>6:00 PM</a:t>
+                      </a:r>
+                    </a:p>
+                  </a:txBody>
+                  <a:tcPr marL="142875" marR="142875" marT="95250" marB="95250" anchor="ctr"/>
+                </a:tc>
+                <a:tc>
+                  <a:txBody>
+                    <a:bodyPr/>
+                    <a:lstStyle/>
+                    <a:p>
+                      <a:pPr algn="l">
+                        <a:spcAft>
+                          <a:spcPts val="2250"/>
+                        </a:spcAft>
+                        <a:buNone/>
+                      </a:pPr>
+                      <a:r>
+                        <a:rPr lang="en-US" sz="1800" b="0" i="0" dirty="0">
+                          <a:solidFill>
+                            <a:srgbClr val="3F3F3F"/>
+                          </a:solidFill>
+                          <a:effectLst/>
+                          <a:latin typeface="+mn-lt"/>
+                        </a:rPr>
+                        <a:t>AI for Software Development and Maintenance</a:t>
+                      </a:r>
+                    </a:p>
+                  </a:txBody>
+                  <a:tcPr marL="142875" marR="142875" marT="95250" marB="95250" anchor="ctr"/>
+                </a:tc>
+                <a:tc>
+                  <a:txBody>
+                    <a:bodyPr/>
+                    <a:lstStyle/>
+                    <a:p>
+                      <a:pPr algn="l">
+                        <a:spcAft>
+                          <a:spcPts val="2250"/>
+                        </a:spcAft>
+                        <a:buNone/>
+                      </a:pPr>
+                      <a:r>
+                        <a:rPr lang="en-US" sz="1800" b="0" i="0">
+                          <a:solidFill>
+                            <a:srgbClr val="3F3F3F"/>
+                          </a:solidFill>
+                          <a:effectLst/>
+                          <a:latin typeface="+mn-lt"/>
+                        </a:rPr>
+                        <a:t>David E. Bernholdt (ORNL)</a:t>
+                      </a:r>
+                    </a:p>
+                  </a:txBody>
+                  <a:tcPr marL="142875" marR="142875" marT="95250" marB="95250" anchor="ctr"/>
+                </a:tc>
+                <a:extLst>
+                  <a:ext uri="{0D108BD9-81ED-4DB2-BD59-A6C34878D82A}">
+                    <a16:rowId xmlns:a16="http://schemas.microsoft.com/office/drawing/2014/main" val="536208135"/>
+                  </a:ext>
+                </a:extLst>
+              </a:tr>
+              <a:tr h="382132">
+                <a:tc>
+                  <a:txBody>
+                    <a:bodyPr/>
+                    <a:lstStyle/>
+                    <a:p>
+                      <a:pPr algn="r">
+                        <a:spcAft>
+                          <a:spcPts val="2250"/>
+                        </a:spcAft>
+                        <a:buNone/>
+                      </a:pPr>
+                      <a:r>
+                        <a:rPr lang="en-US" sz="1800" b="0" i="0">
+                          <a:solidFill>
+                            <a:srgbClr val="3F3F3F"/>
+                          </a:solidFill>
+                          <a:effectLst/>
+                          <a:latin typeface="+mn-lt"/>
+                        </a:rPr>
+                        <a:t>6:30 PM</a:t>
+                      </a:r>
+                    </a:p>
+                  </a:txBody>
+                  <a:tcPr marL="142875" marR="142875" marT="95250" marB="95250" anchor="ctr"/>
+                </a:tc>
+                <a:tc>
+                  <a:txBody>
+                    <a:bodyPr/>
+                    <a:lstStyle/>
+                    <a:p>
+                      <a:pPr algn="l">
+                        <a:spcAft>
+                          <a:spcPts val="2250"/>
+                        </a:spcAft>
+                        <a:buNone/>
+                      </a:pPr>
+                      <a:r>
+                        <a:rPr lang="en-US" sz="1800" b="0" i="1">
+                          <a:solidFill>
+                            <a:srgbClr val="3F3F3F"/>
+                          </a:solidFill>
+                          <a:effectLst/>
+                          <a:latin typeface="+mn-lt"/>
+                        </a:rPr>
+                        <a:t>Adjourn</a:t>
+                      </a:r>
+                      <a:endParaRPr lang="en-US" sz="1800" b="0" i="0">
+                        <a:solidFill>
+                          <a:srgbClr val="3F3F3F"/>
+                        </a:solidFill>
+                        <a:effectLst/>
+                        <a:latin typeface="+mn-lt"/>
+                      </a:endParaRPr>
+                    </a:p>
+                  </a:txBody>
+                  <a:tcPr marL="142875" marR="142875" marT="95250" marB="95250" anchor="ctr"/>
+                </a:tc>
+                <a:tc>
+                  <a:txBody>
+                    <a:bodyPr/>
+                    <a:lstStyle/>
+                    <a:p>
+                      <a:pPr algn="l">
+                        <a:spcAft>
+                          <a:spcPts val="2250"/>
+                        </a:spcAft>
+                        <a:buNone/>
+                      </a:pPr>
+                      <a:endParaRPr lang="en-US" sz="1800" b="0" i="0" dirty="0">
+                        <a:solidFill>
+                          <a:srgbClr val="3F3F3F"/>
+                        </a:solidFill>
+                        <a:effectLst/>
+                        <a:latin typeface="+mn-lt"/>
+                      </a:endParaRPr>
+                    </a:p>
+                  </a:txBody>
+                  <a:tcPr marL="142875" marR="142875" marT="95250" marB="95250" anchor="ctr"/>
+                </a:tc>
+                <a:extLst>
+                  <a:ext uri="{0D108BD9-81ED-4DB2-BD59-A6C34878D82A}">
+                    <a16:rowId xmlns:a16="http://schemas.microsoft.com/office/drawing/2014/main" val="662051237"/>
+                  </a:ext>
+                </a:extLst>
+              </a:tr>
+            </a:tbl>
+          </a:graphicData>
+        </a:graphic>
+      </p:graphicFrame>
+      <p:sp>
+        <p:nvSpPr>
+          <p:cNvPr id="9" name="TextBox 8">
+            <a:extLst>
+              <a:ext uri="{FF2B5EF4-FFF2-40B4-BE49-F238E27FC236}">
+                <a16:creationId xmlns:a16="http://schemas.microsoft.com/office/drawing/2014/main" id="{2C67F121-FA5A-4323-B777-FC3438185944}"/>
+              </a:ext>
+            </a:extLst>
+          </p:cNvPr>
+          <p:cNvSpPr txBox="1"/>
+          <p:nvPr/>
         </p:nvSpPr>
         <p:spPr>
           <a:xfrm>
-            <a:off x="365760" y="1737360"/>
-            <a:ext cx="11369809" cy="4047778"/>
+            <a:off x="4537710" y="45720"/>
+            <a:ext cx="7651115" cy="646331"/>
           </a:xfrm>
+          <a:prstGeom prst="rect">
+            <a:avLst/>
+          </a:prstGeom>
+          <a:noFill/>
         </p:spPr>
         <p:txBody>
-          <a:bodyPr/>
+          <a:bodyPr wrap="square">
+            <a:spAutoFit/>
+          </a:bodyPr>
           <a:lstStyle/>
           <a:p>
-            <a:r>
-              <a:rPr lang="en-US" b="1" dirty="0"/>
-              <a:t>For detailed information, see the tutorial web page: </a:t>
-            </a:r>
-            <a:r>
-              <a:rPr lang="en-US" b="1" dirty="0">
+            <a:pPr marL="0" marR="0" lvl="0" indent="0" algn="l" defTabSz="914400" rtl="0" eaLnBrk="1" fontAlgn="base" latinLnBrk="0" hangingPunct="1">
+              <a:lnSpc>
+                <a:spcPct val="100000"/>
+              </a:lnSpc>
+              <a:spcBef>
+                <a:spcPct val="0"/>
+              </a:spcBef>
+              <a:spcAft>
+                <a:spcPct val="0"/>
+              </a:spcAft>
+              <a:buClrTx/>
+              <a:buSzTx/>
+              <a:buFontTx/>
+              <a:buNone/>
+              <a:tabLst/>
+              <a:defRPr/>
+            </a:pPr>
+            <a:r>
+              <a:rPr kumimoji="0" lang="en-US" sz="1800" b="0" i="0" u="none" strike="noStrike" kern="1200" cap="none" spc="0" normalizeH="0" baseline="0" noProof="0" dirty="0">
+                <a:ln>
+                  <a:noFill/>
+                </a:ln>
+                <a:solidFill>
+                  <a:prstClr val="black"/>
+                </a:solidFill>
+                <a:effectLst/>
+                <a:uLnTx/>
+                <a:uFillTx/>
+                <a:latin typeface="Arial" charset="0"/>
+                <a:ea typeface="+mn-ea"/>
+                <a:cs typeface="Arial" charset="0"/>
+              </a:rPr>
+              <a:t>The agenda is also available on the tutorial web page.  Visit </a:t>
+            </a:r>
+            <a:r>
+              <a:rPr kumimoji="0" lang="en-US" sz="1800" b="1" i="0" u="none" strike="noStrike" kern="1200" cap="none" spc="0" normalizeH="0" baseline="0" noProof="0" dirty="0">
+                <a:ln>
+                  <a:noFill/>
+                </a:ln>
+                <a:solidFill>
+                  <a:prstClr val="black"/>
+                </a:solidFill>
+                <a:effectLst/>
+                <a:uLnTx/>
+                <a:uFillTx/>
+                <a:latin typeface="Arial" charset="0"/>
+                <a:ea typeface="+mn-ea"/>
+                <a:cs typeface="Arial" charset="0"/>
                 <a:hlinkClick r:id="rId2"/>
               </a:rPr>
-              <a:t>https://bssw-tutorial.github.io/2026-01-26-hpcasia/</a:t>
-            </a:r>
-            <a:endParaRPr lang="en-US" b="1" dirty="0"/>
-          </a:p>
-          <a:p>
-            <a:r>
-              <a:rPr lang="en-US" dirty="0"/>
-              <a:t>The hands-on session uses Code-Scribe</a:t>
-            </a:r>
-          </a:p>
-          <a:p>
-            <a:pPr lvl="1"/>
-            <a:r>
-              <a:rPr lang="en-US" dirty="0"/>
-              <a:t>You will be using an LLM through its API interface </a:t>
-            </a:r>
-          </a:p>
-          <a:p>
-            <a:r>
-              <a:rPr lang="en-US" dirty="0"/>
-              <a:t>Participation in the hands-on is encouraged but not required</a:t>
-            </a:r>
-          </a:p>
-          <a:p>
-            <a:pPr lvl="1"/>
-            <a:r>
-              <a:rPr lang="en-US" dirty="0"/>
-              <a:t>The instructor’s prompts and generated code will be made available to participants after the exercise</a:t>
-            </a:r>
-          </a:p>
-          <a:p>
-            <a:r>
-              <a:rPr lang="en-US" b="1" dirty="0"/>
-              <a:t>To participate in the hands-on, you will need Code-Scribe and access to a LLM chat tool </a:t>
+              <a:t>https://bssw-tutorial.github.io</a:t>
+            </a:r>
+            <a:r>
+              <a:rPr kumimoji="0" lang="en-US" sz="1800" b="1" i="0" u="none" strike="noStrike" kern="1200" cap="none" spc="0" normalizeH="0" baseline="0" noProof="0" dirty="0">
+                <a:ln>
+                  <a:noFill/>
+                </a:ln>
+                <a:solidFill>
+                  <a:prstClr val="black"/>
+                </a:solidFill>
+                <a:effectLst/>
+                <a:uLnTx/>
+                <a:uFillTx/>
+                <a:latin typeface="Arial" charset="0"/>
+                <a:ea typeface="+mn-ea"/>
+                <a:cs typeface="Arial" charset="0"/>
+              </a:rPr>
+              <a:t> </a:t>
+            </a:r>
+            <a:r>
+              <a:rPr kumimoji="0" lang="en-US" sz="1800" b="0" i="0" u="none" strike="noStrike" kern="1200" cap="none" spc="0" normalizeH="0" baseline="0" noProof="0" dirty="0">
+                <a:ln>
+                  <a:noFill/>
+                </a:ln>
+                <a:solidFill>
+                  <a:prstClr val="black"/>
+                </a:solidFill>
+                <a:effectLst/>
+                <a:uLnTx/>
+                <a:uFillTx/>
+                <a:latin typeface="Arial" charset="0"/>
+                <a:ea typeface="+mn-ea"/>
+                <a:cs typeface="Arial" charset="0"/>
+              </a:rPr>
+              <a:t>and click on the link for today’s tutorial</a:t>
             </a:r>
           </a:p>
         </p:txBody>
@@ -7614,7 +7236,7 @@
     </p:spTree>
     <p:extLst>
       <p:ext uri="{BB962C8B-B14F-4D97-AF65-F5344CB8AC3E}">
-        <p14:creationId xmlns:p14="http://schemas.microsoft.com/office/powerpoint/2010/main" val="2959188582"/>
+        <p14:creationId xmlns:p14="http://schemas.microsoft.com/office/powerpoint/2010/main" val="3643219827"/>
       </p:ext>
     </p:extLst>
   </p:cSld>
@@ -8537,15 +8159,6 @@
 </file>
 
 <file path=customXml/item1.xml><?xml version="1.0" encoding="utf-8"?>
-<?mso-contentType ?>
-<FormTemplates xmlns="http://schemas.microsoft.com/sharepoint/v3/contenttype/forms">
-  <Display>DocumentLibraryForm</Display>
-  <Edit>DocumentLibraryForm</Edit>
-  <New>DocumentLibraryForm</New>
-</FormTemplates>
-</file>
-
-<file path=customXml/item2.xml><?xml version="1.0" encoding="utf-8"?>
 <ct:contentTypeSchema xmlns:ct="http://schemas.microsoft.com/office/2006/metadata/contentType" xmlns:ma="http://schemas.microsoft.com/office/2006/metadata/properties/metaAttributes" ct:_="" ma:_="" ma:contentTypeName="Document" ma:contentTypeID="0x010100565464437F680748A68B85EB6594EA7D" ma:contentTypeVersion="0" ma:contentTypeDescription="Create a new document." ma:contentTypeScope="" ma:versionID="fe3f4dd58d5914c51cfc6deaa8ad845c">
   <xsd:schema xmlns:xsd="http://www.w3.org/2001/XMLSchema" xmlns:p="http://schemas.microsoft.com/office/2006/metadata/properties" targetNamespace="http://schemas.microsoft.com/office/2006/metadata/properties" ma:root="true" ma:fieldsID="4aeb20c0e3442673af7ee10786458764">
     <xsd:element name="properties">
@@ -8594,6 +8207,15 @@
 </ct:contentTypeSchema>
 </file>
 
+<file path=customXml/item2.xml><?xml version="1.0" encoding="utf-8"?>
+<?mso-contentType ?>
+<FormTemplates xmlns="http://schemas.microsoft.com/sharepoint/v3/contenttype/forms">
+  <Display>DocumentLibraryForm</Display>
+  <Edit>DocumentLibraryForm</Edit>
+  <New>DocumentLibraryForm</New>
+</FormTemplates>
+</file>
+
 <file path=customXml/item3.xml><?xml version="1.0" encoding="utf-8"?>
 <p:properties xmlns:p="http://schemas.microsoft.com/office/2006/metadata/properties" xmlns:xsi="http://www.w3.org/2001/XMLSchema-instance" xmlns:pc="http://schemas.microsoft.com/office/infopath/2007/PartnerControls">
   <documentManagement/>
@@ -8601,14 +8223,6 @@
 </file>
 
 <file path=customXml/itemProps1.xml><?xml version="1.0" encoding="utf-8"?>
-<ds:datastoreItem xmlns:ds="http://schemas.openxmlformats.org/officeDocument/2006/customXml" ds:itemID="{19E20559-B232-4371-8690-E3D8007EDB82}">
-  <ds:schemaRefs>
-    <ds:schemaRef ds:uri="http://schemas.microsoft.com/sharepoint/v3/contenttype/forms"/>
-  </ds:schemaRefs>
-</ds:datastoreItem>
-</file>
-
-<file path=customXml/itemProps2.xml><?xml version="1.0" encoding="utf-8"?>
 <ds:datastoreItem xmlns:ds="http://schemas.openxmlformats.org/officeDocument/2006/customXml" ds:itemID="{E8DB7DEB-074E-4EE8-9B6E-FD277323109C}">
   <ds:schemaRefs>
     <ds:schemaRef ds:uri="http://schemas.microsoft.com/office/2006/metadata/contentType"/>
@@ -8619,6 +8233,14 @@
     <ds:schemaRef ds:uri="http://purl.org/dc/elements/1.1/"/>
     <ds:schemaRef ds:uri="http://purl.org/dc/terms/"/>
     <ds:schemaRef ds:uri="http://schemas.microsoft.com/office/internal/2005/internalDocumentation"/>
+  </ds:schemaRefs>
+</ds:datastoreItem>
+</file>
+
+<file path=customXml/itemProps2.xml><?xml version="1.0" encoding="utf-8"?>
+<ds:datastoreItem xmlns:ds="http://schemas.openxmlformats.org/officeDocument/2006/customXml" ds:itemID="{19E20559-B232-4371-8690-E3D8007EDB82}">
+  <ds:schemaRefs>
+    <ds:schemaRef ds:uri="http://schemas.microsoft.com/sharepoint/v3/contenttype/forms"/>
   </ds:schemaRefs>
 </ds:datastoreItem>
 </file>

</xml_diff>